<commit_message>
complete confirmatory evidence and reviewer-facing simulation
</commit_message>
<xml_diff>
--- a/slides/HTX_Task4_Operational_Insights.pptx
+++ b/slides/HTX_Task4_Operational_Insights.pptx
@@ -2,17 +2,17 @@
 <file path=ppt/presentation.xml><?xml version="1.0" encoding="utf-8"?>
 <p:presentation xmlns:p="http://schemas.openxmlformats.org/presentationml/2006/main">
   <p:sldMasterIdLst>
-    <p:sldMasterId xmlns:r="http://schemas.openxmlformats.org/officeDocument/2006/relationships" id="2147483648" r:id="Ra407f94d5f0d460a"/>
+    <p:sldMasterId xmlns:r="http://schemas.openxmlformats.org/officeDocument/2006/relationships" id="2147483648" r:id="Rb92c6d46b47c4334"/>
   </p:sldMasterIdLst>
   <p:notesMasterIdLst>
-    <p:notesMasterId xmlns:r="http://schemas.openxmlformats.org/officeDocument/2006/relationships" r:id="R41bdb56092eb4d82"/>
+    <p:notesMasterId xmlns:r="http://schemas.openxmlformats.org/officeDocument/2006/relationships" r:id="Racc00dedc625416c"/>
   </p:notesMasterIdLst>
   <p:sldIdLst>
-    <p:sldId xmlns:r="http://schemas.openxmlformats.org/officeDocument/2006/relationships" id="256" r:id="Rc859b84c38ea437e"/>
-    <p:sldId xmlns:r="http://schemas.openxmlformats.org/officeDocument/2006/relationships" id="257" r:id="R2b93bd00452c4307"/>
-    <p:sldId xmlns:r="http://schemas.openxmlformats.org/officeDocument/2006/relationships" id="258" r:id="R7067e0546ec44f3d"/>
-    <p:sldId xmlns:r="http://schemas.openxmlformats.org/officeDocument/2006/relationships" id="259" r:id="Raf19ab4eb15042f1"/>
-    <p:sldId xmlns:r="http://schemas.openxmlformats.org/officeDocument/2006/relationships" id="260" r:id="R643b0492042744a5"/>
+    <p:sldId xmlns:r="http://schemas.openxmlformats.org/officeDocument/2006/relationships" id="256" r:id="R931886ca42094bb9"/>
+    <p:sldId xmlns:r="http://schemas.openxmlformats.org/officeDocument/2006/relationships" id="257" r:id="Ra3e7b03b2b424c88"/>
+    <p:sldId xmlns:r="http://schemas.openxmlformats.org/officeDocument/2006/relationships" id="258" r:id="R59b35f8aa28f4cea"/>
+    <p:sldId xmlns:r="http://schemas.openxmlformats.org/officeDocument/2006/relationships" id="259" r:id="R8b7ffc3b7bd143a0"/>
+    <p:sldId xmlns:r="http://schemas.openxmlformats.org/officeDocument/2006/relationships" id="260" r:id="Re82e3e30d0244067"/>
   </p:sldIdLst>
   <p:sldSz cx="12192000" cy="6858000"/>
   <p:notesSz cx="6858000" cy="9144000"/>
@@ -446,7 +446,7 @@
           <a:lstStyle xmlns:a="http://schemas.openxmlformats.org/drawingml/2006/main"/>
           <a:p xmlns:a="http://schemas.openxmlformats.org/drawingml/2006/main">
             <a:r>
-              <a:t>Frame the task as a decision-under-uncertainty problem. The short clip is useful evidence, but it cannot validate a full checkpoint or justify a staffing forecast.</a:t>
+              <a:t>The operational question is larger than the local evidence. We have one 24.9-second corridor clip, so the responsible output is an auditable what-if model—not a calibrated checkpoint forecast. Human adjudication owns the accepted directional counts, the simulation makes every capacity and service assumption explicit, and a predeclared 600-run study quantifies the capacity mechanism under those assumptions. The purpose of this deck is to identify a mechanism worth field-testing and the evidence still required before any staffing or deployment decision.</a:t>
             </a:r>
           </a:p>
           <a:p xmlns:a="http://schemas.openxmlformats.org/drawingml/2006/main">
@@ -466,7 +466,17 @@
           </a:p>
           <a:p xmlns:a="http://schemas.openxmlformats.org/drawingml/2006/main">
             <a:r>
-              <a:t>- data/derived/task1_final_aggregate.csv (accepted aggregate, local source)</a:t>
+              <a:t>- data/derived/task1_final_aggregate.csv (accepted aggregate and exact clip duration, local source)</a:t>
+            </a:r>
+          </a:p>
+          <a:p xmlns:a="http://schemas.openxmlformats.org/drawingml/2006/main">
+            <a:r>
+              <a:t>- docs/task3_confirmatory_design.md (frozen design and claim boundary, local source)</a:t>
+            </a:r>
+          </a:p>
+          <a:p xmlns:a="http://schemas.openxmlformats.org/drawingml/2006/main">
+            <a:r>
+              <a:t>- results/analysis/confirmatory_capacity/analysis_manifest.json (executed study result, local source)</a:t>
             </a:r>
           </a:p>
         </p:txBody>
@@ -536,7 +546,7 @@
           <a:lstStyle xmlns:a="http://schemas.openxmlformats.org/drawingml/2006/main"/>
           <a:p xmlns:a="http://schemas.openxmlformats.org/drawingml/2006/main">
             <a:r>
-              <a:t>Explain why each layer exists. Detection is a candidate-generation tool, the AnyLogic animation is an inspectable explanation layer, and replicated output—not a visually convincing run—is the evidence layer.</a:t>
+              <a:t>The first control is ownership of the measurement. The accepted aggregate is 12 left-to-right and 34 right-to-left; only the 34 right-to-left crossings feed the arrival anchor. The exact 0.945-to-1.906 per-second interval represents Poisson count sampling conditional on that accepted count; it does not represent human disagreement or time-of-day demand. The second control is a deliberately minimal two-stage pooled queue. The third is a frozen confirmatory contract: 12 cells, 50 replications each and 150 common-random-number groups, with pairing authorized only after traveller-level alignment passes.</a:t>
             </a:r>
           </a:p>
           <a:p xmlns:a="http://schemas.openxmlformats.org/drawingml/2006/main">
@@ -551,7 +561,7 @@
           </a:p>
           <a:p xmlns:a="http://schemas.openxmlformats.org/drawingml/2006/main">
             <a:r>
-              <a:t>- data/derived/task1_final_aggregate.csv (accepted aggregate, local source)</a:t>
+              <a:t>- data/derived/task1_final_aggregate.csv (accepted aggregate and duration, local source)</a:t>
             </a:r>
           </a:p>
           <a:p xmlns:a="http://schemas.openxmlformats.org/drawingml/2006/main">
@@ -561,27 +571,22 @@
           </a:p>
           <a:p xmlns:a="http://schemas.openxmlformats.org/drawingml/2006/main">
             <a:r>
-              <a:t>- docs/literature_to_design_matrix.md (design-evidence matrix, local source)</a:t>
+              <a:t>- docs/task3_confirmatory_design.md (input interval, precision target and primary contrast, local source)</a:t>
+            </a:r>
+          </a:p>
+          <a:p xmlns:a="http://schemas.openxmlformats.org/drawingml/2006/main">
+            <a:r>
+              <a:t>- config/confirmatory_seed_manifest.csv (frozen random-stream groups, local source)</a:t>
+            </a:r>
+          </a:p>
+          <a:p xmlns:a="http://schemas.openxmlformats.org/drawingml/2006/main">
+            <a:r>
+              <a:t>- results/analysis/confirmatory_capacity/crn_alignment.json (executed alignment gate, local source)</a:t>
             </a:r>
           </a:p>
           <a:p xmlns:a="http://schemas.openxmlformats.org/drawingml/2006/main">
             <a:r>
               <a:t>- https://informs-sim.org/wsc20papers/134.pdf</a:t>
-            </a:r>
-          </a:p>
-          <a:p xmlns:a="http://schemas.openxmlformats.org/drawingml/2006/main">
-            <a:r>
-              <a:t>- https://github.com/Megvii-BaseDetection/YOLOX</a:t>
-            </a:r>
-          </a:p>
-          <a:p xmlns:a="http://schemas.openxmlformats.org/drawingml/2006/main">
-            <a:r>
-              <a:t>- https://www.ecva.net/papers/eccv_2022/papers_ECCV/papers/136820001.pdf</a:t>
-            </a:r>
-          </a:p>
-          <a:p xmlns:a="http://schemas.openxmlformats.org/drawingml/2006/main">
-            <a:r>
-              <a:t>- https://www.ultralytics.com/license</a:t>
             </a:r>
           </a:p>
         </p:txBody>
@@ -651,7 +656,7 @@
           <a:lstStyle xmlns:a="http://schemas.openxmlformats.org/drawingml/2006/main"/>
           <a:p xmlns:a="http://schemas.openxmlformats.org/drawingml/2006/main">
             <a:r>
-              <a:t>Call this a reference assumption sandbox, never observed HTX baseline performance. Its low waiting time is expected because capacity was derived with headroom, service times are fixed, and the system starts empty.</a:t>
+              <a:t>The confirmatory status comes from the contract, not the label. Before seeing these outcomes, the study fixed one primary comparison, a one-second half-width target, 50 replications per cell and all random streams. The run completed 600 of 600 cells with 253,756 traveller rows. CRN validation then matched 150 scenario groups, identical traveller sets and more than 1.14 million branch-invariant draw values. Only after that PASS was the paired interval authorised. The result is still conditional on the registered model; it is not observed checkpoint performance.</a:t>
             </a:r>
           </a:p>
           <a:p xmlns:a="http://schemas.openxmlformats.org/drawingml/2006/main">
@@ -666,32 +671,27 @@
           </a:p>
           <a:p xmlns:a="http://schemas.openxmlformats.org/drawingml/2006/main">
             <a:r>
-              <a:t>- docs/task3_operational_contract.md (executed model contract, local source)</a:t>
-            </a:r>
-          </a:p>
-          <a:p xmlns:a="http://schemas.openxmlformats.org/drawingml/2006/main">
-            <a:r>
-              <a:t>- results/intermediate/operational_results/validation.json (strict validation, local source)</a:t>
-            </a:r>
-          </a:p>
-          <a:p xmlns:a="http://schemas.openxmlformats.org/drawingml/2006/main">
-            <a:r>
-              <a:t>- results/analysis/operational/scenario_estimates.csv (reference estimates, local source)</a:t>
-            </a:r>
-          </a:p>
-          <a:p xmlns:a="http://schemas.openxmlformats.org/drawingml/2006/main">
-            <a:r>
-              <a:t>- docs/task3_results.md (interpretation and limits, local source)</a:t>
+              <a:t>- docs/task3_confirmatory_design.md (predeclared design and precision target, local source)</a:t>
+            </a:r>
+          </a:p>
+          <a:p xmlns:a="http://schemas.openxmlformats.org/drawingml/2006/main">
+            <a:r>
+              <a:t>- results/analysis/confirmatory_capacity/validation.json (600-run coverage gate, local source)</a:t>
+            </a:r>
+          </a:p>
+          <a:p xmlns:a="http://schemas.openxmlformats.org/drawingml/2006/main">
+            <a:r>
+              <a:t>- results/analysis/confirmatory_capacity/crn_alignment.json (traveller-level CRN gate, local source)</a:t>
+            </a:r>
+          </a:p>
+          <a:p xmlns:a="http://schemas.openxmlformats.org/drawingml/2006/main">
+            <a:r>
+              <a:t>- results/analysis/confirmatory_capacity/primary_result.json (achieved precision, local source)</a:t>
             </a:r>
           </a:p>
           <a:p xmlns:a="http://schemas.openxmlformats.org/drawingml/2006/main">
             <a:r>
               <a:t>- https://www.gao.gov/assets/a257263.html</a:t>
-            </a:r>
-          </a:p>
-          <a:p xmlns:a="http://schemas.openxmlformats.org/drawingml/2006/main">
-            <a:r>
-              <a:t>- https://www.mha.gov.sg/media-room/newsroom/average-duration-to-process-travellers-at-bus-halls-of-land-checkpoints-using-qr-code-or-passport/</a:t>
             </a:r>
           </a:p>
         </p:txBody>
@@ -761,7 +761,7 @@
           <a:lstStyle xmlns:a="http://schemas.openxmlformats.org/drawingml/2006/main"/>
           <a:p xmlns:a="http://schemas.openxmlformats.org/drawingml/2006/main">
             <a:r>
-              <a:t>Read the stage-level bars first: expanding Security removes Security wait but leaves Immigration active; expanding Immigration does the reverse. Joint capacity is the only clear capacity contrast at n=10, but the larger operational lesson is that demand and service assumptions dominate these small changes.</a:t>
+              <a:t>At the base arrival rate, the joint arm lowers mean replication-level total queue-wait P95 from 3.929 to 1.250 seconds. The predeclared paired difference is minus 2.679 seconds, with a 95% interval from minus 3.061 to minus 2.297 and a 0.382-second half-width. Supporting rate checks show a resolved joint benefit at all three count-based rates: 0.067 seconds at the lower endpoint, 2.679 at the point estimate and 33.158 at the upper endpoint. The joint arm has the best point estimate throughout, but some other pairwise intervals are unresolved, so this is not evidence that every capacity option is statistically distinct.</a:t>
             </a:r>
           </a:p>
           <a:p xmlns:a="http://schemas.openxmlformats.org/drawingml/2006/main">
@@ -776,27 +776,27 @@
           </a:p>
           <a:p xmlns:a="http://schemas.openxmlformats.org/drawingml/2006/main">
             <a:r>
-              <a:t>- results/analysis/operational/scenario_estimates.csv (scenario estimates, local source)</a:t>
-            </a:r>
-          </a:p>
-          <a:p xmlns:a="http://schemas.openxmlformats.org/drawingml/2006/main">
-            <a:r>
-              <a:t>- results/analysis/operational/scenario_contrasts.csv (Welch contrasts, local source)</a:t>
-            </a:r>
-          </a:p>
-          <a:p xmlns:a="http://schemas.openxmlformats.org/drawingml/2006/main">
-            <a:r>
-              <a:t>- results/analysis/operational/analysis_manifest.json (CRN status and method, local source)</a:t>
-            </a:r>
-          </a:p>
-          <a:p xmlns:a="http://schemas.openxmlformats.org/drawingml/2006/main">
-            <a:r>
-              <a:t>- docs/task3_results.md (scenario interpretation and limitations, local source)</a:t>
-            </a:r>
-          </a:p>
-          <a:p xmlns:a="http://schemas.openxmlformats.org/drawingml/2006/main">
-            <a:r>
-              <a:t>- https://www.ica.gov.sg/news-and-publications/newsroom/media-release/new-immigration-kiosks-at-woodlands-train-checkpoint-increases-automated-clearance-capacity-and-provides-faster-clearance</a:t>
+              <a:t>- results/analysis/confirmatory_capacity/scenario_estimates.csv (base-rate stage estimates, local source)</a:t>
+            </a:r>
+          </a:p>
+          <a:p xmlns:a="http://schemas.openxmlformats.org/drawingml/2006/main">
+            <a:r>
+              <a:t>- results/analysis/confirmatory_capacity/primary_result.json (predeclared primary result, local source)</a:t>
+            </a:r>
+          </a:p>
+          <a:p xmlns:a="http://schemas.openxmlformats.org/drawingml/2006/main">
+            <a:r>
+              <a:t>- results/analysis/confirmatory_capacity/within_rate_pairwise_contrasts.csv (rate-boundary contrasts, local source)</a:t>
+            </a:r>
+          </a:p>
+          <a:p xmlns:a="http://schemas.openxmlformats.org/drawingml/2006/main">
+            <a:r>
+              <a:t>- results/analysis/confirmatory_capacity/ranking_stability.json (supporting ranking interpretation, local source)</a:t>
+            </a:r>
+          </a:p>
+          <a:p xmlns:a="http://schemas.openxmlformats.org/drawingml/2006/main">
+            <a:r>
+              <a:t>- results/analysis/confirmatory_capacity/crn_alignment.json (paired-analysis gate, local source)</a:t>
             </a:r>
           </a:p>
         </p:txBody>
@@ -866,7 +866,7 @@
           <a:lstStyle xmlns:a="http://schemas.openxmlformats.org/drawingml/2006/main"/>
           <a:p xmlns:a="http://schemas.openxmlformats.org/drawingml/2006/main">
             <a:r>
-              <a:t>Recommend a staged programme: retain pooled FCFS and full-drain diagnostics, use balanced capacity as a mechanism pilot, collect local arrival/service/exception/roster data, then rerun a confirmatory experiment with a precision target and costs. Treat detector licensing as a production procurement decision, not a hidden deployment assumption.</a:t>
+              <a:t>The confirmatory evidence is strong enough to advance one mechanism, not to prescribe staffing. Under the registered assumptions, joint plus-four and plus-three reduces the base-rate P95 by 2.679 seconds and remains beneficial at both exact count-rate endpoints. The next gate is field evidence: signed event times across time of day, stage service and exception distributions, observed open resources, rosters and downtime. Only after calibration and validation should HTX price a controlled joint-capacity pilot and assess space, staffing, security and production computer-vision licensing.</a:t>
             </a:r>
           </a:p>
           <a:p xmlns:a="http://schemas.openxmlformats.org/drawingml/2006/main">
@@ -881,12 +881,17 @@
           </a:p>
           <a:p xmlns:a="http://schemas.openxmlformats.org/drawingml/2006/main">
             <a:r>
-              <a:t>- docs/task3_results.md (risk-bound interpretation, guardrail critique and limits, local source)</a:t>
-            </a:r>
-          </a:p>
-          <a:p xmlns:a="http://schemas.openxmlformats.org/drawingml/2006/main">
-            <a:r>
-              <a:t>- results/analysis/operational/scenario_estimates.csv (risk scenario estimates, local source)</a:t>
+              <a:t>- results/analysis/confirmatory_capacity/primary_result.json (primary capacity result, local source)</a:t>
+            </a:r>
+          </a:p>
+          <a:p xmlns:a="http://schemas.openxmlformats.org/drawingml/2006/main">
+            <a:r>
+              <a:t>- results/analysis/confirmatory_capacity/ranking_stability.json (cross-rate supporting result, local source)</a:t>
+            </a:r>
+          </a:p>
+          <a:p xmlns:a="http://schemas.openxmlformats.org/drawingml/2006/main">
+            <a:r>
+              <a:t>- docs/task3_results.md (decision interpretation and limitations, local source)</a:t>
             </a:r>
           </a:p>
           <a:p xmlns:a="http://schemas.openxmlformats.org/drawingml/2006/main">
@@ -896,12 +901,7 @@
           </a:p>
           <a:p xmlns:a="http://schemas.openxmlformats.org/drawingml/2006/main">
             <a:r>
-              <a:t>- LICENSING.md (measurement/deployment licence boundary, local source)</a:t>
-            </a:r>
-          </a:p>
-          <a:p xmlns:a="http://schemas.openxmlformats.org/drawingml/2006/main">
-            <a:r>
-              <a:t>- https://www.cbp.gov/sites/default/files/documents/Final%20Preclearance%20Guidance_092014.pdf</a:t>
+              <a:t>- LICENSING.md (measurement and deployment licence boundary, local source)</a:t>
             </a:r>
           </a:p>
           <a:p xmlns:a="http://schemas.openxmlformats.org/drawingml/2006/main">
@@ -974,7 +974,7 @@
   </p:cSld>
   <p:clrMap bg1="lt1" tx1="dk1" bg2="lt2" tx2="dk2" accent1="accent1" accent2="accent2" accent3="accent3" accent4="accent4" accent5="accent5" accent6="accent6" hlink="hlink" folHlink="folHlink"/>
   <p:sldLayoutIdLst>
-    <p:sldLayoutId xmlns:r="http://schemas.openxmlformats.org/officeDocument/2006/relationships" id="2147483649" r:id="R2c206034e56a4e8e"/>
+    <p:sldLayoutId xmlns:r="http://schemas.openxmlformats.org/officeDocument/2006/relationships" id="2147483649" r:id="Rb2dc059eccad4db0"/>
   </p:sldLayoutIdLst>
   <p:txStyles>
     <p:titleStyle>
@@ -1543,16 +1543,16 @@
               <c:formatCode>0.00</c:formatCode>
               <c:ptCount val="4"/>
               <c:pt idx="0">
-                <c:v>2.07</c:v>
+                <c:v>2.318877</c:v>
               </c:pt>
               <c:pt idx="1">
-                <c:v>0.02</c:v>
+                <c:v>0.530461</c:v>
               </c:pt>
               <c:pt idx="2">
-                <c:v>2.12</c:v>
+                <c:v>2.318877</c:v>
               </c:pt>
               <c:pt idx="3">
-                <c:v>0.75</c:v>
+                <c:v>0.530461</c:v>
               </c:pt>
             </c:numLit>
           </c:val>
@@ -1590,16 +1590,16 @@
               <c:formatCode>0.00</c:formatCode>
               <c:ptCount val="4"/>
               <c:pt idx="0">
-                <c:v>2.32</c:v>
+                <c:v>2.334975</c:v>
               </c:pt>
               <c:pt idx="1">
-                <c:v>2.52</c:v>
+                <c:v>3.259367</c:v>
               </c:pt>
               <c:pt idx="2">
-                <c:v>0.17</c:v>
+                <c:v>0.359401</c:v>
               </c:pt>
               <c:pt idx="3">
-                <c:v>0.75</c:v>
+                <c:v>0.705027</c:v>
               </c:pt>
             </c:numLit>
           </c:val>
@@ -1637,16 +1637,16 @@
               <c:formatCode>0.00</c:formatCode>
               <c:ptCount val="4"/>
               <c:pt idx="0">
-                <c:v>3.52</c:v>
+                <c:v>3.928792</c:v>
               </c:pt>
               <c:pt idx="1">
-                <c:v>2.68</c:v>
+                <c:v>3.71883</c:v>
               </c:pt>
               <c:pt idx="2">
-                <c:v>2.31</c:v>
+                <c:v>2.576771</c:v>
               </c:pt>
               <c:pt idx="3">
-                <c:v>1.62</c:v>
+                <c:v>1.25006</c:v>
               </c:pt>
             </c:numLit>
           </c:val>
@@ -1828,31 +1828,40 @@
         </p:nvSpPr>
         <p:spPr>
           <a:xfrm xmlns:a="http://schemas.openxmlformats.org/drawingml/2006/main">
-            <a:off x="393668" y="1738789"/>
-            <a:ext cx="9448800" cy="2491454"/>
+            <a:off x="393668" y="1619250"/>
+            <a:ext cx="10668000" cy="2571750"/>
           </a:xfrm>
           <a:prstGeom xmlns:a="http://schemas.openxmlformats.org/drawingml/2006/main" prst="rect">
             <a:avLst/>
           </a:prstGeom>
         </p:spPr>
         <p:txBody>
-          <a:bodyPr xmlns:a="http://schemas.openxmlformats.org/drawingml/2006/main" lIns="0" tIns="0" rIns="0" bIns="0" anchor="b">
+          <a:bodyPr xmlns:a="http://schemas.openxmlformats.org/drawingml/2006/main" lIns="0" tIns="0" rIns="0" bIns="0" anchor="t">
             <a:noAutofit/>
           </a:bodyPr>
           <a:lstStyle xmlns:a="http://schemas.openxmlformats.org/drawingml/2006/main"/>
           <a:p xmlns:a="http://schemas.openxmlformats.org/drawingml/2006/main">
             <a:pPr algn="l">
-              <a:defRPr sz="6000">
-                <a:solidFill>
-                  <a:srgbClr val="000000"/>
-                </a:solidFill>
-                <a:latin typeface="Helvetica Neue"/>
-                <a:ea typeface="Helvetica Neue"/>
-                <a:cs typeface="Helvetica Neue"/>
-              </a:defRPr>
-            </a:pPr>
-            <a:r>
-              <a:t>From 25 seconds of video to a decision-ready checkpoint model</a:t>
+              <a:buNone/>
+              <a:defRPr sz="5400" b="0">
+                <a:solidFill>
+                  <a:srgbClr val="000000"/>
+                </a:solidFill>
+                <a:latin typeface="Helvetica Neue"/>
+                <a:ea typeface="Helvetica Neue"/>
+                <a:cs typeface="Helvetica Neue"/>
+              </a:defRPr>
+            </a:pPr>
+            <a:r>
+              <a:rPr sz="5400" b="0">
+                <a:solidFill>
+                  <a:srgbClr val="000000"/>
+                </a:solidFill>
+                <a:latin typeface="Helvetica Neue"/>
+                <a:ea typeface="Helvetica Neue"/>
+                <a:cs typeface="Helvetica Neue"/>
+              </a:rPr>
+              <a:t>From 24.9 seconds of video to an auditable checkpoint what-if model</a:t>
             </a:r>
           </a:p>
         </p:txBody>
@@ -1873,31 +1882,64 @@
         </p:nvSpPr>
         <p:spPr>
           <a:xfrm xmlns:a="http://schemas.openxmlformats.org/drawingml/2006/main">
-            <a:off x="393668" y="4742212"/>
-            <a:ext cx="5702332" cy="1080230"/>
+            <a:off x="393668" y="4572000"/>
+            <a:ext cx="9525000" cy="1285875"/>
           </a:xfrm>
           <a:prstGeom xmlns:a="http://schemas.openxmlformats.org/drawingml/2006/main" prst="rect">
             <a:avLst/>
           </a:prstGeom>
         </p:spPr>
         <p:txBody>
-          <a:bodyPr xmlns:a="http://schemas.openxmlformats.org/drawingml/2006/main" lIns="0" tIns="0" rIns="0" bIns="0">
+          <a:bodyPr xmlns:a="http://schemas.openxmlformats.org/drawingml/2006/main" lIns="0" tIns="0" rIns="0" bIns="0" anchor="t">
             <a:noAutofit/>
           </a:bodyPr>
           <a:lstStyle xmlns:a="http://schemas.openxmlformats.org/drawingml/2006/main"/>
           <a:p xmlns:a="http://schemas.openxmlformats.org/drawingml/2006/main">
             <a:pPr algn="l">
-              <a:defRPr sz="2400">
-                <a:solidFill>
-                  <a:srgbClr val="000000"/>
-                </a:solidFill>
-                <a:latin typeface="Helvetica Neue"/>
-                <a:ea typeface="Helvetica Neue"/>
-                <a:cs typeface="Helvetica Neue"/>
-              </a:defRPr>
-            </a:pPr>
-            <a:r>
-              <a:t>Evidence-led measurement · verified discrete-event simulation · bounded operational recommendations</a:t>
+              <a:buNone/>
+              <a:defRPr sz="2175" b="0">
+                <a:solidFill>
+                  <a:srgbClr val="000000"/>
+                </a:solidFill>
+                <a:latin typeface="Helvetica Neue"/>
+                <a:ea typeface="Helvetica Neue"/>
+                <a:cs typeface="Helvetica Neue"/>
+              </a:defRPr>
+            </a:pPr>
+            <a:r>
+              <a:rPr sz="2175" b="0">
+                <a:solidFill>
+                  <a:srgbClr val="000000"/>
+                </a:solidFill>
+                <a:latin typeface="Helvetica Neue"/>
+                <a:ea typeface="Helvetica Neue"/>
+                <a:cs typeface="Helvetica Neue"/>
+              </a:rPr>
+              <a:t>Peak-period decisions; one short local corridor clip.</a:t>
+            </a:r>
+          </a:p>
+          <a:p xmlns:a="http://schemas.openxmlformats.org/drawingml/2006/main">
+            <a:pPr algn="l">
+              <a:buNone/>
+              <a:defRPr sz="2175" b="0">
+                <a:solidFill>
+                  <a:srgbClr val="000000"/>
+                </a:solidFill>
+                <a:latin typeface="Helvetica Neue"/>
+                <a:ea typeface="Helvetica Neue"/>
+                <a:cs typeface="Helvetica Neue"/>
+              </a:defRPr>
+            </a:pPr>
+            <a:r>
+              <a:rPr sz="2175" b="0">
+                <a:solidFill>
+                  <a:srgbClr val="000000"/>
+                </a:solidFill>
+                <a:latin typeface="Helvetica Neue"/>
+                <a:ea typeface="Helvetica Neue"/>
+                <a:cs typeface="Helvetica Neue"/>
+              </a:rPr>
+              <a:t>Human-adjudicated aggregate · executable DES · predeclared 600-run evidence</a:t>
             </a:r>
           </a:p>
         </p:txBody>
@@ -1918,31 +1960,40 @@
         </p:nvSpPr>
         <p:spPr>
           <a:xfrm xmlns:a="http://schemas.openxmlformats.org/drawingml/2006/main">
-            <a:off x="393668" y="392240"/>
-            <a:ext cx="5702332" cy="649129"/>
+            <a:off x="393668" y="381000"/>
+            <a:ext cx="8572500" cy="457200"/>
           </a:xfrm>
           <a:prstGeom xmlns:a="http://schemas.openxmlformats.org/drawingml/2006/main" prst="rect">
             <a:avLst/>
           </a:prstGeom>
         </p:spPr>
         <p:txBody>
-          <a:bodyPr xmlns:a="http://schemas.openxmlformats.org/drawingml/2006/main" lIns="0" tIns="0" rIns="0" bIns="0">
+          <a:bodyPr xmlns:a="http://schemas.openxmlformats.org/drawingml/2006/main" lIns="0" tIns="0" rIns="0" bIns="0" anchor="t">
             <a:noAutofit/>
           </a:bodyPr>
           <a:lstStyle xmlns:a="http://schemas.openxmlformats.org/drawingml/2006/main"/>
           <a:p xmlns:a="http://schemas.openxmlformats.org/drawingml/2006/main">
             <a:pPr algn="l">
-              <a:defRPr sz="2400">
-                <a:solidFill>
-                  <a:srgbClr val="000000"/>
-                </a:solidFill>
-                <a:latin typeface="Helvetica Neue"/>
-                <a:ea typeface="Helvetica Neue"/>
-                <a:cs typeface="Helvetica Neue"/>
-              </a:defRPr>
-            </a:pPr>
-            <a:r>
-              <a:t>HTX DSAI TECHNICAL ASSESSMENT · TASK 4</a:t>
+              <a:buNone/>
+              <a:defRPr sz="1875" b="0">
+                <a:solidFill>
+                  <a:srgbClr val="000000"/>
+                </a:solidFill>
+                <a:latin typeface="Helvetica Neue"/>
+                <a:ea typeface="Helvetica Neue"/>
+                <a:cs typeface="Helvetica Neue"/>
+              </a:defRPr>
+            </a:pPr>
+            <a:r>
+              <a:rPr sz="1875" b="0">
+                <a:solidFill>
+                  <a:srgbClr val="000000"/>
+                </a:solidFill>
+                <a:latin typeface="Helvetica Neue"/>
+                <a:ea typeface="Helvetica Neue"/>
+                <a:cs typeface="Helvetica Neue"/>
+              </a:rPr>
+              <a:t>WANG YU · HTX DSAI TECHNICAL ASSESSMENT · TASK 4</a:t>
             </a:r>
           </a:p>
         </p:txBody>
@@ -1997,6 +2048,7 @@
           <a:lstStyle xmlns:a="http://schemas.openxmlformats.org/drawingml/2006/main"/>
           <a:p xmlns:a="http://schemas.openxmlformats.org/drawingml/2006/main">
             <a:pPr algn="r">
+              <a:buNone/>
               <a:defRPr sz="1000">
                 <a:solidFill>
                   <a:srgbClr val="000000"/>
@@ -2028,8 +2080,8 @@
         </p:nvSpPr>
         <p:spPr>
           <a:xfrm xmlns:a="http://schemas.openxmlformats.org/drawingml/2006/main">
-            <a:off x="393668" y="344043"/>
-            <a:ext cx="11404568" cy="1047464"/>
+            <a:off x="393668" y="323850"/>
+            <a:ext cx="11404568" cy="762000"/>
           </a:xfrm>
           <a:prstGeom xmlns:a="http://schemas.openxmlformats.org/drawingml/2006/main" prst="rect">
             <a:avLst/>
@@ -2037,35 +2089,44 @@
         </p:spPr>
         <p:txBody>
           <a:bodyPr xmlns:a="http://schemas.openxmlformats.org/drawingml/2006/main" lIns="0" tIns="0" rIns="0" bIns="0" anchor="t">
-            <a:normAutofit fontScale="100000"/>
+            <a:noAutofit/>
           </a:bodyPr>
           <a:lstStyle xmlns:a="http://schemas.openxmlformats.org/drawingml/2006/main"/>
           <a:p xmlns:a="http://schemas.openxmlformats.org/drawingml/2006/main">
             <a:pPr algn="l">
-              <a:defRPr sz="2900">
-                <a:solidFill>
-                  <a:srgbClr val="000000"/>
-                </a:solidFill>
-                <a:latin typeface="Helvetica Neue"/>
-                <a:ea typeface="Helvetica Neue"/>
-                <a:cs typeface="Helvetica Neue"/>
-              </a:defRPr>
-            </a:pPr>
-            <a:r>
-              <a:t>The pipeline prevents a short clip from becoming a false baseline</a:t>
+              <a:buNone/>
+              <a:defRPr sz="3200" b="0">
+                <a:solidFill>
+                  <a:srgbClr val="000000"/>
+                </a:solidFill>
+                <a:latin typeface="Helvetica Neue"/>
+                <a:ea typeface="Helvetica Neue"/>
+                <a:cs typeface="Helvetica Neue"/>
+              </a:defRPr>
+            </a:pPr>
+            <a:r>
+              <a:rPr sz="3200" b="0">
+                <a:solidFill>
+                  <a:srgbClr val="000000"/>
+                </a:solidFill>
+                <a:latin typeface="Helvetica Neue"/>
+                <a:ea typeface="Helvetica Neue"/>
+                <a:cs typeface="Helvetica Neue"/>
+              </a:rPr>
+              <a:t>Measurement, model and inference are kept separate</a:t>
             </a:r>
           </a:p>
         </p:txBody>
       </p:sp>
       <p:cxnSp>
         <p:nvCxnSpPr>
-          <p:cNvPr id="15" name="Google-Shape-2259-p159-4"/>
+          <p:cNvPr id="27" name="Google-Shape-2259-p159-4"/>
           <p:cNvCxnSpPr/>
           <p:nvPr/>
         </p:nvCxnSpPr>
         <p:spPr>
           <a:xfrm xmlns:a="http://schemas.openxmlformats.org/drawingml/2006/main">
-            <a:off x="337757" y="3373755"/>
+            <a:off x="337757" y="2857500"/>
             <a:ext cx="12245435" cy="286"/>
           </a:xfrm>
           <a:prstGeom xmlns:a="http://schemas.openxmlformats.org/drawingml/2006/main" prst="straightConnector1">
@@ -2095,7 +2156,7 @@
         </p:nvSpPr>
         <p:spPr>
           <a:xfrm xmlns:a="http://schemas.openxmlformats.org/drawingml/2006/main">
-            <a:off x="337757" y="3320225"/>
+            <a:off x="337757" y="2803970"/>
             <a:ext cx="107061" cy="107061"/>
           </a:xfrm>
           <a:prstGeom xmlns:a="http://schemas.openxmlformats.org/drawingml/2006/main" prst="ellipse">
@@ -2122,7 +2183,7 @@
         </p:nvSpPr>
         <p:spPr>
           <a:xfrm xmlns:a="http://schemas.openxmlformats.org/drawingml/2006/main">
-            <a:off x="4251770" y="3320225"/>
+            <a:off x="4251770" y="2803970"/>
             <a:ext cx="107061" cy="107061"/>
           </a:xfrm>
           <a:prstGeom xmlns:a="http://schemas.openxmlformats.org/drawingml/2006/main" prst="ellipse">
@@ -2149,7 +2210,7 @@
         </p:nvSpPr>
         <p:spPr>
           <a:xfrm xmlns:a="http://schemas.openxmlformats.org/drawingml/2006/main">
-            <a:off x="8176070" y="3320225"/>
+            <a:off x="8176070" y="2803970"/>
             <a:ext cx="107061" cy="107061"/>
           </a:xfrm>
           <a:prstGeom xmlns:a="http://schemas.openxmlformats.org/drawingml/2006/main" prst="ellipse">
@@ -2176,30 +2237,39 @@
         </p:nvSpPr>
         <p:spPr>
           <a:xfrm xmlns:a="http://schemas.openxmlformats.org/drawingml/2006/main">
-            <a:off x="393668" y="2843308"/>
-            <a:ext cx="1612868" cy="262414"/>
+            <a:off x="393668" y="2324100"/>
+            <a:ext cx="1714500" cy="285750"/>
           </a:xfrm>
           <a:prstGeom xmlns:a="http://schemas.openxmlformats.org/drawingml/2006/main" prst="rect">
             <a:avLst/>
           </a:prstGeom>
         </p:spPr>
         <p:txBody>
-          <a:bodyPr xmlns:a="http://schemas.openxmlformats.org/drawingml/2006/main" lIns="0" tIns="0" rIns="0" bIns="0">
+          <a:bodyPr xmlns:a="http://schemas.openxmlformats.org/drawingml/2006/main" lIns="0" tIns="0" rIns="0" bIns="0" anchor="t">
             <a:noAutofit/>
           </a:bodyPr>
           <a:lstStyle xmlns:a="http://schemas.openxmlformats.org/drawingml/2006/main"/>
           <a:p xmlns:a="http://schemas.openxmlformats.org/drawingml/2006/main">
             <a:pPr algn="l">
-              <a:defRPr sz="1600">
-                <a:solidFill>
-                  <a:srgbClr val="000000"/>
-                </a:solidFill>
-                <a:latin typeface="Helvetica Neue"/>
-                <a:ea typeface="Helvetica Neue"/>
-                <a:cs typeface="Helvetica Neue"/>
-              </a:defRPr>
-            </a:pPr>
-            <a:r>
+              <a:buNone/>
+              <a:defRPr sz="1600" b="0">
+                <a:solidFill>
+                  <a:srgbClr val="000000"/>
+                </a:solidFill>
+                <a:latin typeface="Helvetica Neue"/>
+                <a:ea typeface="Helvetica Neue"/>
+                <a:cs typeface="Helvetica Neue"/>
+              </a:defRPr>
+            </a:pPr>
+            <a:r>
+              <a:rPr sz="1600" b="0">
+                <a:solidFill>
+                  <a:srgbClr val="000000"/>
+                </a:solidFill>
+                <a:latin typeface="Helvetica Neue"/>
+                <a:ea typeface="Helvetica Neue"/>
+                <a:cs typeface="Helvetica Neue"/>
+              </a:rPr>
               <a:t>MEASURE</a:t>
             </a:r>
           </a:p>
@@ -2221,30 +2291,39 @@
         </p:nvSpPr>
         <p:spPr>
           <a:xfrm xmlns:a="http://schemas.openxmlformats.org/drawingml/2006/main">
-            <a:off x="4294156" y="2843308"/>
-            <a:ext cx="1612868" cy="262414"/>
+            <a:off x="4314825" y="2324100"/>
+            <a:ext cx="1714500" cy="285750"/>
           </a:xfrm>
           <a:prstGeom xmlns:a="http://schemas.openxmlformats.org/drawingml/2006/main" prst="rect">
             <a:avLst/>
           </a:prstGeom>
         </p:spPr>
         <p:txBody>
-          <a:bodyPr xmlns:a="http://schemas.openxmlformats.org/drawingml/2006/main" lIns="0" tIns="0" rIns="0" bIns="0">
+          <a:bodyPr xmlns:a="http://schemas.openxmlformats.org/drawingml/2006/main" lIns="0" tIns="0" rIns="0" bIns="0" anchor="t">
             <a:noAutofit/>
           </a:bodyPr>
           <a:lstStyle xmlns:a="http://schemas.openxmlformats.org/drawingml/2006/main"/>
           <a:p xmlns:a="http://schemas.openxmlformats.org/drawingml/2006/main">
             <a:pPr algn="l">
-              <a:defRPr sz="1600">
-                <a:solidFill>
-                  <a:srgbClr val="000000"/>
-                </a:solidFill>
-                <a:latin typeface="Helvetica Neue"/>
-                <a:ea typeface="Helvetica Neue"/>
-                <a:cs typeface="Helvetica Neue"/>
-              </a:defRPr>
-            </a:pPr>
-            <a:r>
+              <a:buNone/>
+              <a:defRPr sz="1600" b="0">
+                <a:solidFill>
+                  <a:srgbClr val="000000"/>
+                </a:solidFill>
+                <a:latin typeface="Helvetica Neue"/>
+                <a:ea typeface="Helvetica Neue"/>
+                <a:cs typeface="Helvetica Neue"/>
+              </a:defRPr>
+            </a:pPr>
+            <a:r>
+              <a:rPr sz="1600" b="0">
+                <a:solidFill>
+                  <a:srgbClr val="000000"/>
+                </a:solidFill>
+                <a:latin typeface="Helvetica Neue"/>
+                <a:ea typeface="Helvetica Neue"/>
+                <a:cs typeface="Helvetica Neue"/>
+              </a:rPr>
               <a:t>MODEL</a:t>
             </a:r>
           </a:p>
@@ -2266,30 +2345,39 @@
         </p:nvSpPr>
         <p:spPr>
           <a:xfrm xmlns:a="http://schemas.openxmlformats.org/drawingml/2006/main">
-            <a:off x="8223218" y="2843308"/>
-            <a:ext cx="1612868" cy="262414"/>
+            <a:off x="8229600" y="2324100"/>
+            <a:ext cx="1714500" cy="285750"/>
           </a:xfrm>
           <a:prstGeom xmlns:a="http://schemas.openxmlformats.org/drawingml/2006/main" prst="rect">
             <a:avLst/>
           </a:prstGeom>
         </p:spPr>
         <p:txBody>
-          <a:bodyPr xmlns:a="http://schemas.openxmlformats.org/drawingml/2006/main" lIns="0" tIns="0" rIns="0" bIns="0">
+          <a:bodyPr xmlns:a="http://schemas.openxmlformats.org/drawingml/2006/main" lIns="0" tIns="0" rIns="0" bIns="0" anchor="t">
             <a:noAutofit/>
           </a:bodyPr>
           <a:lstStyle xmlns:a="http://schemas.openxmlformats.org/drawingml/2006/main"/>
           <a:p xmlns:a="http://schemas.openxmlformats.org/drawingml/2006/main">
             <a:pPr algn="l">
-              <a:defRPr sz="1600">
-                <a:solidFill>
-                  <a:srgbClr val="000000"/>
-                </a:solidFill>
-                <a:latin typeface="Helvetica Neue"/>
-                <a:ea typeface="Helvetica Neue"/>
-                <a:cs typeface="Helvetica Neue"/>
-              </a:defRPr>
-            </a:pPr>
-            <a:r>
+              <a:buNone/>
+              <a:defRPr sz="1600" b="0">
+                <a:solidFill>
+                  <a:srgbClr val="000000"/>
+                </a:solidFill>
+                <a:latin typeface="Helvetica Neue"/>
+                <a:ea typeface="Helvetica Neue"/>
+                <a:cs typeface="Helvetica Neue"/>
+              </a:defRPr>
+            </a:pPr>
+            <a:r>
+              <a:rPr sz="1600" b="0">
+                <a:solidFill>
+                  <a:srgbClr val="000000"/>
+                </a:solidFill>
+                <a:latin typeface="Helvetica Neue"/>
+                <a:ea typeface="Helvetica Neue"/>
+                <a:cs typeface="Helvetica Neue"/>
+              </a:rPr>
               <a:t>INFER</a:t>
             </a:r>
           </a:p>
@@ -2311,34 +2399,37 @@
         </p:nvSpPr>
         <p:spPr>
           <a:xfrm xmlns:a="http://schemas.openxmlformats.org/drawingml/2006/main">
-            <a:off x="4317111" y="3822668"/>
-            <a:ext cx="3156109" cy="1586294"/>
+            <a:off x="4314825" y="3238500"/>
+            <a:ext cx="3524250" cy="2667000"/>
           </a:xfrm>
           <a:prstGeom xmlns:a="http://schemas.openxmlformats.org/drawingml/2006/main" prst="rect">
             <a:avLst/>
           </a:prstGeom>
         </p:spPr>
         <p:txBody>
-          <a:bodyPr xmlns:a="http://schemas.openxmlformats.org/drawingml/2006/main" lIns="0" tIns="0" rIns="0" bIns="0">
+          <a:bodyPr xmlns:a="http://schemas.openxmlformats.org/drawingml/2006/main" lIns="0" tIns="0" rIns="0" bIns="0" anchor="t">
             <a:noAutofit/>
           </a:bodyPr>
           <a:lstStyle xmlns:a="http://schemas.openxmlformats.org/drawingml/2006/main"/>
           <a:p xmlns:a="http://schemas.openxmlformats.org/drawingml/2006/main">
             <a:pPr algn="l">
+              <a:spcBef>
+                <a:spcPts val="0"/>
+              </a:spcBef>
               <a:spcAft>
-                <a:spcPts val="500"/>
+                <a:spcPts val="8"/>
               </a:spcAft>
-              <a:defRPr sz="2400">
-                <a:solidFill>
-                  <a:srgbClr val="000000"/>
-                </a:solidFill>
-                <a:latin typeface="Helvetica Neue"/>
-                <a:ea typeface="Helvetica Neue"/>
-                <a:cs typeface="Helvetica Neue"/>
-              </a:defRPr>
-            </a:pPr>
-            <a:r>
-              <a:rPr sz="2100" b="1">
+              <a:defRPr sz="1600">
+                <a:solidFill>
+                  <a:srgbClr val="000000"/>
+                </a:solidFill>
+                <a:latin typeface="Helvetica Neue"/>
+                <a:ea typeface="Helvetica Neue"/>
+                <a:cs typeface="Helvetica Neue"/>
+              </a:defRPr>
+            </a:pPr>
+            <a:r>
+              <a:rPr sz="1875" b="1">
                 <a:solidFill>
                   <a:srgbClr val="000000"/>
                 </a:solidFill>
@@ -2346,26 +2437,28 @@
                 <a:ea typeface="Helvetica Neue"/>
                 <a:cs typeface="Helvetica Neue"/>
               </a:rPr>
-              <a:t>Events—not frames—drive the engine</a:t>
+              <a:t>A minimal DES exposes the mechanism</a:t>
             </a:r>
           </a:p>
           <a:p xmlns:a="http://schemas.openxmlformats.org/drawingml/2006/main">
             <a:pPr algn="l">
-              <a:lnSpc>
-                <a:spcPct val="112000"/>
-              </a:lnSpc>
-              <a:buNone/>
-              <a:defRPr sz="2400">
-                <a:solidFill>
-                  <a:srgbClr val="000000"/>
-                </a:solidFill>
-                <a:latin typeface="Helvetica Neue"/>
-                <a:ea typeface="Helvetica Neue"/>
-                <a:cs typeface="Helvetica Neue"/>
-              </a:defRPr>
-            </a:pPr>
-            <a:r>
-              <a:rPr sz="1350">
+              <a:spcBef>
+                <a:spcPts val="0"/>
+              </a:spcBef>
+              <a:spcAft>
+                <a:spcPts val="8"/>
+              </a:spcAft>
+              <a:defRPr sz="1600">
+                <a:solidFill>
+                  <a:srgbClr val="000000"/>
+                </a:solidFill>
+                <a:latin typeface="Helvetica Neue"/>
+                <a:ea typeface="Helvetica Neue"/>
+                <a:cs typeface="Helvetica Neue"/>
+              </a:defRPr>
+            </a:pPr>
+            <a:r>
+              <a:rPr sz="1600" b="0">
                 <a:solidFill>
                   <a:srgbClr val="000000"/>
                 </a:solidFill>
@@ -2373,7 +2466,36 @@
                 <a:ea typeface="Helvetica Neue"/>
                 <a:cs typeface="Helvetica Neue"/>
               </a:rPr>
-              <a:t>Arrival → Security → Immigration → full drain. Finite resources, queues and service completions are true discrete events.</a:t>
+              <a:t>Poisson arrivals → pooled FCFS Security → Immigration → full drain; empty and idle start.</a:t>
+            </a:r>
+          </a:p>
+          <a:p xmlns:a="http://schemas.openxmlformats.org/drawingml/2006/main">
+            <a:pPr algn="l">
+              <a:spcBef>
+                <a:spcPts val="0"/>
+              </a:spcBef>
+              <a:spcAft>
+                <a:spcPts val="0"/>
+              </a:spcAft>
+              <a:defRPr sz="1600">
+                <a:solidFill>
+                  <a:srgbClr val="000000"/>
+                </a:solidFill>
+                <a:latin typeface="Helvetica Neue"/>
+                <a:ea typeface="Helvetica Neue"/>
+                <a:cs typeface="Helvetica Neue"/>
+              </a:defRPr>
+            </a:pPr>
+            <a:r>
+              <a:rPr sz="1600" b="0">
+                <a:solidFill>
+                  <a:srgbClr val="000000"/>
+                </a:solidFill>
+                <a:latin typeface="Helvetica Neue"/>
+                <a:ea typeface="Helvetica Neue"/>
+                <a:cs typeface="Helvetica Neue"/>
+              </a:rPr>
+              <a:t>36 / 21 resources; fixed 21.82 / 13.0 s service. Four capacities × three rates; no site calibration.</a:t>
             </a:r>
           </a:p>
         </p:txBody>
@@ -2394,34 +2516,37 @@
         </p:nvSpPr>
         <p:spPr>
           <a:xfrm xmlns:a="http://schemas.openxmlformats.org/drawingml/2006/main">
-            <a:off x="399859" y="3822668"/>
-            <a:ext cx="3156109" cy="1586294"/>
+            <a:off x="393668" y="3238500"/>
+            <a:ext cx="3524250" cy="2667000"/>
           </a:xfrm>
           <a:prstGeom xmlns:a="http://schemas.openxmlformats.org/drawingml/2006/main" prst="rect">
             <a:avLst/>
           </a:prstGeom>
         </p:spPr>
         <p:txBody>
-          <a:bodyPr xmlns:a="http://schemas.openxmlformats.org/drawingml/2006/main" lIns="0" tIns="0" rIns="0" bIns="0">
+          <a:bodyPr xmlns:a="http://schemas.openxmlformats.org/drawingml/2006/main" lIns="0" tIns="0" rIns="0" bIns="0" anchor="t">
             <a:noAutofit/>
           </a:bodyPr>
           <a:lstStyle xmlns:a="http://schemas.openxmlformats.org/drawingml/2006/main"/>
           <a:p xmlns:a="http://schemas.openxmlformats.org/drawingml/2006/main">
             <a:pPr algn="l">
+              <a:spcBef>
+                <a:spcPts val="0"/>
+              </a:spcBef>
               <a:spcAft>
-                <a:spcPts val="500"/>
+                <a:spcPts val="8"/>
               </a:spcAft>
-              <a:defRPr sz="2400">
-                <a:solidFill>
-                  <a:srgbClr val="000000"/>
-                </a:solidFill>
-                <a:latin typeface="Helvetica Neue"/>
-                <a:ea typeface="Helvetica Neue"/>
-                <a:cs typeface="Helvetica Neue"/>
-              </a:defRPr>
-            </a:pPr>
-            <a:r>
-              <a:rPr sz="2100" b="1">
+              <a:defRPr sz="1600">
+                <a:solidFill>
+                  <a:srgbClr val="000000"/>
+                </a:solidFill>
+                <a:latin typeface="Helvetica Neue"/>
+                <a:ea typeface="Helvetica Neue"/>
+                <a:cs typeface="Helvetica Neue"/>
+              </a:defRPr>
+            </a:pPr>
+            <a:r>
+              <a:rPr sz="1875" b="1">
                 <a:solidFill>
                   <a:srgbClr val="000000"/>
                 </a:solidFill>
@@ -2429,26 +2554,28 @@
                 <a:ea typeface="Helvetica Neue"/>
                 <a:cs typeface="Helvetica Neue"/>
               </a:rPr>
-              <a:t>Candidates, then human ownership</a:t>
+              <a:t>The count is owned; its error is explicit</a:t>
             </a:r>
           </a:p>
           <a:p xmlns:a="http://schemas.openxmlformats.org/drawingml/2006/main">
             <a:pPr algn="l">
-              <a:lnSpc>
-                <a:spcPct val="112000"/>
-              </a:lnSpc>
-              <a:buNone/>
-              <a:defRPr sz="2400">
-                <a:solidFill>
-                  <a:srgbClr val="000000"/>
-                </a:solidFill>
-                <a:latin typeface="Helvetica Neue"/>
-                <a:ea typeface="Helvetica Neue"/>
-                <a:cs typeface="Helvetica Neue"/>
-              </a:defRPr>
-            </a:pPr>
-            <a:r>
-              <a:rPr sz="1350">
+              <a:spcBef>
+                <a:spcPts val="0"/>
+              </a:spcBef>
+              <a:spcAft>
+                <a:spcPts val="8"/>
+              </a:spcAft>
+              <a:defRPr sz="1600">
+                <a:solidFill>
+                  <a:srgbClr val="000000"/>
+                </a:solidFill>
+                <a:latin typeface="Helvetica Neue"/>
+                <a:ea typeface="Helvetica Neue"/>
+                <a:cs typeface="Helvetica Neue"/>
+              </a:defRPr>
+            </a:pPr>
+            <a:r>
+              <a:rPr sz="1600" b="0">
                 <a:solidFill>
                   <a:srgbClr val="000000"/>
                 </a:solidFill>
@@ -2456,7 +2583,36 @@
                 <a:ea typeface="Helvetica Neue"/>
                 <a:cs typeface="Helvetica Neue"/>
               </a:rPr>
-              <a:t>YOLO26m + BoT-SORT generates candidates; YOLOX-S + ByteTrack cross-checks. Human adjudication owns 12 L→R / 34 R→L.</a:t>
+              <a:t>Accepted: 12 L→R / 34 R→L. Arrival anchor: 34 ÷ 24.9228 s = 1.364/s.</a:t>
+            </a:r>
+          </a:p>
+          <a:p xmlns:a="http://schemas.openxmlformats.org/drawingml/2006/main">
+            <a:pPr algn="l">
+              <a:spcBef>
+                <a:spcPts val="0"/>
+              </a:spcBef>
+              <a:spcAft>
+                <a:spcPts val="0"/>
+              </a:spcAft>
+              <a:defRPr sz="1600">
+                <a:solidFill>
+                  <a:srgbClr val="000000"/>
+                </a:solidFill>
+                <a:latin typeface="Helvetica Neue"/>
+                <a:ea typeface="Helvetica Neue"/>
+                <a:cs typeface="Helvetica Neue"/>
+              </a:defRPr>
+            </a:pPr>
+            <a:r>
+              <a:rPr sz="1600" b="0">
+                <a:solidFill>
+                  <a:srgbClr val="000000"/>
+                </a:solidFill>
+                <a:latin typeface="Helvetica Neue"/>
+                <a:ea typeface="Helvetica Neue"/>
+                <a:cs typeface="Helvetica Neue"/>
+              </a:rPr>
+              <a:t>Exact conditional HPP 95% interval: 0.945–1.906/s. It excludes adjudication and time-of-day error.</a:t>
             </a:r>
           </a:p>
         </p:txBody>
@@ -2477,34 +2633,37 @@
         </p:nvSpPr>
         <p:spPr>
           <a:xfrm xmlns:a="http://schemas.openxmlformats.org/drawingml/2006/main">
-            <a:off x="8177879" y="3822668"/>
-            <a:ext cx="3156109" cy="1586294"/>
+            <a:off x="8229600" y="3238500"/>
+            <a:ext cx="3524250" cy="2667000"/>
           </a:xfrm>
           <a:prstGeom xmlns:a="http://schemas.openxmlformats.org/drawingml/2006/main" prst="rect">
             <a:avLst/>
           </a:prstGeom>
         </p:spPr>
         <p:txBody>
-          <a:bodyPr xmlns:a="http://schemas.openxmlformats.org/drawingml/2006/main" lIns="0" tIns="0" rIns="0" bIns="0">
+          <a:bodyPr xmlns:a="http://schemas.openxmlformats.org/drawingml/2006/main" lIns="0" tIns="0" rIns="0" bIns="0" anchor="t">
             <a:noAutofit/>
           </a:bodyPr>
           <a:lstStyle xmlns:a="http://schemas.openxmlformats.org/drawingml/2006/main"/>
           <a:p xmlns:a="http://schemas.openxmlformats.org/drawingml/2006/main">
             <a:pPr algn="l">
+              <a:spcBef>
+                <a:spcPts val="0"/>
+              </a:spcBef>
               <a:spcAft>
-                <a:spcPts val="500"/>
+                <a:spcPts val="8"/>
               </a:spcAft>
-              <a:defRPr sz="2400">
-                <a:solidFill>
-                  <a:srgbClr val="000000"/>
-                </a:solidFill>
-                <a:latin typeface="Helvetica Neue"/>
-                <a:ea typeface="Helvetica Neue"/>
-                <a:cs typeface="Helvetica Neue"/>
-              </a:defRPr>
-            </a:pPr>
-            <a:r>
-              <a:rPr sz="2100" b="1">
+              <a:defRPr sz="1600">
+                <a:solidFill>
+                  <a:srgbClr val="000000"/>
+                </a:solidFill>
+                <a:latin typeface="Helvetica Neue"/>
+                <a:ea typeface="Helvetica Neue"/>
+                <a:cs typeface="Helvetica Neue"/>
+              </a:defRPr>
+            </a:pPr>
+            <a:r>
+              <a:rPr sz="1875" b="1">
                 <a:solidFill>
                   <a:srgbClr val="000000"/>
                 </a:solidFill>
@@ -2512,26 +2671,28 @@
                 <a:ea typeface="Helvetica Neue"/>
                 <a:cs typeface="Helvetica Neue"/>
               </a:rPr>
-              <a:t>Replications—not animation—support claims</a:t>
+              <a:t>One question is confirmatory</a:t>
             </a:r>
           </a:p>
           <a:p xmlns:a="http://schemas.openxmlformats.org/drawingml/2006/main">
             <a:pPr algn="l">
-              <a:lnSpc>
-                <a:spcPct val="112000"/>
-              </a:lnSpc>
-              <a:buNone/>
-              <a:defRPr sz="2400">
-                <a:solidFill>
-                  <a:srgbClr val="000000"/>
-                </a:solidFill>
-                <a:latin typeface="Helvetica Neue"/>
-                <a:ea typeface="Helvetica Neue"/>
-                <a:cs typeface="Helvetica Neue"/>
-              </a:defRPr>
-            </a:pPr>
-            <a:r>
-              <a:rPr sz="1350">
+              <a:spcBef>
+                <a:spcPts val="0"/>
+              </a:spcBef>
+              <a:spcAft>
+                <a:spcPts val="8"/>
+              </a:spcAft>
+              <a:defRPr sz="1600">
+                <a:solidFill>
+                  <a:srgbClr val="000000"/>
+                </a:solidFill>
+                <a:latin typeface="Helvetica Neue"/>
+                <a:ea typeface="Helvetica Neue"/>
+                <a:cs typeface="Helvetica Neue"/>
+              </a:defRPr>
+            </a:pPr>
+            <a:r>
+              <a:rPr sz="1600" b="0">
                 <a:solidFill>
                   <a:srgbClr val="000000"/>
                 </a:solidFill>
@@ -2539,7 +2700,36 @@
                 <a:ea typeface="Helvetica Neue"/>
                 <a:cs typeface="Helvetica Neue"/>
               </a:rPr>
-              <a:t>Seeded runs yield replication-level P95, cutoff WIP, clear time and confidence intervals with explicit claim boundaries.</a:t>
+              <a:t>12 cells × 50 = 600 serial runs. Frozen 150 CRN groups align travellers and branch-invariant draws.</a:t>
+            </a:r>
+          </a:p>
+          <a:p xmlns:a="http://schemas.openxmlformats.org/drawingml/2006/main">
+            <a:pPr algn="l">
+              <a:spcBef>
+                <a:spcPts val="0"/>
+              </a:spcBef>
+              <a:spcAft>
+                <a:spcPts val="0"/>
+              </a:spcAft>
+              <a:defRPr sz="1600">
+                <a:solidFill>
+                  <a:srgbClr val="000000"/>
+                </a:solidFill>
+                <a:latin typeface="Helvetica Neue"/>
+                <a:ea typeface="Helvetica Neue"/>
+                <a:cs typeface="Helvetica Neue"/>
+              </a:defRPr>
+            </a:pPr>
+            <a:r>
+              <a:rPr sz="1600" b="0">
+                <a:solidFill>
+                  <a:srgbClr val="000000"/>
+                </a:solidFill>
+                <a:latin typeface="Helvetica Neue"/>
+                <a:ea typeface="Helvetica Neue"/>
+                <a:cs typeface="Helvetica Neue"/>
+              </a:rPr>
+              <a:t>Paired only after CRN PASS. Primary: base-rate joint +4/+3 versus reference.</a:t>
             </a:r>
           </a:p>
         </p:txBody>
@@ -2582,8 +2772,8 @@
         </p:nvSpPr>
         <p:spPr>
           <a:xfrm xmlns:a="http://schemas.openxmlformats.org/drawingml/2006/main">
-            <a:off x="393668" y="3022568"/>
-            <a:ext cx="3568732" cy="2971800"/>
+            <a:off x="393668" y="3143250"/>
+            <a:ext cx="3568732" cy="2762250"/>
           </a:xfrm>
           <a:prstGeom xmlns:a="http://schemas.openxmlformats.org/drawingml/2006/main" prst="roundRect">
             <a:avLst>
@@ -2611,8 +2801,8 @@
         </p:nvSpPr>
         <p:spPr>
           <a:xfrm xmlns:a="http://schemas.openxmlformats.org/drawingml/2006/main">
-            <a:off x="4311682" y="3022568"/>
-            <a:ext cx="3568732" cy="2971800"/>
+            <a:off x="4311682" y="3143250"/>
+            <a:ext cx="3568732" cy="2762250"/>
           </a:xfrm>
           <a:prstGeom xmlns:a="http://schemas.openxmlformats.org/drawingml/2006/main" prst="roundRect">
             <a:avLst>
@@ -2640,8 +2830,8 @@
         </p:nvSpPr>
         <p:spPr>
           <a:xfrm xmlns:a="http://schemas.openxmlformats.org/drawingml/2006/main">
-            <a:off x="8232267" y="3022568"/>
-            <a:ext cx="3568732" cy="2971800"/>
+            <a:off x="8232267" y="3143250"/>
+            <a:ext cx="3568732" cy="2762250"/>
           </a:xfrm>
           <a:prstGeom xmlns:a="http://schemas.openxmlformats.org/drawingml/2006/main" prst="roundRect">
             <a:avLst>
@@ -2681,6 +2871,7 @@
           <a:lstStyle xmlns:a="http://schemas.openxmlformats.org/drawingml/2006/main"/>
           <a:p xmlns:a="http://schemas.openxmlformats.org/drawingml/2006/main">
             <a:pPr algn="r">
+              <a:buNone/>
               <a:defRPr sz="1000">
                 <a:solidFill>
                   <a:srgbClr val="000000"/>
@@ -2712,8 +2903,8 @@
         </p:nvSpPr>
         <p:spPr>
           <a:xfrm xmlns:a="http://schemas.openxmlformats.org/drawingml/2006/main">
-            <a:off x="393668" y="344043"/>
-            <a:ext cx="11404568" cy="1047464"/>
+            <a:off x="393668" y="323850"/>
+            <a:ext cx="11404568" cy="742950"/>
           </a:xfrm>
           <a:prstGeom xmlns:a="http://schemas.openxmlformats.org/drawingml/2006/main" prst="rect">
             <a:avLst/>
@@ -2721,22 +2912,31 @@
         </p:spPr>
         <p:txBody>
           <a:bodyPr xmlns:a="http://schemas.openxmlformats.org/drawingml/2006/main" lIns="0" tIns="0" rIns="0" bIns="0" anchor="t">
-            <a:normAutofit fontScale="100000"/>
+            <a:noAutofit/>
           </a:bodyPr>
           <a:lstStyle xmlns:a="http://schemas.openxmlformats.org/drawingml/2006/main"/>
           <a:p xmlns:a="http://schemas.openxmlformats.org/drawingml/2006/main">
             <a:pPr algn="l">
-              <a:defRPr sz="2900">
-                <a:solidFill>
-                  <a:srgbClr val="000000"/>
-                </a:solidFill>
-                <a:latin typeface="Helvetica Neue"/>
-                <a:ea typeface="Helvetica Neue"/>
-                <a:cs typeface="Helvetica Neue"/>
-              </a:defRPr>
-            </a:pPr>
-            <a:r>
-              <a:t>The reference is stable because its assumptions provide headroom</a:t>
+              <a:buNone/>
+              <a:defRPr sz="3200" b="0">
+                <a:solidFill>
+                  <a:srgbClr val="000000"/>
+                </a:solidFill>
+                <a:latin typeface="Helvetica Neue"/>
+                <a:ea typeface="Helvetica Neue"/>
+                <a:cs typeface="Helvetica Neue"/>
+              </a:defRPr>
+            </a:pPr>
+            <a:r>
+              <a:rPr sz="3200" b="0">
+                <a:solidFill>
+                  <a:srgbClr val="000000"/>
+                </a:solidFill>
+                <a:latin typeface="Helvetica Neue"/>
+                <a:ea typeface="Helvetica Neue"/>
+                <a:cs typeface="Helvetica Neue"/>
+              </a:rPr>
+              <a:t>The 600-run claim is predeclared, paired and auditable</a:t>
             </a:r>
           </a:p>
         </p:txBody>
@@ -2757,16 +2957,16 @@
         </p:nvSpPr>
         <p:spPr>
           <a:xfrm xmlns:a="http://schemas.openxmlformats.org/drawingml/2006/main">
-            <a:off x="702374" y="4900613"/>
-            <a:ext cx="2949607" cy="819150"/>
+            <a:off x="702374" y="4714875"/>
+            <a:ext cx="2949607" cy="1047750"/>
           </a:xfrm>
           <a:prstGeom xmlns:a="http://schemas.openxmlformats.org/drawingml/2006/main" prst="rect">
             <a:avLst/>
           </a:prstGeom>
         </p:spPr>
         <p:txBody>
-          <a:bodyPr xmlns:a="http://schemas.openxmlformats.org/drawingml/2006/main" lIns="91440" tIns="45720" rIns="91440" bIns="45720">
-            <a:normAutofit fontScale="100000"/>
+          <a:bodyPr xmlns:a="http://schemas.openxmlformats.org/drawingml/2006/main" lIns="0" tIns="0" rIns="0" bIns="0" anchor="t">
+            <a:noAutofit/>
           </a:bodyPr>
           <a:lstStyle xmlns:a="http://schemas.openxmlformats.org/drawingml/2006/main"/>
           <a:p xmlns:a="http://schemas.openxmlformats.org/drawingml/2006/main">
@@ -2775,17 +2975,17 @@
                 <a:spcPct val="112000"/>
               </a:lnSpc>
               <a:buNone/>
-              <a:defRPr sz="2400">
-                <a:solidFill>
-                  <a:srgbClr val="000000"/>
-                </a:solidFill>
-                <a:latin typeface="Helvetica Neue"/>
-                <a:ea typeface="Helvetica Neue"/>
-                <a:cs typeface="Helvetica Neue"/>
-              </a:defRPr>
-            </a:pPr>
-            <a:r>
-              <a:rPr sz="1350">
+              <a:defRPr sz="1600" b="0">
+                <a:solidFill>
+                  <a:srgbClr val="000000"/>
+                </a:solidFill>
+                <a:latin typeface="Helvetica Neue"/>
+                <a:ea typeface="Helvetica Neue"/>
+                <a:cs typeface="Helvetica Neue"/>
+              </a:defRPr>
+            </a:pPr>
+            <a:r>
+              <a:rPr sz="1600" b="0">
                 <a:solidFill>
                   <a:srgbClr val="000000"/>
                 </a:solidFill>
@@ -2793,8 +2993,61 @@
                 <a:ea typeface="Helvetica Neue"/>
                 <a:cs typeface="Helvetica Neue"/>
               </a:rPr>
-              <a:t>Total queue-wait P95
-95% CI 2.92–4.12</a:t>
+              <a:t>12 cells × 50 replications</a:t>
+            </a:r>
+          </a:p>
+          <a:p xmlns:a="http://schemas.openxmlformats.org/drawingml/2006/main">
+            <a:pPr algn="l">
+              <a:lnSpc>
+                <a:spcPct val="112000"/>
+              </a:lnSpc>
+              <a:buNone/>
+              <a:defRPr sz="1600" b="0">
+                <a:solidFill>
+                  <a:srgbClr val="000000"/>
+                </a:solidFill>
+                <a:latin typeface="Helvetica Neue"/>
+                <a:ea typeface="Helvetica Neue"/>
+                <a:cs typeface="Helvetica Neue"/>
+              </a:defRPr>
+            </a:pPr>
+            <a:r>
+              <a:rPr sz="1600" b="0">
+                <a:solidFill>
+                  <a:srgbClr val="000000"/>
+                </a:solidFill>
+                <a:latin typeface="Helvetica Neue"/>
+                <a:ea typeface="Helvetica Neue"/>
+                <a:cs typeface="Helvetica Neue"/>
+              </a:rPr>
+              <a:t>253,756 traveller rows</a:t>
+            </a:r>
+          </a:p>
+          <a:p xmlns:a="http://schemas.openxmlformats.org/drawingml/2006/main">
+            <a:pPr algn="l">
+              <a:lnSpc>
+                <a:spcPct val="112000"/>
+              </a:lnSpc>
+              <a:buNone/>
+              <a:defRPr sz="1600" b="0">
+                <a:solidFill>
+                  <a:srgbClr val="000000"/>
+                </a:solidFill>
+                <a:latin typeface="Helvetica Neue"/>
+                <a:ea typeface="Helvetica Neue"/>
+                <a:cs typeface="Helvetica Neue"/>
+              </a:defRPr>
+            </a:pPr>
+            <a:r>
+              <a:rPr sz="1600" b="0">
+                <a:solidFill>
+                  <a:srgbClr val="000000"/>
+                </a:solidFill>
+                <a:latin typeface="Helvetica Neue"/>
+                <a:ea typeface="Helvetica Neue"/>
+                <a:cs typeface="Helvetica Neue"/>
+              </a:rPr>
+              <a:t>strict coverage PASS</a:t>
             </a:r>
           </a:p>
         </p:txBody>
@@ -2815,16 +3068,16 @@
         </p:nvSpPr>
         <p:spPr>
           <a:xfrm xmlns:a="http://schemas.openxmlformats.org/drawingml/2006/main">
-            <a:off x="8541830" y="4900613"/>
-            <a:ext cx="2949607" cy="819150"/>
+            <a:off x="8541830" y="4714875"/>
+            <a:ext cx="2949607" cy="1047750"/>
           </a:xfrm>
           <a:prstGeom xmlns:a="http://schemas.openxmlformats.org/drawingml/2006/main" prst="rect">
             <a:avLst/>
           </a:prstGeom>
         </p:spPr>
         <p:txBody>
-          <a:bodyPr xmlns:a="http://schemas.openxmlformats.org/drawingml/2006/main" lIns="91440" tIns="45720" rIns="91440" bIns="45720">
-            <a:normAutofit fontScale="100000"/>
+          <a:bodyPr xmlns:a="http://schemas.openxmlformats.org/drawingml/2006/main" lIns="0" tIns="0" rIns="0" bIns="0" anchor="t">
+            <a:noAutofit/>
           </a:bodyPr>
           <a:lstStyle xmlns:a="http://schemas.openxmlformats.org/drawingml/2006/main"/>
           <a:p xmlns:a="http://schemas.openxmlformats.org/drawingml/2006/main">
@@ -2833,17 +3086,17 @@
                 <a:spcPct val="112000"/>
               </a:lnSpc>
               <a:buNone/>
-              <a:defRPr sz="2400">
-                <a:solidFill>
-                  <a:srgbClr val="000000"/>
-                </a:solidFill>
-                <a:latin typeface="Helvetica Neue"/>
-                <a:ea typeface="Helvetica Neue"/>
-                <a:cs typeface="Helvetica Neue"/>
-              </a:defRPr>
-            </a:pPr>
-            <a:r>
-              <a:rPr sz="1350">
+              <a:defRPr sz="1600" b="0">
+                <a:solidFill>
+                  <a:srgbClr val="000000"/>
+                </a:solidFill>
+                <a:latin typeface="Helvetica Neue"/>
+                <a:ea typeface="Helvetica Neue"/>
+                <a:cs typeface="Helvetica Neue"/>
+              </a:defRPr>
+            </a:pPr>
+            <a:r>
+              <a:rPr sz="1600" b="0">
                 <a:solidFill>
                   <a:srgbClr val="000000"/>
                 </a:solidFill>
@@ -2851,8 +3104,61 @@
                 <a:ea typeface="Helvetica Neue"/>
                 <a:cs typeface="Helvetica Neue"/>
               </a:rPr>
-              <a:t>Clear after 300 s cutoff
-95% CI 34.1–36.5</a:t>
+              <a:t>Actual 95% half-width</a:t>
+            </a:r>
+          </a:p>
+          <a:p xmlns:a="http://schemas.openxmlformats.org/drawingml/2006/main">
+            <a:pPr algn="l">
+              <a:lnSpc>
+                <a:spcPct val="112000"/>
+              </a:lnSpc>
+              <a:buNone/>
+              <a:defRPr sz="1600" b="0">
+                <a:solidFill>
+                  <a:srgbClr val="000000"/>
+                </a:solidFill>
+                <a:latin typeface="Helvetica Neue"/>
+                <a:ea typeface="Helvetica Neue"/>
+                <a:cs typeface="Helvetica Neue"/>
+              </a:defRPr>
+            </a:pPr>
+            <a:r>
+              <a:rPr sz="1600" b="0">
+                <a:solidFill>
+                  <a:srgbClr val="000000"/>
+                </a:solidFill>
+                <a:latin typeface="Helvetica Neue"/>
+                <a:ea typeface="Helvetica Neue"/>
+                <a:cs typeface="Helvetica Neue"/>
+              </a:rPr>
+              <a:t>target ≤ 1.0 s</a:t>
+            </a:r>
+          </a:p>
+          <a:p xmlns:a="http://schemas.openxmlformats.org/drawingml/2006/main">
+            <a:pPr algn="l">
+              <a:lnSpc>
+                <a:spcPct val="112000"/>
+              </a:lnSpc>
+              <a:buNone/>
+              <a:defRPr sz="1600" b="0">
+                <a:solidFill>
+                  <a:srgbClr val="000000"/>
+                </a:solidFill>
+                <a:latin typeface="Helvetica Neue"/>
+                <a:ea typeface="Helvetica Neue"/>
+                <a:cs typeface="Helvetica Neue"/>
+              </a:defRPr>
+            </a:pPr>
+            <a:r>
+              <a:rPr sz="1600" b="0">
+                <a:solidFill>
+                  <a:srgbClr val="000000"/>
+                </a:solidFill>
+                <a:latin typeface="Helvetica Neue"/>
+                <a:ea typeface="Helvetica Neue"/>
+                <a:cs typeface="Helvetica Neue"/>
+              </a:rPr>
+              <a:t>no post-hoc runs</a:t>
             </a:r>
           </a:p>
         </p:txBody>
@@ -2873,16 +3179,16 @@
         </p:nvSpPr>
         <p:spPr>
           <a:xfrm xmlns:a="http://schemas.openxmlformats.org/drawingml/2006/main">
-            <a:off x="4621244" y="4900613"/>
-            <a:ext cx="2949607" cy="819150"/>
+            <a:off x="4621244" y="4714875"/>
+            <a:ext cx="2949607" cy="1047750"/>
           </a:xfrm>
           <a:prstGeom xmlns:a="http://schemas.openxmlformats.org/drawingml/2006/main" prst="rect">
             <a:avLst/>
           </a:prstGeom>
         </p:spPr>
         <p:txBody>
-          <a:bodyPr xmlns:a="http://schemas.openxmlformats.org/drawingml/2006/main" lIns="91440" tIns="45720" rIns="91440" bIns="45720">
-            <a:normAutofit fontScale="100000"/>
+          <a:bodyPr xmlns:a="http://schemas.openxmlformats.org/drawingml/2006/main" lIns="0" tIns="0" rIns="0" bIns="0" anchor="t">
+            <a:noAutofit/>
           </a:bodyPr>
           <a:lstStyle xmlns:a="http://schemas.openxmlformats.org/drawingml/2006/main"/>
           <a:p xmlns:a="http://schemas.openxmlformats.org/drawingml/2006/main">
@@ -2891,17 +3197,17 @@
                 <a:spcPct val="112000"/>
               </a:lnSpc>
               <a:buNone/>
-              <a:defRPr sz="2400">
-                <a:solidFill>
-                  <a:srgbClr val="000000"/>
-                </a:solidFill>
-                <a:latin typeface="Helvetica Neue"/>
-                <a:ea typeface="Helvetica Neue"/>
-                <a:cs typeface="Helvetica Neue"/>
-              </a:defRPr>
-            </a:pPr>
-            <a:r>
-              <a:rPr sz="1350">
+              <a:defRPr sz="1600" b="0">
+                <a:solidFill>
+                  <a:srgbClr val="000000"/>
+                </a:solidFill>
+                <a:latin typeface="Helvetica Neue"/>
+                <a:ea typeface="Helvetica Neue"/>
+                <a:cs typeface="Helvetica Neue"/>
+              </a:defRPr>
+            </a:pPr>
+            <a:r>
+              <a:rPr sz="1600" b="0">
                 <a:solidFill>
                   <a:srgbClr val="000000"/>
                 </a:solidFill>
@@ -2909,7 +3215,61 @@
                 <a:ea typeface="Helvetica Neue"/>
                 <a:cs typeface="Helvetica Neue"/>
               </a:rPr>
-              <a:t>Security / Immigration utilization</a:t>
+              <a:t>150 pairing groups</a:t>
+            </a:r>
+          </a:p>
+          <a:p xmlns:a="http://schemas.openxmlformats.org/drawingml/2006/main">
+            <a:pPr algn="l">
+              <a:lnSpc>
+                <a:spcPct val="112000"/>
+              </a:lnSpc>
+              <a:buNone/>
+              <a:defRPr sz="1600" b="0">
+                <a:solidFill>
+                  <a:srgbClr val="000000"/>
+                </a:solidFill>
+                <a:latin typeface="Helvetica Neue"/>
+                <a:ea typeface="Helvetica Neue"/>
+                <a:cs typeface="Helvetica Neue"/>
+              </a:defRPr>
+            </a:pPr>
+            <a:r>
+              <a:rPr sz="1600" b="0">
+                <a:solidFill>
+                  <a:srgbClr val="000000"/>
+                </a:solidFill>
+                <a:latin typeface="Helvetica Neue"/>
+                <a:ea typeface="Helvetica Neue"/>
+                <a:cs typeface="Helvetica Neue"/>
+              </a:rPr>
+              <a:t>1,141,902 draw checks</a:t>
+            </a:r>
+          </a:p>
+          <a:p xmlns:a="http://schemas.openxmlformats.org/drawingml/2006/main">
+            <a:pPr algn="l">
+              <a:lnSpc>
+                <a:spcPct val="112000"/>
+              </a:lnSpc>
+              <a:buNone/>
+              <a:defRPr sz="1600" b="0">
+                <a:solidFill>
+                  <a:srgbClr val="000000"/>
+                </a:solidFill>
+                <a:latin typeface="Helvetica Neue"/>
+                <a:ea typeface="Helvetica Neue"/>
+                <a:cs typeface="Helvetica Neue"/>
+              </a:defRPr>
+            </a:pPr>
+            <a:r>
+              <a:rPr sz="1600" b="0">
+                <a:solidFill>
+                  <a:srgbClr val="000000"/>
+                </a:solidFill>
+                <a:latin typeface="Helvetica Neue"/>
+                <a:ea typeface="Helvetica Neue"/>
+                <a:cs typeface="Helvetica Neue"/>
+              </a:rPr>
+              <a:t>paired t authorised</a:t>
             </a:r>
           </a:p>
         </p:txBody>
@@ -2930,31 +3290,32 @@
         </p:nvSpPr>
         <p:spPr>
           <a:xfrm xmlns:a="http://schemas.openxmlformats.org/drawingml/2006/main">
-            <a:off x="702374" y="3429000"/>
-            <a:ext cx="2940082" cy="1359313"/>
+            <a:off x="702374" y="3524250"/>
+            <a:ext cx="2940082" cy="1047750"/>
           </a:xfrm>
           <a:prstGeom xmlns:a="http://schemas.openxmlformats.org/drawingml/2006/main" prst="rect">
             <a:avLst/>
           </a:prstGeom>
         </p:spPr>
         <p:txBody>
-          <a:bodyPr xmlns:a="http://schemas.openxmlformats.org/drawingml/2006/main" lIns="0" tIns="0" rIns="0" bIns="0" anchor="b">
-            <a:normAutofit fontScale="100000"/>
+          <a:bodyPr xmlns:a="http://schemas.openxmlformats.org/drawingml/2006/main" lIns="0" tIns="0" rIns="0" bIns="0" anchor="ctr">
+            <a:noAutofit/>
           </a:bodyPr>
           <a:lstStyle xmlns:a="http://schemas.openxmlformats.org/drawingml/2006/main"/>
           <a:p xmlns:a="http://schemas.openxmlformats.org/drawingml/2006/main">
             <a:pPr algn="l">
-              <a:defRPr sz="2400">
-                <a:solidFill>
-                  <a:srgbClr val="000000"/>
-                </a:solidFill>
-                <a:latin typeface="Helvetica Neue"/>
-                <a:ea typeface="Helvetica Neue"/>
-                <a:cs typeface="Helvetica Neue"/>
-              </a:defRPr>
-            </a:pPr>
-            <a:r>
-              <a:rPr sz="4050" b="1">
+              <a:buNone/>
+              <a:defRPr sz="4125" b="1">
+                <a:solidFill>
+                  <a:srgbClr val="000000"/>
+                </a:solidFill>
+                <a:latin typeface="Helvetica Neue"/>
+                <a:ea typeface="Helvetica Neue"/>
+                <a:cs typeface="Helvetica Neue"/>
+              </a:defRPr>
+            </a:pPr>
+            <a:r>
+              <a:rPr sz="4125" b="1">
                 <a:solidFill>
                   <a:srgbClr val="000000"/>
                 </a:solidFill>
@@ -2962,7 +3323,7 @@
                 <a:ea typeface="Helvetica Neue"/>
                 <a:cs typeface="Helvetica Neue"/>
               </a:rPr>
-              <a:t>3.52 s</a:t>
+              <a:t>600 / 600</a:t>
             </a:r>
           </a:p>
         </p:txBody>
@@ -2983,31 +3344,32 @@
         </p:nvSpPr>
         <p:spPr>
           <a:xfrm xmlns:a="http://schemas.openxmlformats.org/drawingml/2006/main">
-            <a:off x="4612958" y="3429000"/>
-            <a:ext cx="2940082" cy="1359313"/>
+            <a:off x="4612958" y="3524250"/>
+            <a:ext cx="2940082" cy="1047750"/>
           </a:xfrm>
           <a:prstGeom xmlns:a="http://schemas.openxmlformats.org/drawingml/2006/main" prst="rect">
             <a:avLst/>
           </a:prstGeom>
         </p:spPr>
         <p:txBody>
-          <a:bodyPr xmlns:a="http://schemas.openxmlformats.org/drawingml/2006/main" lIns="0" tIns="0" rIns="0" bIns="0" anchor="b">
-            <a:normAutofit fontScale="100000"/>
+          <a:bodyPr xmlns:a="http://schemas.openxmlformats.org/drawingml/2006/main" lIns="0" tIns="0" rIns="0" bIns="0" anchor="ctr">
+            <a:noAutofit/>
           </a:bodyPr>
           <a:lstStyle xmlns:a="http://schemas.openxmlformats.org/drawingml/2006/main"/>
           <a:p xmlns:a="http://schemas.openxmlformats.org/drawingml/2006/main">
             <a:pPr algn="l">
-              <a:defRPr sz="2400">
-                <a:solidFill>
-                  <a:srgbClr val="000000"/>
-                </a:solidFill>
-                <a:latin typeface="Helvetica Neue"/>
-                <a:ea typeface="Helvetica Neue"/>
-                <a:cs typeface="Helvetica Neue"/>
-              </a:defRPr>
-            </a:pPr>
-            <a:r>
-              <a:rPr sz="4050" b="1">
+              <a:buNone/>
+              <a:defRPr sz="3750" b="1">
+                <a:solidFill>
+                  <a:srgbClr val="000000"/>
+                </a:solidFill>
+                <a:latin typeface="Helvetica Neue"/>
+                <a:ea typeface="Helvetica Neue"/>
+                <a:cs typeface="Helvetica Neue"/>
+              </a:defRPr>
+            </a:pPr>
+            <a:r>
+              <a:rPr sz="3750" b="1">
                 <a:solidFill>
                   <a:srgbClr val="000000"/>
                 </a:solidFill>
@@ -3015,7 +3377,7 @@
                 <a:ea typeface="Helvetica Neue"/>
                 <a:cs typeface="Helvetica Neue"/>
               </a:rPr>
-              <a:t>74 / 75.6%</a:t>
+              <a:t>CRN PASS</a:t>
             </a:r>
           </a:p>
         </p:txBody>
@@ -3036,31 +3398,32 @@
         </p:nvSpPr>
         <p:spPr>
           <a:xfrm xmlns:a="http://schemas.openxmlformats.org/drawingml/2006/main">
-            <a:off x="8562404" y="3429000"/>
-            <a:ext cx="2940082" cy="1359313"/>
+            <a:off x="8562404" y="3524250"/>
+            <a:ext cx="2940082" cy="1047750"/>
           </a:xfrm>
           <a:prstGeom xmlns:a="http://schemas.openxmlformats.org/drawingml/2006/main" prst="rect">
             <a:avLst/>
           </a:prstGeom>
         </p:spPr>
         <p:txBody>
-          <a:bodyPr xmlns:a="http://schemas.openxmlformats.org/drawingml/2006/main" lIns="0" tIns="0" rIns="0" bIns="0" anchor="b">
-            <a:normAutofit fontScale="100000"/>
+          <a:bodyPr xmlns:a="http://schemas.openxmlformats.org/drawingml/2006/main" lIns="0" tIns="0" rIns="0" bIns="0" anchor="ctr">
+            <a:noAutofit/>
           </a:bodyPr>
           <a:lstStyle xmlns:a="http://schemas.openxmlformats.org/drawingml/2006/main"/>
           <a:p xmlns:a="http://schemas.openxmlformats.org/drawingml/2006/main">
             <a:pPr algn="l">
-              <a:defRPr sz="2400">
-                <a:solidFill>
-                  <a:srgbClr val="000000"/>
-                </a:solidFill>
-                <a:latin typeface="Helvetica Neue"/>
-                <a:ea typeface="Helvetica Neue"/>
-                <a:cs typeface="Helvetica Neue"/>
-              </a:defRPr>
-            </a:pPr>
-            <a:r>
-              <a:rPr sz="4050" b="1">
+              <a:buNone/>
+              <a:defRPr sz="4125" b="1">
+                <a:solidFill>
+                  <a:srgbClr val="000000"/>
+                </a:solidFill>
+                <a:latin typeface="Helvetica Neue"/>
+                <a:ea typeface="Helvetica Neue"/>
+                <a:cs typeface="Helvetica Neue"/>
+              </a:defRPr>
+            </a:pPr>
+            <a:r>
+              <a:rPr sz="4125" b="1">
                 <a:solidFill>
                   <a:srgbClr val="000000"/>
                 </a:solidFill>
@@ -3068,7 +3431,7 @@
                 <a:ea typeface="Helvetica Neue"/>
                 <a:cs typeface="Helvetica Neue"/>
               </a:rPr>
-              <a:t>35.3 s</a:t>
+              <a:t>0.382 s</a:t>
             </a:r>
           </a:p>
         </p:txBody>
@@ -3089,22 +3452,25 @@
         </p:nvSpPr>
         <p:spPr>
           <a:xfrm xmlns:a="http://schemas.openxmlformats.org/drawingml/2006/main">
-            <a:off x="393668" y="1138333"/>
-            <a:ext cx="11404568" cy="1599438"/>
+            <a:off x="393668" y="1104900"/>
+            <a:ext cx="11404568" cy="1809750"/>
           </a:xfrm>
           <a:prstGeom xmlns:a="http://schemas.openxmlformats.org/drawingml/2006/main" prst="rect">
             <a:avLst/>
           </a:prstGeom>
         </p:spPr>
         <p:txBody>
-          <a:bodyPr xmlns:a="http://schemas.openxmlformats.org/drawingml/2006/main" lIns="0" tIns="0" rIns="0" bIns="0">
+          <a:bodyPr xmlns:a="http://schemas.openxmlformats.org/drawingml/2006/main" lIns="0" tIns="0" rIns="0" bIns="0" anchor="t">
             <a:noAutofit/>
           </a:bodyPr>
           <a:lstStyle xmlns:a="http://schemas.openxmlformats.org/drawingml/2006/main"/>
           <a:p xmlns:a="http://schemas.openxmlformats.org/drawingml/2006/main">
             <a:pPr algn="l">
+              <a:spcBef>
+                <a:spcPts val="0"/>
+              </a:spcBef>
               <a:spcAft>
-                <a:spcPts val="500"/>
+                <a:spcPts val="7"/>
               </a:spcAft>
               <a:defRPr sz="1600">
                 <a:solidFill>
@@ -3124,15 +3490,17 @@
                 <a:ea typeface="Helvetica Neue"/>
                 <a:cs typeface="Helvetica Neue"/>
               </a:rPr>
-              <a:t>REFERENCE ≠ OBSERVED BASELINE</a:t>
+              <a:t>ONE PRIMARY CONTRAST · FIXED N · NO POST-HOC EXTENSION</a:t>
             </a:r>
           </a:p>
           <a:p xmlns:a="http://schemas.openxmlformats.org/drawingml/2006/main">
             <a:pPr algn="l">
-              <a:lnSpc>
-                <a:spcPct val="112000"/>
-              </a:lnSpc>
-              <a:buNone/>
+              <a:spcBef>
+                <a:spcPts val="0"/>
+              </a:spcBef>
+              <a:spcAft>
+                <a:spcPts val="7"/>
+              </a:spcAft>
               <a:defRPr sz="1600">
                 <a:solidFill>
                   <a:srgbClr val="000000"/>
@@ -3143,7 +3511,7 @@
               </a:defRPr>
             </a:pPr>
             <a:r>
-              <a:rPr sz="1425">
+              <a:rPr sz="1600" b="0">
                 <a:solidFill>
                   <a:srgbClr val="000000"/>
                 </a:solidFill>
@@ -3151,7 +3519,65 @@
                 <a:ea typeface="Helvetica Neue"/>
                 <a:cs typeface="Helvetica Neue"/>
               </a:rPr>
-              <a:t>Registered pooled-FCFS sandbox: 1.364/s HPP for 300 s; 36 Security × 21.8 s; 21 Immigration × 13 s; empty start; full drain. Result gate: 150/150 runs, 61,218 travellers, zero drops, strict PASS.</a:t>
+              <a:t>Base-rate joint +4/+3 minus reference; low/high rate endpoints are supporting. N=50 per cell was frozen from pilot precision before outcome inspection.</a:t>
+            </a:r>
+          </a:p>
+          <a:p xmlns:a="http://schemas.openxmlformats.org/drawingml/2006/main">
+            <a:pPr algn="l">
+              <a:spcBef>
+                <a:spcPts val="0"/>
+              </a:spcBef>
+              <a:spcAft>
+                <a:spcPts val="5"/>
+              </a:spcAft>
+              <a:defRPr sz="1600">
+                <a:solidFill>
+                  <a:srgbClr val="000000"/>
+                </a:solidFill>
+                <a:latin typeface="Helvetica Neue"/>
+                <a:ea typeface="Helvetica Neue"/>
+                <a:cs typeface="Helvetica Neue"/>
+              </a:defRPr>
+            </a:pPr>
+            <a:r>
+              <a:rPr sz="1600" b="1">
+                <a:solidFill>
+                  <a:srgbClr val="000000"/>
+                </a:solidFill>
+                <a:latin typeface="Helvetica Neue"/>
+                <a:ea typeface="Helvetica Neue"/>
+                <a:cs typeface="Helvetica Neue"/>
+              </a:rPr>
+              <a:t>Conditional model: pooled FCFS · fixed service · empty start · full drain · not calibrated HTX performance.</a:t>
+            </a:r>
+          </a:p>
+          <a:p xmlns:a="http://schemas.openxmlformats.org/drawingml/2006/main">
+            <a:pPr algn="l">
+              <a:spcBef>
+                <a:spcPts val="0"/>
+              </a:spcBef>
+              <a:spcAft>
+                <a:spcPts val="0"/>
+              </a:spcAft>
+              <a:defRPr sz="1600">
+                <a:solidFill>
+                  <a:srgbClr val="000000"/>
+                </a:solidFill>
+                <a:latin typeface="Helvetica Neue"/>
+                <a:ea typeface="Helvetica Neue"/>
+                <a:cs typeface="Helvetica Neue"/>
+              </a:defRPr>
+            </a:pPr>
+            <a:r>
+              <a:rPr sz="1600" b="0">
+                <a:solidFill>
+                  <a:srgbClr val="5E6570"/>
+                </a:solidFill>
+                <a:latin typeface="Helvetica Neue"/>
+                <a:ea typeface="Helvetica Neue"/>
+                <a:cs typeface="Helvetica Neue"/>
+              </a:rPr>
+              <a:t>Executed 600/600 runs · 253,756 traveller rows · exact coverage, conservation and CRN validators PASS.</a:t>
             </a:r>
           </a:p>
         </p:txBody>
@@ -3194,8 +3620,8 @@
         </p:nvSpPr>
         <p:spPr>
           <a:xfrm xmlns:a="http://schemas.openxmlformats.org/drawingml/2006/main">
-            <a:off x="393668" y="344043"/>
-            <a:ext cx="11404568" cy="809625"/>
+            <a:off x="393668" y="323850"/>
+            <a:ext cx="11404568" cy="723900"/>
           </a:xfrm>
           <a:prstGeom xmlns:a="http://schemas.openxmlformats.org/drawingml/2006/main" prst="rect">
             <a:avLst/>
@@ -3203,22 +3629,31 @@
         </p:spPr>
         <p:txBody>
           <a:bodyPr xmlns:a="http://schemas.openxmlformats.org/drawingml/2006/main" lIns="0" tIns="0" rIns="0" bIns="0" anchor="t">
-            <a:normAutofit fontScale="100000"/>
+            <a:noAutofit/>
           </a:bodyPr>
           <a:lstStyle xmlns:a="http://schemas.openxmlformats.org/drawingml/2006/main"/>
           <a:p xmlns:a="http://schemas.openxmlformats.org/drawingml/2006/main">
             <a:pPr algn="l">
-              <a:defRPr sz="2900">
-                <a:solidFill>
-                  <a:srgbClr val="000000"/>
-                </a:solidFill>
-                <a:latin typeface="Helvetica Neue"/>
-                <a:ea typeface="Helvetica Neue"/>
-                <a:cs typeface="Helvetica Neue"/>
-              </a:defRPr>
-            </a:pPr>
-            <a:r>
-              <a:t>Single-stage capacity moves the bottleneck; service evidence dominates</a:t>
+              <a:buNone/>
+              <a:defRPr sz="3200" b="0">
+                <a:solidFill>
+                  <a:srgbClr val="000000"/>
+                </a:solidFill>
+                <a:latin typeface="Helvetica Neue"/>
+                <a:ea typeface="Helvetica Neue"/>
+                <a:cs typeface="Helvetica Neue"/>
+              </a:defRPr>
+            </a:pPr>
+            <a:r>
+              <a:rPr sz="3200" b="0">
+                <a:solidFill>
+                  <a:srgbClr val="000000"/>
+                </a:solidFill>
+                <a:latin typeface="Helvetica Neue"/>
+                <a:ea typeface="Helvetica Neue"/>
+                <a:cs typeface="Helvetica Neue"/>
+              </a:rPr>
+              <a:t>Joint +4/+3 cuts P95 queueing; the gain rises with demand</a:t>
             </a:r>
           </a:p>
         </p:txBody>
@@ -3239,19 +3674,22 @@
         </p:nvSpPr>
         <p:spPr>
           <a:xfrm xmlns:a="http://schemas.openxmlformats.org/drawingml/2006/main">
-            <a:off x="438150" y="1133475"/>
-            <a:ext cx="5334000" cy="238125"/>
+            <a:off x="438150" y="1104900"/>
+            <a:ext cx="5810250" cy="266700"/>
           </a:xfrm>
           <a:prstGeom xmlns:a="http://schemas.openxmlformats.org/drawingml/2006/main" prst="rect">
             <a:avLst/>
           </a:prstGeom>
         </p:spPr>
         <p:txBody>
-          <a:bodyPr xmlns:a="http://schemas.openxmlformats.org/drawingml/2006/main" lIns="0" tIns="0" rIns="0" bIns="0"/>
+          <a:bodyPr xmlns:a="http://schemas.openxmlformats.org/drawingml/2006/main" lIns="0" tIns="0" rIns="0" bIns="0" anchor="t">
+            <a:noAutofit/>
+          </a:bodyPr>
           <a:lstStyle xmlns:a="http://schemas.openxmlformats.org/drawingml/2006/main"/>
           <a:p xmlns:a="http://schemas.openxmlformats.org/drawingml/2006/main">
             <a:pPr algn="l">
-              <a:defRPr sz="1200">
+              <a:buNone/>
+              <a:defRPr sz="1600" b="0">
                 <a:solidFill>
                   <a:srgbClr val="5E6570"/>
                 </a:solidFill>
@@ -3261,7 +3699,15 @@
               </a:defRPr>
             </a:pPr>
             <a:r>
-              <a:t>Replication-level queue-wait P95 (seconds)</a:t>
+              <a:rPr sz="1600" b="0">
+                <a:solidFill>
+                  <a:srgbClr val="5E6570"/>
+                </a:solidFill>
+                <a:latin typeface="Helvetica Neue"/>
+                <a:ea typeface="Helvetica Neue"/>
+                <a:cs typeface="Helvetica Neue"/>
+              </a:rPr>
+              <a:t>Base-rate mean stage queue-wait P95 (s), n=50/cell</a:t>
             </a:r>
           </a:p>
         </p:txBody>
@@ -3311,34 +3757,37 @@
         </p:nvSpPr>
         <p:spPr>
           <a:xfrm xmlns:a="http://schemas.openxmlformats.org/drawingml/2006/main">
-            <a:off x="6858000" y="1371600"/>
-            <a:ext cx="4667250" cy="990600"/>
+            <a:off x="6800850" y="1295400"/>
+            <a:ext cx="4810125" cy="1162050"/>
           </a:xfrm>
           <a:prstGeom xmlns:a="http://schemas.openxmlformats.org/drawingml/2006/main" prst="rect">
             <a:avLst/>
           </a:prstGeom>
         </p:spPr>
         <p:txBody>
-          <a:bodyPr xmlns:a="http://schemas.openxmlformats.org/drawingml/2006/main" lIns="0" tIns="0" rIns="0" bIns="0">
-            <a:normAutofit fontScale="86215"/>
+          <a:bodyPr xmlns:a="http://schemas.openxmlformats.org/drawingml/2006/main" lIns="0" tIns="0" rIns="0" bIns="0" anchor="t">
+            <a:noAutofit/>
           </a:bodyPr>
           <a:lstStyle xmlns:a="http://schemas.openxmlformats.org/drawingml/2006/main"/>
           <a:p xmlns:a="http://schemas.openxmlformats.org/drawingml/2006/main">
             <a:pPr algn="l">
+              <a:spcBef>
+                <a:spcPts val="0"/>
+              </a:spcBef>
               <a:spcAft>
-                <a:spcPts val="500"/>
+                <a:spcPts val="6"/>
               </a:spcAft>
-              <a:defRPr sz="1800">
-                <a:solidFill>
-                  <a:srgbClr val="000000"/>
-                </a:solidFill>
-                <a:latin typeface="Helvetica Neue"/>
-                <a:ea typeface="Helvetica Neue"/>
-                <a:cs typeface="Helvetica Neue"/>
-              </a:defRPr>
-            </a:pPr>
-            <a:r>
-              <a:rPr sz="2100" b="1">
+              <a:defRPr sz="1600">
+                <a:solidFill>
+                  <a:srgbClr val="000000"/>
+                </a:solidFill>
+                <a:latin typeface="Helvetica Neue"/>
+                <a:ea typeface="Helvetica Neue"/>
+                <a:cs typeface="Helvetica Neue"/>
+              </a:defRPr>
+            </a:pPr>
+            <a:r>
+              <a:rPr sz="2025" b="1">
                 <a:solidFill>
                   <a:srgbClr val="000000"/>
                 </a:solidFill>
@@ -3346,26 +3795,28 @@
                 <a:ea typeface="Helvetica Neue"/>
                 <a:cs typeface="Helvetica Neue"/>
               </a:rPr>
-              <a:t>Balanced capacity is the only clear capacity result</a:t>
+              <a:t>Primary effect: −2.679 s</a:t>
             </a:r>
           </a:p>
           <a:p xmlns:a="http://schemas.openxmlformats.org/drawingml/2006/main">
             <a:pPr algn="l">
-              <a:lnSpc>
-                <a:spcPct val="112000"/>
-              </a:lnSpc>
-              <a:buNone/>
-              <a:defRPr sz="1800">
-                <a:solidFill>
-                  <a:srgbClr val="000000"/>
-                </a:solidFill>
-                <a:latin typeface="Helvetica Neue"/>
-                <a:ea typeface="Helvetica Neue"/>
-                <a:cs typeface="Helvetica Neue"/>
-              </a:defRPr>
-            </a:pPr>
-            <a:r>
-              <a:rPr sz="1275">
+              <a:spcBef>
+                <a:spcPts val="0"/>
+              </a:spcBef>
+              <a:spcAft>
+                <a:spcPts val="0"/>
+              </a:spcAft>
+              <a:defRPr sz="1600">
+                <a:solidFill>
+                  <a:srgbClr val="000000"/>
+                </a:solidFill>
+                <a:latin typeface="Helvetica Neue"/>
+                <a:ea typeface="Helvetica Neue"/>
+                <a:cs typeface="Helvetica Neue"/>
+              </a:defRPr>
+            </a:pPr>
+            <a:r>
+              <a:rPr sz="1600" b="0">
                 <a:solidFill>
                   <a:srgbClr val="000000"/>
                 </a:solidFill>
@@ -3373,7 +3824,7 @@
                 <a:ea typeface="Helvetica Neue"/>
                 <a:cs typeface="Helvetica Neue"/>
               </a:rPr>
-              <a:t>Both +4/+3: −1.91 s vs reference (95% CI −3.37 to −0.44). Each single-stage interval crosses zero at n=10.</a:t>
+              <a:t>Joint minus reference [95% paired CI −3.061, −2.297]. Half-width 0.382 s; target ≤ 1.0 s.</a:t>
             </a:r>
           </a:p>
         </p:txBody>
@@ -3423,34 +3874,37 @@
         </p:nvSpPr>
         <p:spPr>
           <a:xfrm xmlns:a="http://schemas.openxmlformats.org/drawingml/2006/main">
-            <a:off x="6858000" y="3019425"/>
-            <a:ext cx="4667250" cy="990600"/>
+            <a:off x="6800850" y="2943225"/>
+            <a:ext cx="4810125" cy="1162050"/>
           </a:xfrm>
           <a:prstGeom xmlns:a="http://schemas.openxmlformats.org/drawingml/2006/main" prst="rect">
             <a:avLst/>
           </a:prstGeom>
         </p:spPr>
         <p:txBody>
-          <a:bodyPr xmlns:a="http://schemas.openxmlformats.org/drawingml/2006/main" lIns="0" tIns="0" rIns="0" bIns="0">
-            <a:normAutofit fontScale="100000"/>
+          <a:bodyPr xmlns:a="http://schemas.openxmlformats.org/drawingml/2006/main" lIns="0" tIns="0" rIns="0" bIns="0" anchor="t">
+            <a:noAutofit/>
           </a:bodyPr>
           <a:lstStyle xmlns:a="http://schemas.openxmlformats.org/drawingml/2006/main"/>
           <a:p xmlns:a="http://schemas.openxmlformats.org/drawingml/2006/main">
             <a:pPr algn="l">
+              <a:spcBef>
+                <a:spcPts val="0"/>
+              </a:spcBef>
               <a:spcAft>
-                <a:spcPts val="500"/>
+                <a:spcPts val="7"/>
               </a:spcAft>
-              <a:defRPr sz="1800">
-                <a:solidFill>
-                  <a:srgbClr val="000000"/>
-                </a:solidFill>
-                <a:latin typeface="Helvetica Neue"/>
-                <a:ea typeface="Helvetica Neue"/>
-                <a:cs typeface="Helvetica Neue"/>
-              </a:defRPr>
-            </a:pPr>
-            <a:r>
-              <a:rPr sz="2250" b="1">
+              <a:defRPr sz="1600">
+                <a:solidFill>
+                  <a:srgbClr val="000000"/>
+                </a:solidFill>
+                <a:latin typeface="Helvetica Neue"/>
+                <a:ea typeface="Helvetica Neue"/>
+                <a:cs typeface="Helvetica Neue"/>
+              </a:defRPr>
+            </a:pPr>
+            <a:r>
+              <a:rPr sz="1875" b="1">
                 <a:solidFill>
                   <a:srgbClr val="000000"/>
                 </a:solidFill>
@@ -3458,26 +3912,28 @@
                 <a:ea typeface="Helvetica Neue"/>
                 <a:cs typeface="Helvetica Neue"/>
               </a:rPr>
-              <a:t>+20% demand: 17.06 s</a:t>
+              <a:t>Robust over the count-rate interval</a:t>
             </a:r>
           </a:p>
           <a:p xmlns:a="http://schemas.openxmlformats.org/drawingml/2006/main">
             <a:pPr algn="l">
-              <a:lnSpc>
-                <a:spcPct val="112000"/>
-              </a:lnSpc>
-              <a:buNone/>
-              <a:defRPr sz="1800">
-                <a:solidFill>
-                  <a:srgbClr val="000000"/>
-                </a:solidFill>
-                <a:latin typeface="Helvetica Neue"/>
-                <a:ea typeface="Helvetica Neue"/>
-                <a:cs typeface="Helvetica Neue"/>
-              </a:defRPr>
-            </a:pPr>
-            <a:r>
-              <a:rPr sz="1275">
+              <a:spcBef>
+                <a:spcPts val="0"/>
+              </a:spcBef>
+              <a:spcAft>
+                <a:spcPts val="0"/>
+              </a:spcAft>
+              <a:defRPr sz="1600">
+                <a:solidFill>
+                  <a:srgbClr val="000000"/>
+                </a:solidFill>
+                <a:latin typeface="Helvetica Neue"/>
+                <a:ea typeface="Helvetica Neue"/>
+                <a:cs typeface="Helvetica Neue"/>
+              </a:defRPr>
+            </a:pPr>
+            <a:r>
+              <a:rPr sz="1600" b="0">
                 <a:solidFill>
                   <a:srgbClr val="000000"/>
                 </a:solidFill>
@@ -3485,7 +3941,7 @@
                 <a:ea typeface="Helvetica Neue"/>
                 <a:cs typeface="Helvetica Neue"/>
               </a:rPr>
-              <a:t>The primary P95 rises by 13.54 s (95% CI +7.21 to +19.86) as both stages approach capacity.</a:t>
+              <a:t>Reference minus joint: 0.067 s low; 2.679 s base; 33.158 s high. All three paired intervals exclude zero.</a:t>
             </a:r>
           </a:p>
         </p:txBody>
@@ -3535,34 +3991,37 @@
         </p:nvSpPr>
         <p:spPr>
           <a:xfrm xmlns:a="http://schemas.openxmlformats.org/drawingml/2006/main">
-            <a:off x="6858000" y="4667250"/>
-            <a:ext cx="4667250" cy="990600"/>
+            <a:off x="6800850" y="4591050"/>
+            <a:ext cx="4810125" cy="1162050"/>
           </a:xfrm>
           <a:prstGeom xmlns:a="http://schemas.openxmlformats.org/drawingml/2006/main" prst="rect">
             <a:avLst/>
           </a:prstGeom>
         </p:spPr>
         <p:txBody>
-          <a:bodyPr xmlns:a="http://schemas.openxmlformats.org/drawingml/2006/main" lIns="0" tIns="0" rIns="0" bIns="0">
-            <a:normAutofit fontScale="100000"/>
+          <a:bodyPr xmlns:a="http://schemas.openxmlformats.org/drawingml/2006/main" lIns="0" tIns="0" rIns="0" bIns="0" anchor="t">
+            <a:noAutofit/>
           </a:bodyPr>
           <a:lstStyle xmlns:a="http://schemas.openxmlformats.org/drawingml/2006/main"/>
           <a:p xmlns:a="http://schemas.openxmlformats.org/drawingml/2006/main">
             <a:pPr algn="l">
+              <a:spcBef>
+                <a:spcPts val="0"/>
+              </a:spcBef>
               <a:spcAft>
-                <a:spcPts val="500"/>
+                <a:spcPts val="7"/>
               </a:spcAft>
-              <a:defRPr sz="1800">
-                <a:solidFill>
-                  <a:srgbClr val="000000"/>
-                </a:solidFill>
-                <a:latin typeface="Helvetica Neue"/>
-                <a:ea typeface="Helvetica Neue"/>
-                <a:cs typeface="Helvetica Neue"/>
-              </a:defRPr>
-            </a:pPr>
-            <a:r>
-              <a:rPr sz="2250" b="1">
+              <a:defRPr sz="1600">
+                <a:solidFill>
+                  <a:srgbClr val="000000"/>
+                </a:solidFill>
+                <a:latin typeface="Helvetica Neue"/>
+                <a:ea typeface="Helvetica Neue"/>
+                <a:cs typeface="Helvetica Neue"/>
+              </a:defRPr>
+            </a:pPr>
+            <a:r>
+              <a:rPr sz="1875" b="1">
                 <a:solidFill>
                   <a:srgbClr val="000000"/>
                 </a:solidFill>
@@ -3570,26 +4029,28 @@
                 <a:ea typeface="Helvetica Neue"/>
                 <a:cs typeface="Helvetica Neue"/>
               </a:rPr>
-              <a:t>Immigration context: 164.87 s</a:t>
+              <a:t>Joint ranks first—not all options separate</a:t>
             </a:r>
           </a:p>
           <a:p xmlns:a="http://schemas.openxmlformats.org/drawingml/2006/main">
             <a:pPr algn="l">
-              <a:lnSpc>
-                <a:spcPct val="112000"/>
-              </a:lnSpc>
-              <a:buNone/>
-              <a:defRPr sz="1800">
-                <a:solidFill>
-                  <a:srgbClr val="000000"/>
-                </a:solidFill>
-                <a:latin typeface="Helvetica Neue"/>
-                <a:ea typeface="Helvetica Neue"/>
-                <a:cs typeface="Helvetica Neue"/>
-              </a:defRPr>
-            </a:pPr>
-            <a:r>
-              <a:rPr sz="1275">
+              <a:spcBef>
+                <a:spcPts val="0"/>
+              </a:spcBef>
+              <a:spcAft>
+                <a:spcPts val="0"/>
+              </a:spcAft>
+              <a:defRPr sz="1600">
+                <a:solidFill>
+                  <a:srgbClr val="000000"/>
+                </a:solidFill>
+                <a:latin typeface="Helvetica Neue"/>
+                <a:ea typeface="Helvetica Neue"/>
+                <a:cs typeface="Helvetica Neue"/>
+              </a:defRPr>
+            </a:pPr>
+            <a:r>
+              <a:rPr sz="1600" b="0">
                 <a:solidFill>
                   <a:srgbClr val="000000"/>
                 </a:solidFill>
@@ -3597,7 +4058,7 @@
                 <a:ea typeface="Helvetica Neue"/>
                 <a:cs typeface="Helvetica Neue"/>
               </a:rPr>
-              <a:t>A 24 s service anchor overwhelms small staffing effects. Input evidence—not animation polish—sets the decision boundary.</a:t>
+              <a:t>Same point order at all three rates. Some supporting pairwise intervals remain unresolved; no universal dominance claim.</a:t>
             </a:r>
           </a:p>
         </p:txBody>
@@ -3618,21 +4079,22 @@
         </p:nvSpPr>
         <p:spPr>
           <a:xfrm xmlns:a="http://schemas.openxmlformats.org/drawingml/2006/main">
-            <a:off x="400050" y="6200775"/>
-            <a:ext cx="9953625" cy="209550"/>
+            <a:off x="400050" y="6019800"/>
+            <a:ext cx="10572750" cy="504825"/>
           </a:xfrm>
           <a:prstGeom xmlns:a="http://schemas.openxmlformats.org/drawingml/2006/main" prst="rect">
             <a:avLst/>
           </a:prstGeom>
         </p:spPr>
         <p:txBody>
-          <a:bodyPr xmlns:a="http://schemas.openxmlformats.org/drawingml/2006/main" lIns="0" tIns="0" rIns="0" bIns="0">
-            <a:normAutofit fontScale="100000"/>
+          <a:bodyPr xmlns:a="http://schemas.openxmlformats.org/drawingml/2006/main" lIns="0" tIns="0" rIns="0" bIns="0" anchor="t">
+            <a:noAutofit/>
           </a:bodyPr>
           <a:lstStyle xmlns:a="http://schemas.openxmlformats.org/drawingml/2006/main"/>
           <a:p xmlns:a="http://schemas.openxmlformats.org/drawingml/2006/main">
             <a:pPr algn="l">
-              <a:defRPr sz="1050">
+              <a:buNone/>
+              <a:defRPr sz="1600" b="0">
                 <a:solidFill>
                   <a:srgbClr val="5E6570"/>
                 </a:solidFill>
@@ -3642,7 +4104,39 @@
               </a:defRPr>
             </a:pPr>
             <a:r>
-              <a:t>Pilot only · n=10/scenario · pooled FCFS · fixed service times · CRN not verified</a:t>
+              <a:rPr sz="1600" b="0">
+                <a:solidFill>
+                  <a:srgbClr val="5E6570"/>
+                </a:solidFill>
+                <a:latin typeface="Helvetica Neue"/>
+                <a:ea typeface="Helvetica Neue"/>
+                <a:cs typeface="Helvetica Neue"/>
+              </a:rPr>
+              <a:t>Confirmatory primary contrast · 12 cells × 50 · CRN PASS → paired 95% CI</a:t>
+            </a:r>
+          </a:p>
+          <a:p xmlns:a="http://schemas.openxmlformats.org/drawingml/2006/main">
+            <a:pPr algn="l">
+              <a:buNone/>
+              <a:defRPr sz="1600" b="0">
+                <a:solidFill>
+                  <a:srgbClr val="5E6570"/>
+                </a:solidFill>
+                <a:latin typeface="Helvetica Neue"/>
+                <a:ea typeface="Helvetica Neue"/>
+                <a:cs typeface="Helvetica Neue"/>
+              </a:defRPr>
+            </a:pPr>
+            <a:r>
+              <a:rPr sz="1600" b="0">
+                <a:solidFill>
+                  <a:srgbClr val="5E6570"/>
+                </a:solidFill>
+                <a:latin typeface="Helvetica Neue"/>
+                <a:ea typeface="Helvetica Neue"/>
+                <a:cs typeface="Helvetica Neue"/>
+              </a:rPr>
+              <a:t>Rate rankings supporting · exact HPP count interval · fixed service · pooled FCFS</a:t>
             </a:r>
           </a:p>
         </p:txBody>
@@ -3675,6 +4169,7 @@
           <a:lstStyle xmlns:a="http://schemas.openxmlformats.org/drawingml/2006/main"/>
           <a:p xmlns:a="http://schemas.openxmlformats.org/drawingml/2006/main">
             <a:pPr algn="r">
+              <a:buNone/>
               <a:defRPr sz="1000">
                 <a:solidFill>
                   <a:srgbClr val="000000"/>
@@ -3692,7 +4187,7 @@
       </p:sp>
       <p:graphicFrame>
         <p:nvGraphicFramePr>
-          <p:cNvPr id="22" name="Chart"/>
+          <p:cNvPr id="24" name="Chart"/>
           <p:cNvGraphicFramePr/>
           <p:nvPr/>
         </p:nvGraphicFramePr>
@@ -3702,7 +4197,7 @@
         </p:xfrm>
         <a:graphic xmlns:a="http://schemas.openxmlformats.org/drawingml/2006/main">
           <a:graphicData uri="http://schemas.openxmlformats.org/drawingml/2006/chart">
-            <c:chart xmlns:r="http://schemas.openxmlformats.org/officeDocument/2006/relationships" xmlns:c="http://schemas.openxmlformats.org/drawingml/2006/chart" r:id="Ra7e1e0afdbb4475f"/>
+            <c:chart xmlns:r="http://schemas.openxmlformats.org/officeDocument/2006/relationships" xmlns:c="http://schemas.openxmlformats.org/drawingml/2006/chart" r:id="R9248e87f6b2d4ea4"/>
           </a:graphicData>
         </a:graphic>
       </p:graphicFrame>
@@ -3758,6 +4253,7 @@
           <a:lstStyle xmlns:a="http://schemas.openxmlformats.org/drawingml/2006/main"/>
           <a:p xmlns:a="http://schemas.openxmlformats.org/drawingml/2006/main">
             <a:pPr algn="r">
+              <a:buNone/>
               <a:defRPr sz="1000">
                 <a:solidFill>
                   <a:srgbClr val="000000"/>
@@ -3789,8 +4285,8 @@
         </p:nvSpPr>
         <p:spPr>
           <a:xfrm xmlns:a="http://schemas.openxmlformats.org/drawingml/2006/main">
-            <a:off x="393668" y="344043"/>
-            <a:ext cx="11404568" cy="1047464"/>
+            <a:off x="393668" y="323850"/>
+            <a:ext cx="11404568" cy="762000"/>
           </a:xfrm>
           <a:prstGeom xmlns:a="http://schemas.openxmlformats.org/drawingml/2006/main" prst="rect">
             <a:avLst/>
@@ -3803,17 +4299,26 @@
           <a:lstStyle xmlns:a="http://schemas.openxmlformats.org/drawingml/2006/main"/>
           <a:p xmlns:a="http://schemas.openxmlformats.org/drawingml/2006/main">
             <a:pPr algn="l">
-              <a:defRPr sz="2900">
-                <a:solidFill>
-                  <a:srgbClr val="000000"/>
-                </a:solidFill>
-                <a:latin typeface="Helvetica Neue"/>
-                <a:ea typeface="Helvetica Neue"/>
-                <a:cs typeface="Helvetica Neue"/>
-              </a:defRPr>
-            </a:pPr>
-            <a:r>
-              <a:t>Pilot balanced capacity—but buy evidence before buying certainty</a:t>
+              <a:buNone/>
+              <a:defRPr sz="3200" b="0">
+                <a:solidFill>
+                  <a:srgbClr val="000000"/>
+                </a:solidFill>
+                <a:latin typeface="Helvetica Neue"/>
+                <a:ea typeface="Helvetica Neue"/>
+                <a:cs typeface="Helvetica Neue"/>
+              </a:defRPr>
+            </a:pPr>
+            <a:r>
+              <a:rPr sz="3200" b="0">
+                <a:solidFill>
+                  <a:srgbClr val="000000"/>
+                </a:solidFill>
+                <a:latin typeface="Helvetica Neue"/>
+                <a:ea typeface="Helvetica Neue"/>
+                <a:cs typeface="Helvetica Neue"/>
+              </a:rPr>
+              <a:t>Advance joint +4/+3 to field calibration—not staffing rollout</a:t>
             </a:r>
           </a:p>
         </p:txBody>
@@ -3834,8 +4339,8 @@
         </p:nvSpPr>
         <p:spPr>
           <a:xfrm xmlns:a="http://schemas.openxmlformats.org/drawingml/2006/main">
-            <a:off x="393668" y="1722406"/>
-            <a:ext cx="5537168" cy="865156"/>
+            <a:off x="393668" y="1619250"/>
+            <a:ext cx="10001250" cy="590550"/>
           </a:xfrm>
           <a:prstGeom xmlns:a="http://schemas.openxmlformats.org/drawingml/2006/main" prst="rect">
             <a:avLst/>
@@ -3848,17 +4353,26 @@
           <a:lstStyle xmlns:a="http://schemas.openxmlformats.org/drawingml/2006/main"/>
           <a:p xmlns:a="http://schemas.openxmlformats.org/drawingml/2006/main">
             <a:pPr algn="l">
-              <a:defRPr sz="2400">
-                <a:solidFill>
-                  <a:srgbClr val="000000"/>
-                </a:solidFill>
-                <a:latin typeface="Helvetica Neue"/>
-                <a:ea typeface="Helvetica Neue"/>
-                <a:cs typeface="Helvetica Neue"/>
-              </a:defRPr>
-            </a:pPr>
-            <a:r>
-              <a:t>The next milestone is a validated site pilot, not a staffing forecast.</a:t>
+              <a:buNone/>
+              <a:defRPr sz="2100" b="0">
+                <a:solidFill>
+                  <a:srgbClr val="000000"/>
+                </a:solidFill>
+                <a:latin typeface="Helvetica Neue"/>
+                <a:ea typeface="Helvetica Neue"/>
+                <a:cs typeface="Helvetica Neue"/>
+              </a:defRPr>
+            </a:pPr>
+            <a:r>
+              <a:rPr sz="2100" b="0">
+                <a:solidFill>
+                  <a:srgbClr val="000000"/>
+                </a:solidFill>
+                <a:latin typeface="Helvetica Neue"/>
+                <a:ea typeface="Helvetica Neue"/>
+                <a:cs typeface="Helvetica Neue"/>
+              </a:rPr>
+              <a:t>Confirmatory mechanism PASS → field calibration → costed operational trial</a:t>
             </a:r>
           </a:p>
         </p:txBody>
@@ -3879,31 +4393,40 @@
         </p:nvSpPr>
         <p:spPr>
           <a:xfrm xmlns:a="http://schemas.openxmlformats.org/drawingml/2006/main">
-            <a:off x="7886700" y="2990279"/>
-            <a:ext cx="3911632" cy="548735"/>
+            <a:off x="7886700" y="2924175"/>
+            <a:ext cx="3911632" cy="590550"/>
           </a:xfrm>
           <a:prstGeom xmlns:a="http://schemas.openxmlformats.org/drawingml/2006/main" prst="rect">
             <a:avLst/>
           </a:prstGeom>
         </p:spPr>
         <p:txBody>
-          <a:bodyPr xmlns:a="http://schemas.openxmlformats.org/drawingml/2006/main" lIns="0" tIns="0" rIns="0" bIns="0">
-            <a:normAutofit fontScale="93680"/>
+          <a:bodyPr xmlns:a="http://schemas.openxmlformats.org/drawingml/2006/main" lIns="0" tIns="0" rIns="0" bIns="0" anchor="ctr">
+            <a:noAutofit/>
           </a:bodyPr>
           <a:lstStyle xmlns:a="http://schemas.openxmlformats.org/drawingml/2006/main"/>
           <a:p xmlns:a="http://schemas.openxmlformats.org/drawingml/2006/main">
             <a:pPr algn="l">
-              <a:defRPr sz="2400">
-                <a:solidFill>
-                  <a:srgbClr val="000000"/>
-                </a:solidFill>
-                <a:latin typeface="Helvetica Neue"/>
-                <a:ea typeface="Helvetica Neue"/>
-                <a:cs typeface="Helvetica Neue"/>
-              </a:defRPr>
-            </a:pPr>
-            <a:r>
-              <a:t>Instrument arrivals by time of day</a:t>
+              <a:buNone/>
+              <a:defRPr sz="1838" b="0">
+                <a:solidFill>
+                  <a:srgbClr val="000000"/>
+                </a:solidFill>
+                <a:latin typeface="Helvetica Neue"/>
+                <a:ea typeface="Helvetica Neue"/>
+                <a:cs typeface="Helvetica Neue"/>
+              </a:defRPr>
+            </a:pPr>
+            <a:r>
+              <a:rPr sz="1838" b="0">
+                <a:solidFill>
+                  <a:srgbClr val="000000"/>
+                </a:solidFill>
+                <a:latin typeface="Helvetica Neue"/>
+                <a:ea typeface="Helvetica Neue"/>
+                <a:cs typeface="Helvetica Neue"/>
+              </a:rPr>
+              <a:t>Collect time-of-day arrivals and signed event times</a:t>
             </a:r>
           </a:p>
         </p:txBody>
@@ -4048,35 +4571,37 @@
         </p:nvSpPr>
         <p:spPr>
           <a:xfrm xmlns:a="http://schemas.openxmlformats.org/drawingml/2006/main">
-            <a:off x="393668" y="2990279"/>
-            <a:ext cx="5537168" cy="2884646"/>
+            <a:off x="393668" y="2781300"/>
+            <a:ext cx="6191250" cy="3143250"/>
           </a:xfrm>
           <a:prstGeom xmlns:a="http://schemas.openxmlformats.org/drawingml/2006/main" prst="rect">
             <a:avLst/>
           </a:prstGeom>
         </p:spPr>
         <p:txBody>
-          <a:bodyPr xmlns:a="http://schemas.openxmlformats.org/drawingml/2006/main" wrap="square" lIns="0" tIns="0" rIns="0" bIns="0">
-            <a:spAutoFit/>
+          <a:bodyPr xmlns:a="http://schemas.openxmlformats.org/drawingml/2006/main" wrap="square" lIns="0" tIns="0" rIns="0" bIns="0" anchor="t">
+            <a:noAutofit/>
           </a:bodyPr>
           <a:lstStyle xmlns:a="http://schemas.openxmlformats.org/drawingml/2006/main"/>
           <a:p xmlns:a="http://schemas.openxmlformats.org/drawingml/2006/main">
             <a:pPr algn="l">
-              <a:lnSpc>
-                <a:spcPct val="112000"/>
-              </a:lnSpc>
-              <a:buNone/>
-              <a:defRPr sz="1800">
-                <a:solidFill>
-                  <a:srgbClr val="000000"/>
-                </a:solidFill>
-                <a:latin typeface="Helvetica Neue"/>
-                <a:ea typeface="Helvetica Neue"/>
-                <a:cs typeface="Helvetica Neue"/>
-              </a:defRPr>
-            </a:pPr>
-            <a:r>
-              <a:rPr sz="2025" b="1">
+              <a:spcBef>
+                <a:spcPts val="0"/>
+              </a:spcBef>
+              <a:spcAft>
+                <a:spcPts val="8"/>
+              </a:spcAft>
+              <a:defRPr sz="1600">
+                <a:solidFill>
+                  <a:srgbClr val="000000"/>
+                </a:solidFill>
+                <a:latin typeface="Helvetica Neue"/>
+                <a:ea typeface="Helvetica Neue"/>
+                <a:cs typeface="Helvetica Neue"/>
+              </a:defRPr>
+            </a:pPr>
+            <a:r>
+              <a:rPr sz="1875" b="1">
                 <a:solidFill>
                   <a:srgbClr val="000000"/>
                 </a:solidFill>
@@ -4084,11 +4609,57 @@
                 <a:ea typeface="Helvetica Neue"/>
                 <a:cs typeface="Helvetica Neue"/>
               </a:rPr>
-              <a:t>A tail metric can hide the operational consequence.
-</a:t>
-            </a:r>
-            <a:r>
-              <a:rPr sz="1500">
+              <a:t>Decision supported: carry joint +4/+3 forward</a:t>
+            </a:r>
+          </a:p>
+          <a:p xmlns:a="http://schemas.openxmlformats.org/drawingml/2006/main">
+            <a:pPr algn="l">
+              <a:spcBef>
+                <a:spcPts val="0"/>
+              </a:spcBef>
+              <a:spcAft>
+                <a:spcPts val="2"/>
+              </a:spcAft>
+              <a:defRPr sz="1600">
+                <a:solidFill>
+                  <a:srgbClr val="000000"/>
+                </a:solidFill>
+                <a:latin typeface="Helvetica Neue"/>
+                <a:ea typeface="Helvetica Neue"/>
+                <a:cs typeface="Helvetica Neue"/>
+              </a:defRPr>
+            </a:pPr>
+            <a:r>
+              <a:rPr sz="2250" b="1">
+                <a:solidFill>
+                  <a:srgbClr val="3D8DFF"/>
+                </a:solidFill>
+                <a:latin typeface="Helvetica Neue"/>
+                <a:ea typeface="Helvetica Neue"/>
+                <a:cs typeface="Helvetica Neue"/>
+              </a:rPr>
+              <a:t>Base-rate reduction: 2.679 s</a:t>
+            </a:r>
+          </a:p>
+          <a:p xmlns:a="http://schemas.openxmlformats.org/drawingml/2006/main">
+            <a:pPr algn="l">
+              <a:spcBef>
+                <a:spcPts val="0"/>
+              </a:spcBef>
+              <a:spcAft>
+                <a:spcPts val="7"/>
+              </a:spcAft>
+              <a:defRPr sz="1600">
+                <a:solidFill>
+                  <a:srgbClr val="000000"/>
+                </a:solidFill>
+                <a:latin typeface="Helvetica Neue"/>
+                <a:ea typeface="Helvetica Neue"/>
+                <a:cs typeface="Helvetica Neue"/>
+              </a:defRPr>
+            </a:pPr>
+            <a:r>
+              <a:rPr sz="1600" b="0">
                 <a:solidFill>
                   <a:srgbClr val="5E6570"/>
                 </a:solidFill>
@@ -4096,11 +4667,28 @@
                 <a:ea typeface="Helvetica Neue"/>
                 <a:cs typeface="Helvetica Neue"/>
               </a:rPr>
-              <a:t>Risk boundary: 2% × 7,200 s
-</a:t>
-            </a:r>
-            <a:r>
-              <a:rPr sz="2325" b="1">
+              <a:t>95% paired CI 2.297–3.061 · half-width 0.382 s</a:t>
+            </a:r>
+          </a:p>
+          <a:p xmlns:a="http://schemas.openxmlformats.org/drawingml/2006/main">
+            <a:pPr algn="l">
+              <a:spcBef>
+                <a:spcPts val="0"/>
+              </a:spcBef>
+              <a:spcAft>
+                <a:spcPts val="2"/>
+              </a:spcAft>
+              <a:defRPr sz="1600">
+                <a:solidFill>
+                  <a:srgbClr val="000000"/>
+                </a:solidFill>
+                <a:latin typeface="Helvetica Neue"/>
+                <a:ea typeface="Helvetica Neue"/>
+                <a:cs typeface="Helvetica Neue"/>
+              </a:defRPr>
+            </a:pPr>
+            <a:r>
+              <a:rPr sz="2175" b="1">
                 <a:solidFill>
                   <a:srgbClr val="3D8DFF"/>
                 </a:solidFill>
@@ -4108,27 +4696,28 @@
                 <a:ea typeface="Helvetica Neue"/>
                 <a:cs typeface="Helvetica Neue"/>
               </a:rPr>
-              <a:t>Queue-wait P95: 30.4 s
-Full-drain clear: 7,214 s ≈ 2.0 h</a:t>
+              <a:t>First-place point rank at all 3 rates</a:t>
             </a:r>
           </a:p>
           <a:p xmlns:a="http://schemas.openxmlformats.org/drawingml/2006/main">
             <a:pPr algn="l">
-              <a:lnSpc>
-                <a:spcPct val="112000"/>
-              </a:lnSpc>
-              <a:buNone/>
-              <a:defRPr sz="1800">
-                <a:solidFill>
-                  <a:srgbClr val="000000"/>
-                </a:solidFill>
-                <a:latin typeface="Helvetica Neue"/>
-                <a:ea typeface="Helvetica Neue"/>
-                <a:cs typeface="Helvetica Neue"/>
-              </a:defRPr>
-            </a:pPr>
-            <a:r>
-              <a:rPr sz="1275">
+              <a:spcBef>
+                <a:spcPts val="0"/>
+              </a:spcBef>
+              <a:spcAft>
+                <a:spcPts val="8"/>
+              </a:spcAft>
+              <a:defRPr sz="1600">
+                <a:solidFill>
+                  <a:srgbClr val="000000"/>
+                </a:solidFill>
+                <a:latin typeface="Helvetica Neue"/>
+                <a:ea typeface="Helvetica Neue"/>
+                <a:cs typeface="Helvetica Neue"/>
+              </a:defRPr>
+            </a:pPr>
+            <a:r>
+              <a:rPr sz="1600" b="0">
                 <a:solidFill>
                   <a:srgbClr val="5E6570"/>
                 </a:solidFill>
@@ -4136,7 +4725,36 @@
                 <a:ea typeface="Helvetica Neue"/>
                 <a:cs typeface="Helvetica Neue"/>
               </a:rPr>
-              <a:t>This is a deliberately pessimistic external boundary—not an ICA forecast. It shows why exception workload and full-drain clearance must be measured.</a:t>
+              <a:t>Resolved benefit: 0.067 s low · 2.679 s base · 33.158 s high</a:t>
+            </a:r>
+          </a:p>
+          <a:p xmlns:a="http://schemas.openxmlformats.org/drawingml/2006/main">
+            <a:pPr algn="l">
+              <a:spcBef>
+                <a:spcPts val="0"/>
+              </a:spcBef>
+              <a:spcAft>
+                <a:spcPts val="0"/>
+              </a:spcAft>
+              <a:defRPr sz="1600">
+                <a:solidFill>
+                  <a:srgbClr val="000000"/>
+                </a:solidFill>
+                <a:latin typeface="Helvetica Neue"/>
+                <a:ea typeface="Helvetica Neue"/>
+                <a:cs typeface="Helvetica Neue"/>
+              </a:defRPr>
+            </a:pPr>
+            <a:r>
+              <a:rPr sz="1600" b="0">
+                <a:solidFill>
+                  <a:srgbClr val="5E6570"/>
+                </a:solidFill>
+                <a:latin typeface="Helvetica Neue"/>
+                <a:ea typeface="Helvetica Neue"/>
+                <a:cs typeface="Helvetica Neue"/>
+              </a:rPr>
+              <a:t>Not a staffing, forecast, cost or site-validation result. The largest uncertainty is real time-of-day arrivals and stage service distributions.</a:t>
             </a:r>
           </a:p>
         </p:txBody>
@@ -4157,31 +4775,40 @@
         </p:nvSpPr>
         <p:spPr>
           <a:xfrm xmlns:a="http://schemas.openxmlformats.org/drawingml/2006/main">
-            <a:off x="7886700" y="3599879"/>
-            <a:ext cx="3911632" cy="548735"/>
+            <a:off x="7886700" y="3533775"/>
+            <a:ext cx="3911632" cy="590550"/>
           </a:xfrm>
           <a:prstGeom xmlns:a="http://schemas.openxmlformats.org/drawingml/2006/main" prst="rect">
             <a:avLst/>
           </a:prstGeom>
         </p:spPr>
         <p:txBody>
-          <a:bodyPr xmlns:a="http://schemas.openxmlformats.org/drawingml/2006/main" lIns="0" tIns="0" rIns="0" bIns="0">
-            <a:normAutofit fontScale="89670"/>
+          <a:bodyPr xmlns:a="http://schemas.openxmlformats.org/drawingml/2006/main" lIns="0" tIns="0" rIns="0" bIns="0" anchor="ctr">
+            <a:noAutofit/>
           </a:bodyPr>
           <a:lstStyle xmlns:a="http://schemas.openxmlformats.org/drawingml/2006/main"/>
           <a:p xmlns:a="http://schemas.openxmlformats.org/drawingml/2006/main">
             <a:pPr algn="l">
-              <a:defRPr sz="2400">
-                <a:solidFill>
-                  <a:srgbClr val="000000"/>
-                </a:solidFill>
-                <a:latin typeface="Helvetica Neue"/>
-                <a:ea typeface="Helvetica Neue"/>
-                <a:cs typeface="Helvetica Neue"/>
-              </a:defRPr>
-            </a:pPr>
-            <a:r>
-              <a:t>Fit service + exception distributions</a:t>
+              <a:buNone/>
+              <a:defRPr sz="1838" b="0">
+                <a:solidFill>
+                  <a:srgbClr val="000000"/>
+                </a:solidFill>
+                <a:latin typeface="Helvetica Neue"/>
+                <a:ea typeface="Helvetica Neue"/>
+                <a:cs typeface="Helvetica Neue"/>
+              </a:defRPr>
+            </a:pPr>
+            <a:r>
+              <a:rPr sz="1838" b="0">
+                <a:solidFill>
+                  <a:srgbClr val="000000"/>
+                </a:solidFill>
+                <a:latin typeface="Helvetica Neue"/>
+                <a:ea typeface="Helvetica Neue"/>
+                <a:cs typeface="Helvetica Neue"/>
+              </a:rPr>
+              <a:t>Measure stage service-time and exception distributions</a:t>
             </a:r>
           </a:p>
         </p:txBody>
@@ -4326,31 +4953,40 @@
         </p:nvSpPr>
         <p:spPr>
           <a:xfrm xmlns:a="http://schemas.openxmlformats.org/drawingml/2006/main">
-            <a:off x="7886700" y="4214813"/>
-            <a:ext cx="3911632" cy="548735"/>
+            <a:off x="7886700" y="4143375"/>
+            <a:ext cx="3911632" cy="590550"/>
           </a:xfrm>
           <a:prstGeom xmlns:a="http://schemas.openxmlformats.org/drawingml/2006/main" prst="rect">
             <a:avLst/>
           </a:prstGeom>
         </p:spPr>
         <p:txBody>
-          <a:bodyPr xmlns:a="http://schemas.openxmlformats.org/drawingml/2006/main" lIns="0" tIns="0" rIns="0" bIns="0">
-            <a:normAutofit fontScale="81761"/>
+          <a:bodyPr xmlns:a="http://schemas.openxmlformats.org/drawingml/2006/main" lIns="0" tIns="0" rIns="0" bIns="0" anchor="ctr">
+            <a:noAutofit/>
           </a:bodyPr>
           <a:lstStyle xmlns:a="http://schemas.openxmlformats.org/drawingml/2006/main"/>
           <a:p xmlns:a="http://schemas.openxmlformats.org/drawingml/2006/main">
             <a:pPr algn="l">
-              <a:defRPr sz="2400">
-                <a:solidFill>
-                  <a:srgbClr val="000000"/>
-                </a:solidFill>
-                <a:latin typeface="Helvetica Neue"/>
-                <a:ea typeface="Helvetica Neue"/>
-                <a:cs typeface="Helvetica Neue"/>
-              </a:defRPr>
-            </a:pPr>
-            <a:r>
-              <a:t>Observe queues, rosters and resources</a:t>
+              <a:buNone/>
+              <a:defRPr sz="1838" b="0">
+                <a:solidFill>
+                  <a:srgbClr val="000000"/>
+                </a:solidFill>
+                <a:latin typeface="Helvetica Neue"/>
+                <a:ea typeface="Helvetica Neue"/>
+                <a:cs typeface="Helvetica Neue"/>
+              </a:defRPr>
+            </a:pPr>
+            <a:r>
+              <a:rPr sz="1838" b="0">
+                <a:solidFill>
+                  <a:srgbClr val="000000"/>
+                </a:solidFill>
+                <a:latin typeface="Helvetica Neue"/>
+                <a:ea typeface="Helvetica Neue"/>
+                <a:cs typeface="Helvetica Neue"/>
+              </a:rPr>
+              <a:t>Observe queues, open resources, rosters and downtime</a:t>
             </a:r>
           </a:p>
         </p:txBody>
@@ -4495,31 +5131,40 @@
         </p:nvSpPr>
         <p:spPr>
           <a:xfrm xmlns:a="http://schemas.openxmlformats.org/drawingml/2006/main">
-            <a:off x="7886700" y="4824317"/>
-            <a:ext cx="3911632" cy="548735"/>
+            <a:off x="7886700" y="4752975"/>
+            <a:ext cx="3911632" cy="590550"/>
           </a:xfrm>
           <a:prstGeom xmlns:a="http://schemas.openxmlformats.org/drawingml/2006/main" prst="rect">
             <a:avLst/>
           </a:prstGeom>
         </p:spPr>
         <p:txBody>
-          <a:bodyPr xmlns:a="http://schemas.openxmlformats.org/drawingml/2006/main" lIns="0" tIns="0" rIns="0" bIns="0">
-            <a:normAutofit fontScale="100000"/>
+          <a:bodyPr xmlns:a="http://schemas.openxmlformats.org/drawingml/2006/main" lIns="0" tIns="0" rIns="0" bIns="0" anchor="ctr">
+            <a:noAutofit/>
           </a:bodyPr>
           <a:lstStyle xmlns:a="http://schemas.openxmlformats.org/drawingml/2006/main"/>
           <a:p xmlns:a="http://schemas.openxmlformats.org/drawingml/2006/main">
             <a:pPr algn="l">
-              <a:defRPr sz="2400">
-                <a:solidFill>
-                  <a:srgbClr val="000000"/>
-                </a:solidFill>
-                <a:latin typeface="Helvetica Neue"/>
-                <a:ea typeface="Helvetica Neue"/>
-                <a:cs typeface="Helvetica Neue"/>
-              </a:defRPr>
-            </a:pPr>
-            <a:r>
-              <a:t>Verify CRN; size confirmatory N</a:t>
+              <a:buNone/>
+              <a:defRPr sz="1838" b="0">
+                <a:solidFill>
+                  <a:srgbClr val="000000"/>
+                </a:solidFill>
+                <a:latin typeface="Helvetica Neue"/>
+                <a:ea typeface="Helvetica Neue"/>
+                <a:cs typeface="Helvetica Neue"/>
+              </a:defRPr>
+            </a:pPr>
+            <a:r>
+              <a:rPr sz="1838" b="0">
+                <a:solidFill>
+                  <a:srgbClr val="000000"/>
+                </a:solidFill>
+                <a:latin typeface="Helvetica Neue"/>
+                <a:ea typeface="Helvetica Neue"/>
+                <a:cs typeface="Helvetica Neue"/>
+              </a:rPr>
+              <a:t>Calibrate, validate and price a joint +4/+3 pilot</a:t>
             </a:r>
           </a:p>
         </p:txBody>
@@ -4664,31 +5309,40 @@
         </p:nvSpPr>
         <p:spPr>
           <a:xfrm xmlns:a="http://schemas.openxmlformats.org/drawingml/2006/main">
-            <a:off x="7886700" y="5446681"/>
-            <a:ext cx="3911632" cy="548735"/>
+            <a:off x="7886700" y="5362575"/>
+            <a:ext cx="3911632" cy="590550"/>
           </a:xfrm>
           <a:prstGeom xmlns:a="http://schemas.openxmlformats.org/drawingml/2006/main" prst="rect">
             <a:avLst/>
           </a:prstGeom>
         </p:spPr>
         <p:txBody>
-          <a:bodyPr xmlns:a="http://schemas.openxmlformats.org/drawingml/2006/main" lIns="0" tIns="0" rIns="0" bIns="0">
-            <a:normAutofit fontScale="98658"/>
+          <a:bodyPr xmlns:a="http://schemas.openxmlformats.org/drawingml/2006/main" lIns="0" tIns="0" rIns="0" bIns="0" anchor="ctr">
+            <a:noAutofit/>
           </a:bodyPr>
           <a:lstStyle xmlns:a="http://schemas.openxmlformats.org/drawingml/2006/main"/>
           <a:p xmlns:a="http://schemas.openxmlformats.org/drawingml/2006/main">
             <a:pPr algn="l">
-              <a:defRPr sz="2400">
-                <a:solidFill>
-                  <a:srgbClr val="000000"/>
-                </a:solidFill>
-                <a:latin typeface="Helvetica Neue"/>
-                <a:ea typeface="Helvetica Neue"/>
-                <a:cs typeface="Helvetica Neue"/>
-              </a:defRPr>
-            </a:pPr>
-            <a:r>
-              <a:t>Add cost and licence constraints</a:t>
+              <a:buNone/>
+              <a:defRPr sz="1838" b="0">
+                <a:solidFill>
+                  <a:srgbClr val="000000"/>
+                </a:solidFill>
+                <a:latin typeface="Helvetica Neue"/>
+                <a:ea typeface="Helvetica Neue"/>
+                <a:cs typeface="Helvetica Neue"/>
+              </a:defRPr>
+            </a:pPr>
+            <a:r>
+              <a:rPr sz="1838" b="0">
+                <a:solidFill>
+                  <a:srgbClr val="000000"/>
+                </a:solidFill>
+                <a:latin typeface="Helvetica Neue"/>
+                <a:ea typeface="Helvetica Neue"/>
+                <a:cs typeface="Helvetica Neue"/>
+              </a:rPr>
+              <a:t>Confirm production CV licence and security controls</a:t>
             </a:r>
           </a:p>
         </p:txBody>

</xml_diff>

<commit_message>
correct tie-aware ranking and final claims
</commit_message>
<xml_diff>
--- a/slides/HTX_Task4_Operational_Insights.pptx
+++ b/slides/HTX_Task4_Operational_Insights.pptx
@@ -2,17 +2,17 @@
 <file path=ppt/presentation.xml><?xml version="1.0" encoding="utf-8"?>
 <p:presentation xmlns:p="http://schemas.openxmlformats.org/presentationml/2006/main">
   <p:sldMasterIdLst>
-    <p:sldMasterId xmlns:r="http://schemas.openxmlformats.org/officeDocument/2006/relationships" id="2147483648" r:id="Rb92c6d46b47c4334"/>
+    <p:sldMasterId xmlns:r="http://schemas.openxmlformats.org/officeDocument/2006/relationships" id="2147483648" r:id="R755fdaa383f34933"/>
   </p:sldMasterIdLst>
   <p:notesMasterIdLst>
-    <p:notesMasterId xmlns:r="http://schemas.openxmlformats.org/officeDocument/2006/relationships" r:id="Racc00dedc625416c"/>
+    <p:notesMasterId xmlns:r="http://schemas.openxmlformats.org/officeDocument/2006/relationships" r:id="R9c43818a0a9640c9"/>
   </p:notesMasterIdLst>
   <p:sldIdLst>
-    <p:sldId xmlns:r="http://schemas.openxmlformats.org/officeDocument/2006/relationships" id="256" r:id="R931886ca42094bb9"/>
-    <p:sldId xmlns:r="http://schemas.openxmlformats.org/officeDocument/2006/relationships" id="257" r:id="Ra3e7b03b2b424c88"/>
-    <p:sldId xmlns:r="http://schemas.openxmlformats.org/officeDocument/2006/relationships" id="258" r:id="R59b35f8aa28f4cea"/>
-    <p:sldId xmlns:r="http://schemas.openxmlformats.org/officeDocument/2006/relationships" id="259" r:id="R8b7ffc3b7bd143a0"/>
-    <p:sldId xmlns:r="http://schemas.openxmlformats.org/officeDocument/2006/relationships" id="260" r:id="Re82e3e30d0244067"/>
+    <p:sldId xmlns:r="http://schemas.openxmlformats.org/officeDocument/2006/relationships" id="256" r:id="R05c9af36c9b9414d"/>
+    <p:sldId xmlns:r="http://schemas.openxmlformats.org/officeDocument/2006/relationships" id="257" r:id="Rb90e4765e3f44843"/>
+    <p:sldId xmlns:r="http://schemas.openxmlformats.org/officeDocument/2006/relationships" id="258" r:id="R3e2dec73290446eb"/>
+    <p:sldId xmlns:r="http://schemas.openxmlformats.org/officeDocument/2006/relationships" id="259" r:id="Rcf048e06ec3f441a"/>
+    <p:sldId xmlns:r="http://schemas.openxmlformats.org/officeDocument/2006/relationships" id="260" r:id="R136b5b1ab3bf4d9d"/>
   </p:sldIdLst>
   <p:sldSz cx="12192000" cy="6858000"/>
   <p:notesSz cx="6858000" cy="9144000"/>
@@ -761,7 +761,7 @@
           <a:lstStyle xmlns:a="http://schemas.openxmlformats.org/drawingml/2006/main"/>
           <a:p xmlns:a="http://schemas.openxmlformats.org/drawingml/2006/main">
             <a:r>
-              <a:t>At the base arrival rate, the joint arm lowers mean replication-level total queue-wait P95 from 3.929 to 1.250 seconds. The predeclared paired difference is minus 2.679 seconds, with a 95% interval from minus 3.061 to minus 2.297 and a 0.382-second half-width. Supporting rate checks show a resolved joint benefit at all three count-based rates: 0.067 seconds at the lower endpoint, 2.679 at the point estimate and 33.158 at the upper endpoint. The joint arm has the best point estimate throughout, but some other pairwise intervals are unresolved, so this is not evidence that every capacity option is statistically distinct.</a:t>
+              <a:t>At the base arrival rate, the joint arm lowers mean replication-level total queue-wait P95 from 3.929 to 1.250 seconds. The predeclared paired difference is minus 2.679 seconds, with a 95% interval from minus 3.061 to minus 2.297 and a 0.382-second half-width. Supporting rate checks show a resolved joint benefit versus reference at all three count-based rates: 0.067 seconds at the lower endpoint, 2.679 at the point estimate and 33.158 at the upper endpoint. Joint is lowest at the base and high rates; at the low endpoint it ties Immigration plus three at zero. Some other pairwise intervals remain unresolved, so this is not evidence that every capacity option is statistically distinct.</a:t>
             </a:r>
           </a:p>
           <a:p xmlns:a="http://schemas.openxmlformats.org/drawingml/2006/main">
@@ -974,7 +974,7 @@
   </p:cSld>
   <p:clrMap bg1="lt1" tx1="dk1" bg2="lt2" tx2="dk2" accent1="accent1" accent2="accent2" accent3="accent3" accent4="accent4" accent5="accent5" accent6="accent6" hlink="hlink" folHlink="folHlink"/>
   <p:sldLayoutIdLst>
-    <p:sldLayoutId xmlns:r="http://schemas.openxmlformats.org/officeDocument/2006/relationships" id="2147483649" r:id="Rb2dc059eccad4db0"/>
+    <p:sldLayoutId xmlns:r="http://schemas.openxmlformats.org/officeDocument/2006/relationships" id="2147483649" r:id="R5bf54cb585ec4c57"/>
   </p:sldLayoutIdLst>
   <p:txStyles>
     <p:titleStyle>
@@ -3653,7 +3653,7 @@
                 <a:ea typeface="Helvetica Neue"/>
                 <a:cs typeface="Helvetica Neue"/>
               </a:rPr>
-              <a:t>Joint +4/+3 cuts P95 queueing; the gain rises with demand</a:t>
+              <a:t>Joint +4/+3 cuts base-rate P95; the modelled gain is rate-dependent</a:t>
             </a:r>
           </a:p>
         </p:txBody>
@@ -3912,7 +3912,7 @@
                 <a:ea typeface="Helvetica Neue"/>
                 <a:cs typeface="Helvetica Neue"/>
               </a:rPr>
-              <a:t>Robust over the count-rate interval</a:t>
+              <a:t>Supporting rate sensitivity</a:t>
             </a:r>
           </a:p>
           <a:p xmlns:a="http://schemas.openxmlformats.org/drawingml/2006/main">
@@ -4029,7 +4029,7 @@
                 <a:ea typeface="Helvetica Neue"/>
                 <a:cs typeface="Helvetica Neue"/>
               </a:rPr>
-              <a:t>Joint ranks first—not all options separate</a:t>
+              <a:t>Joint is lowest or tied-lowest—not dominant</a:t>
             </a:r>
           </a:p>
           <a:p xmlns:a="http://schemas.openxmlformats.org/drawingml/2006/main">
@@ -4058,7 +4058,7 @@
                 <a:ea typeface="Helvetica Neue"/>
                 <a:cs typeface="Helvetica Neue"/>
               </a:rPr>
-              <a:t>Same point order at all three rates. Some supporting pairwise intervals remain unresolved; no universal dominance claim.</a:t>
+              <a:t>At the low endpoint, Joint and Immigration +3 tie at 0.000 s. Joint is lowest at base/high; some supporting intervals remain unresolved.</a:t>
             </a:r>
           </a:p>
         </p:txBody>
@@ -4197,7 +4197,7 @@
         </p:xfrm>
         <a:graphic xmlns:a="http://schemas.openxmlformats.org/drawingml/2006/main">
           <a:graphicData uri="http://schemas.openxmlformats.org/drawingml/2006/chart">
-            <c:chart xmlns:r="http://schemas.openxmlformats.org/officeDocument/2006/relationships" xmlns:c="http://schemas.openxmlformats.org/drawingml/2006/chart" r:id="R9248e87f6b2d4ea4"/>
+            <c:chart xmlns:r="http://schemas.openxmlformats.org/officeDocument/2006/relationships" xmlns:c="http://schemas.openxmlformats.org/drawingml/2006/chart" r:id="R73d4158c27114bd0"/>
           </a:graphicData>
         </a:graphic>
       </p:graphicFrame>
@@ -4696,7 +4696,7 @@
                 <a:ea typeface="Helvetica Neue"/>
                 <a:cs typeface="Helvetica Neue"/>
               </a:rPr>
-              <a:t>First-place point rank at all 3 rates</a:t>
+              <a:t>Lowest or tied-lowest at all 3 rates</a:t>
             </a:r>
           </a:p>
           <a:p xmlns:a="http://schemas.openxmlformats.org/drawingml/2006/main">
@@ -4725,7 +4725,7 @@
                 <a:ea typeface="Helvetica Neue"/>
                 <a:cs typeface="Helvetica Neue"/>
               </a:rPr>
-              <a:t>Resolved benefit: 0.067 s low · 2.679 s base · 33.158 s high</a:t>
+              <a:t>Low: tied with Immigration +3 · base/high: lowest point estimate</a:t>
             </a:r>
           </a:p>
           <a:p xmlns:a="http://schemas.openxmlformats.org/drawingml/2006/main">

</xml_diff>

<commit_message>
make submission verification portable
</commit_message>
<xml_diff>
--- a/slides/HTX_Task4_Operational_Insights.pptx
+++ b/slides/HTX_Task4_Operational_Insights.pptx
@@ -2,17 +2,17 @@
 <file path=ppt/presentation.xml><?xml version="1.0" encoding="utf-8"?>
 <p:presentation xmlns:p="http://schemas.openxmlformats.org/presentationml/2006/main">
   <p:sldMasterIdLst>
-    <p:sldMasterId xmlns:r="http://schemas.openxmlformats.org/officeDocument/2006/relationships" id="2147483648" r:id="R755fdaa383f34933"/>
+    <p:sldMasterId xmlns:r="http://schemas.openxmlformats.org/officeDocument/2006/relationships" id="2147483648" r:id="R5d7b85e9967e4ddd"/>
   </p:sldMasterIdLst>
   <p:notesMasterIdLst>
-    <p:notesMasterId xmlns:r="http://schemas.openxmlformats.org/officeDocument/2006/relationships" r:id="R9c43818a0a9640c9"/>
+    <p:notesMasterId xmlns:r="http://schemas.openxmlformats.org/officeDocument/2006/relationships" r:id="R74d78462c58749ad"/>
   </p:notesMasterIdLst>
   <p:sldIdLst>
-    <p:sldId xmlns:r="http://schemas.openxmlformats.org/officeDocument/2006/relationships" id="256" r:id="R05c9af36c9b9414d"/>
-    <p:sldId xmlns:r="http://schemas.openxmlformats.org/officeDocument/2006/relationships" id="257" r:id="Rb90e4765e3f44843"/>
-    <p:sldId xmlns:r="http://schemas.openxmlformats.org/officeDocument/2006/relationships" id="258" r:id="R3e2dec73290446eb"/>
-    <p:sldId xmlns:r="http://schemas.openxmlformats.org/officeDocument/2006/relationships" id="259" r:id="Rcf048e06ec3f441a"/>
-    <p:sldId xmlns:r="http://schemas.openxmlformats.org/officeDocument/2006/relationships" id="260" r:id="R136b5b1ab3bf4d9d"/>
+    <p:sldId xmlns:r="http://schemas.openxmlformats.org/officeDocument/2006/relationships" id="256" r:id="R3377183f1d2043fe"/>
+    <p:sldId xmlns:r="http://schemas.openxmlformats.org/officeDocument/2006/relationships" id="257" r:id="R6b7ae976f76d4549"/>
+    <p:sldId xmlns:r="http://schemas.openxmlformats.org/officeDocument/2006/relationships" id="258" r:id="R3ef653f8c9cd495e"/>
+    <p:sldId xmlns:r="http://schemas.openxmlformats.org/officeDocument/2006/relationships" id="259" r:id="Rb3a78dfbf3594d0e"/>
+    <p:sldId xmlns:r="http://schemas.openxmlformats.org/officeDocument/2006/relationships" id="260" r:id="R1f1bc3634c23493e"/>
   </p:sldIdLst>
   <p:sldSz cx="12192000" cy="6858000"/>
   <p:notesSz cx="6858000" cy="9144000"/>
@@ -656,7 +656,7 @@
           <a:lstStyle xmlns:a="http://schemas.openxmlformats.org/drawingml/2006/main"/>
           <a:p xmlns:a="http://schemas.openxmlformats.org/drawingml/2006/main">
             <a:r>
-              <a:t>The confirmatory status comes from the contract, not the label. Before seeing these outcomes, the study fixed one primary comparison, a one-second half-width target, 50 replications per cell and all random streams. The run completed 600 of 600 cells with 253,756 traveller rows. CRN validation then matched 150 scenario groups, identical traveller sets and more than 1.14 million branch-invariant draw values. Only after that PASS was the paired interval authorised. The result is still conditional on the registered model; it is not observed checkpoint performance.</a:t>
+              <a:t>The confirmatory status comes from the contract, not the label. Before seeing these outcomes, the study fixed one primary comparison, a one-second half-width target, 50 replications per cell and all random streams. The study completed all 600 planned runs across 12 cells, producing 253,756 traveller rows. CRN validation then matched 150 scenario groups, identical traveller sets and more than 1.14 million branch-invariant draw values. Only after that PASS was the paired interval authorised. The result is still conditional on the registered model; it is not observed checkpoint performance.</a:t>
             </a:r>
           </a:p>
           <a:p xmlns:a="http://schemas.openxmlformats.org/drawingml/2006/main">
@@ -974,7 +974,7 @@
   </p:cSld>
   <p:clrMap bg1="lt1" tx1="dk1" bg2="lt2" tx2="dk2" accent1="accent1" accent2="accent2" accent3="accent3" accent4="accent4" accent5="accent5" accent6="accent6" hlink="hlink" folHlink="folHlink"/>
   <p:sldLayoutIdLst>
-    <p:sldLayoutId xmlns:r="http://schemas.openxmlformats.org/officeDocument/2006/relationships" id="2147483649" r:id="R5bf54cb585ec4c57"/>
+    <p:sldLayoutId xmlns:r="http://schemas.openxmlformats.org/officeDocument/2006/relationships" id="2147483649" r:id="Raf4017933ae7481a"/>
   </p:sldLayoutIdLst>
   <p:txStyles>
     <p:titleStyle>
@@ -4197,7 +4197,7 @@
         </p:xfrm>
         <a:graphic xmlns:a="http://schemas.openxmlformats.org/drawingml/2006/main">
           <a:graphicData uri="http://schemas.openxmlformats.org/drawingml/2006/chart">
-            <c:chart xmlns:r="http://schemas.openxmlformats.org/officeDocument/2006/relationships" xmlns:c="http://schemas.openxmlformats.org/drawingml/2006/chart" r:id="R73d4158c27114bd0"/>
+            <c:chart xmlns:r="http://schemas.openxmlformats.org/officeDocument/2006/relationships" xmlns:c="http://schemas.openxmlformats.org/drawingml/2006/chart" r:id="R02207a6133c04e3c"/>
           </a:graphicData>
         </a:graphic>
       </p:graphicFrame>

</xml_diff>

<commit_message>
strengthen load-regime evidence and recommendation
</commit_message>
<xml_diff>
--- a/slides/HTX_Task4_Operational_Insights.pptx
+++ b/slides/HTX_Task4_Operational_Insights.pptx
@@ -2,17 +2,17 @@
 <file path=ppt/presentation.xml><?xml version="1.0" encoding="utf-8"?>
 <p:presentation xmlns:p="http://schemas.openxmlformats.org/presentationml/2006/main">
   <p:sldMasterIdLst>
-    <p:sldMasterId xmlns:r="http://schemas.openxmlformats.org/officeDocument/2006/relationships" id="2147483648" r:id="R5d7b85e9967e4ddd"/>
+    <p:sldMasterId xmlns:r="http://schemas.openxmlformats.org/officeDocument/2006/relationships" id="2147483648" r:id="R54fcadbf3e224672"/>
   </p:sldMasterIdLst>
   <p:notesMasterIdLst>
-    <p:notesMasterId xmlns:r="http://schemas.openxmlformats.org/officeDocument/2006/relationships" r:id="R74d78462c58749ad"/>
+    <p:notesMasterId xmlns:r="http://schemas.openxmlformats.org/officeDocument/2006/relationships" r:id="Re818ad3efe5c4793"/>
   </p:notesMasterIdLst>
   <p:sldIdLst>
-    <p:sldId xmlns:r="http://schemas.openxmlformats.org/officeDocument/2006/relationships" id="256" r:id="R3377183f1d2043fe"/>
-    <p:sldId xmlns:r="http://schemas.openxmlformats.org/officeDocument/2006/relationships" id="257" r:id="R6b7ae976f76d4549"/>
-    <p:sldId xmlns:r="http://schemas.openxmlformats.org/officeDocument/2006/relationships" id="258" r:id="R3ef653f8c9cd495e"/>
-    <p:sldId xmlns:r="http://schemas.openxmlformats.org/officeDocument/2006/relationships" id="259" r:id="Rb3a78dfbf3594d0e"/>
-    <p:sldId xmlns:r="http://schemas.openxmlformats.org/officeDocument/2006/relationships" id="260" r:id="R1f1bc3634c23493e"/>
+    <p:sldId xmlns:r="http://schemas.openxmlformats.org/officeDocument/2006/relationships" id="256" r:id="R326daa6b6b3142bf"/>
+    <p:sldId xmlns:r="http://schemas.openxmlformats.org/officeDocument/2006/relationships" id="257" r:id="Rf2e1ebd663734dd2"/>
+    <p:sldId xmlns:r="http://schemas.openxmlformats.org/officeDocument/2006/relationships" id="258" r:id="R654451b6b25e4014"/>
+    <p:sldId xmlns:r="http://schemas.openxmlformats.org/officeDocument/2006/relationships" id="259" r:id="R8ad641f990aa4026"/>
+    <p:sldId xmlns:r="http://schemas.openxmlformats.org/officeDocument/2006/relationships" id="260" r:id="R30eca37d88f5410f"/>
   </p:sldIdLst>
   <p:sldSz cx="12192000" cy="6858000"/>
   <p:notesSz cx="6858000" cy="9144000"/>
@@ -761,7 +761,7 @@
           <a:lstStyle xmlns:a="http://schemas.openxmlformats.org/drawingml/2006/main"/>
           <a:p xmlns:a="http://schemas.openxmlformats.org/drawingml/2006/main">
             <a:r>
-              <a:t>At the base arrival rate, the joint arm lowers mean replication-level total queue-wait P95 from 3.929 to 1.250 seconds. The predeclared paired difference is minus 2.679 seconds, with a 95% interval from minus 3.061 to minus 2.297 and a 0.382-second half-width. Supporting rate checks show a resolved joint benefit versus reference at all three count-based rates: 0.067 seconds at the lower endpoint, 2.679 at the point estimate and 33.158 at the upper endpoint. Joint is lowest at the base and high rates; at the low endpoint it ties Immigration plus three at zero. Some other pairwise intervals remain unresolved, so this is not evidence that every capacity option is statistically distinct.</a:t>
+              <a:t>The frozen design already spans light through stressed conditions. Reference nominal maximum offered load is 0.585 at low, 0.845 at base and 1.180 at high. Reference versus joint +4/+3 total queue-wait P95 is 0.067 versus 0.000 seconds at low, 3.929 versus 1.250 at base, and 51.671 versus 18.513 at high. The high-rate reference-minus-joint improvement is 33.158 seconds with a paired 95% interval from 31.410 to 34.906. Single-stage relief moves the serial bottleneck: Security +4 leaves Immigration P95 at 35.902 seconds, while Immigration +3 leaves Security P95 at 44.107. The 15, 30 and 60 second exceedance diagnostics are post-hoc model-scale supporting evidence, not ICA service standards or new confirmatory endpoints.</a:t>
             </a:r>
           </a:p>
           <a:p xmlns:a="http://schemas.openxmlformats.org/drawingml/2006/main">
@@ -776,27 +776,27 @@
           </a:p>
           <a:p xmlns:a="http://schemas.openxmlformats.org/drawingml/2006/main">
             <a:r>
-              <a:t>- results/analysis/confirmatory_capacity/scenario_estimates.csv (base-rate stage estimates, local source)</a:t>
-            </a:r>
-          </a:p>
-          <a:p xmlns:a="http://schemas.openxmlformats.org/drawingml/2006/main">
-            <a:r>
-              <a:t>- results/analysis/confirmatory_capacity/primary_result.json (predeclared primary result, local source)</a:t>
-            </a:r>
-          </a:p>
-          <a:p xmlns:a="http://schemas.openxmlformats.org/drawingml/2006/main">
-            <a:r>
-              <a:t>- results/analysis/confirmatory_capacity/within_rate_pairwise_contrasts.csv (rate-boundary contrasts, local source)</a:t>
-            </a:r>
-          </a:p>
-          <a:p xmlns:a="http://schemas.openxmlformats.org/drawingml/2006/main">
-            <a:r>
-              <a:t>- results/analysis/confirmatory_capacity/ranking_stability.json (supporting ranking interpretation, local source)</a:t>
-            </a:r>
-          </a:p>
-          <a:p xmlns:a="http://schemas.openxmlformats.org/drawingml/2006/main">
-            <a:r>
-              <a:t>- results/analysis/confirmatory_capacity/crn_alignment.json (paired-analysis gate, local source)</a:t>
+              <a:t>- results/analysis/confirmatory_capacity/scenario_estimates.csv (registered low/base/high P95 estimates, local source)</a:t>
+            </a:r>
+          </a:p>
+          <a:p xmlns:a="http://schemas.openxmlformats.org/drawingml/2006/main">
+            <a:r>
+              <a:t>- results/analysis/confirmatory_capacity/within_rate_pairwise_contrasts.csv (paired high-rate contrast, local source)</a:t>
+            </a:r>
+          </a:p>
+          <a:p xmlns:a="http://schemas.openxmlformats.org/drawingml/2006/main">
+            <a:r>
+              <a:t>- results/analysis/confirmatory_capacity/regime_estimates.csv (offered load and arrival-window utilization, local source)</a:t>
+            </a:r>
+          </a:p>
+          <a:p xmlns:a="http://schemas.openxmlformats.org/drawingml/2006/main">
+            <a:r>
+              <a:t>- results/analysis/confirmatory_capacity/regime_reference_joint_contrasts.csv (post-hoc 15/30/60-second diagnostics, local source)</a:t>
+            </a:r>
+          </a:p>
+          <a:p xmlns:a="http://schemas.openxmlformats.org/drawingml/2006/main">
+            <a:r>
+              <a:t>- results/analysis/confirmatory_capacity/regime_diagnostics_manifest.json (hash-linked supporting-analysis boundary, local source)</a:t>
             </a:r>
           </a:p>
         </p:txBody>
@@ -866,7 +866,7 @@
           <a:lstStyle xmlns:a="http://schemas.openxmlformats.org/drawingml/2006/main"/>
           <a:p xmlns:a="http://schemas.openxmlformats.org/drawingml/2006/main">
             <a:r>
-              <a:t>The confirmatory evidence is strong enough to advance one mechanism, not to prescribe staffing. Under the registered assumptions, joint plus-four and plus-three reduces the base-rate P95 by 2.679 seconds and remains beneficial at both exact count-rate endpoints. The next gate is field evidence: signed event times across time of day, stage service and exception distributions, observed open resources, rosters and downtime. Only after calibration and validation should HTX price a controlled joint-capacity pilot and assess space, staffing, security and production computer-vision licensing.</a:t>
+              <a:t>The recommendation is conditional but actionable. Carry the joint +4/+3 mechanism into one-site field calibration now. At the frozen base rate it reduces total queue-wait P95 by 2.679 seconds; at the stressed high endpoint it reduces P95 by 33.158 seconds, with paired intervals excluding zero. Trigger a costed controlled pilot only if observed time-of-day arrivals and stage service distributions reproduce material peak queues. The numbers +4/+3 are model levers, not a roster or procurement instruction. Costs, layout constraints, downtime, local service distributions and production computer-vision licensing remain open gates.</a:t>
             </a:r>
           </a:p>
           <a:p xmlns:a="http://schemas.openxmlformats.org/drawingml/2006/main">
@@ -881,32 +881,32 @@
           </a:p>
           <a:p xmlns:a="http://schemas.openxmlformats.org/drawingml/2006/main">
             <a:r>
-              <a:t>- results/analysis/confirmatory_capacity/primary_result.json (primary capacity result, local source)</a:t>
-            </a:r>
-          </a:p>
-          <a:p xmlns:a="http://schemas.openxmlformats.org/drawingml/2006/main">
-            <a:r>
-              <a:t>- results/analysis/confirmatory_capacity/ranking_stability.json (cross-rate supporting result, local source)</a:t>
-            </a:r>
-          </a:p>
-          <a:p xmlns:a="http://schemas.openxmlformats.org/drawingml/2006/main">
-            <a:r>
-              <a:t>- docs/task3_results.md (decision interpretation and limitations, local source)</a:t>
-            </a:r>
-          </a:p>
-          <a:p xmlns:a="http://schemas.openxmlformats.org/drawingml/2006/main">
-            <a:r>
-              <a:t>- docs/analysis_plan.md (confirmatory precision and claim controls, local source)</a:t>
-            </a:r>
-          </a:p>
-          <a:p xmlns:a="http://schemas.openxmlformats.org/drawingml/2006/main">
-            <a:r>
-              <a:t>- LICENSING.md (measurement and deployment licence boundary, local source)</a:t>
-            </a:r>
-          </a:p>
-          <a:p xmlns:a="http://schemas.openxmlformats.org/drawingml/2006/main">
-            <a:r>
-              <a:t>- https://www.ultralytics.com/license</a:t>
+              <a:t>- results/analysis/confirmatory_capacity/primary_result.json (base-rate paired primary result, local source)</a:t>
+            </a:r>
+          </a:p>
+          <a:p xmlns:a="http://schemas.openxmlformats.org/drawingml/2006/main">
+            <a:r>
+              <a:t>- results/analysis/confirmatory_capacity/scenario_estimates.csv (low/base/high results, local source)</a:t>
+            </a:r>
+          </a:p>
+          <a:p xmlns:a="http://schemas.openxmlformats.org/drawingml/2006/main">
+            <a:r>
+              <a:t>- results/analysis/confirmatory_capacity/regime_reference_joint_contrasts.csv (stressed-regime post-hoc diagnostics, local source)</a:t>
+            </a:r>
+          </a:p>
+          <a:p xmlns:a="http://schemas.openxmlformats.org/drawingml/2006/main">
+            <a:r>
+              <a:t>- docs/task1_measurement.md (signed-event-ledger limitation, local source)</a:t>
+            </a:r>
+          </a:p>
+          <a:p xmlns:a="http://schemas.openxmlformats.org/drawingml/2006/main">
+            <a:r>
+              <a:t>- docs/task2_system_design.md (assumptions and field-calibration requirements, local source)</a:t>
+            </a:r>
+          </a:p>
+          <a:p xmlns:a="http://schemas.openxmlformats.org/drawingml/2006/main">
+            <a:r>
+              <a:t>- LICENSING.md (production computer-vision licence boundary, local source)</a:t>
             </a:r>
           </a:p>
         </p:txBody>
@@ -974,7 +974,7 @@
   </p:cSld>
   <p:clrMap bg1="lt1" tx1="dk1" bg2="lt2" tx2="dk2" accent1="accent1" accent2="accent2" accent3="accent3" accent4="accent4" accent5="accent5" accent6="accent6" hlink="hlink" folHlink="folHlink"/>
   <p:sldLayoutIdLst>
-    <p:sldLayoutId xmlns:r="http://schemas.openxmlformats.org/officeDocument/2006/relationships" id="2147483649" r:id="Raf4017933ae7481a"/>
+    <p:sldLayoutId xmlns:r="http://schemas.openxmlformats.org/officeDocument/2006/relationships" id="2147483649" r:id="R08190503d8974edb"/>
   </p:sldLayoutIdLst>
   <p:txStyles>
     <p:titleStyle>
@@ -1514,7 +1514,7 @@
           <c:idx val="0"/>
           <c:order val="0"/>
           <c:tx>
-            <c:v>Security wait P95</c:v>
+            <c:v>Reference</c:v>
           </c:tx>
           <c:spPr>
             <a:solidFill xmlns:a="http://schemas.openxmlformats.org/drawingml/2006/main">
@@ -1523,36 +1523,33 @@
           </c:spPr>
           <c:cat>
             <c:strLit>
-              <c:ptCount val="4"/>
+              <c:ptCount val="3"/>
               <c:pt idx="0">
-                <c:v>Reference</c:v>
+                <c:v>Low
+max rho 0.585</c:v>
               </c:pt>
               <c:pt idx="1">
-                <c:v>Security +4</c:v>
+                <c:v>Base
+max rho 0.845</c:v>
               </c:pt>
               <c:pt idx="2">
-                <c:v>Immigration +3</c:v>
-              </c:pt>
-              <c:pt idx="3">
-                <c:v>Both +4/+3</c:v>
+                <c:v>High
+max rho 1.180</c:v>
               </c:pt>
             </c:strLit>
           </c:cat>
           <c:val>
             <c:numLit>
               <c:formatCode>0.00</c:formatCode>
-              <c:ptCount val="4"/>
+              <c:ptCount val="3"/>
               <c:pt idx="0">
-                <c:v>2.318877</c:v>
+                <c:v>0.06690438318</c:v>
               </c:pt>
               <c:pt idx="1">
-                <c:v>0.530461</c:v>
+                <c:v>3.92879239474</c:v>
               </c:pt>
               <c:pt idx="2">
-                <c:v>2.318877</c:v>
-              </c:pt>
-              <c:pt idx="3">
-                <c:v>0.530461</c:v>
+                <c:v>51.6713585174</c:v>
               </c:pt>
             </c:numLit>
           </c:val>
@@ -1561,54 +1558,7 @@
           <c:idx val="1"/>
           <c:order val="1"/>
           <c:tx>
-            <c:v>Immigration wait P95</c:v>
-          </c:tx>
-          <c:spPr>
-            <a:solidFill xmlns:a="http://schemas.openxmlformats.org/drawingml/2006/main">
-              <a:srgbClr val="6DCBF4"/>
-            </a:solidFill>
-          </c:spPr>
-          <c:cat>
-            <c:strLit>
-              <c:ptCount val="4"/>
-              <c:pt idx="0">
-                <c:v>Reference</c:v>
-              </c:pt>
-              <c:pt idx="1">
-                <c:v>Security +4</c:v>
-              </c:pt>
-              <c:pt idx="2">
-                <c:v>Immigration +3</c:v>
-              </c:pt>
-              <c:pt idx="3">
-                <c:v>Both +4/+3</c:v>
-              </c:pt>
-            </c:strLit>
-          </c:cat>
-          <c:val>
-            <c:numLit>
-              <c:formatCode>0.00</c:formatCode>
-              <c:ptCount val="4"/>
-              <c:pt idx="0">
-                <c:v>2.334975</c:v>
-              </c:pt>
-              <c:pt idx="1">
-                <c:v>3.259367</c:v>
-              </c:pt>
-              <c:pt idx="2">
-                <c:v>0.359401</c:v>
-              </c:pt>
-              <c:pt idx="3">
-                <c:v>0.705027</c:v>
-              </c:pt>
-            </c:numLit>
-          </c:val>
-        </c:ser>
-        <c:ser>
-          <c:idx val="2"/>
-          <c:order val="2"/>
-          <c:tx>
-            <c:v>Total wait P95</c:v>
+            <c:v>Joint +4/+3</c:v>
           </c:tx>
           <c:spPr>
             <a:solidFill xmlns:a="http://schemas.openxmlformats.org/drawingml/2006/main">
@@ -1617,36 +1567,33 @@
           </c:spPr>
           <c:cat>
             <c:strLit>
-              <c:ptCount val="4"/>
+              <c:ptCount val="3"/>
               <c:pt idx="0">
-                <c:v>Reference</c:v>
+                <c:v>Low
+max rho 0.585</c:v>
               </c:pt>
               <c:pt idx="1">
-                <c:v>Security +4</c:v>
+                <c:v>Base
+max rho 0.845</c:v>
               </c:pt>
               <c:pt idx="2">
-                <c:v>Immigration +3</c:v>
-              </c:pt>
-              <c:pt idx="3">
-                <c:v>Both +4/+3</c:v>
+                <c:v>High
+max rho 1.180</c:v>
               </c:pt>
             </c:strLit>
           </c:cat>
           <c:val>
             <c:numLit>
               <c:formatCode>0.00</c:formatCode>
-              <c:ptCount val="4"/>
+              <c:ptCount val="3"/>
               <c:pt idx="0">
-                <c:v>3.928792</c:v>
+                <c:v>0</c:v>
               </c:pt>
               <c:pt idx="1">
-                <c:v>3.71883</c:v>
+                <c:v>1.25006024874</c:v>
               </c:pt>
               <c:pt idx="2">
-                <c:v>2.576771</c:v>
-              </c:pt>
-              <c:pt idx="3">
-                <c:v>1.25006</c:v>
+                <c:v>18.5130449023</c:v>
               </c:pt>
             </c:numLit>
           </c:val>
@@ -1724,7 +1671,7 @@
         <c:axId val="48672768"/>
         <c:scaling>
           <c:orientation val="minMax"/>
-          <c:max val="4"/>
+          <c:max val="60"/>
           <c:min val="0"/>
         </c:scaling>
         <c:delete val="0"/>
@@ -1739,7 +1686,7 @@
             </a:ln>
           </c:spPr>
         </c:majorGridlines>
-        <c:numFmt formatCode="0.0"/>
+        <c:numFmt formatCode="0"/>
         <c:majorTickMark val="none"/>
         <c:minorTickMark val="none"/>
         <c:spPr>
@@ -1768,7 +1715,7 @@
         </c:txPr>
         <c:crossAx val="48650112"/>
         <c:crossBetween val="between"/>
-        <c:majorUnit val="1"/>
+        <c:majorUnit val="10"/>
       </c:valAx>
       <c:spPr>
         <a:noFill xmlns:a="http://schemas.openxmlformats.org/drawingml/2006/main"/>
@@ -2120,7 +2067,7 @@
       </p:sp>
       <p:cxnSp>
         <p:nvCxnSpPr>
-          <p:cNvPr id="27" name="Google-Shape-2259-p159-4"/>
+          <p:cNvPr id="30" name="Google-Shape-2259-p159-4"/>
           <p:cNvCxnSpPr/>
           <p:nvPr/>
         </p:nvCxnSpPr>
@@ -2419,6 +2366,7 @@
               <a:spcAft>
                 <a:spcPts val="8"/>
               </a:spcAft>
+              <a:buNone/>
               <a:defRPr sz="1600">
                 <a:solidFill>
                   <a:srgbClr val="000000"/>
@@ -2448,6 +2396,7 @@
               <a:spcAft>
                 <a:spcPts val="8"/>
               </a:spcAft>
+              <a:buNone/>
               <a:defRPr sz="1600">
                 <a:solidFill>
                   <a:srgbClr val="000000"/>
@@ -2477,6 +2426,7 @@
               <a:spcAft>
                 <a:spcPts val="0"/>
               </a:spcAft>
+              <a:buNone/>
               <a:defRPr sz="1600">
                 <a:solidFill>
                   <a:srgbClr val="000000"/>
@@ -2536,6 +2486,7 @@
               <a:spcAft>
                 <a:spcPts val="8"/>
               </a:spcAft>
+              <a:buNone/>
               <a:defRPr sz="1600">
                 <a:solidFill>
                   <a:srgbClr val="000000"/>
@@ -2565,6 +2516,7 @@
               <a:spcAft>
                 <a:spcPts val="8"/>
               </a:spcAft>
+              <a:buNone/>
               <a:defRPr sz="1600">
                 <a:solidFill>
                   <a:srgbClr val="000000"/>
@@ -2594,6 +2546,7 @@
               <a:spcAft>
                 <a:spcPts val="0"/>
               </a:spcAft>
+              <a:buNone/>
               <a:defRPr sz="1600">
                 <a:solidFill>
                   <a:srgbClr val="000000"/>
@@ -2653,6 +2606,7 @@
               <a:spcAft>
                 <a:spcPts val="8"/>
               </a:spcAft>
+              <a:buNone/>
               <a:defRPr sz="1600">
                 <a:solidFill>
                   <a:srgbClr val="000000"/>
@@ -2682,6 +2636,7 @@
               <a:spcAft>
                 <a:spcPts val="8"/>
               </a:spcAft>
+              <a:buNone/>
               <a:defRPr sz="1600">
                 <a:solidFill>
                   <a:srgbClr val="000000"/>
@@ -2711,6 +2666,7 @@
               <a:spcAft>
                 <a:spcPts val="0"/>
               </a:spcAft>
+              <a:buNone/>
               <a:defRPr sz="1600">
                 <a:solidFill>
                   <a:srgbClr val="000000"/>
@@ -3472,6 +3428,7 @@
               <a:spcAft>
                 <a:spcPts val="7"/>
               </a:spcAft>
+              <a:buNone/>
               <a:defRPr sz="1600">
                 <a:solidFill>
                   <a:srgbClr val="000000"/>
@@ -3501,6 +3458,7 @@
               <a:spcAft>
                 <a:spcPts val="7"/>
               </a:spcAft>
+              <a:buNone/>
               <a:defRPr sz="1600">
                 <a:solidFill>
                   <a:srgbClr val="000000"/>
@@ -3530,6 +3488,7 @@
               <a:spcAft>
                 <a:spcPts val="5"/>
               </a:spcAft>
+              <a:buNone/>
               <a:defRPr sz="1600">
                 <a:solidFill>
                   <a:srgbClr val="000000"/>
@@ -3559,6 +3518,7 @@
               <a:spcAft>
                 <a:spcPts val="0"/>
               </a:spcAft>
+              <a:buNone/>
               <a:defRPr sz="1600">
                 <a:solidFill>
                   <a:srgbClr val="000000"/>
@@ -3653,7 +3613,7 @@
                 <a:ea typeface="Helvetica Neue"/>
                 <a:cs typeface="Helvetica Neue"/>
               </a:rPr>
-              <a:t>Joint +4/+3 cuts base-rate P95; the modelled gain is rate-dependent</a:t>
+              <a:t>Under stress, joint capacity prevents bottleneck migration</a:t>
             </a:r>
           </a:p>
         </p:txBody>
@@ -3707,7 +3667,7 @@
                 <a:ea typeface="Helvetica Neue"/>
                 <a:cs typeface="Helvetica Neue"/>
               </a:rPr>
-              <a:t>Base-rate mean stage queue-wait P95 (s), n=50/cell</a:t>
+              <a:t>Reference vs joint total queue-wait P95 (s), n=50/cell</a:t>
             </a:r>
           </a:p>
         </p:txBody>
@@ -3777,6 +3737,7 @@
               <a:spcAft>
                 <a:spcPts val="6"/>
               </a:spcAft>
+              <a:buNone/>
               <a:defRPr sz="1600">
                 <a:solidFill>
                   <a:srgbClr val="000000"/>
@@ -3795,7 +3756,7 @@
                 <a:ea typeface="Helvetica Neue"/>
                 <a:cs typeface="Helvetica Neue"/>
               </a:rPr>
-              <a:t>Primary effect: −2.679 s</a:t>
+              <a:t>Low load: no capacity action</a:t>
             </a:r>
           </a:p>
           <a:p xmlns:a="http://schemas.openxmlformats.org/drawingml/2006/main">
@@ -3806,6 +3767,7 @@
               <a:spcAft>
                 <a:spcPts val="0"/>
               </a:spcAft>
+              <a:buNone/>
               <a:defRPr sz="1600">
                 <a:solidFill>
                   <a:srgbClr val="000000"/>
@@ -3824,7 +3786,29 @@
                 <a:ea typeface="Helvetica Neue"/>
                 <a:cs typeface="Helvetica Neue"/>
               </a:rPr>
-              <a:t>Joint minus reference [95% paired CI −3.061, −2.297]. Half-width 0.382 s; target ≤ 1.0 s.</a:t>
+              <a:t>At </a:t>
+            </a:r>
+            <a:r>
+              <a:rPr sz="1600" b="0">
+                <a:solidFill>
+                  <a:srgbClr val="000000"/>
+                </a:solidFill>
+                <a:latin typeface="Helvetica Neue"/>
+                <a:ea typeface="Helvetica Neue"/>
+                <a:cs typeface="Helvetica Neue"/>
+              </a:rPr>
+              <a:t>max rho</a:t>
+            </a:r>
+            <a:r>
+              <a:rPr sz="1600" b="0">
+                <a:solidFill>
+                  <a:srgbClr val="000000"/>
+                </a:solidFill>
+                <a:latin typeface="Helvetica Neue"/>
+                <a:ea typeface="Helvetica Neue"/>
+                <a:cs typeface="Helvetica Neue"/>
+              </a:rPr>
+              <a:t> 0.585, reference P95 is 0.067 s and joint is 0.000 s. Statistically resolved; operationally negligible.</a:t>
             </a:r>
           </a:p>
         </p:txBody>
@@ -3894,6 +3878,7 @@
               <a:spcAft>
                 <a:spcPts val="7"/>
               </a:spcAft>
+              <a:buNone/>
               <a:defRPr sz="1600">
                 <a:solidFill>
                   <a:srgbClr val="000000"/>
@@ -3912,7 +3897,7 @@
                 <a:ea typeface="Helvetica Neue"/>
                 <a:cs typeface="Helvetica Neue"/>
               </a:rPr>
-              <a:t>Supporting rate sensitivity</a:t>
+              <a:t>High load: decision becomes material</a:t>
             </a:r>
           </a:p>
           <a:p xmlns:a="http://schemas.openxmlformats.org/drawingml/2006/main">
@@ -3923,6 +3908,7 @@
               <a:spcAft>
                 <a:spcPts val="0"/>
               </a:spcAft>
+              <a:buNone/>
               <a:defRPr sz="1600">
                 <a:solidFill>
                   <a:srgbClr val="000000"/>
@@ -3941,7 +3927,29 @@
                 <a:ea typeface="Helvetica Neue"/>
                 <a:cs typeface="Helvetica Neue"/>
               </a:rPr>
-              <a:t>Reference minus joint: 0.067 s low; 2.679 s base; 33.158 s high. All three paired intervals exclude zero.</a:t>
+              <a:t>At </a:t>
+            </a:r>
+            <a:r>
+              <a:rPr sz="1600" b="0">
+                <a:solidFill>
+                  <a:srgbClr val="000000"/>
+                </a:solidFill>
+                <a:latin typeface="Helvetica Neue"/>
+                <a:ea typeface="Helvetica Neue"/>
+                <a:cs typeface="Helvetica Neue"/>
+              </a:rPr>
+              <a:t>max rho</a:t>
+            </a:r>
+            <a:r>
+              <a:rPr sz="1600" b="0">
+                <a:solidFill>
+                  <a:srgbClr val="000000"/>
+                </a:solidFill>
+                <a:latin typeface="Helvetica Neue"/>
+                <a:ea typeface="Helvetica Neue"/>
+                <a:cs typeface="Helvetica Neue"/>
+              </a:rPr>
+              <a:t> 1.180, reference P95 is 51.671 s and joint is 18.513 s. Gain 33.158 s [31.410, 34.906].</a:t>
             </a:r>
           </a:p>
         </p:txBody>
@@ -4011,6 +4019,7 @@
               <a:spcAft>
                 <a:spcPts val="7"/>
               </a:spcAft>
+              <a:buNone/>
               <a:defRPr sz="1600">
                 <a:solidFill>
                   <a:srgbClr val="000000"/>
@@ -4029,7 +4038,7 @@
                 <a:ea typeface="Helvetica Neue"/>
                 <a:cs typeface="Helvetica Neue"/>
               </a:rPr>
-              <a:t>Joint is lowest or tied-lowest—not dominant</a:t>
+              <a:t>Single-stage relief moves the constraint</a:t>
             </a:r>
           </a:p>
           <a:p xmlns:a="http://schemas.openxmlformats.org/drawingml/2006/main">
@@ -4040,6 +4049,7 @@
               <a:spcAft>
                 <a:spcPts val="0"/>
               </a:spcAft>
+              <a:buNone/>
               <a:defRPr sz="1600">
                 <a:solidFill>
                   <a:srgbClr val="000000"/>
@@ -4058,7 +4068,7 @@
                 <a:ea typeface="Helvetica Neue"/>
                 <a:cs typeface="Helvetica Neue"/>
               </a:rPr>
-              <a:t>At the low endpoint, Joint and Immigration +3 tie at 0.000 s. Joint is lowest at base/high; some supporting intervals remain unresolved.</a:t>
+              <a:t>At high rate, Security +4 leaves Immigration P95 35.902 s; Immigration +3 leaves Security P95 44.107 s.</a:t>
             </a:r>
           </a:p>
         </p:txBody>
@@ -4112,7 +4122,7 @@
                 <a:ea typeface="Helvetica Neue"/>
                 <a:cs typeface="Helvetica Neue"/>
               </a:rPr>
-              <a:t>Confirmatory primary contrast · 12 cells × 50 · CRN PASS → paired 95% CI</a:t>
+              <a:t>15/30/60 s diagnostics are post-hoc—not ICA SLAs · primary base contrast frozen</a:t>
             </a:r>
           </a:p>
           <a:p xmlns:a="http://schemas.openxmlformats.org/drawingml/2006/main">
@@ -4136,7 +4146,7 @@
                 <a:ea typeface="Helvetica Neue"/>
                 <a:cs typeface="Helvetica Neue"/>
               </a:rPr>
-              <a:t>Rate rankings supporting · exact HPP count interval · fixed service · pooled FCFS</a:t>
+              <a:t>Nominal offered load on x-axis · fixed service · pooled FCFS · empty start · full drain</a:t>
             </a:r>
           </a:p>
         </p:txBody>
@@ -4197,7 +4207,7 @@
         </p:xfrm>
         <a:graphic xmlns:a="http://schemas.openxmlformats.org/drawingml/2006/main">
           <a:graphicData uri="http://schemas.openxmlformats.org/drawingml/2006/chart">
-            <c:chart xmlns:r="http://schemas.openxmlformats.org/officeDocument/2006/relationships" xmlns:c="http://schemas.openxmlformats.org/drawingml/2006/chart" r:id="R02207a6133c04e3c"/>
+            <c:chart xmlns:r="http://schemas.openxmlformats.org/officeDocument/2006/relationships" xmlns:c="http://schemas.openxmlformats.org/drawingml/2006/chart" r:id="R92b88b4ee4cd4299"/>
           </a:graphicData>
         </a:graphic>
       </p:graphicFrame>
@@ -4372,7 +4382,7 @@
                 <a:ea typeface="Helvetica Neue"/>
                 <a:cs typeface="Helvetica Neue"/>
               </a:rPr>
-              <a:t>Confirmatory mechanism PASS → field calibration → costed operational trial</a:t>
+              <a:t>NOW: calibrate → TRIGGER: peak queues → NEXT: price pilot → LIMIT: no rollout</a:t>
             </a:r>
           </a:p>
         </p:txBody>
@@ -4591,6 +4601,7 @@
               <a:spcAft>
                 <a:spcPts val="8"/>
               </a:spcAft>
+              <a:buNone/>
               <a:defRPr sz="1600">
                 <a:solidFill>
                   <a:srgbClr val="000000"/>
@@ -4609,7 +4620,7 @@
                 <a:ea typeface="Helvetica Neue"/>
                 <a:cs typeface="Helvetica Neue"/>
               </a:rPr>
-              <a:t>Decision supported: carry joint +4/+3 forward</a:t>
+              <a:t>NOW — carry joint +4/+3 into field calibration</a:t>
             </a:r>
           </a:p>
           <a:p xmlns:a="http://schemas.openxmlformats.org/drawingml/2006/main">
@@ -4620,6 +4631,7 @@
               <a:spcAft>
                 <a:spcPts val="2"/>
               </a:spcAft>
+              <a:buNone/>
               <a:defRPr sz="1600">
                 <a:solidFill>
                   <a:srgbClr val="000000"/>
@@ -4638,7 +4650,7 @@
                 <a:ea typeface="Helvetica Neue"/>
                 <a:cs typeface="Helvetica Neue"/>
               </a:rPr>
-              <a:t>Base-rate reduction: 2.679 s</a:t>
+              <a:t>EVIDENCE — 2.679 s base; 33.158 s high</a:t>
             </a:r>
           </a:p>
           <a:p xmlns:a="http://schemas.openxmlformats.org/drawingml/2006/main">
@@ -4649,6 +4661,7 @@
               <a:spcAft>
                 <a:spcPts val="7"/>
               </a:spcAft>
+              <a:buNone/>
               <a:defRPr sz="1600">
                 <a:solidFill>
                   <a:srgbClr val="000000"/>
@@ -4667,7 +4680,7 @@
                 <a:ea typeface="Helvetica Neue"/>
                 <a:cs typeface="Helvetica Neue"/>
               </a:rPr>
-              <a:t>95% paired CI 2.297–3.061 · half-width 0.382 s</a:t>
+              <a:t>Paired 95% CIs exclude zero · 50 replications per cell</a:t>
             </a:r>
           </a:p>
           <a:p xmlns:a="http://schemas.openxmlformats.org/drawingml/2006/main">
@@ -4678,6 +4691,7 @@
               <a:spcAft>
                 <a:spcPts val="2"/>
               </a:spcAft>
+              <a:buNone/>
               <a:defRPr sz="1600">
                 <a:solidFill>
                   <a:srgbClr val="000000"/>
@@ -4696,7 +4710,7 @@
                 <a:ea typeface="Helvetica Neue"/>
                 <a:cs typeface="Helvetica Neue"/>
               </a:rPr>
-              <a:t>Lowest or tied-lowest at all 3 rates</a:t>
+              <a:t>TRIGGER — measured peak queues are material</a:t>
             </a:r>
           </a:p>
           <a:p xmlns:a="http://schemas.openxmlformats.org/drawingml/2006/main">
@@ -4707,6 +4721,7 @@
               <a:spcAft>
                 <a:spcPts val="8"/>
               </a:spcAft>
+              <a:buNone/>
               <a:defRPr sz="1600">
                 <a:solidFill>
                   <a:srgbClr val="000000"/>
@@ -4725,7 +4740,7 @@
                 <a:ea typeface="Helvetica Neue"/>
                 <a:cs typeface="Helvetica Neue"/>
               </a:rPr>
-              <a:t>Low: tied with Immigration +3 · base/high: lowest point estimate</a:t>
+              <a:t>Use time-of-day arrivals + stage service distributions</a:t>
             </a:r>
           </a:p>
           <a:p xmlns:a="http://schemas.openxmlformats.org/drawingml/2006/main">
@@ -4736,6 +4751,7 @@
               <a:spcAft>
                 <a:spcPts val="0"/>
               </a:spcAft>
+              <a:buNone/>
               <a:defRPr sz="1600">
                 <a:solidFill>
                   <a:srgbClr val="000000"/>
@@ -4754,7 +4770,7 @@
                 <a:ea typeface="Helvetica Neue"/>
                 <a:cs typeface="Helvetica Neue"/>
               </a:rPr>
-              <a:t>Not a staffing, forecast, cost or site-validation result. The largest uncertainty is real time-of-day arrivals and stage service distributions.</a:t>
+              <a:t>LIMIT — no roster count, site forecast, economic optimum or deployment approval.</a:t>
             </a:r>
           </a:p>
         </p:txBody>

</xml_diff>

<commit_message>
Refine Task 4 framing and evidence boundaries
</commit_message>
<xml_diff>
--- a/slides/HTX_Task4_Operational_Insights.pptx
+++ b/slides/HTX_Task4_Operational_Insights.pptx
@@ -2,17 +2,17 @@
 <file path=ppt/presentation.xml><?xml version="1.0" encoding="utf-8"?>
 <p:presentation xmlns:p="http://schemas.openxmlformats.org/presentationml/2006/main">
   <p:sldMasterIdLst>
-    <p:sldMasterId xmlns:r="http://schemas.openxmlformats.org/officeDocument/2006/relationships" id="2147483648" r:id="R469502352ce74ba2"/>
+    <p:sldMasterId xmlns:r="http://schemas.openxmlformats.org/officeDocument/2006/relationships" id="2147483648" r:id="R6516814f0a9f4452"/>
   </p:sldMasterIdLst>
   <p:notesMasterIdLst>
-    <p:notesMasterId xmlns:r="http://schemas.openxmlformats.org/officeDocument/2006/relationships" r:id="R0abd3eb344624eaa"/>
+    <p:notesMasterId xmlns:r="http://schemas.openxmlformats.org/officeDocument/2006/relationships" r:id="R169d0fb4336e4369"/>
   </p:notesMasterIdLst>
   <p:sldIdLst>
-    <p:sldId xmlns:r="http://schemas.openxmlformats.org/officeDocument/2006/relationships" id="256" r:id="R5eb244bd70984e3f"/>
-    <p:sldId xmlns:r="http://schemas.openxmlformats.org/officeDocument/2006/relationships" id="257" r:id="R721ec3b0e1f54a36"/>
-    <p:sldId xmlns:r="http://schemas.openxmlformats.org/officeDocument/2006/relationships" id="258" r:id="Re3fdd7f528b64733"/>
-    <p:sldId xmlns:r="http://schemas.openxmlformats.org/officeDocument/2006/relationships" id="259" r:id="R0babbaa336654ac8"/>
-    <p:sldId xmlns:r="http://schemas.openxmlformats.org/officeDocument/2006/relationships" id="260" r:id="R0140eb22a4884283"/>
+    <p:sldId xmlns:r="http://schemas.openxmlformats.org/officeDocument/2006/relationships" id="256" r:id="R56165029c4034130"/>
+    <p:sldId xmlns:r="http://schemas.openxmlformats.org/officeDocument/2006/relationships" id="257" r:id="R6ba46074551c4222"/>
+    <p:sldId xmlns:r="http://schemas.openxmlformats.org/officeDocument/2006/relationships" id="258" r:id="R198a000c90fc4930"/>
+    <p:sldId xmlns:r="http://schemas.openxmlformats.org/officeDocument/2006/relationships" id="259" r:id="R71bd3fb00d804889"/>
+    <p:sldId xmlns:r="http://schemas.openxmlformats.org/officeDocument/2006/relationships" id="260" r:id="Re20cf3b48d464ab8"/>
   </p:sldIdLst>
   <p:sldSz cx="12192000" cy="6858000"/>
   <p:notesSz cx="6858000" cy="9144000"/>
@@ -666,12 +666,22 @@
           </a:p>
           <a:p xmlns:a="http://schemas.openxmlformats.org/drawingml/2006/main">
             <a:r>
-              <a:t>The deterministic oracle remains at zero before saturation; stochastic HPP arrivals already create transient queues.</a:t>
-            </a:r>
-          </a:p>
-          <a:p xmlns:a="http://schemas.openxmlformats.org/drawingml/2006/main">
-            <a:r>
-              <a:t>Both one-position penalties and paired second differences increase toward the threshold.</a:t>
+              <a:t>Every cell admits travellers for 300 seconds from an empty and idle start, then drains the full cohort.</a:t>
+            </a:r>
+          </a:p>
+          <a:p xmlns:a="http://schemas.openxmlformats.org/drawingml/2006/main">
+            <a:r>
+              <a:t>The deterministic oracle uses regular arrivals and fixed service. Stochastic HPP arrivals create transient queues before deterministic saturation.</a:t>
+            </a:r>
+          </a:p>
+          <a:p xmlns:a="http://schemas.openxmlformats.org/drawingml/2006/main">
+            <a:r>
+              <a:t>The plotted response is the mean replication-level P95 total queue wait: 3.93–35.92 seconds across the 54 cells.</a:t>
+            </a:r>
+          </a:p>
+          <a:p xmlns:a="http://schemas.openxmlformats.org/drawingml/2006/main">
+            <a:r>
+              <a:t>Neither series is a calibrated site forecast; physical corridor-to-processing-unit allocation, routing and resource sharing were not observed.</a:t>
             </a:r>
           </a:p>
           <a:p xmlns:a="http://schemas.openxmlformats.org/drawingml/2006/main">
@@ -686,6 +696,16 @@
           </a:p>
           <a:p xmlns:a="http://schemas.openxmlformats.org/drawingml/2006/main">
             <a:r>
+              <a:t>- docs/task1_measurement.md</a:t>
+            </a:r>
+          </a:p>
+          <a:p xmlns:a="http://schemas.openxmlformats.org/drawingml/2006/main">
+            <a:r>
+              <a:t>- docs/task3_capacity_response_surface_design.md</a:t>
+            </a:r>
+          </a:p>
+          <a:p xmlns:a="http://schemas.openxmlformats.org/drawingml/2006/main">
+            <a:r>
               <a:t>- results/analysis/capacity_response_surface/security_only_slice.csv</a:t>
             </a:r>
           </a:p>
@@ -696,27 +716,12 @@
           </a:p>
           <a:p xmlns:a="http://schemas.openxmlformats.org/drawingml/2006/main">
             <a:r>
-              <a:t>- results/analysis/capacity_response_surface/adjacent_marginal_penalties.csv</a:t>
-            </a:r>
-          </a:p>
-          <a:p xmlns:a="http://schemas.openxmlformats.org/drawingml/2006/main">
-            <a:r>
-              <a:t>- results/analysis/capacity_response_surface/second_finite_differences.csv</a:t>
-            </a:r>
-          </a:p>
-          <a:p xmlns:a="http://schemas.openxmlformats.org/drawingml/2006/main">
-            <a:r>
               <a:t>- results/analysis/capacity_response_surface/ideal_case_comparator.csv</a:t>
             </a:r>
           </a:p>
           <a:p xmlns:a="http://schemas.openxmlformats.org/drawingml/2006/main">
             <a:r>
               <a:t>- results/analysis/capacity_response_surface/validation.json</a:t>
-            </a:r>
-          </a:p>
-          <a:p xmlns:a="http://schemas.openxmlformats.org/drawingml/2006/main">
-            <a:r>
-              <a:t>- results/analysis/capacity_response_surface/crn_alignment.json</a:t>
             </a:r>
           </a:p>
           <a:p xmlns:a="http://schemas.openxmlformats.org/drawingml/2006/main">
@@ -796,6 +801,16 @@
           </a:p>
           <a:p xmlns:a="http://schemas.openxmlformats.org/drawingml/2006/main">
             <a:r>
+              <a:t>This is a 300-second terminating Base-demand cohort from an empty and idle start, followed by full drain, with 50 independent replications per cell.</a:t>
+            </a:r>
+          </a:p>
+          <a:p xmlns:a="http://schemas.openxmlformats.org/drawingml/2006/main">
+            <a:r>
+              <a:t>The plotted cell means span 3.93–35.92 seconds. Registered 600-, 900- and 1200-second traveller-level exceedance rates are zero in all 2,700 runs; these are illustrative diagnostics, not a local ICA SLA.</a:t>
+            </a:r>
+          </a:p>
+          <a:p xmlns:a="http://schemas.openxmlformats.org/drawingml/2006/main">
+            <a:r>
               <a:t>The negative local interaction is a tandem-queue metering effect. It does not mean removing capacity improves performance.</a:t>
             </a:r>
           </a:p>
@@ -811,6 +826,11 @@
           </a:p>
           <a:p xmlns:a="http://schemas.openxmlformats.org/drawingml/2006/main">
             <a:r>
+              <a:t>- docs/task3_results.md</a:t>
+            </a:r>
+          </a:p>
+          <a:p xmlns:a="http://schemas.openxmlformats.org/drawingml/2006/main">
+            <a:r>
               <a:t>- results/analysis/capacity_response_surface/heatmap.csv</a:t>
             </a:r>
           </a:p>
@@ -826,7 +846,7 @@
           </a:p>
           <a:p xmlns:a="http://schemas.openxmlformats.org/drawingml/2006/main">
             <a:r>
-              <a:t>- results/analysis/capacity_response_surface/cross_batch_reproducibility.json</a:t>
+              <a:t>- results/analysis/capacity_response_surface/threshold_exceedance_diagnostics.json</a:t>
             </a:r>
           </a:p>
           <a:p xmlns:a="http://schemas.openxmlformats.org/drawingml/2006/main">
@@ -906,6 +926,16 @@
           </a:p>
           <a:p xmlns:a="http://schemas.openxmlformats.org/drawingml/2006/main">
             <a:r>
+              <a:t>The accepted 1.364213/s rate is a directional corridor line-crossing aggregate, not an observed arrival rate for one physical pooled processing unit.</a:t>
+            </a:r>
+          </a:p>
+          <a:p xmlns:a="http://schemas.openxmlformats.org/drawingml/2006/main">
+            <a:r>
+              <a:t>Field calibration must identify corridor-to-processing-unit allocation, routing, resource sharing, open-resource schedules, stage service and exception pathways.</a:t>
+            </a:r>
+          </a:p>
+          <a:p xmlns:a="http://schemas.openxmlformats.org/drawingml/2006/main">
+            <a:r>
               <a:t>Use joint +4/+3 as a validated stress-test mechanism, not a default field recommendation.</a:t>
             </a:r>
           </a:p>
@@ -917,6 +947,16 @@
           <a:p xmlns:a="http://schemas.openxmlformats.org/drawingml/2006/main">
             <a:r>
               <a:t>[Sources]</a:t>
+            </a:r>
+          </a:p>
+          <a:p xmlns:a="http://schemas.openxmlformats.org/drawingml/2006/main">
+            <a:r>
+              <a:t>- docs/task1_measurement.md</a:t>
+            </a:r>
+          </a:p>
+          <a:p xmlns:a="http://schemas.openxmlformats.org/drawingml/2006/main">
+            <a:r>
+              <a:t>- docs/task2_system_design.md</a:t>
             </a:r>
           </a:p>
           <a:p xmlns:a="http://schemas.openxmlformats.org/drawingml/2006/main">
@@ -1004,7 +1044,7 @@
   </p:cSld>
   <p:clrMap bg1="lt1" tx1="dk1" bg2="lt2" tx2="dk2" accent1="accent1" accent2="accent2" accent3="accent3" accent4="accent4" accent5="accent5" accent6="accent6" hlink="hlink" folHlink="folHlink"/>
   <p:sldLayoutIdLst>
-    <p:sldLayoutId xmlns:r="http://schemas.openxmlformats.org/officeDocument/2006/relationships" id="2147483649" r:id="R7a64b20a6a8340b0"/>
+    <p:sldLayoutId xmlns:r="http://schemas.openxmlformats.org/officeDocument/2006/relationships" id="2147483649" r:id="R77caedd6d5b4496a"/>
   </p:sldLayoutIdLst>
   <p:txStyles>
     <p:titleStyle>
@@ -1560,15 +1600,15 @@
         <p:spPr>
           <a:xfrm xmlns:a="http://schemas.openxmlformats.org/drawingml/2006/main">
             <a:off x="390525" y="1409700"/>
-            <a:ext cx="5810250" cy="2457450"/>
+            <a:ext cx="6048375" cy="552450"/>
           </a:xfrm>
           <a:prstGeom xmlns:a="http://schemas.openxmlformats.org/drawingml/2006/main" prst="rect">
             <a:avLst/>
           </a:prstGeom>
         </p:spPr>
         <p:txBody>
-          <a:bodyPr xmlns:a="http://schemas.openxmlformats.org/drawingml/2006/main" lIns="0" tIns="0" rIns="0" bIns="0" anchor="t">
-            <a:normAutofit fontScale="100000"/>
+          <a:bodyPr xmlns:a="http://schemas.openxmlformats.org/drawingml/2006/main" wrap="none" lIns="0" tIns="0" rIns="0" bIns="0" anchor="t">
+            <a:noAutofit/>
           </a:bodyPr>
           <a:lstStyle xmlns:a="http://schemas.openxmlformats.org/drawingml/2006/main"/>
           <a:p xmlns:a="http://schemas.openxmlformats.org/drawingml/2006/main">
@@ -1577,25 +1617,25 @@
                 <a:spcPct val="94000"/>
               </a:lnSpc>
               <a:buNone/>
-              <a:defRPr sz="3600" b="0">
-                <a:solidFill>
-                  <a:srgbClr val="111318"/>
-                </a:solidFill>
-                <a:latin typeface="Helvetica Neue"/>
-                <a:ea typeface="Helvetica Neue"/>
-                <a:cs typeface="Helvetica Neue"/>
-              </a:defRPr>
-            </a:pPr>
-            <a:r>
-              <a:rPr sz="3600" b="0">
-                <a:solidFill>
-                  <a:srgbClr val="111318"/>
-                </a:solidFill>
-                <a:latin typeface="Helvetica Neue"/>
-                <a:ea typeface="Helvetica Neue"/>
-                <a:cs typeface="Helvetica Neue"/>
-              </a:rPr>
-              <a:t>From 24.9 seconds of video to an auditable decision model</a:t>
+              <a:defRPr sz="2850" b="1">
+                <a:solidFill>
+                  <a:srgbClr val="111318"/>
+                </a:solidFill>
+                <a:latin typeface="Helvetica Neue"/>
+                <a:ea typeface="Helvetica Neue"/>
+                <a:cs typeface="Helvetica Neue"/>
+              </a:defRPr>
+            </a:pPr>
+            <a:r>
+              <a:rPr sz="2850" b="1">
+                <a:solidFill>
+                  <a:srgbClr val="111318"/>
+                </a:solidFill>
+                <a:latin typeface="Helvetica Neue"/>
+                <a:ea typeface="Helvetica Neue"/>
+                <a:cs typeface="Helvetica Neue"/>
+              </a:rPr>
+              <a:t>Evidence-Driven Checkpoint Simulation</a:t>
             </a:r>
           </a:p>
         </p:txBody>
@@ -1773,14 +1813,14 @@
       </p:sp>
       <p:pic>
         <p:nvPicPr>
-          <p:cNvPr id="18" name=""/>
+          <p:cNvPr id="19" name=""/>
           <p:cNvPicPr>
             <a:picLocks xmlns:a="http://schemas.openxmlformats.org/drawingml/2006/main" noChangeAspect="1"/>
           </p:cNvPicPr>
           <p:nvPr/>
         </p:nvPicPr>
         <p:blipFill>
-          <a:blip xmlns:r="http://schemas.openxmlformats.org/officeDocument/2006/relationships" xmlns:a="http://schemas.openxmlformats.org/drawingml/2006/main" r:embed="Rf952ed9880df42e5"/>
+          <a:blip xmlns:r="http://schemas.openxmlformats.org/officeDocument/2006/relationships" xmlns:a="http://schemas.openxmlformats.org/drawingml/2006/main" r:embed="Rd3ed1c7481a24050"/>
           <a:srcRect xmlns:a="http://schemas.openxmlformats.org/drawingml/2006/main" l="0" t="21" r="0" b="21"/>
           <a:stretch xmlns:a="http://schemas.openxmlformats.org/drawingml/2006/main">
             <a:fillRect l="0" t="0" r="0" b="0"/>
@@ -2120,6 +2160,95 @@
                 <a:cs typeface="Helvetica Neue"/>
               </a:rPr>
               <a:t>Human-adjudicated aggregate · not a long-run demand estimate</a:t>
+            </a:r>
+          </a:p>
+        </p:txBody>
+      </p:sp>
+      <p:sp>
+        <p:nvSpPr>
+          <p:cNvPr id="14" name="cover-subtitle">
+            <a:extLst xmlns:a="http://schemas.openxmlformats.org/drawingml/2006/main">
+              <a:ext uri="{FF2B5EF4-FFF2-40B4-BE49-F238E27FC236}">
+                <a16:creationId xmlns:a16="http://schemas.microsoft.com/office/drawing/2014/main" id="{302F7C1E-79AD-46F9-838D-8F539C78353D}"/>
+              </a:ext>
+            </a:extLst>
+          </p:cNvPr>
+          <p:cNvSpPr>
+            <a:spLocks xmlns:a="http://schemas.openxmlformats.org/drawingml/2006/main" noGrp="1"/>
+          </p:cNvSpPr>
+          <p:nvPr/>
+        </p:nvSpPr>
+        <p:spPr>
+          <a:xfrm xmlns:a="http://schemas.openxmlformats.org/drawingml/2006/main">
+            <a:off x="390525" y="2133600"/>
+            <a:ext cx="5810250" cy="838200"/>
+          </a:xfrm>
+          <a:prstGeom xmlns:a="http://schemas.openxmlformats.org/drawingml/2006/main" prst="rect">
+            <a:avLst/>
+          </a:prstGeom>
+          <a:noFill xmlns:a="http://schemas.openxmlformats.org/drawingml/2006/main"/>
+          <a:ln xmlns:a="http://schemas.openxmlformats.org/drawingml/2006/main" w="0">
+            <a:noFill/>
+            <a:prstDash val="solid"/>
+          </a:ln>
+        </p:spPr>
+        <p:txBody>
+          <a:bodyPr xmlns:a="http://schemas.openxmlformats.org/drawingml/2006/main" wrap="square" lIns="0" tIns="0" rIns="0" bIns="0" anchor="t">
+            <a:noAutofit/>
+          </a:bodyPr>
+          <a:lstStyle xmlns:a="http://schemas.openxmlformats.org/drawingml/2006/main"/>
+          <a:p xmlns:a="http://schemas.openxmlformats.org/drawingml/2006/main">
+            <a:pPr algn="l">
+              <a:lnSpc>
+                <a:spcPct val="105000"/>
+              </a:lnSpc>
+              <a:buNone/>
+              <a:defRPr sz="2250">
+                <a:solidFill>
+                  <a:srgbClr val="606A78"/>
+                </a:solidFill>
+                <a:latin typeface="Helvetica Neue"/>
+                <a:ea typeface="Helvetica Neue"/>
+                <a:cs typeface="Helvetica Neue"/>
+              </a:defRPr>
+            </a:pPr>
+            <a:r>
+              <a:rPr sz="2250">
+                <a:solidFill>
+                  <a:srgbClr val="606A78"/>
+                </a:solidFill>
+                <a:latin typeface="Helvetica Neue"/>
+                <a:ea typeface="Helvetica Neue"/>
+                <a:cs typeface="Helvetica Neue"/>
+              </a:rPr>
+              <a:t>From 24.9 seconds of video to</a:t>
+            </a:r>
+          </a:p>
+          <a:p xmlns:a="http://schemas.openxmlformats.org/drawingml/2006/main">
+            <a:pPr algn="l">
+              <a:lnSpc>
+                <a:spcPct val="105000"/>
+              </a:lnSpc>
+              <a:buNone/>
+              <a:defRPr sz="2250">
+                <a:solidFill>
+                  <a:srgbClr val="606A78"/>
+                </a:solidFill>
+                <a:latin typeface="Helvetica Neue"/>
+                <a:ea typeface="Helvetica Neue"/>
+                <a:cs typeface="Helvetica Neue"/>
+              </a:defRPr>
+            </a:pPr>
+            <a:r>
+              <a:rPr sz="2250">
+                <a:solidFill>
+                  <a:srgbClr val="606A78"/>
+                </a:solidFill>
+                <a:latin typeface="Helvetica Neue"/>
+                <a:ea typeface="Helvetica Neue"/>
+                <a:cs typeface="Helvetica Neue"/>
+              </a:rPr>
+              <a:t>an auditable decision model</a:t>
             </a:r>
           </a:p>
         </p:txBody>
@@ -2246,7 +2375,7 @@
       </p:sp>
       <p:cxnSp>
         <p:nvCxnSpPr>
-          <p:cNvPr id="72" name="Google-Shape-2259-p159-4"/>
+          <p:cNvPr id="92" name="Google-Shape-2259-p159-4"/>
           <p:cNvCxnSpPr/>
           <p:nvPr/>
         </p:nvCxnSpPr>
@@ -2823,14 +2952,14 @@
       </p:sp>
       <p:pic>
         <p:nvPicPr>
-          <p:cNvPr id="83" name=""/>
+          <p:cNvPr id="103" name=""/>
           <p:cNvPicPr>
             <a:picLocks xmlns:a="http://schemas.openxmlformats.org/drawingml/2006/main" noChangeAspect="1"/>
           </p:cNvPicPr>
           <p:nvPr/>
         </p:nvPicPr>
         <p:blipFill>
-          <a:blip xmlns:r="http://schemas.openxmlformats.org/officeDocument/2006/relationships" xmlns:a="http://schemas.openxmlformats.org/drawingml/2006/main" r:embed="R5b0d60890fda46c6"/>
+          <a:blip xmlns:r="http://schemas.openxmlformats.org/officeDocument/2006/relationships" xmlns:a="http://schemas.openxmlformats.org/drawingml/2006/main" r:embed="R6917c91f7e1a4ff6"/>
           <a:srcRect xmlns:a="http://schemas.openxmlformats.org/drawingml/2006/main" l="0" t="1627" r="0" b="1627"/>
           <a:stretch xmlns:a="http://schemas.openxmlformats.org/drawingml/2006/main">
             <a:fillRect l="0" t="0" r="0" b="0"/>
@@ -2883,14 +3012,14 @@
       </p:sp>
       <p:pic>
         <p:nvPicPr>
-          <p:cNvPr id="85" name=""/>
+          <p:cNvPr id="105" name=""/>
           <p:cNvPicPr>
             <a:picLocks xmlns:a="http://schemas.openxmlformats.org/drawingml/2006/main" noChangeAspect="1"/>
           </p:cNvPicPr>
           <p:nvPr/>
         </p:nvPicPr>
         <p:blipFill>
-          <a:blip xmlns:r="http://schemas.openxmlformats.org/officeDocument/2006/relationships" xmlns:a="http://schemas.openxmlformats.org/drawingml/2006/main" r:embed="Ra69672afbc064cad"/>
+          <a:blip xmlns:r="http://schemas.openxmlformats.org/officeDocument/2006/relationships" xmlns:a="http://schemas.openxmlformats.org/drawingml/2006/main" r:embed="R1815f72c52684584"/>
           <a:srcRect xmlns:a="http://schemas.openxmlformats.org/drawingml/2006/main" l="0" t="8139" r="0" b="8139"/>
           <a:stretch xmlns:a="http://schemas.openxmlformats.org/drawingml/2006/main">
             <a:fillRect l="0" t="0" r="0" b="0"/>
@@ -4415,6 +4544,7 @@
               <a:spcAft>
                 <a:spcPts val="4"/>
               </a:spcAft>
+              <a:buNone/>
               <a:defRPr sz="1600">
                 <a:solidFill>
                   <a:srgbClr val="000000"/>
@@ -4438,6 +4568,7 @@
           </a:p>
           <a:p xmlns:a="http://schemas.openxmlformats.org/drawingml/2006/main">
             <a:pPr>
+              <a:buNone/>
               <a:defRPr sz="1600">
                 <a:solidFill>
                   <a:srgbClr val="000000"/>
@@ -4494,6 +4625,7 @@
               <a:spcAft>
                 <a:spcPts val="4"/>
               </a:spcAft>
+              <a:buNone/>
               <a:defRPr sz="1600">
                 <a:solidFill>
                   <a:srgbClr val="000000"/>
@@ -4517,6 +4649,7 @@
           </a:p>
           <a:p xmlns:a="http://schemas.openxmlformats.org/drawingml/2006/main">
             <a:pPr>
+              <a:buNone/>
               <a:defRPr sz="1600">
                 <a:solidFill>
                   <a:srgbClr val="000000"/>
@@ -4573,6 +4706,7 @@
               <a:spcAft>
                 <a:spcPts val="4"/>
               </a:spcAft>
+              <a:buNone/>
               <a:defRPr sz="1600">
                 <a:solidFill>
                   <a:srgbClr val="000000"/>
@@ -4596,6 +4730,7 @@
           </a:p>
           <a:p xmlns:a="http://schemas.openxmlformats.org/drawingml/2006/main">
             <a:pPr>
+              <a:buNone/>
               <a:defRPr sz="1600">
                 <a:solidFill>
                   <a:srgbClr val="000000"/>
@@ -4668,7 +4803,7 @@
                 <a:ea typeface="Helvetica Neue"/>
                 <a:cs typeface="Helvetica Neue"/>
               </a:rPr>
-              <a:t>Ideal = regular arrivals + fixed service—not a site forecast.</a:t>
+              <a:t>300-s terminating cohort · empty/idle start · full drain; ideal = regular arrivals + fixed service.</a:t>
             </a:r>
           </a:p>
           <a:p xmlns:a="http://schemas.openxmlformats.org/drawingml/2006/main">
@@ -4692,7 +4827,7 @@
                 <a:ea typeface="Helvetica Neue"/>
                 <a:cs typeface="Helvetica Neue"/>
               </a:rPr>
-              <a:t>Only integer capacities were simulated; connecting lines are visual guides.</a:t>
+              <a:t>Cell-mean P95 spans 3.93–35.92 s; neither series is a calibrated site forecast.</a:t>
             </a:r>
           </a:p>
         </p:txBody>
@@ -4750,7 +4885,7 @@
           <p:nvPr/>
         </p:nvPicPr>
         <p:blipFill>
-          <a:blip xmlns:r="http://schemas.openxmlformats.org/officeDocument/2006/relationships" xmlns:a="http://schemas.openxmlformats.org/drawingml/2006/main" r:embed="R7dd444da82444c01"/>
+          <a:blip xmlns:r="http://schemas.openxmlformats.org/officeDocument/2006/relationships" xmlns:a="http://schemas.openxmlformats.org/drawingml/2006/main" r:embed="Rf08fa1ab821f49ec"/>
           <a:stretch xmlns:a="http://schemas.openxmlformats.org/drawingml/2006/main"/>
         </p:blipFill>
         <p:spPr>
@@ -4834,7 +4969,7 @@
                 <a:ea typeface="Helvetica Neue"/>
                 <a:cs typeface="Helvetica Neue"/>
               </a:rPr>
-              <a:t>The active bottleneck—not two shortages added—sets delay</a:t>
+              <a:t>The bottleneck shifts—but waits stay sub-minute at this model scale</a:t>
             </a:r>
           </a:p>
         </p:txBody>
@@ -4926,6 +5061,7 @@
               <a:spcAft>
                 <a:spcPts val="4"/>
               </a:spcAft>
+              <a:buNone/>
               <a:defRPr sz="1600">
                 <a:solidFill>
                   <a:srgbClr val="000000"/>
@@ -4949,6 +5085,7 @@
           </a:p>
           <a:p xmlns:a="http://schemas.openxmlformats.org/drawingml/2006/main">
             <a:pPr>
+              <a:buNone/>
               <a:defRPr sz="1600">
                 <a:solidFill>
                   <a:srgbClr val="000000"/>
@@ -5005,6 +5142,7 @@
               <a:spcAft>
                 <a:spcPts val="4"/>
               </a:spcAft>
+              <a:buNone/>
               <a:defRPr sz="1600">
                 <a:solidFill>
                   <a:srgbClr val="000000"/>
@@ -5028,6 +5166,7 @@
           </a:p>
           <a:p xmlns:a="http://schemas.openxmlformats.org/drawingml/2006/main">
             <a:pPr>
+              <a:buNone/>
               <a:defRPr sz="1600">
                 <a:solidFill>
                   <a:srgbClr val="000000"/>
@@ -5084,6 +5223,7 @@
               <a:spcAft>
                 <a:spcPts val="4"/>
               </a:spcAft>
+              <a:buNone/>
               <a:defRPr sz="1600">
                 <a:solidFill>
                   <a:srgbClr val="000000"/>
@@ -5107,6 +5247,7 @@
           </a:p>
           <a:p xmlns:a="http://schemas.openxmlformats.org/drawingml/2006/main">
             <a:pPr>
+              <a:buNone/>
               <a:defRPr sz="1600">
                 <a:solidFill>
                   <a:srgbClr val="000000"/>
@@ -5179,7 +5320,7 @@
                 <a:ea typeface="Helvetica Neue"/>
                 <a:cs typeface="Helvetica Neue"/>
               </a:rPr>
-              <a:t>Exploratory sensitivity at fixed Base demand · n=50/cell · 2,700/2,700 COMPLETE</a:t>
+              <a:t>300-s Base cohort · empty/idle start · full drain · n=50/cell</a:t>
             </a:r>
           </a:p>
           <a:p xmlns:a="http://schemas.openxmlformats.org/drawingml/2006/main">
@@ -5203,7 +5344,7 @@
                 <a:ea typeface="Helvetica Neue"/>
                 <a:cs typeface="Helvetica Neue"/>
               </a:rPr>
-              <a:t>Bottleneck map is conditional evidence—not a staffing recommendation.</a:t>
+              <a:t>Cell-mean P95 3.93–35.92 s; 600/900/1200-s exceedance = 0—not an ICA SLA.</a:t>
             </a:r>
           </a:p>
         </p:txBody>
@@ -5261,7 +5402,7 @@
           <p:nvPr/>
         </p:nvPicPr>
         <p:blipFill>
-          <a:blip xmlns:r="http://schemas.openxmlformats.org/officeDocument/2006/relationships" xmlns:a="http://schemas.openxmlformats.org/drawingml/2006/main" r:embed="Rb3c910794dd1451c"/>
+          <a:blip xmlns:r="http://schemas.openxmlformats.org/officeDocument/2006/relationships" xmlns:a="http://schemas.openxmlformats.org/drawingml/2006/main" r:embed="Rb2ed192b369b413e"/>
           <a:srcRect xmlns:a="http://schemas.openxmlformats.org/drawingml/2006/main" l="0" t="9865" r="0" b="9865"/>
           <a:stretch xmlns:a="http://schemas.openxmlformats.org/drawingml/2006/main">
             <a:fillRect l="0" t="0" r="0" b="0"/>
@@ -5610,6 +5751,7 @@
           <a:lstStyle xmlns:a="http://schemas.openxmlformats.org/drawingml/2006/main"/>
           <a:p xmlns:a="http://schemas.openxmlformats.org/drawingml/2006/main">
             <a:pPr>
+              <a:buNone/>
               <a:defRPr sz="1350">
                 <a:solidFill>
                   <a:srgbClr val="111318"/>
@@ -5636,6 +5778,7 @@
               <a:spcAft>
                 <a:spcPts val="12"/>
               </a:spcAft>
+              <a:buNone/>
               <a:defRPr sz="1350">
                 <a:solidFill>
                   <a:srgbClr val="111318"/>
@@ -5659,6 +5802,7 @@
           </a:p>
           <a:p xmlns:a="http://schemas.openxmlformats.org/drawingml/2006/main">
             <a:pPr>
+              <a:buNone/>
               <a:defRPr sz="1350">
                 <a:solidFill>
                   <a:srgbClr val="111318"/>
@@ -5685,6 +5829,7 @@
               <a:spcAft>
                 <a:spcPts val="12"/>
               </a:spcAft>
+              <a:buNone/>
               <a:defRPr sz="1350">
                 <a:solidFill>
                   <a:srgbClr val="111318"/>
@@ -5708,6 +5853,7 @@
           </a:p>
           <a:p xmlns:a="http://schemas.openxmlformats.org/drawingml/2006/main">
             <a:pPr>
+              <a:buNone/>
               <a:defRPr sz="1350">
                 <a:solidFill>
                   <a:srgbClr val="111318"/>
@@ -5731,6 +5877,7 @@
           </a:p>
           <a:p xmlns:a="http://schemas.openxmlformats.org/drawingml/2006/main">
             <a:pPr>
+              <a:buNone/>
               <a:defRPr sz="1350">
                 <a:solidFill>
                   <a:srgbClr val="111318"/>
@@ -5749,7 +5896,7 @@
                 <a:ea typeface="Helvetica Neue"/>
                 <a:cs typeface="Helvetica Neue"/>
               </a:rPr>
-              <a:t>36/21 is a derived reference—not observed staffing. No roster or deployment approval.</a:t>
+              <a:t>36/21 is a derived pooled reference—not observed staffing. Corridor-to-processing-unit allocation is unobserved.</a:t>
             </a:r>
           </a:p>
         </p:txBody>
@@ -5806,7 +5953,7 @@
                 <a:ea typeface="Helvetica Neue"/>
                 <a:cs typeface="Helvetica Neue"/>
               </a:rPr>
-              <a:t>Stage service, exception and downtime distributions</a:t>
+              <a:t>Corridor-to-processing-unit allocation + routing</a:t>
             </a:r>
           </a:p>
         </p:txBody>
@@ -5987,7 +6134,7 @@
                 <a:ea typeface="Helvetica Neue"/>
                 <a:cs typeface="Helvetica Neue"/>
               </a:rPr>
-              <a:t>Observed queues, open resources and rosters</a:t>
+              <a:t>Stage service, exceptions + open-resource schedules</a:t>
             </a:r>
           </a:p>
         </p:txBody>
@@ -6168,7 +6315,7 @@
                 <a:ea typeface="Helvetica Neue"/>
                 <a:cs typeface="Helvetica Neue"/>
               </a:rPr>
-              <a:t>Costed bottleneck-aware pilot + operating constraints</a:t>
+              <a:t>Observed queues + costed pilot constraints</a:t>
             </a:r>
           </a:p>
         </p:txBody>

</xml_diff>

<commit_message>
Finalize Task 4 evidence deck
</commit_message>
<xml_diff>
--- a/slides/HTX_Task4_Operational_Insights.pptx
+++ b/slides/HTX_Task4_Operational_Insights.pptx
@@ -2,17 +2,17 @@
 <file path=ppt/presentation.xml><?xml version="1.0" encoding="utf-8"?>
 <p:presentation xmlns:p="http://schemas.openxmlformats.org/presentationml/2006/main">
   <p:sldMasterIdLst>
-    <p:sldMasterId xmlns:r="http://schemas.openxmlformats.org/officeDocument/2006/relationships" id="2147483648" r:id="R6516814f0a9f4452"/>
+    <p:sldMasterId xmlns:r="http://schemas.openxmlformats.org/officeDocument/2006/relationships" id="2147483648" r:id="R8c425503849e416e"/>
   </p:sldMasterIdLst>
   <p:notesMasterIdLst>
-    <p:notesMasterId xmlns:r="http://schemas.openxmlformats.org/officeDocument/2006/relationships" r:id="R169d0fb4336e4369"/>
+    <p:notesMasterId xmlns:r="http://schemas.openxmlformats.org/officeDocument/2006/relationships" r:id="R6b5b9dc16dac44e3"/>
   </p:notesMasterIdLst>
   <p:sldIdLst>
-    <p:sldId xmlns:r="http://schemas.openxmlformats.org/officeDocument/2006/relationships" id="256" r:id="R56165029c4034130"/>
-    <p:sldId xmlns:r="http://schemas.openxmlformats.org/officeDocument/2006/relationships" id="257" r:id="R6ba46074551c4222"/>
-    <p:sldId xmlns:r="http://schemas.openxmlformats.org/officeDocument/2006/relationships" id="258" r:id="R198a000c90fc4930"/>
-    <p:sldId xmlns:r="http://schemas.openxmlformats.org/officeDocument/2006/relationships" id="259" r:id="R71bd3fb00d804889"/>
-    <p:sldId xmlns:r="http://schemas.openxmlformats.org/officeDocument/2006/relationships" id="260" r:id="Re20cf3b48d464ab8"/>
+    <p:sldId xmlns:r="http://schemas.openxmlformats.org/officeDocument/2006/relationships" id="256" r:id="R26e0ce142c7743ee"/>
+    <p:sldId xmlns:r="http://schemas.openxmlformats.org/officeDocument/2006/relationships" id="257" r:id="Re8897910e7f34930"/>
+    <p:sldId xmlns:r="http://schemas.openxmlformats.org/officeDocument/2006/relationships" id="258" r:id="Rd582a5bf99b74fd2"/>
+    <p:sldId xmlns:r="http://schemas.openxmlformats.org/officeDocument/2006/relationships" id="259" r:id="R69666be41df948b7"/>
+    <p:sldId xmlns:r="http://schemas.openxmlformats.org/officeDocument/2006/relationships" id="260" r:id="R5f47166071a742b5"/>
   </p:sldIdLst>
   <p:sldSz cx="12192000" cy="6858000"/>
   <p:notesSz cx="6858000" cy="9144000"/>
@@ -446,12 +446,17 @@
           <a:lstStyle xmlns:a="http://schemas.openxmlformats.org/drawingml/2006/main"/>
           <a:p xmlns:a="http://schemas.openxmlformats.org/drawingml/2006/main">
             <a:r>
-              <a:t>Open with the evidence chain: a human-adjudicated short-window count becomes a conditional simulation input, not a site forecast.</a:t>
-            </a:r>
-          </a:p>
-          <a:p xmlns:a="http://schemas.openxmlformats.org/drawingml/2006/main">
-            <a:r>
-              <a:t>The response surface extends the analysis without changing that measurement boundary.</a:t>
+              <a:t>Open with the evidence boundary: the 24.9-second clip provides a human-adjudicated directional corridor anchor, not a site demand forecast.</a:t>
+            </a:r>
+          </a:p>
+          <a:p xmlns:a="http://schemas.openxmlformats.org/drawingml/2006/main">
+            <a:r>
+              <a:t>The executable model then asks conditional operating questions under explicit assumptions.</a:t>
+            </a:r>
+          </a:p>
+          <a:p xmlns:a="http://schemas.openxmlformats.org/drawingml/2006/main">
+            <a:r>
+              <a:t>The main AnyLogic evidence comprises 600 confirmatory, 2,700 capacity-surface, 450 service-variability and 1,000 peak-duration runs.</a:t>
             </a:r>
           </a:p>
           <a:p xmlns:a="http://schemas.openxmlformats.org/drawingml/2006/main">
@@ -477,6 +482,21 @@
           <a:p xmlns:a="http://schemas.openxmlformats.org/drawingml/2006/main">
             <a:r>
               <a:t>- docs/task3_capacity_response_surface_design.md</a:t>
+            </a:r>
+          </a:p>
+          <a:p xmlns:a="http://schemas.openxmlformats.org/drawingml/2006/main">
+            <a:r>
+              <a:t>- docs/task3_service_variability_sensitivity_design.md</a:t>
+            </a:r>
+          </a:p>
+          <a:p xmlns:a="http://schemas.openxmlformats.org/drawingml/2006/main">
+            <a:r>
+              <a:t>- docs/task3_peak_duration_sensitivity_design.md</a:t>
+            </a:r>
+          </a:p>
+          <a:p xmlns:a="http://schemas.openxmlformats.org/drawingml/2006/main">
+            <a:r>
+              <a:t>- simulation/anylogic/HTXCheckpointSimulation/HTXCheckpointSimulation.alpx</a:t>
             </a:r>
           </a:p>
           <a:p xmlns:a="http://schemas.openxmlformats.org/drawingml/2006/main">
@@ -551,12 +571,17 @@
           <a:lstStyle xmlns:a="http://schemas.openxmlformats.org/drawingml/2006/main"/>
           <a:p xmlns:a="http://schemas.openxmlformats.org/drawingml/2006/main">
             <a:r>
-              <a:t>Keep the three layers separate: measurement supplies the demand anchor; the DES encodes the mechanism; inference is split into confirmatory and exploratory studies.</a:t>
-            </a:r>
-          </a:p>
-          <a:p xmlns:a="http://schemas.openxmlformats.org/drawingml/2006/main">
-            <a:r>
-              <a:t>The five old capacity cells validate reproducibility only and contribute no observations to the new response surface.</a:t>
+              <a:t>This slide keeps the evidence layers separate so each claim can be traced to its source and assumptions.</a:t>
+            </a:r>
+          </a:p>
+          <a:p xmlns:a="http://schemas.openxmlformats.org/drawingml/2006/main">
+            <a:r>
+              <a:t>The production-reference detector/tracker is licence-permissive YOLOX-S + ByteTrack; the YOLO26m + BoT-SORT run is retained only as a rapid technical-assessment demonstration.</a:t>
+            </a:r>
+          </a:p>
+          <a:p xmlns:a="http://schemas.openxmlformats.org/drawingml/2006/main">
+            <a:r>
+              <a:t>The queue-layout result is an offline exact-gated conditional replay. The AnyLogic model and UI implement pooled FCFS only.</a:t>
             </a:r>
           </a:p>
           <a:p xmlns:a="http://schemas.openxmlformats.org/drawingml/2006/main">
@@ -576,17 +601,32 @@
           </a:p>
           <a:p xmlns:a="http://schemas.openxmlformats.org/drawingml/2006/main">
             <a:r>
-              <a:t>- simulation/anylogic/HTXCheckpointSimulation/HTXCheckpointSimulation.alpx</a:t>
-            </a:r>
-          </a:p>
-          <a:p xmlns:a="http://schemas.openxmlformats.org/drawingml/2006/main">
-            <a:r>
-              <a:t>- docs/task3_confirmatory_design.md</a:t>
-            </a:r>
-          </a:p>
-          <a:p xmlns:a="http://schemas.openxmlformats.org/drawingml/2006/main">
-            <a:r>
-              <a:t>- docs/task3_capacity_response_surface_design.md</a:t>
+              <a:t>- docs/task2_system_design.md</a:t>
+            </a:r>
+          </a:p>
+          <a:p xmlns:a="http://schemas.openxmlformats.org/drawingml/2006/main">
+            <a:r>
+              <a:t>- docs/task3_results.md</a:t>
+            </a:r>
+          </a:p>
+          <a:p xmlns:a="http://schemas.openxmlformats.org/drawingml/2006/main">
+            <a:r>
+              <a:t>- results/analysis/capacity_response_surface/validation.json</a:t>
+            </a:r>
+          </a:p>
+          <a:p xmlns:a="http://schemas.openxmlformats.org/drawingml/2006/main">
+            <a:r>
+              <a:t>- results/analysis/service_variability/validation.json</a:t>
+            </a:r>
+          </a:p>
+          <a:p xmlns:a="http://schemas.openxmlformats.org/drawingml/2006/main">
+            <a:r>
+              <a:t>- results/analysis/peak_duration_sensitivity/validation.json</a:t>
+            </a:r>
+          </a:p>
+          <a:p xmlns:a="http://schemas.openxmlformats.org/drawingml/2006/main">
+            <a:r>
+              <a:t>- LICENSING.md</a:t>
             </a:r>
           </a:p>
           <a:p xmlns:a="http://schemas.openxmlformats.org/drawingml/2006/main">
@@ -661,27 +701,17 @@
           <a:lstStyle xmlns:a="http://schemas.openxmlformats.org/drawingml/2006/main"/>
           <a:p xmlns:a="http://schemas.openxmlformats.org/drawingml/2006/main">
             <a:r>
-              <a:t>The straight relationship belongs to throughput capacity, not queueing delay.</a:t>
-            </a:r>
-          </a:p>
-          <a:p xmlns:a="http://schemas.openxmlformats.org/drawingml/2006/main">
-            <a:r>
-              <a:t>Every cell admits travellers for 300 seconds from an empty and idle start, then drains the full cohort.</a:t>
-            </a:r>
-          </a:p>
-          <a:p xmlns:a="http://schemas.openxmlformats.org/drawingml/2006/main">
-            <a:r>
-              <a:t>The deterministic oracle uses regular arrivals and fixed service. Stochastic HPP arrivals create transient queues before deterministic saturation.</a:t>
-            </a:r>
-          </a:p>
-          <a:p xmlns:a="http://schemas.openxmlformats.org/drawingml/2006/main">
-            <a:r>
-              <a:t>The plotted response is the mean replication-level P95 total queue wait: 3.93–35.92 seconds across the 54 cells.</a:t>
-            </a:r>
-          </a:p>
-          <a:p xmlns:a="http://schemas.openxmlformats.org/drawingml/2006/main">
-            <a:r>
-              <a:t>Neither series is a calibrated site forecast; physical corridor-to-processing-unit allocation, routing and resource sharing were not observed.</a:t>
+              <a:t>The heatmap is the decision surface: flat regions show one stage masking the other; steep regions expose the active bottleneck.</a:t>
+            </a:r>
+          </a:p>
+          <a:p xmlns:a="http://schemas.openxmlformats.org/drawingml/2006/main">
+            <a:r>
+              <a:t>The deterministic oracle remains useful as a counterfactual: at the 36/21 model reference it predicts zero wait, whereas HPP arrivals create a 3.93-second P95.</a:t>
+            </a:r>
+          </a:p>
+          <a:p xmlns:a="http://schemas.openxmlformats.org/drawingml/2006/main">
+            <a:r>
+              <a:t>36/21 is a derived pooled capacity reference, not observed staffing or a recommended roster.</a:t>
             </a:r>
           </a:p>
           <a:p xmlns:a="http://schemas.openxmlformats.org/drawingml/2006/main">
@@ -696,22 +726,17 @@
           </a:p>
           <a:p xmlns:a="http://schemas.openxmlformats.org/drawingml/2006/main">
             <a:r>
-              <a:t>- docs/task1_measurement.md</a:t>
-            </a:r>
-          </a:p>
-          <a:p xmlns:a="http://schemas.openxmlformats.org/drawingml/2006/main">
-            <a:r>
               <a:t>- docs/task3_capacity_response_surface_design.md</a:t>
             </a:r>
           </a:p>
           <a:p xmlns:a="http://schemas.openxmlformats.org/drawingml/2006/main">
             <a:r>
-              <a:t>- results/analysis/capacity_response_surface/security_only_slice.csv</a:t>
-            </a:r>
-          </a:p>
-          <a:p xmlns:a="http://schemas.openxmlformats.org/drawingml/2006/main">
-            <a:r>
-              <a:t>- results/analysis/capacity_response_surface/immigration_only_slice.csv</a:t>
+              <a:t>- results/analysis/capacity_response_surface/heatmap.csv</a:t>
+            </a:r>
+          </a:p>
+          <a:p xmlns:a="http://schemas.openxmlformats.org/drawingml/2006/main">
+            <a:r>
+              <a:t>- results/analysis/capacity_response_surface/stage_bottleneck_map.csv</a:t>
             </a:r>
           </a:p>
           <a:p xmlns:a="http://schemas.openxmlformats.org/drawingml/2006/main">
@@ -796,22 +821,17 @@
           <a:lstStyle xmlns:a="http://schemas.openxmlformats.org/drawingml/2006/main"/>
           <a:p xmlns:a="http://schemas.openxmlformats.org/drawingml/2006/main">
             <a:r>
-              <a:t>Read the heatmap by columns and rows: flat regions identify which upstream or downstream stage is masking the other.</a:t>
-            </a:r>
-          </a:p>
-          <a:p xmlns:a="http://schemas.openxmlformats.org/drawingml/2006/main">
-            <a:r>
-              <a:t>This is a 300-second terminating Base-demand cohort from an empty and idle start, followed by full drain, with 50 independent replications per cell.</a:t>
-            </a:r>
-          </a:p>
-          <a:p xmlns:a="http://schemas.openxmlformats.org/drawingml/2006/main">
-            <a:r>
-              <a:t>The plotted cell means span 3.93–35.92 seconds. Registered 600-, 900- and 1200-second traveller-level exceedance rates are zero in all 2,700 runs; these are illustrative diagnostics, not a local ICA SLA.</a:t>
-            </a:r>
-          </a:p>
-          <a:p xmlns:a="http://schemas.openxmlformats.org/drawingml/2006/main">
-            <a:r>
-              <a:t>The negative local interaction is a tandem-queue metering effect. It does not mean removing capacity improves performance.</a:t>
+              <a:t>Duration changes the interpretation. The stable model reference remains bounded, the near-critical case has a long transient, and rho above one accumulates travellers over the finite exposure.</a:t>
+            </a:r>
+          </a:p>
+          <a:p xmlns:a="http://schemas.openxmlformats.org/drawingml/2006/main">
+            <a:r>
+              <a:t>The two robustness checks identify different operational levers: service variability mainly affects tail and recovery, while pooling absorbs randomness that separate queues cannot share.</a:t>
+            </a:r>
+          </a:p>
+          <a:p xmlns:a="http://schemas.openxmlformats.org/drawingml/2006/main">
+            <a:r>
+              <a:t>The stationary-HPP extension is a conditional sensitivity, not an observed two-hour peak or a steady-state forecast.</a:t>
             </a:r>
           </a:p>
           <a:p xmlns:a="http://schemas.openxmlformats.org/drawingml/2006/main">
@@ -826,27 +846,27 @@
           </a:p>
           <a:p xmlns:a="http://schemas.openxmlformats.org/drawingml/2006/main">
             <a:r>
-              <a:t>- docs/task3_results.md</a:t>
-            </a:r>
-          </a:p>
-          <a:p xmlns:a="http://schemas.openxmlformats.org/drawingml/2006/main">
-            <a:r>
-              <a:t>- results/analysis/capacity_response_surface/heatmap.csv</a:t>
-            </a:r>
-          </a:p>
-          <a:p xmlns:a="http://schemas.openxmlformats.org/drawingml/2006/main">
-            <a:r>
-              <a:t>- results/analysis/capacity_response_surface/stage_bottleneck_map.csv</a:t>
-            </a:r>
-          </a:p>
-          <a:p xmlns:a="http://schemas.openxmlformats.org/drawingml/2006/main">
-            <a:r>
-              <a:t>- results/analysis/capacity_response_surface/local_interactions.csv</a:t>
-            </a:r>
-          </a:p>
-          <a:p xmlns:a="http://schemas.openxmlformats.org/drawingml/2006/main">
-            <a:r>
-              <a:t>- results/analysis/capacity_response_surface/threshold_exceedance_diagnostics.json</a:t>
+              <a:t>- docs/task3_peak_duration_sensitivity_design.md</a:t>
+            </a:r>
+          </a:p>
+          <a:p xmlns:a="http://schemas.openxmlformats.org/drawingml/2006/main">
+            <a:r>
+              <a:t>- results/analysis/peak_duration_sensitivity/peak_duration_queue_sensitivity.csv</a:t>
+            </a:r>
+          </a:p>
+          <a:p xmlns:a="http://schemas.openxmlformats.org/drawingml/2006/main">
+            <a:r>
+              <a:t>- results/analysis/peak_duration_sensitivity/validation.json</a:t>
+            </a:r>
+          </a:p>
+          <a:p xmlns:a="http://schemas.openxmlformats.org/drawingml/2006/main">
+            <a:r>
+              <a:t>- results/analysis/service_variability/paired_contrasts.csv</a:t>
+            </a:r>
+          </a:p>
+          <a:p xmlns:a="http://schemas.openxmlformats.org/drawingml/2006/main">
+            <a:r>
+              <a:t>- results/analysis/queue_policy_sensitivity/paired_contrasts.csv</a:t>
             </a:r>
           </a:p>
           <a:p xmlns:a="http://schemas.openxmlformats.org/drawingml/2006/main">
@@ -921,22 +941,17 @@
           <a:lstStyle xmlns:a="http://schemas.openxmlformats.org/drawingml/2006/main"/>
           <a:p xmlns:a="http://schemas.openxmlformats.org/drawingml/2006/main">
             <a:r>
-              <a:t>The response surface informs what to measure and which intervention to test; it does not select a roster without calibration.</a:t>
-            </a:r>
-          </a:p>
-          <a:p xmlns:a="http://schemas.openxmlformats.org/drawingml/2006/main">
-            <a:r>
-              <a:t>The accepted 1.364213/s rate is a directional corridor line-crossing aggregate, not an observed arrival rate for one physical pooled processing unit.</a:t>
-            </a:r>
-          </a:p>
-          <a:p xmlns:a="http://schemas.openxmlformats.org/drawingml/2006/main">
-            <a:r>
-              <a:t>Field calibration must identify corridor-to-processing-unit allocation, routing, resource sharing, open-resource schedules, stage service and exception pathways.</a:t>
-            </a:r>
-          </a:p>
-          <a:p xmlns:a="http://schemas.openxmlformats.org/drawingml/2006/main">
-            <a:r>
-              <a:t>Use joint +4/+3 as a validated stress-test mechanism, not a default field recommendation.</a:t>
+              <a:t>The output is a decision sequence, not a roster recommendation.</a:t>
+            </a:r>
+          </a:p>
+          <a:p xmlns:a="http://schemas.openxmlformats.org/drawingml/2006/main">
+            <a:r>
+              <a:t>First calibrate actual time-of-day arrivals, routing, open resources and stage service distributions. Then locate the operating regime and active bottleneck before choosing a lever.</a:t>
+            </a:r>
+          </a:p>
+          <a:p xmlns:a="http://schemas.openxmlformats.org/drawingml/2006/main">
+            <a:r>
+              <a:t>The pilot must validate queue, tail, recovery, cost, layout and security constraints together.</a:t>
             </a:r>
           </a:p>
           <a:p xmlns:a="http://schemas.openxmlformats.org/drawingml/2006/main">
@@ -966,7 +981,7 @@
           </a:p>
           <a:p xmlns:a="http://schemas.openxmlformats.org/drawingml/2006/main">
             <a:r>
-              <a:t>- docs/task3_capacity_response_surface_design.md</a:t>
+              <a:t>- docs/task3_peak_duration_sensitivity_design.md</a:t>
             </a:r>
           </a:p>
           <a:p xmlns:a="http://schemas.openxmlformats.org/drawingml/2006/main">
@@ -1044,7 +1059,7 @@
   </p:cSld>
   <p:clrMap bg1="lt1" tx1="dk1" bg2="lt2" tx2="dk2" accent1="accent1" accent2="accent2" accent3="accent3" accent4="accent4" accent5="accent5" accent6="accent6" hlink="hlink" folHlink="folHlink"/>
   <p:sldLayoutIdLst>
-    <p:sldLayoutId xmlns:r="http://schemas.openxmlformats.org/officeDocument/2006/relationships" id="2147483649" r:id="R77caedd6d5b4496a"/>
+    <p:sldLayoutId xmlns:r="http://schemas.openxmlformats.org/officeDocument/2006/relationships" id="2147483649" r:id="R3fc44018402f4411"/>
   </p:sldLayoutIdLst>
   <p:txStyles>
     <p:titleStyle>
@@ -1664,29 +1679,28 @@
           </a:prstGeom>
         </p:spPr>
         <p:txBody>
-          <a:bodyPr xmlns:a="http://schemas.openxmlformats.org/drawingml/2006/main" lIns="0" tIns="0" rIns="0" bIns="0" anchor="t">
+          <a:bodyPr xmlns:a="http://schemas.openxmlformats.org/drawingml/2006/main" wrap="square" lIns="0" tIns="0" rIns="0" bIns="0" anchor="ctr">
             <a:normAutofit fontScale="100000"/>
           </a:bodyPr>
           <a:lstStyle xmlns:a="http://schemas.openxmlformats.org/drawingml/2006/main"/>
           <a:p xmlns:a="http://schemas.openxmlformats.org/drawingml/2006/main">
-            <a:pPr>
-              <a:lnSpc>
-                <a:spcPct val="108000"/>
-              </a:lnSpc>
-              <a:buNone/>
-              <a:defRPr sz="1500">
-                <a:solidFill>
-                  <a:srgbClr val="606A78"/>
-                </a:solidFill>
-                <a:latin typeface="Helvetica Neue"/>
-                <a:ea typeface="Helvetica Neue"/>
-                <a:cs typeface="Helvetica Neue"/>
-              </a:defRPr>
-            </a:pPr>
-            <a:r>
-              <a:rPr sz="1500" b="1">
-                <a:solidFill>
-                  <a:srgbClr val="606A78"/>
+            <a:pPr algn="l">
+              <a:spcAft>
+                <a:spcPts val="5"/>
+              </a:spcAft>
+              <a:defRPr sz="1350">
+                <a:solidFill>
+                  <a:srgbClr val="596579"/>
+                </a:solidFill>
+                <a:latin typeface="Helvetica Neue"/>
+                <a:ea typeface="Helvetica Neue"/>
+                <a:cs typeface="Helvetica Neue"/>
+              </a:defRPr>
+            </a:pPr>
+            <a:r>
+              <a:rPr sz="1350" b="1">
+                <a:solidFill>
+                  <a:srgbClr val="596579"/>
                 </a:solidFill>
                 <a:latin typeface="Helvetica Neue"/>
                 <a:ea typeface="Helvetica Neue"/>
@@ -1696,30 +1710,26 @@
             </a:r>
           </a:p>
           <a:p xmlns:a="http://schemas.openxmlformats.org/drawingml/2006/main">
-            <a:pPr>
-              <a:lnSpc>
-                <a:spcPct val="108000"/>
-              </a:lnSpc>
-              <a:buNone/>
-              <a:defRPr sz="1500">
-                <a:solidFill>
-                  <a:srgbClr val="606A78"/>
-                </a:solidFill>
-                <a:latin typeface="Helvetica Neue"/>
-                <a:ea typeface="Helvetica Neue"/>
-                <a:cs typeface="Helvetica Neue"/>
-              </a:defRPr>
-            </a:pPr>
-            <a:r>
-              <a:rPr sz="1500">
-                <a:solidFill>
-                  <a:srgbClr val="606A78"/>
-                </a:solidFill>
-                <a:latin typeface="Helvetica Neue"/>
-                <a:ea typeface="Helvetica Neue"/>
-                <a:cs typeface="Helvetica Neue"/>
-              </a:rPr>
-              <a:t>600 confirmatory runs test the mechanism; 2,700 exploratory runs map its operating boundary.</a:t>
+            <a:pPr algn="l">
+              <a:defRPr sz="1350">
+                <a:solidFill>
+                  <a:srgbClr val="596579"/>
+                </a:solidFill>
+                <a:latin typeface="Helvetica Neue"/>
+                <a:ea typeface="Helvetica Neue"/>
+                <a:cs typeface="Helvetica Neue"/>
+              </a:defRPr>
+            </a:pPr>
+            <a:r>
+              <a:rPr sz="1350">
+                <a:solidFill>
+                  <a:srgbClr val="596579"/>
+                </a:solidFill>
+                <a:latin typeface="Helvetica Neue"/>
+                <a:ea typeface="Helvetica Neue"/>
+                <a:cs typeface="Helvetica Neue"/>
+              </a:rPr>
+              <a:t>4,750 validated AnyLogic runs + exact-gated replay map its operating boundary.</a:t>
             </a:r>
           </a:p>
         </p:txBody>
@@ -1748,24 +1758,24 @@
           </a:prstGeom>
         </p:spPr>
         <p:txBody>
-          <a:bodyPr xmlns:a="http://schemas.openxmlformats.org/drawingml/2006/main" lIns="0" tIns="0" rIns="0" bIns="0" anchor="t">
-            <a:noAutofit/>
+          <a:bodyPr xmlns:a="http://schemas.openxmlformats.org/drawingml/2006/main" wrap="square" lIns="0" tIns="0" rIns="0" bIns="0" anchor="ctr">
+            <a:normAutofit fontScale="100000"/>
           </a:bodyPr>
           <a:lstStyle xmlns:a="http://schemas.openxmlformats.org/drawingml/2006/main"/>
           <a:p xmlns:a="http://schemas.openxmlformats.org/drawingml/2006/main">
             <a:pPr algn="l">
               <a:buNone/>
-              <a:defRPr sz="1875" b="0">
-                <a:solidFill>
-                  <a:srgbClr val="000000"/>
-                </a:solidFill>
-                <a:latin typeface="Helvetica Neue"/>
-                <a:ea typeface="Helvetica Neue"/>
-                <a:cs typeface="Helvetica Neue"/>
-              </a:defRPr>
-            </a:pPr>
-            <a:r>
-              <a:rPr sz="1875" b="0">
+              <a:defRPr sz="975" b="0">
+                <a:solidFill>
+                  <a:srgbClr val="000000"/>
+                </a:solidFill>
+                <a:latin typeface="Helvetica Neue"/>
+                <a:ea typeface="Helvetica Neue"/>
+                <a:cs typeface="Helvetica Neue"/>
+              </a:defRPr>
+            </a:pPr>
+            <a:r>
+              <a:rPr sz="975" b="0">
                 <a:solidFill>
                   <a:srgbClr val="000000"/>
                 </a:solidFill>
@@ -1813,15 +1823,15 @@
       </p:sp>
       <p:pic>
         <p:nvPicPr>
-          <p:cNvPr id="19" name=""/>
+          <p:cNvPr id="20" name=""/>
           <p:cNvPicPr>
             <a:picLocks xmlns:a="http://schemas.openxmlformats.org/drawingml/2006/main" noChangeAspect="1"/>
           </p:cNvPicPr>
           <p:nvPr/>
         </p:nvPicPr>
         <p:blipFill>
-          <a:blip xmlns:r="http://schemas.openxmlformats.org/officeDocument/2006/relationships" xmlns:a="http://schemas.openxmlformats.org/drawingml/2006/main" r:embed="Rd3ed1c7481a24050"/>
-          <a:srcRect xmlns:a="http://schemas.openxmlformats.org/drawingml/2006/main" l="0" t="21" r="0" b="21"/>
+          <a:blip xmlns:r="http://schemas.openxmlformats.org/officeDocument/2006/relationships" xmlns:a="http://schemas.openxmlformats.org/drawingml/2006/main" r:embed="Rd8d3dc3955164a19"/>
+          <a:srcRect xmlns:a="http://schemas.openxmlformats.org/drawingml/2006/main" l="0" t="8696" r="0" b="8696"/>
           <a:stretch xmlns:a="http://schemas.openxmlformats.org/drawingml/2006/main">
             <a:fillRect l="0" t="0" r="0" b="0"/>
           </a:stretch>
@@ -1832,9 +1842,7 @@
             <a:ext cx="5048250" cy="2838450"/>
           </a:xfrm>
           <a:prstGeom xmlns:a="http://schemas.openxmlformats.org/drawingml/2006/main" prst="roundRect">
-            <a:avLst>
-              <a:gd name="adj" fmla="val 3356"/>
-            </a:avLst>
+            <a:avLst/>
           </a:prstGeom>
         </p:spPr>
       </p:pic>
@@ -2100,7 +2108,7 @@
                 <a:ea typeface="Helvetica Neue"/>
                 <a:cs typeface="Helvetica Neue"/>
               </a:rPr>
-              <a:t>arrival anchor</a:t>
+              <a:t>short-window anchor</a:t>
             </a:r>
           </a:p>
         </p:txBody>
@@ -2159,7 +2167,7 @@
                 <a:ea typeface="Helvetica Neue"/>
                 <a:cs typeface="Helvetica Neue"/>
               </a:rPr>
-              <a:t>Human-adjudicated aggregate · not a long-run demand estimate</a:t>
+              <a:t>Human-adjudicated short-window aggregate · not a long-run demand estimate</a:t>
             </a:r>
           </a:p>
         </p:txBody>
@@ -2193,8 +2201,8 @@
           </a:ln>
         </p:spPr>
         <p:txBody>
-          <a:bodyPr xmlns:a="http://schemas.openxmlformats.org/drawingml/2006/main" wrap="square" lIns="0" tIns="0" rIns="0" bIns="0" anchor="t">
-            <a:noAutofit/>
+          <a:bodyPr xmlns:a="http://schemas.openxmlformats.org/drawingml/2006/main" wrap="square" lIns="0" tIns="0" rIns="0" bIns="0" anchor="ctr">
+            <a:normAutofit fontScale="100000"/>
           </a:bodyPr>
           <a:lstStyle xmlns:a="http://schemas.openxmlformats.org/drawingml/2006/main"/>
           <a:p xmlns:a="http://schemas.openxmlformats.org/drawingml/2006/main">
@@ -2203,25 +2211,25 @@
                 <a:spcPct val="105000"/>
               </a:lnSpc>
               <a:buNone/>
-              <a:defRPr sz="2250">
-                <a:solidFill>
-                  <a:srgbClr val="606A78"/>
-                </a:solidFill>
-                <a:latin typeface="Helvetica Neue"/>
-                <a:ea typeface="Helvetica Neue"/>
-                <a:cs typeface="Helvetica Neue"/>
-              </a:defRPr>
-            </a:pPr>
-            <a:r>
-              <a:rPr sz="2250">
-                <a:solidFill>
-                  <a:srgbClr val="606A78"/>
-                </a:solidFill>
-                <a:latin typeface="Helvetica Neue"/>
-                <a:ea typeface="Helvetica Neue"/>
-                <a:cs typeface="Helvetica Neue"/>
-              </a:rPr>
-              <a:t>From 24.9 seconds of video to</a:t>
+              <a:defRPr sz="2025">
+                <a:solidFill>
+                  <a:srgbClr val="596579"/>
+                </a:solidFill>
+                <a:latin typeface="Helvetica Neue"/>
+                <a:ea typeface="Helvetica Neue"/>
+                <a:cs typeface="Helvetica Neue"/>
+              </a:defRPr>
+            </a:pPr>
+            <a:r>
+              <a:rPr sz="2025">
+                <a:solidFill>
+                  <a:srgbClr val="596579"/>
+                </a:solidFill>
+                <a:latin typeface="Helvetica Neue"/>
+                <a:ea typeface="Helvetica Neue"/>
+                <a:cs typeface="Helvetica Neue"/>
+              </a:rPr>
+              <a:t>From a 24.9-second observation to</a:t>
             </a:r>
           </a:p>
           <a:p xmlns:a="http://schemas.openxmlformats.org/drawingml/2006/main">
@@ -2230,25 +2238,25 @@
                 <a:spcPct val="105000"/>
               </a:lnSpc>
               <a:buNone/>
-              <a:defRPr sz="2250">
-                <a:solidFill>
-                  <a:srgbClr val="606A78"/>
-                </a:solidFill>
-                <a:latin typeface="Helvetica Neue"/>
-                <a:ea typeface="Helvetica Neue"/>
-                <a:cs typeface="Helvetica Neue"/>
-              </a:defRPr>
-            </a:pPr>
-            <a:r>
-              <a:rPr sz="2250">
-                <a:solidFill>
-                  <a:srgbClr val="606A78"/>
-                </a:solidFill>
-                <a:latin typeface="Helvetica Neue"/>
-                <a:ea typeface="Helvetica Neue"/>
-                <a:cs typeface="Helvetica Neue"/>
-              </a:rPr>
-              <a:t>an auditable decision model</a:t>
+              <a:defRPr sz="2025">
+                <a:solidFill>
+                  <a:srgbClr val="596579"/>
+                </a:solidFill>
+                <a:latin typeface="Helvetica Neue"/>
+                <a:ea typeface="Helvetica Neue"/>
+                <a:cs typeface="Helvetica Neue"/>
+              </a:defRPr>
+            </a:pPr>
+            <a:r>
+              <a:rPr sz="2025">
+                <a:solidFill>
+                  <a:srgbClr val="596579"/>
+                </a:solidFill>
+                <a:latin typeface="Helvetica Neue"/>
+                <a:ea typeface="Helvetica Neue"/>
+                <a:cs typeface="Helvetica Neue"/>
+              </a:rPr>
+              <a:t>a bounded decision sandbox</a:t>
             </a:r>
           </a:p>
         </p:txBody>
@@ -2368,14 +2376,14 @@
                 <a:ea typeface="Helvetica Neue"/>
                 <a:cs typeface="Helvetica Neue"/>
               </a:rPr>
-              <a:t>Measurement, model and inference stay separate—and visible</a:t>
+              <a:t>Measurement, mechanism and inference stay separate—and auditable</a:t>
             </a:r>
           </a:p>
         </p:txBody>
       </p:sp>
       <p:cxnSp>
         <p:nvCxnSpPr>
-          <p:cNvPr id="92" name="Google-Shape-2259-p159-4"/>
+          <p:cNvPr id="107" name="Google-Shape-2259-p159-4"/>
           <p:cNvCxnSpPr/>
           <p:nvPr/>
         </p:nvCxnSpPr>
@@ -2662,19 +2670,19 @@
           </a:prstGeom>
         </p:spPr>
         <p:txBody>
-          <a:bodyPr xmlns:a="http://schemas.openxmlformats.org/drawingml/2006/main" lIns="0" tIns="0" rIns="0" bIns="0" anchor="t">
+          <a:bodyPr xmlns:a="http://schemas.openxmlformats.org/drawingml/2006/main" wrap="square" lIns="0" tIns="0" rIns="0" bIns="0" anchor="t">
             <a:normAutofit fontScale="100000"/>
           </a:bodyPr>
           <a:lstStyle xmlns:a="http://schemas.openxmlformats.org/drawingml/2006/main"/>
           <a:p xmlns:a="http://schemas.openxmlformats.org/drawingml/2006/main">
-            <a:pPr>
+            <a:pPr algn="l">
               <a:lnSpc>
                 <a:spcPct val="102000"/>
               </a:lnSpc>
               <a:buNone/>
               <a:defRPr sz="1125">
                 <a:solidFill>
-                  <a:srgbClr val="111318"/>
+                  <a:srgbClr val="000000"/>
                 </a:solidFill>
                 <a:latin typeface="Helvetica Neue"/>
                 <a:ea typeface="Helvetica Neue"/>
@@ -2684,7 +2692,7 @@
             <a:r>
               <a:rPr sz="1125" b="1">
                 <a:solidFill>
-                  <a:srgbClr val="111318"/>
+                  <a:srgbClr val="000000"/>
                 </a:solidFill>
                 <a:latin typeface="Helvetica Neue"/>
                 <a:ea typeface="Helvetica Neue"/>
@@ -2694,14 +2702,14 @@
             </a:r>
           </a:p>
           <a:p xmlns:a="http://schemas.openxmlformats.org/drawingml/2006/main">
-            <a:pPr>
+            <a:pPr algn="l">
               <a:lnSpc>
                 <a:spcPct val="102000"/>
               </a:lnSpc>
               <a:buNone/>
               <a:defRPr sz="1125">
                 <a:solidFill>
-                  <a:srgbClr val="111318"/>
+                  <a:srgbClr val="000000"/>
                 </a:solidFill>
                 <a:latin typeface="Helvetica Neue"/>
                 <a:ea typeface="Helvetica Neue"/>
@@ -2711,165 +2719,135 @@
             <a:r>
               <a:rPr sz="1125">
                 <a:solidFill>
-                  <a:srgbClr val="111318"/>
-                </a:solidFill>
-                <a:latin typeface="Helvetica Neue"/>
-                <a:ea typeface="Helvetica Neue"/>
-                <a:cs typeface="Helvetica Neue"/>
-              </a:rPr>
-              <a:t>Pooled FCFS · fixed service · full drain.</a:t>
-            </a:r>
-          </a:p>
-        </p:txBody>
-      </p:sp>
-      <p:sp>
-        <p:nvSpPr>
-          <p:cNvPr id="11" name="Text-Placeholder-16-12">
-            <a:extLst xmlns:a="http://schemas.openxmlformats.org/drawingml/2006/main">
-              <a:ext uri="{FF2B5EF4-FFF2-40B4-BE49-F238E27FC236}">
-                <a16:creationId xmlns:a16="http://schemas.microsoft.com/office/drawing/2014/main" id="{9AA59D89-3FCE-416F-9E9C-2F45161A0EC6}"/>
-              </a:ext>
-            </a:extLst>
-          </p:cNvPr>
-          <p:cNvSpPr>
-            <a:spLocks xmlns:a="http://schemas.openxmlformats.org/drawingml/2006/main" noGrp="1"/>
-          </p:cNvSpPr>
-          <p:nvPr/>
-        </p:nvSpPr>
-        <p:spPr>
-          <a:xfrm xmlns:a="http://schemas.openxmlformats.org/drawingml/2006/main">
-            <a:off x="390525" y="5105400"/>
-            <a:ext cx="3524250" cy="838200"/>
-          </a:xfrm>
-          <a:prstGeom xmlns:a="http://schemas.openxmlformats.org/drawingml/2006/main" prst="rect">
-            <a:avLst/>
-          </a:prstGeom>
-        </p:spPr>
-        <p:txBody>
-          <a:bodyPr xmlns:a="http://schemas.openxmlformats.org/drawingml/2006/main" lIns="0" tIns="0" rIns="0" bIns="0" anchor="t">
-            <a:normAutofit fontScale="100000"/>
-          </a:bodyPr>
-          <a:lstStyle xmlns:a="http://schemas.openxmlformats.org/drawingml/2006/main"/>
-          <a:p xmlns:a="http://schemas.openxmlformats.org/drawingml/2006/main">
-            <a:pPr>
+                  <a:srgbClr val="000000"/>
+                </a:solidFill>
+                <a:latin typeface="Helvetica Neue"/>
+                <a:ea typeface="Helvetica Neue"/>
+                <a:cs typeface="Helvetica Neue"/>
+              </a:rPr>
+              <a:t>Pooled FCFS · finite resources · full drain.</a:t>
+            </a:r>
+          </a:p>
+          <a:p xmlns:a="http://schemas.openxmlformats.org/drawingml/2006/main">
+            <a:pPr algn="l">
               <a:lnSpc>
                 <a:spcPct val="102000"/>
               </a:lnSpc>
               <a:buNone/>
               <a:defRPr sz="1125">
                 <a:solidFill>
-                  <a:srgbClr val="111318"/>
-                </a:solidFill>
-                <a:latin typeface="Helvetica Neue"/>
-                <a:ea typeface="Helvetica Neue"/>
-                <a:cs typeface="Helvetica Neue"/>
-              </a:defRPr>
-            </a:pPr>
-            <a:r>
-              <a:rPr sz="1125" b="1">
-                <a:solidFill>
-                  <a:srgbClr val="111318"/>
-                </a:solidFill>
-                <a:latin typeface="Helvetica Neue"/>
-                <a:ea typeface="Helvetica Neue"/>
-                <a:cs typeface="Helvetica Neue"/>
-              </a:rPr>
-              <a:t>34 accepted R→L</a:t>
-            </a:r>
-          </a:p>
-          <a:p xmlns:a="http://schemas.openxmlformats.org/drawingml/2006/main">
-            <a:pPr>
+                  <a:srgbClr val="000000"/>
+                </a:solidFill>
+                <a:latin typeface="Helvetica Neue"/>
+                <a:ea typeface="Helvetica Neue"/>
+                <a:cs typeface="Helvetica Neue"/>
+              </a:defRPr>
+            </a:pPr>
+            <a:r>
+              <a:rPr sz="1125">
+                <a:solidFill>
+                  <a:srgbClr val="000000"/>
+                </a:solidFill>
+                <a:latin typeface="Helvetica Neue"/>
+                <a:ea typeface="Helvetica Neue"/>
+                <a:cs typeface="Helvetica Neue"/>
+              </a:rPr>
+              <a:t>36/21 derived model reference.</a:t>
+            </a:r>
+          </a:p>
+        </p:txBody>
+      </p:sp>
+      <p:sp>
+        <p:nvSpPr>
+          <p:cNvPr id="11" name="Text-Placeholder-16-12">
+            <a:extLst xmlns:a="http://schemas.openxmlformats.org/drawingml/2006/main">
+              <a:ext uri="{FF2B5EF4-FFF2-40B4-BE49-F238E27FC236}">
+                <a16:creationId xmlns:a16="http://schemas.microsoft.com/office/drawing/2014/main" id="{9AA59D89-3FCE-416F-9E9C-2F45161A0EC6}"/>
+              </a:ext>
+            </a:extLst>
+          </p:cNvPr>
+          <p:cNvSpPr>
+            <a:spLocks xmlns:a="http://schemas.openxmlformats.org/drawingml/2006/main" noGrp="1"/>
+          </p:cNvSpPr>
+          <p:nvPr/>
+        </p:nvSpPr>
+        <p:spPr>
+          <a:xfrm xmlns:a="http://schemas.openxmlformats.org/drawingml/2006/main">
+            <a:off x="390525" y="5105400"/>
+            <a:ext cx="3524250" cy="838200"/>
+          </a:xfrm>
+          <a:prstGeom xmlns:a="http://schemas.openxmlformats.org/drawingml/2006/main" prst="rect">
+            <a:avLst/>
+          </a:prstGeom>
+        </p:spPr>
+        <p:txBody>
+          <a:bodyPr xmlns:a="http://schemas.openxmlformats.org/drawingml/2006/main" wrap="square" lIns="0" tIns="0" rIns="0" bIns="0" anchor="t">
+            <a:normAutofit fontScale="100000"/>
+          </a:bodyPr>
+          <a:lstStyle xmlns:a="http://schemas.openxmlformats.org/drawingml/2006/main"/>
+          <a:p xmlns:a="http://schemas.openxmlformats.org/drawingml/2006/main">
+            <a:pPr algn="l">
               <a:lnSpc>
                 <a:spcPct val="102000"/>
               </a:lnSpc>
               <a:buNone/>
               <a:defRPr sz="1125">
                 <a:solidFill>
-                  <a:srgbClr val="111318"/>
-                </a:solidFill>
-                <a:latin typeface="Helvetica Neue"/>
-                <a:ea typeface="Helvetica Neue"/>
-                <a:cs typeface="Helvetica Neue"/>
-              </a:defRPr>
-            </a:pPr>
-            <a:r>
-              <a:rPr sz="1125">
-                <a:solidFill>
-                  <a:srgbClr val="111318"/>
-                </a:solidFill>
-                <a:latin typeface="Helvetica Neue"/>
-                <a:ea typeface="Helvetica Neue"/>
-                <a:cs typeface="Helvetica Neue"/>
-              </a:rPr>
-              <a:t>Human-checked count; HPP interval kept separate.</a:t>
-            </a:r>
-          </a:p>
-        </p:txBody>
-      </p:sp>
-      <p:sp>
-        <p:nvSpPr>
-          <p:cNvPr id="12" name="Text-Placeholder-16-13">
-            <a:extLst xmlns:a="http://schemas.openxmlformats.org/drawingml/2006/main">
-              <a:ext uri="{FF2B5EF4-FFF2-40B4-BE49-F238E27FC236}">
-                <a16:creationId xmlns:a16="http://schemas.microsoft.com/office/drawing/2014/main" id="{5D61E3C9-CDBA-4B52-866E-004F630827F8}"/>
-              </a:ext>
-            </a:extLst>
-          </p:cNvPr>
-          <p:cNvSpPr>
-            <a:spLocks xmlns:a="http://schemas.openxmlformats.org/drawingml/2006/main" noGrp="1"/>
-          </p:cNvSpPr>
-          <p:nvPr/>
-        </p:nvSpPr>
-        <p:spPr>
-          <a:xfrm xmlns:a="http://schemas.openxmlformats.org/drawingml/2006/main">
-            <a:off x="8229600" y="5105400"/>
-            <a:ext cx="3524250" cy="838200"/>
-          </a:xfrm>
-          <a:prstGeom xmlns:a="http://schemas.openxmlformats.org/drawingml/2006/main" prst="rect">
-            <a:avLst/>
-          </a:prstGeom>
-        </p:spPr>
-        <p:txBody>
-          <a:bodyPr xmlns:a="http://schemas.openxmlformats.org/drawingml/2006/main" lIns="0" tIns="0" rIns="0" bIns="0" anchor="t">
-            <a:normAutofit fontScale="100000"/>
-          </a:bodyPr>
-          <a:lstStyle xmlns:a="http://schemas.openxmlformats.org/drawingml/2006/main"/>
-          <a:p xmlns:a="http://schemas.openxmlformats.org/drawingml/2006/main">
-            <a:pPr>
+                  <a:srgbClr val="000000"/>
+                </a:solidFill>
+                <a:latin typeface="Helvetica Neue"/>
+                <a:ea typeface="Helvetica Neue"/>
+                <a:cs typeface="Helvetica Neue"/>
+              </a:defRPr>
+            </a:pPr>
+            <a:r>
+              <a:rPr sz="1125" b="1">
+                <a:solidFill>
+                  <a:srgbClr val="000000"/>
+                </a:solidFill>
+                <a:latin typeface="Helvetica Neue"/>
+                <a:ea typeface="Helvetica Neue"/>
+                <a:cs typeface="Helvetica Neue"/>
+              </a:rPr>
+              <a:t>34 accepted R→L</a:t>
+            </a:r>
+          </a:p>
+          <a:p xmlns:a="http://schemas.openxmlformats.org/drawingml/2006/main">
+            <a:pPr algn="l">
               <a:lnSpc>
                 <a:spcPct val="102000"/>
               </a:lnSpc>
               <a:buNone/>
               <a:defRPr sz="1125">
                 <a:solidFill>
-                  <a:srgbClr val="111318"/>
-                </a:solidFill>
-                <a:latin typeface="Helvetica Neue"/>
-                <a:ea typeface="Helvetica Neue"/>
-                <a:cs typeface="Helvetica Neue"/>
-              </a:defRPr>
-            </a:pPr>
-            <a:r>
-              <a:rPr sz="1125" b="1">
-                <a:solidFill>
-                  <a:srgbClr val="111318"/>
-                </a:solidFill>
-                <a:latin typeface="Helvetica Neue"/>
-                <a:ea typeface="Helvetica Neue"/>
-                <a:cs typeface="Helvetica Neue"/>
-              </a:rPr>
-              <a:t>Confirm: frozen primary contrast</a:t>
-            </a:r>
-          </a:p>
-          <a:p xmlns:a="http://schemas.openxmlformats.org/drawingml/2006/main">
-            <a:pPr>
+                  <a:srgbClr val="000000"/>
+                </a:solidFill>
+                <a:latin typeface="Helvetica Neue"/>
+                <a:ea typeface="Helvetica Neue"/>
+                <a:cs typeface="Helvetica Neue"/>
+              </a:defRPr>
+            </a:pPr>
+            <a:r>
+              <a:rPr sz="1125">
+                <a:solidFill>
+                  <a:srgbClr val="000000"/>
+                </a:solidFill>
+                <a:latin typeface="Helvetica Neue"/>
+                <a:ea typeface="Helvetica Neue"/>
+                <a:cs typeface="Helvetica Neue"/>
+              </a:rPr>
+              <a:t>CV-assisted; human-adjudicated.</a:t>
+            </a:r>
+          </a:p>
+          <a:p xmlns:a="http://schemas.openxmlformats.org/drawingml/2006/main">
+            <a:pPr algn="l">
               <a:lnSpc>
                 <a:spcPct val="102000"/>
               </a:lnSpc>
               <a:buNone/>
               <a:defRPr sz="1125">
                 <a:solidFill>
-                  <a:srgbClr val="111318"/>
+                  <a:srgbClr val="000000"/>
                 </a:solidFill>
                 <a:latin typeface="Helvetica Neue"/>
                 <a:ea typeface="Helvetica Neue"/>
@@ -2879,24 +2857,81 @@
             <a:r>
               <a:rPr sz="1125">
                 <a:solidFill>
-                  <a:srgbClr val="111318"/>
-                </a:solidFill>
-                <a:latin typeface="Helvetica Neue"/>
-                <a:ea typeface="Helvetica Neue"/>
-                <a:cs typeface="Helvetica Neue"/>
-              </a:rPr>
-              <a:t>Explore: Base-demand operating boundary</a:t>
-            </a:r>
-          </a:p>
-          <a:p xmlns:a="http://schemas.openxmlformats.org/drawingml/2006/main">
-            <a:pPr>
+                  <a:srgbClr val="000000"/>
+                </a:solidFill>
+                <a:latin typeface="Helvetica Neue"/>
+                <a:ea typeface="Helvetica Neue"/>
+                <a:cs typeface="Helvetica Neue"/>
+              </a:rPr>
+              <a:t>YOLOX-S + ByteTrack deployment reference.</a:t>
+            </a:r>
+          </a:p>
+        </p:txBody>
+      </p:sp>
+      <p:sp>
+        <p:nvSpPr>
+          <p:cNvPr id="12" name="Text-Placeholder-16-13">
+            <a:extLst xmlns:a="http://schemas.openxmlformats.org/drawingml/2006/main">
+              <a:ext uri="{FF2B5EF4-FFF2-40B4-BE49-F238E27FC236}">
+                <a16:creationId xmlns:a16="http://schemas.microsoft.com/office/drawing/2014/main" id="{5D61E3C9-CDBA-4B52-866E-004F630827F8}"/>
+              </a:ext>
+            </a:extLst>
+          </p:cNvPr>
+          <p:cNvSpPr>
+            <a:spLocks xmlns:a="http://schemas.openxmlformats.org/drawingml/2006/main" noGrp="1"/>
+          </p:cNvSpPr>
+          <p:nvPr/>
+        </p:nvSpPr>
+        <p:spPr>
+          <a:xfrm xmlns:a="http://schemas.openxmlformats.org/drawingml/2006/main">
+            <a:off x="8229600" y="5105400"/>
+            <a:ext cx="3524250" cy="838200"/>
+          </a:xfrm>
+          <a:prstGeom xmlns:a="http://schemas.openxmlformats.org/drawingml/2006/main" prst="rect">
+            <a:avLst/>
+          </a:prstGeom>
+        </p:spPr>
+        <p:txBody>
+          <a:bodyPr xmlns:a="http://schemas.openxmlformats.org/drawingml/2006/main" wrap="square" lIns="0" tIns="0" rIns="0" bIns="0" anchor="t">
+            <a:normAutofit fontScale="100000"/>
+          </a:bodyPr>
+          <a:lstStyle xmlns:a="http://schemas.openxmlformats.org/drawingml/2006/main"/>
+          <a:p xmlns:a="http://schemas.openxmlformats.org/drawingml/2006/main">
+            <a:pPr algn="l">
               <a:lnSpc>
                 <a:spcPct val="102000"/>
               </a:lnSpc>
               <a:buNone/>
               <a:defRPr sz="1125">
                 <a:solidFill>
-                  <a:srgbClr val="111318"/>
+                  <a:srgbClr val="000000"/>
+                </a:solidFill>
+                <a:latin typeface="Helvetica Neue"/>
+                <a:ea typeface="Helvetica Neue"/>
+                <a:cs typeface="Helvetica Neue"/>
+              </a:defRPr>
+            </a:pPr>
+            <a:r>
+              <a:rPr sz="1125" b="1">
+                <a:solidFill>
+                  <a:srgbClr val="000000"/>
+                </a:solidFill>
+                <a:latin typeface="Helvetica Neue"/>
+                <a:ea typeface="Helvetica Neue"/>
+                <a:cs typeface="Helvetica Neue"/>
+              </a:rPr>
+              <a:t>Four validated AnyLogic studies</a:t>
+            </a:r>
+          </a:p>
+          <a:p xmlns:a="http://schemas.openxmlformats.org/drawingml/2006/main">
+            <a:pPr algn="l">
+              <a:lnSpc>
+                <a:spcPct val="102000"/>
+              </a:lnSpc>
+              <a:buNone/>
+              <a:defRPr sz="1125">
+                <a:solidFill>
+                  <a:srgbClr val="000000"/>
                 </a:solidFill>
                 <a:latin typeface="Helvetica Neue"/>
                 <a:ea typeface="Helvetica Neue"/>
@@ -2906,13 +2941,40 @@
             <a:r>
               <a:rPr sz="1125">
                 <a:solidFill>
-                  <a:srgbClr val="111318"/>
-                </a:solidFill>
-                <a:latin typeface="Helvetica Neue"/>
-                <a:ea typeface="Helvetica Neue"/>
-                <a:cs typeface="Helvetica Neue"/>
-              </a:rPr>
-              <a:t>CRN + validation PASS in both.</a:t>
+                  <a:srgbClr val="000000"/>
+                </a:solidFill>
+                <a:latin typeface="Helvetica Neue"/>
+                <a:ea typeface="Helvetica Neue"/>
+                <a:cs typeface="Helvetica Neue"/>
+              </a:rPr>
+              <a:t>CRN + strict gates; queue replay exact-gated.</a:t>
+            </a:r>
+          </a:p>
+          <a:p xmlns:a="http://schemas.openxmlformats.org/drawingml/2006/main">
+            <a:pPr algn="l">
+              <a:lnSpc>
+                <a:spcPct val="102000"/>
+              </a:lnSpc>
+              <a:buNone/>
+              <a:defRPr sz="1125">
+                <a:solidFill>
+                  <a:srgbClr val="000000"/>
+                </a:solidFill>
+                <a:latin typeface="Helvetica Neue"/>
+                <a:ea typeface="Helvetica Neue"/>
+                <a:cs typeface="Helvetica Neue"/>
+              </a:defRPr>
+            </a:pPr>
+            <a:r>
+              <a:rPr sz="1125">
+                <a:solidFill>
+                  <a:srgbClr val="000000"/>
+                </a:solidFill>
+                <a:latin typeface="Helvetica Neue"/>
+                <a:ea typeface="Helvetica Neue"/>
+                <a:cs typeface="Helvetica Neue"/>
+              </a:rPr>
+              <a:t>No staffing, SLA or site-forecast claim.</a:t>
             </a:r>
           </a:p>
         </p:txBody>
@@ -2950,33 +3012,6 @@
           </a:ln>
         </p:spPr>
       </p:sp>
-      <p:pic>
-        <p:nvPicPr>
-          <p:cNvPr id="103" name=""/>
-          <p:cNvPicPr>
-            <a:picLocks xmlns:a="http://schemas.openxmlformats.org/drawingml/2006/main" noChangeAspect="1"/>
-          </p:cNvPicPr>
-          <p:nvPr/>
-        </p:nvPicPr>
-        <p:blipFill>
-          <a:blip xmlns:r="http://schemas.openxmlformats.org/officeDocument/2006/relationships" xmlns:a="http://schemas.openxmlformats.org/drawingml/2006/main" r:embed="R6917c91f7e1a4ff6"/>
-          <a:srcRect xmlns:a="http://schemas.openxmlformats.org/drawingml/2006/main" l="0" t="1627" r="0" b="1627"/>
-          <a:stretch xmlns:a="http://schemas.openxmlformats.org/drawingml/2006/main">
-            <a:fillRect l="0" t="0" r="0" b="0"/>
-          </a:stretch>
-        </p:blipFill>
-        <p:spPr>
-          <a:xfrm xmlns:a="http://schemas.openxmlformats.org/drawingml/2006/main">
-            <a:off x="428625" y="3028950"/>
-            <a:ext cx="3448050" cy="1876425"/>
-          </a:xfrm>
-          <a:prstGeom xmlns:a="http://schemas.openxmlformats.org/drawingml/2006/main" prst="roundRect">
-            <a:avLst>
-              <a:gd name="adj" fmla="val 4569"/>
-            </a:avLst>
-          </a:prstGeom>
-        </p:spPr>
-      </p:pic>
       <p:sp>
         <p:nvSpPr>
           <p:cNvPr id="36" name="model-visual-frame">
@@ -3012,14 +3047,14 @@
       </p:sp>
       <p:pic>
         <p:nvPicPr>
-          <p:cNvPr id="105" name=""/>
+          <p:cNvPr id="119" name=""/>
           <p:cNvPicPr>
             <a:picLocks xmlns:a="http://schemas.openxmlformats.org/drawingml/2006/main" noChangeAspect="1"/>
           </p:cNvPicPr>
           <p:nvPr/>
         </p:nvPicPr>
         <p:blipFill>
-          <a:blip xmlns:r="http://schemas.openxmlformats.org/officeDocument/2006/relationships" xmlns:a="http://schemas.openxmlformats.org/drawingml/2006/main" r:embed="R1815f72c52684584"/>
+          <a:blip xmlns:r="http://schemas.openxmlformats.org/officeDocument/2006/relationships" xmlns:a="http://schemas.openxmlformats.org/drawingml/2006/main" r:embed="Ra54d4421968a4de4"/>
           <a:srcRect xmlns:a="http://schemas.openxmlformats.org/drawingml/2006/main" l="0" t="8139" r="0" b="8139"/>
           <a:stretch xmlns:a="http://schemas.openxmlformats.org/drawingml/2006/main">
             <a:fillRect l="0" t="0" r="0" b="0"/>
@@ -3099,32 +3134,32 @@
           </a:ln>
         </p:spPr>
         <p:txBody>
-          <a:bodyPr xmlns:a="http://schemas.openxmlformats.org/drawingml/2006/main" lIns="0" tIns="0" rIns="0" bIns="0" anchor="t">
+          <a:bodyPr xmlns:a="http://schemas.openxmlformats.org/drawingml/2006/main" wrap="square" lIns="0" tIns="0" rIns="0" bIns="0" anchor="ctr">
             <a:normAutofit fontScale="100000"/>
           </a:bodyPr>
           <a:lstStyle xmlns:a="http://schemas.openxmlformats.org/drawingml/2006/main"/>
           <a:p xmlns:a="http://schemas.openxmlformats.org/drawingml/2006/main">
             <a:pPr algn="ctr">
               <a:buNone/>
-              <a:defRPr sz="1350" b="1">
-                <a:solidFill>
-                  <a:srgbClr val="111318"/>
-                </a:solidFill>
-                <a:latin typeface="Helvetica Neue"/>
-                <a:ea typeface="Helvetica Neue"/>
-                <a:cs typeface="Helvetica Neue"/>
-              </a:defRPr>
-            </a:pPr>
-            <a:r>
-              <a:rPr sz="1350" b="1">
-                <a:solidFill>
-                  <a:srgbClr val="111318"/>
-                </a:solidFill>
-                <a:latin typeface="Helvetica Neue"/>
-                <a:ea typeface="Helvetica Neue"/>
-                <a:cs typeface="Helvetica Neue"/>
-              </a:rPr>
-              <a:t>CONFIRM · 4 × 3 × 50 = 600</a:t>
+              <a:defRPr sz="1050" b="1">
+                <a:solidFill>
+                  <a:srgbClr val="071B3A"/>
+                </a:solidFill>
+                <a:latin typeface="Helvetica Neue"/>
+                <a:ea typeface="Helvetica Neue"/>
+                <a:cs typeface="Helvetica Neue"/>
+              </a:defRPr>
+            </a:pPr>
+            <a:r>
+              <a:rPr sz="1050" b="1">
+                <a:solidFill>
+                  <a:srgbClr val="071B3A"/>
+                </a:solidFill>
+                <a:latin typeface="Helvetica Neue"/>
+                <a:ea typeface="Helvetica Neue"/>
+                <a:cs typeface="Helvetica Neue"/>
+              </a:rPr>
+              <a:t>VALIDATED ANYLOGIC STUDIES</a:t>
             </a:r>
           </a:p>
         </p:txBody>
@@ -3158,7 +3193,7 @@
           </a:ln>
         </p:spPr>
         <p:txBody>
-          <a:bodyPr xmlns:a="http://schemas.openxmlformats.org/drawingml/2006/main" lIns="0" tIns="0" rIns="0" bIns="0" anchor="ctr">
+          <a:bodyPr xmlns:a="http://schemas.openxmlformats.org/drawingml/2006/main" wrap="square" lIns="0" tIns="0" rIns="0" bIns="0" anchor="ctr">
             <a:normAutofit fontScale="100000"/>
           </a:bodyPr>
           <a:lstStyle xmlns:a="http://schemas.openxmlformats.org/drawingml/2006/main"/>
@@ -3167,7 +3202,7 @@
               <a:buNone/>
               <a:defRPr sz="825" b="1">
                 <a:solidFill>
-                  <a:srgbClr val="606A78"/>
+                  <a:srgbClr val="596579"/>
                 </a:solidFill>
                 <a:latin typeface="Helvetica Neue"/>
                 <a:ea typeface="Helvetica Neue"/>
@@ -3177,13 +3212,13 @@
             <a:r>
               <a:rPr sz="825" b="1">
                 <a:solidFill>
-                  <a:srgbClr val="606A78"/>
-                </a:solidFill>
-                <a:latin typeface="Helvetica Neue"/>
-                <a:ea typeface="Helvetica Neue"/>
-                <a:cs typeface="Helvetica Neue"/>
-              </a:rPr>
-              <a:t>LOW</a:t>
+                  <a:srgbClr val="596579"/>
+                </a:solidFill>
+                <a:latin typeface="Helvetica Neue"/>
+                <a:ea typeface="Helvetica Neue"/>
+                <a:cs typeface="Helvetica Neue"/>
+              </a:rPr>
+              <a:t>RUNS</a:t>
             </a:r>
           </a:p>
         </p:txBody>
@@ -3217,7 +3252,7 @@
           </a:ln>
         </p:spPr>
         <p:txBody>
-          <a:bodyPr xmlns:a="http://schemas.openxmlformats.org/drawingml/2006/main" lIns="0" tIns="0" rIns="0" bIns="0" anchor="ctr">
+          <a:bodyPr xmlns:a="http://schemas.openxmlformats.org/drawingml/2006/main" wrap="square" lIns="0" tIns="0" rIns="0" bIns="0" anchor="ctr">
             <a:normAutofit fontScale="100000"/>
           </a:bodyPr>
           <a:lstStyle xmlns:a="http://schemas.openxmlformats.org/drawingml/2006/main"/>
@@ -3226,7 +3261,7 @@
               <a:buNone/>
               <a:defRPr sz="825" b="1">
                 <a:solidFill>
-                  <a:srgbClr val="606A78"/>
+                  <a:srgbClr val="596579"/>
                 </a:solidFill>
                 <a:latin typeface="Helvetica Neue"/>
                 <a:ea typeface="Helvetica Neue"/>
@@ -3236,13 +3271,13 @@
             <a:r>
               <a:rPr sz="825" b="1">
                 <a:solidFill>
-                  <a:srgbClr val="606A78"/>
-                </a:solidFill>
-                <a:latin typeface="Helvetica Neue"/>
-                <a:ea typeface="Helvetica Neue"/>
-                <a:cs typeface="Helvetica Neue"/>
-              </a:rPr>
-              <a:t>BASE</a:t>
+                  <a:srgbClr val="596579"/>
+                </a:solidFill>
+                <a:latin typeface="Helvetica Neue"/>
+                <a:ea typeface="Helvetica Neue"/>
+                <a:cs typeface="Helvetica Neue"/>
+              </a:rPr>
+              <a:t>CRN</a:t>
             </a:r>
           </a:p>
         </p:txBody>
@@ -3276,7 +3311,7 @@
           </a:ln>
         </p:spPr>
         <p:txBody>
-          <a:bodyPr xmlns:a="http://schemas.openxmlformats.org/drawingml/2006/main" lIns="0" tIns="0" rIns="0" bIns="0" anchor="ctr">
+          <a:bodyPr xmlns:a="http://schemas.openxmlformats.org/drawingml/2006/main" wrap="square" lIns="0" tIns="0" rIns="0" bIns="0" anchor="ctr">
             <a:normAutofit fontScale="100000"/>
           </a:bodyPr>
           <a:lstStyle xmlns:a="http://schemas.openxmlformats.org/drawingml/2006/main"/>
@@ -3285,7 +3320,7 @@
               <a:buNone/>
               <a:defRPr sz="825" b="1">
                 <a:solidFill>
-                  <a:srgbClr val="606A78"/>
+                  <a:srgbClr val="596579"/>
                 </a:solidFill>
                 <a:latin typeface="Helvetica Neue"/>
                 <a:ea typeface="Helvetica Neue"/>
@@ -3295,13 +3330,13 @@
             <a:r>
               <a:rPr sz="825" b="1">
                 <a:solidFill>
-                  <a:srgbClr val="606A78"/>
-                </a:solidFill>
-                <a:latin typeface="Helvetica Neue"/>
-                <a:ea typeface="Helvetica Neue"/>
-                <a:cs typeface="Helvetica Neue"/>
-              </a:rPr>
-              <a:t>HIGH</a:t>
+                  <a:srgbClr val="596579"/>
+                </a:solidFill>
+                <a:latin typeface="Helvetica Neue"/>
+                <a:ea typeface="Helvetica Neue"/>
+                <a:cs typeface="Helvetica Neue"/>
+              </a:rPr>
+              <a:t>GATE</a:t>
             </a:r>
           </a:p>
         </p:txBody>
@@ -3335,32 +3370,32 @@
           </a:ln>
         </p:spPr>
         <p:txBody>
-          <a:bodyPr xmlns:a="http://schemas.openxmlformats.org/drawingml/2006/main" lIns="0" tIns="0" rIns="0" bIns="0" anchor="ctr">
+          <a:bodyPr xmlns:a="http://schemas.openxmlformats.org/drawingml/2006/main" wrap="square" lIns="0" tIns="0" rIns="0" bIns="0" anchor="ctr">
             <a:normAutofit fontScale="100000"/>
           </a:bodyPr>
           <a:lstStyle xmlns:a="http://schemas.openxmlformats.org/drawingml/2006/main"/>
           <a:p xmlns:a="http://schemas.openxmlformats.org/drawingml/2006/main">
-            <a:pPr algn="r">
+            <a:pPr algn="ctr">
               <a:buNone/>
-              <a:defRPr sz="825" b="0">
-                <a:solidFill>
-                  <a:srgbClr val="606A78"/>
-                </a:solidFill>
-                <a:latin typeface="Helvetica Neue"/>
-                <a:ea typeface="Helvetica Neue"/>
-                <a:cs typeface="Helvetica Neue"/>
-              </a:defRPr>
-            </a:pPr>
-            <a:r>
-              <a:rPr sz="825" b="0">
-                <a:solidFill>
-                  <a:srgbClr val="606A78"/>
-                </a:solidFill>
-                <a:latin typeface="Helvetica Neue"/>
-                <a:ea typeface="Helvetica Neue"/>
-                <a:cs typeface="Helvetica Neue"/>
-              </a:rPr>
-              <a:t>REF</a:t>
+              <a:defRPr sz="825" b="1">
+                <a:solidFill>
+                  <a:srgbClr val="596579"/>
+                </a:solidFill>
+                <a:latin typeface="Helvetica Neue"/>
+                <a:ea typeface="Helvetica Neue"/>
+                <a:cs typeface="Helvetica Neue"/>
+              </a:defRPr>
+            </a:pPr>
+            <a:r>
+              <a:rPr sz="825" b="1">
+                <a:solidFill>
+                  <a:srgbClr val="596579"/>
+                </a:solidFill>
+                <a:latin typeface="Helvetica Neue"/>
+                <a:ea typeface="Helvetica Neue"/>
+                <a:cs typeface="Helvetica Neue"/>
+              </a:rPr>
+              <a:t>CONF</a:t>
             </a:r>
           </a:p>
         </p:txBody>
@@ -3400,32 +3435,32 @@
           </a:ln>
         </p:spPr>
         <p:txBody>
-          <a:bodyPr xmlns:a="http://schemas.openxmlformats.org/drawingml/2006/main" lIns="0" tIns="0" rIns="0" bIns="0" anchor="ctr">
+          <a:bodyPr xmlns:a="http://schemas.openxmlformats.org/drawingml/2006/main" wrap="square" lIns="0" tIns="0" rIns="0" bIns="0" anchor="ctr">
             <a:normAutofit fontScale="100000"/>
           </a:bodyPr>
           <a:lstStyle xmlns:a="http://schemas.openxmlformats.org/drawingml/2006/main"/>
           <a:p xmlns:a="http://schemas.openxmlformats.org/drawingml/2006/main">
             <a:pPr algn="ctr">
               <a:buNone/>
-              <a:defRPr sz="900" b="1">
-                <a:solidFill>
-                  <a:srgbClr val="111318"/>
-                </a:solidFill>
-                <a:latin typeface="Helvetica Neue"/>
-                <a:ea typeface="Helvetica Neue"/>
-                <a:cs typeface="Helvetica Neue"/>
-              </a:defRPr>
-            </a:pPr>
-            <a:r>
-              <a:rPr sz="900" b="1">
-                <a:solidFill>
-                  <a:srgbClr val="111318"/>
-                </a:solidFill>
-                <a:latin typeface="Helvetica Neue"/>
-                <a:ea typeface="Helvetica Neue"/>
-                <a:cs typeface="Helvetica Neue"/>
-              </a:rPr>
-              <a:t>50</a:t>
+              <a:defRPr sz="788" b="1">
+                <a:solidFill>
+                  <a:srgbClr val="071B3A"/>
+                </a:solidFill>
+                <a:latin typeface="Helvetica Neue"/>
+                <a:ea typeface="Helvetica Neue"/>
+                <a:cs typeface="Helvetica Neue"/>
+              </a:defRPr>
+            </a:pPr>
+            <a:r>
+              <a:rPr sz="788" b="1">
+                <a:solidFill>
+                  <a:srgbClr val="071B3A"/>
+                </a:solidFill>
+                <a:latin typeface="Helvetica Neue"/>
+                <a:ea typeface="Helvetica Neue"/>
+                <a:cs typeface="Helvetica Neue"/>
+              </a:rPr>
+              <a:t>600</a:t>
             </a:r>
           </a:p>
         </p:txBody>
@@ -3465,32 +3500,32 @@
           </a:ln>
         </p:spPr>
         <p:txBody>
-          <a:bodyPr xmlns:a="http://schemas.openxmlformats.org/drawingml/2006/main" lIns="0" tIns="0" rIns="0" bIns="0" anchor="ctr">
+          <a:bodyPr xmlns:a="http://schemas.openxmlformats.org/drawingml/2006/main" wrap="square" lIns="0" tIns="0" rIns="0" bIns="0" anchor="ctr">
             <a:normAutofit fontScale="100000"/>
           </a:bodyPr>
           <a:lstStyle xmlns:a="http://schemas.openxmlformats.org/drawingml/2006/main"/>
           <a:p xmlns:a="http://schemas.openxmlformats.org/drawingml/2006/main">
             <a:pPr algn="ctr">
               <a:buNone/>
-              <a:defRPr sz="900" b="1">
-                <a:solidFill>
-                  <a:srgbClr val="111318"/>
-                </a:solidFill>
-                <a:latin typeface="Helvetica Neue"/>
-                <a:ea typeface="Helvetica Neue"/>
-                <a:cs typeface="Helvetica Neue"/>
-              </a:defRPr>
-            </a:pPr>
-            <a:r>
-              <a:rPr sz="900" b="1">
-                <a:solidFill>
-                  <a:srgbClr val="111318"/>
-                </a:solidFill>
-                <a:latin typeface="Helvetica Neue"/>
-                <a:ea typeface="Helvetica Neue"/>
-                <a:cs typeface="Helvetica Neue"/>
-              </a:rPr>
-              <a:t>50</a:t>
+              <a:defRPr sz="788" b="1">
+                <a:solidFill>
+                  <a:srgbClr val="071B3A"/>
+                </a:solidFill>
+                <a:latin typeface="Helvetica Neue"/>
+                <a:ea typeface="Helvetica Neue"/>
+                <a:cs typeface="Helvetica Neue"/>
+              </a:defRPr>
+            </a:pPr>
+            <a:r>
+              <a:rPr sz="788" b="1">
+                <a:solidFill>
+                  <a:srgbClr val="071B3A"/>
+                </a:solidFill>
+                <a:latin typeface="Helvetica Neue"/>
+                <a:ea typeface="Helvetica Neue"/>
+                <a:cs typeface="Helvetica Neue"/>
+              </a:rPr>
+              <a:t>PASS</a:t>
             </a:r>
           </a:p>
         </p:txBody>
@@ -3530,32 +3565,32 @@
           </a:ln>
         </p:spPr>
         <p:txBody>
-          <a:bodyPr xmlns:a="http://schemas.openxmlformats.org/drawingml/2006/main" lIns="0" tIns="0" rIns="0" bIns="0" anchor="ctr">
+          <a:bodyPr xmlns:a="http://schemas.openxmlformats.org/drawingml/2006/main" wrap="square" lIns="0" tIns="0" rIns="0" bIns="0" anchor="ctr">
             <a:normAutofit fontScale="100000"/>
           </a:bodyPr>
           <a:lstStyle xmlns:a="http://schemas.openxmlformats.org/drawingml/2006/main"/>
           <a:p xmlns:a="http://schemas.openxmlformats.org/drawingml/2006/main">
             <a:pPr algn="ctr">
               <a:buNone/>
-              <a:defRPr sz="900" b="1">
-                <a:solidFill>
-                  <a:srgbClr val="FFFFFF"/>
-                </a:solidFill>
-                <a:latin typeface="Helvetica Neue"/>
-                <a:ea typeface="Helvetica Neue"/>
-                <a:cs typeface="Helvetica Neue"/>
-              </a:defRPr>
-            </a:pPr>
-            <a:r>
-              <a:rPr sz="900" b="1">
-                <a:solidFill>
-                  <a:srgbClr val="FFFFFF"/>
-                </a:solidFill>
-                <a:latin typeface="Helvetica Neue"/>
-                <a:ea typeface="Helvetica Neue"/>
-                <a:cs typeface="Helvetica Neue"/>
-              </a:rPr>
-              <a:t>50</a:t>
+              <a:defRPr sz="788" b="1">
+                <a:solidFill>
+                  <a:srgbClr val="071B3A"/>
+                </a:solidFill>
+                <a:latin typeface="Helvetica Neue"/>
+                <a:ea typeface="Helvetica Neue"/>
+                <a:cs typeface="Helvetica Neue"/>
+              </a:defRPr>
+            </a:pPr>
+            <a:r>
+              <a:rPr sz="788" b="1">
+                <a:solidFill>
+                  <a:srgbClr val="071B3A"/>
+                </a:solidFill>
+                <a:latin typeface="Helvetica Neue"/>
+                <a:ea typeface="Helvetica Neue"/>
+                <a:cs typeface="Helvetica Neue"/>
+              </a:rPr>
+              <a:t>PASS</a:t>
             </a:r>
           </a:p>
         </p:txBody>
@@ -3589,32 +3624,32 @@
           </a:ln>
         </p:spPr>
         <p:txBody>
-          <a:bodyPr xmlns:a="http://schemas.openxmlformats.org/drawingml/2006/main" lIns="0" tIns="0" rIns="0" bIns="0" anchor="ctr">
+          <a:bodyPr xmlns:a="http://schemas.openxmlformats.org/drawingml/2006/main" wrap="square" lIns="0" tIns="0" rIns="0" bIns="0" anchor="ctr">
             <a:normAutofit fontScale="100000"/>
           </a:bodyPr>
           <a:lstStyle xmlns:a="http://schemas.openxmlformats.org/drawingml/2006/main"/>
           <a:p xmlns:a="http://schemas.openxmlformats.org/drawingml/2006/main">
-            <a:pPr algn="r">
+            <a:pPr algn="ctr">
               <a:buNone/>
-              <a:defRPr sz="825" b="0">
-                <a:solidFill>
-                  <a:srgbClr val="606A78"/>
-                </a:solidFill>
-                <a:latin typeface="Helvetica Neue"/>
-                <a:ea typeface="Helvetica Neue"/>
-                <a:cs typeface="Helvetica Neue"/>
-              </a:defRPr>
-            </a:pPr>
-            <a:r>
-              <a:rPr sz="825" b="0">
-                <a:solidFill>
-                  <a:srgbClr val="606A78"/>
-                </a:solidFill>
-                <a:latin typeface="Helvetica Neue"/>
-                <a:ea typeface="Helvetica Neue"/>
-                <a:cs typeface="Helvetica Neue"/>
-              </a:rPr>
-              <a:t>S+4</a:t>
+              <a:defRPr sz="825" b="1">
+                <a:solidFill>
+                  <a:srgbClr val="596579"/>
+                </a:solidFill>
+                <a:latin typeface="Helvetica Neue"/>
+                <a:ea typeface="Helvetica Neue"/>
+                <a:cs typeface="Helvetica Neue"/>
+              </a:defRPr>
+            </a:pPr>
+            <a:r>
+              <a:rPr sz="825" b="1">
+                <a:solidFill>
+                  <a:srgbClr val="596579"/>
+                </a:solidFill>
+                <a:latin typeface="Helvetica Neue"/>
+                <a:ea typeface="Helvetica Neue"/>
+                <a:cs typeface="Helvetica Neue"/>
+              </a:rPr>
+              <a:t>CAP</a:t>
             </a:r>
           </a:p>
         </p:txBody>
@@ -3654,32 +3689,32 @@
           </a:ln>
         </p:spPr>
         <p:txBody>
-          <a:bodyPr xmlns:a="http://schemas.openxmlformats.org/drawingml/2006/main" lIns="0" tIns="0" rIns="0" bIns="0" anchor="ctr">
+          <a:bodyPr xmlns:a="http://schemas.openxmlformats.org/drawingml/2006/main" wrap="square" lIns="0" tIns="0" rIns="0" bIns="0" anchor="ctr">
             <a:normAutofit fontScale="100000"/>
           </a:bodyPr>
           <a:lstStyle xmlns:a="http://schemas.openxmlformats.org/drawingml/2006/main"/>
           <a:p xmlns:a="http://schemas.openxmlformats.org/drawingml/2006/main">
             <a:pPr algn="ctr">
               <a:buNone/>
-              <a:defRPr sz="900" b="1">
-                <a:solidFill>
-                  <a:srgbClr val="111318"/>
-                </a:solidFill>
-                <a:latin typeface="Helvetica Neue"/>
-                <a:ea typeface="Helvetica Neue"/>
-                <a:cs typeface="Helvetica Neue"/>
-              </a:defRPr>
-            </a:pPr>
-            <a:r>
-              <a:rPr sz="900" b="1">
-                <a:solidFill>
-                  <a:srgbClr val="111318"/>
-                </a:solidFill>
-                <a:latin typeface="Helvetica Neue"/>
-                <a:ea typeface="Helvetica Neue"/>
-                <a:cs typeface="Helvetica Neue"/>
-              </a:rPr>
-              <a:t>50</a:t>
+              <a:defRPr sz="788" b="1">
+                <a:solidFill>
+                  <a:srgbClr val="071B3A"/>
+                </a:solidFill>
+                <a:latin typeface="Helvetica Neue"/>
+                <a:ea typeface="Helvetica Neue"/>
+                <a:cs typeface="Helvetica Neue"/>
+              </a:defRPr>
+            </a:pPr>
+            <a:r>
+              <a:rPr sz="788" b="1">
+                <a:solidFill>
+                  <a:srgbClr val="071B3A"/>
+                </a:solidFill>
+                <a:latin typeface="Helvetica Neue"/>
+                <a:ea typeface="Helvetica Neue"/>
+                <a:cs typeface="Helvetica Neue"/>
+              </a:rPr>
+              <a:t>2,700</a:t>
             </a:r>
           </a:p>
         </p:txBody>
@@ -3719,32 +3754,32 @@
           </a:ln>
         </p:spPr>
         <p:txBody>
-          <a:bodyPr xmlns:a="http://schemas.openxmlformats.org/drawingml/2006/main" lIns="0" tIns="0" rIns="0" bIns="0" anchor="ctr">
+          <a:bodyPr xmlns:a="http://schemas.openxmlformats.org/drawingml/2006/main" wrap="square" lIns="0" tIns="0" rIns="0" bIns="0" anchor="ctr">
             <a:normAutofit fontScale="100000"/>
           </a:bodyPr>
           <a:lstStyle xmlns:a="http://schemas.openxmlformats.org/drawingml/2006/main"/>
           <a:p xmlns:a="http://schemas.openxmlformats.org/drawingml/2006/main">
             <a:pPr algn="ctr">
               <a:buNone/>
-              <a:defRPr sz="900" b="1">
-                <a:solidFill>
-                  <a:srgbClr val="111318"/>
-                </a:solidFill>
-                <a:latin typeface="Helvetica Neue"/>
-                <a:ea typeface="Helvetica Neue"/>
-                <a:cs typeface="Helvetica Neue"/>
-              </a:defRPr>
-            </a:pPr>
-            <a:r>
-              <a:rPr sz="900" b="1">
-                <a:solidFill>
-                  <a:srgbClr val="111318"/>
-                </a:solidFill>
-                <a:latin typeface="Helvetica Neue"/>
-                <a:ea typeface="Helvetica Neue"/>
-                <a:cs typeface="Helvetica Neue"/>
-              </a:rPr>
-              <a:t>50</a:t>
+              <a:defRPr sz="788" b="1">
+                <a:solidFill>
+                  <a:srgbClr val="071B3A"/>
+                </a:solidFill>
+                <a:latin typeface="Helvetica Neue"/>
+                <a:ea typeface="Helvetica Neue"/>
+                <a:cs typeface="Helvetica Neue"/>
+              </a:defRPr>
+            </a:pPr>
+            <a:r>
+              <a:rPr sz="788" b="1">
+                <a:solidFill>
+                  <a:srgbClr val="071B3A"/>
+                </a:solidFill>
+                <a:latin typeface="Helvetica Neue"/>
+                <a:ea typeface="Helvetica Neue"/>
+                <a:cs typeface="Helvetica Neue"/>
+              </a:rPr>
+              <a:t>PASS</a:t>
             </a:r>
           </a:p>
         </p:txBody>
@@ -3784,32 +3819,32 @@
           </a:ln>
         </p:spPr>
         <p:txBody>
-          <a:bodyPr xmlns:a="http://schemas.openxmlformats.org/drawingml/2006/main" lIns="0" tIns="0" rIns="0" bIns="0" anchor="ctr">
+          <a:bodyPr xmlns:a="http://schemas.openxmlformats.org/drawingml/2006/main" wrap="square" lIns="0" tIns="0" rIns="0" bIns="0" anchor="ctr">
             <a:normAutofit fontScale="100000"/>
           </a:bodyPr>
           <a:lstStyle xmlns:a="http://schemas.openxmlformats.org/drawingml/2006/main"/>
           <a:p xmlns:a="http://schemas.openxmlformats.org/drawingml/2006/main">
             <a:pPr algn="ctr">
               <a:buNone/>
-              <a:defRPr sz="900" b="1">
-                <a:solidFill>
-                  <a:srgbClr val="FFFFFF"/>
-                </a:solidFill>
-                <a:latin typeface="Helvetica Neue"/>
-                <a:ea typeface="Helvetica Neue"/>
-                <a:cs typeface="Helvetica Neue"/>
-              </a:defRPr>
-            </a:pPr>
-            <a:r>
-              <a:rPr sz="900" b="1">
-                <a:solidFill>
-                  <a:srgbClr val="FFFFFF"/>
-                </a:solidFill>
-                <a:latin typeface="Helvetica Neue"/>
-                <a:ea typeface="Helvetica Neue"/>
-                <a:cs typeface="Helvetica Neue"/>
-              </a:rPr>
-              <a:t>50</a:t>
+              <a:defRPr sz="788" b="1">
+                <a:solidFill>
+                  <a:srgbClr val="071B3A"/>
+                </a:solidFill>
+                <a:latin typeface="Helvetica Neue"/>
+                <a:ea typeface="Helvetica Neue"/>
+                <a:cs typeface="Helvetica Neue"/>
+              </a:defRPr>
+            </a:pPr>
+            <a:r>
+              <a:rPr sz="788" b="1">
+                <a:solidFill>
+                  <a:srgbClr val="071B3A"/>
+                </a:solidFill>
+                <a:latin typeface="Helvetica Neue"/>
+                <a:ea typeface="Helvetica Neue"/>
+                <a:cs typeface="Helvetica Neue"/>
+              </a:rPr>
+              <a:t>PASS</a:t>
             </a:r>
           </a:p>
         </p:txBody>
@@ -3843,32 +3878,32 @@
           </a:ln>
         </p:spPr>
         <p:txBody>
-          <a:bodyPr xmlns:a="http://schemas.openxmlformats.org/drawingml/2006/main" lIns="0" tIns="0" rIns="0" bIns="0" anchor="ctr">
+          <a:bodyPr xmlns:a="http://schemas.openxmlformats.org/drawingml/2006/main" wrap="square" lIns="0" tIns="0" rIns="0" bIns="0" anchor="ctr">
             <a:normAutofit fontScale="100000"/>
           </a:bodyPr>
           <a:lstStyle xmlns:a="http://schemas.openxmlformats.org/drawingml/2006/main"/>
           <a:p xmlns:a="http://schemas.openxmlformats.org/drawingml/2006/main">
-            <a:pPr algn="r">
+            <a:pPr algn="ctr">
               <a:buNone/>
-              <a:defRPr sz="825" b="0">
-                <a:solidFill>
-                  <a:srgbClr val="606A78"/>
-                </a:solidFill>
-                <a:latin typeface="Helvetica Neue"/>
-                <a:ea typeface="Helvetica Neue"/>
-                <a:cs typeface="Helvetica Neue"/>
-              </a:defRPr>
-            </a:pPr>
-            <a:r>
-              <a:rPr sz="825" b="0">
-                <a:solidFill>
-                  <a:srgbClr val="606A78"/>
-                </a:solidFill>
-                <a:latin typeface="Helvetica Neue"/>
-                <a:ea typeface="Helvetica Neue"/>
-                <a:cs typeface="Helvetica Neue"/>
-              </a:rPr>
-              <a:t>I+3</a:t>
+              <a:defRPr sz="825" b="1">
+                <a:solidFill>
+                  <a:srgbClr val="596579"/>
+                </a:solidFill>
+                <a:latin typeface="Helvetica Neue"/>
+                <a:ea typeface="Helvetica Neue"/>
+                <a:cs typeface="Helvetica Neue"/>
+              </a:defRPr>
+            </a:pPr>
+            <a:r>
+              <a:rPr sz="825" b="1">
+                <a:solidFill>
+                  <a:srgbClr val="596579"/>
+                </a:solidFill>
+                <a:latin typeface="Helvetica Neue"/>
+                <a:ea typeface="Helvetica Neue"/>
+                <a:cs typeface="Helvetica Neue"/>
+              </a:rPr>
+              <a:t>CV</a:t>
             </a:r>
           </a:p>
         </p:txBody>
@@ -3908,32 +3943,32 @@
           </a:ln>
         </p:spPr>
         <p:txBody>
-          <a:bodyPr xmlns:a="http://schemas.openxmlformats.org/drawingml/2006/main" lIns="0" tIns="0" rIns="0" bIns="0" anchor="ctr">
+          <a:bodyPr xmlns:a="http://schemas.openxmlformats.org/drawingml/2006/main" wrap="square" lIns="0" tIns="0" rIns="0" bIns="0" anchor="ctr">
             <a:normAutofit fontScale="100000"/>
           </a:bodyPr>
           <a:lstStyle xmlns:a="http://schemas.openxmlformats.org/drawingml/2006/main"/>
           <a:p xmlns:a="http://schemas.openxmlformats.org/drawingml/2006/main">
             <a:pPr algn="ctr">
               <a:buNone/>
-              <a:defRPr sz="900" b="1">
-                <a:solidFill>
-                  <a:srgbClr val="111318"/>
-                </a:solidFill>
-                <a:latin typeface="Helvetica Neue"/>
-                <a:ea typeface="Helvetica Neue"/>
-                <a:cs typeface="Helvetica Neue"/>
-              </a:defRPr>
-            </a:pPr>
-            <a:r>
-              <a:rPr sz="900" b="1">
-                <a:solidFill>
-                  <a:srgbClr val="111318"/>
-                </a:solidFill>
-                <a:latin typeface="Helvetica Neue"/>
-                <a:ea typeface="Helvetica Neue"/>
-                <a:cs typeface="Helvetica Neue"/>
-              </a:rPr>
-              <a:t>50</a:t>
+              <a:defRPr sz="788" b="1">
+                <a:solidFill>
+                  <a:srgbClr val="071B3A"/>
+                </a:solidFill>
+                <a:latin typeface="Helvetica Neue"/>
+                <a:ea typeface="Helvetica Neue"/>
+                <a:cs typeface="Helvetica Neue"/>
+              </a:defRPr>
+            </a:pPr>
+            <a:r>
+              <a:rPr sz="788" b="1">
+                <a:solidFill>
+                  <a:srgbClr val="071B3A"/>
+                </a:solidFill>
+                <a:latin typeface="Helvetica Neue"/>
+                <a:ea typeface="Helvetica Neue"/>
+                <a:cs typeface="Helvetica Neue"/>
+              </a:rPr>
+              <a:t>450</a:t>
             </a:r>
           </a:p>
         </p:txBody>
@@ -3973,32 +4008,32 @@
           </a:ln>
         </p:spPr>
         <p:txBody>
-          <a:bodyPr xmlns:a="http://schemas.openxmlformats.org/drawingml/2006/main" lIns="0" tIns="0" rIns="0" bIns="0" anchor="ctr">
+          <a:bodyPr xmlns:a="http://schemas.openxmlformats.org/drawingml/2006/main" wrap="square" lIns="0" tIns="0" rIns="0" bIns="0" anchor="ctr">
             <a:normAutofit fontScale="100000"/>
           </a:bodyPr>
           <a:lstStyle xmlns:a="http://schemas.openxmlformats.org/drawingml/2006/main"/>
           <a:p xmlns:a="http://schemas.openxmlformats.org/drawingml/2006/main">
             <a:pPr algn="ctr">
               <a:buNone/>
-              <a:defRPr sz="900" b="1">
-                <a:solidFill>
-                  <a:srgbClr val="111318"/>
-                </a:solidFill>
-                <a:latin typeface="Helvetica Neue"/>
-                <a:ea typeface="Helvetica Neue"/>
-                <a:cs typeface="Helvetica Neue"/>
-              </a:defRPr>
-            </a:pPr>
-            <a:r>
-              <a:rPr sz="900" b="1">
-                <a:solidFill>
-                  <a:srgbClr val="111318"/>
-                </a:solidFill>
-                <a:latin typeface="Helvetica Neue"/>
-                <a:ea typeface="Helvetica Neue"/>
-                <a:cs typeface="Helvetica Neue"/>
-              </a:rPr>
-              <a:t>50</a:t>
+              <a:defRPr sz="788" b="1">
+                <a:solidFill>
+                  <a:srgbClr val="071B3A"/>
+                </a:solidFill>
+                <a:latin typeface="Helvetica Neue"/>
+                <a:ea typeface="Helvetica Neue"/>
+                <a:cs typeface="Helvetica Neue"/>
+              </a:defRPr>
+            </a:pPr>
+            <a:r>
+              <a:rPr sz="788" b="1">
+                <a:solidFill>
+                  <a:srgbClr val="071B3A"/>
+                </a:solidFill>
+                <a:latin typeface="Helvetica Neue"/>
+                <a:ea typeface="Helvetica Neue"/>
+                <a:cs typeface="Helvetica Neue"/>
+              </a:rPr>
+              <a:t>PASS</a:t>
             </a:r>
           </a:p>
         </p:txBody>
@@ -4038,32 +4073,32 @@
           </a:ln>
         </p:spPr>
         <p:txBody>
-          <a:bodyPr xmlns:a="http://schemas.openxmlformats.org/drawingml/2006/main" lIns="0" tIns="0" rIns="0" bIns="0" anchor="ctr">
+          <a:bodyPr xmlns:a="http://schemas.openxmlformats.org/drawingml/2006/main" wrap="square" lIns="0" tIns="0" rIns="0" bIns="0" anchor="ctr">
             <a:normAutofit fontScale="100000"/>
           </a:bodyPr>
           <a:lstStyle xmlns:a="http://schemas.openxmlformats.org/drawingml/2006/main"/>
           <a:p xmlns:a="http://schemas.openxmlformats.org/drawingml/2006/main">
             <a:pPr algn="ctr">
               <a:buNone/>
-              <a:defRPr sz="900" b="1">
-                <a:solidFill>
-                  <a:srgbClr val="FFFFFF"/>
-                </a:solidFill>
-                <a:latin typeface="Helvetica Neue"/>
-                <a:ea typeface="Helvetica Neue"/>
-                <a:cs typeface="Helvetica Neue"/>
-              </a:defRPr>
-            </a:pPr>
-            <a:r>
-              <a:rPr sz="900" b="1">
-                <a:solidFill>
-                  <a:srgbClr val="FFFFFF"/>
-                </a:solidFill>
-                <a:latin typeface="Helvetica Neue"/>
-                <a:ea typeface="Helvetica Neue"/>
-                <a:cs typeface="Helvetica Neue"/>
-              </a:rPr>
-              <a:t>50</a:t>
+              <a:defRPr sz="788" b="1">
+                <a:solidFill>
+                  <a:srgbClr val="071B3A"/>
+                </a:solidFill>
+                <a:latin typeface="Helvetica Neue"/>
+                <a:ea typeface="Helvetica Neue"/>
+                <a:cs typeface="Helvetica Neue"/>
+              </a:defRPr>
+            </a:pPr>
+            <a:r>
+              <a:rPr sz="788" b="1">
+                <a:solidFill>
+                  <a:srgbClr val="071B3A"/>
+                </a:solidFill>
+                <a:latin typeface="Helvetica Neue"/>
+                <a:ea typeface="Helvetica Neue"/>
+                <a:cs typeface="Helvetica Neue"/>
+              </a:rPr>
+              <a:t>PASS</a:t>
             </a:r>
           </a:p>
         </p:txBody>
@@ -4097,16 +4132,16 @@
           </a:ln>
         </p:spPr>
         <p:txBody>
-          <a:bodyPr xmlns:a="http://schemas.openxmlformats.org/drawingml/2006/main" lIns="0" tIns="0" rIns="0" bIns="0" anchor="ctr">
+          <a:bodyPr xmlns:a="http://schemas.openxmlformats.org/drawingml/2006/main" wrap="square" lIns="0" tIns="0" rIns="0" bIns="0" anchor="ctr">
             <a:normAutofit fontScale="100000"/>
           </a:bodyPr>
           <a:lstStyle xmlns:a="http://schemas.openxmlformats.org/drawingml/2006/main"/>
           <a:p xmlns:a="http://schemas.openxmlformats.org/drawingml/2006/main">
-            <a:pPr algn="r">
+            <a:pPr algn="ctr">
               <a:buNone/>
               <a:defRPr sz="825" b="1">
                 <a:solidFill>
-                  <a:srgbClr val="245FCB"/>
+                  <a:srgbClr val="596579"/>
                 </a:solidFill>
                 <a:latin typeface="Helvetica Neue"/>
                 <a:ea typeface="Helvetica Neue"/>
@@ -4116,13 +4151,13 @@
             <a:r>
               <a:rPr sz="825" b="1">
                 <a:solidFill>
-                  <a:srgbClr val="245FCB"/>
-                </a:solidFill>
-                <a:latin typeface="Helvetica Neue"/>
-                <a:ea typeface="Helvetica Neue"/>
-                <a:cs typeface="Helvetica Neue"/>
-              </a:rPr>
-              <a:t>JOINT</a:t>
+                  <a:srgbClr val="596579"/>
+                </a:solidFill>
+                <a:latin typeface="Helvetica Neue"/>
+                <a:ea typeface="Helvetica Neue"/>
+                <a:cs typeface="Helvetica Neue"/>
+              </a:rPr>
+              <a:t>PEAK</a:t>
             </a:r>
           </a:p>
         </p:txBody>
@@ -4162,32 +4197,32 @@
           </a:ln>
         </p:spPr>
         <p:txBody>
-          <a:bodyPr xmlns:a="http://schemas.openxmlformats.org/drawingml/2006/main" lIns="0" tIns="0" rIns="0" bIns="0" anchor="ctr">
+          <a:bodyPr xmlns:a="http://schemas.openxmlformats.org/drawingml/2006/main" wrap="square" lIns="0" tIns="0" rIns="0" bIns="0" anchor="ctr">
             <a:normAutofit fontScale="100000"/>
           </a:bodyPr>
           <a:lstStyle xmlns:a="http://schemas.openxmlformats.org/drawingml/2006/main"/>
           <a:p xmlns:a="http://schemas.openxmlformats.org/drawingml/2006/main">
             <a:pPr algn="ctr">
               <a:buNone/>
-              <a:defRPr sz="900" b="1">
-                <a:solidFill>
-                  <a:srgbClr val="111318"/>
-                </a:solidFill>
-                <a:latin typeface="Helvetica Neue"/>
-                <a:ea typeface="Helvetica Neue"/>
-                <a:cs typeface="Helvetica Neue"/>
-              </a:defRPr>
-            </a:pPr>
-            <a:r>
-              <a:rPr sz="900" b="1">
-                <a:solidFill>
-                  <a:srgbClr val="111318"/>
-                </a:solidFill>
-                <a:latin typeface="Helvetica Neue"/>
-                <a:ea typeface="Helvetica Neue"/>
-                <a:cs typeface="Helvetica Neue"/>
-              </a:rPr>
-              <a:t>50</a:t>
+              <a:defRPr sz="788" b="1">
+                <a:solidFill>
+                  <a:srgbClr val="071B3A"/>
+                </a:solidFill>
+                <a:latin typeface="Helvetica Neue"/>
+                <a:ea typeface="Helvetica Neue"/>
+                <a:cs typeface="Helvetica Neue"/>
+              </a:defRPr>
+            </a:pPr>
+            <a:r>
+              <a:rPr sz="788" b="1">
+                <a:solidFill>
+                  <a:srgbClr val="071B3A"/>
+                </a:solidFill>
+                <a:latin typeface="Helvetica Neue"/>
+                <a:ea typeface="Helvetica Neue"/>
+                <a:cs typeface="Helvetica Neue"/>
+              </a:rPr>
+              <a:t>1,000</a:t>
             </a:r>
           </a:p>
         </p:txBody>
@@ -4227,32 +4262,32 @@
           </a:ln>
         </p:spPr>
         <p:txBody>
-          <a:bodyPr xmlns:a="http://schemas.openxmlformats.org/drawingml/2006/main" lIns="0" tIns="0" rIns="0" bIns="0" anchor="ctr">
+          <a:bodyPr xmlns:a="http://schemas.openxmlformats.org/drawingml/2006/main" wrap="square" lIns="0" tIns="0" rIns="0" bIns="0" anchor="ctr">
             <a:normAutofit fontScale="100000"/>
           </a:bodyPr>
           <a:lstStyle xmlns:a="http://schemas.openxmlformats.org/drawingml/2006/main"/>
           <a:p xmlns:a="http://schemas.openxmlformats.org/drawingml/2006/main">
             <a:pPr algn="ctr">
               <a:buNone/>
-              <a:defRPr sz="900" b="1">
-                <a:solidFill>
-                  <a:srgbClr val="111318"/>
-                </a:solidFill>
-                <a:latin typeface="Helvetica Neue"/>
-                <a:ea typeface="Helvetica Neue"/>
-                <a:cs typeface="Helvetica Neue"/>
-              </a:defRPr>
-            </a:pPr>
-            <a:r>
-              <a:rPr sz="900" b="1">
-                <a:solidFill>
-                  <a:srgbClr val="111318"/>
-                </a:solidFill>
-                <a:latin typeface="Helvetica Neue"/>
-                <a:ea typeface="Helvetica Neue"/>
-                <a:cs typeface="Helvetica Neue"/>
-              </a:rPr>
-              <a:t>50</a:t>
+              <a:defRPr sz="788" b="1">
+                <a:solidFill>
+                  <a:srgbClr val="071B3A"/>
+                </a:solidFill>
+                <a:latin typeface="Helvetica Neue"/>
+                <a:ea typeface="Helvetica Neue"/>
+                <a:cs typeface="Helvetica Neue"/>
+              </a:defRPr>
+            </a:pPr>
+            <a:r>
+              <a:rPr sz="788" b="1">
+                <a:solidFill>
+                  <a:srgbClr val="071B3A"/>
+                </a:solidFill>
+                <a:latin typeface="Helvetica Neue"/>
+                <a:ea typeface="Helvetica Neue"/>
+                <a:cs typeface="Helvetica Neue"/>
+              </a:rPr>
+              <a:t>PASS</a:t>
             </a:r>
           </a:p>
         </p:txBody>
@@ -4292,32 +4327,32 @@
           </a:ln>
         </p:spPr>
         <p:txBody>
-          <a:bodyPr xmlns:a="http://schemas.openxmlformats.org/drawingml/2006/main" lIns="0" tIns="0" rIns="0" bIns="0" anchor="ctr">
+          <a:bodyPr xmlns:a="http://schemas.openxmlformats.org/drawingml/2006/main" wrap="square" lIns="0" tIns="0" rIns="0" bIns="0" anchor="ctr">
             <a:normAutofit fontScale="100000"/>
           </a:bodyPr>
           <a:lstStyle xmlns:a="http://schemas.openxmlformats.org/drawingml/2006/main"/>
           <a:p xmlns:a="http://schemas.openxmlformats.org/drawingml/2006/main">
             <a:pPr algn="ctr">
               <a:buNone/>
-              <a:defRPr sz="900" b="1">
-                <a:solidFill>
-                  <a:srgbClr val="FFFFFF"/>
-                </a:solidFill>
-                <a:latin typeface="Helvetica Neue"/>
-                <a:ea typeface="Helvetica Neue"/>
-                <a:cs typeface="Helvetica Neue"/>
-              </a:defRPr>
-            </a:pPr>
-            <a:r>
-              <a:rPr sz="900" b="1">
-                <a:solidFill>
-                  <a:srgbClr val="FFFFFF"/>
-                </a:solidFill>
-                <a:latin typeface="Helvetica Neue"/>
-                <a:ea typeface="Helvetica Neue"/>
-                <a:cs typeface="Helvetica Neue"/>
-              </a:rPr>
-              <a:t>50</a:t>
+              <a:defRPr sz="788" b="1">
+                <a:solidFill>
+                  <a:srgbClr val="071B3A"/>
+                </a:solidFill>
+                <a:latin typeface="Helvetica Neue"/>
+                <a:ea typeface="Helvetica Neue"/>
+                <a:cs typeface="Helvetica Neue"/>
+              </a:defRPr>
+            </a:pPr>
+            <a:r>
+              <a:rPr sz="788" b="1">
+                <a:solidFill>
+                  <a:srgbClr val="071B3A"/>
+                </a:solidFill>
+                <a:latin typeface="Helvetica Neue"/>
+                <a:ea typeface="Helvetica Neue"/>
+                <a:cs typeface="Helvetica Neue"/>
+              </a:rPr>
+              <a:t>PASS</a:t>
             </a:r>
           </a:p>
         </p:txBody>
@@ -4351,32 +4386,322 @@
           </a:ln>
         </p:spPr>
         <p:txBody>
-          <a:bodyPr xmlns:a="http://schemas.openxmlformats.org/drawingml/2006/main" lIns="0" tIns="0" rIns="0" bIns="0" anchor="ctr">
+          <a:bodyPr xmlns:a="http://schemas.openxmlformats.org/drawingml/2006/main" wrap="square" lIns="0" tIns="0" rIns="0" bIns="0" anchor="ctr">
             <a:normAutofit fontScale="100000"/>
           </a:bodyPr>
           <a:lstStyle xmlns:a="http://schemas.openxmlformats.org/drawingml/2006/main"/>
           <a:p xmlns:a="http://schemas.openxmlformats.org/drawingml/2006/main">
             <a:pPr algn="ctr">
               <a:buNone/>
-              <a:defRPr sz="900" b="1">
-                <a:solidFill>
-                  <a:srgbClr val="245FCB"/>
-                </a:solidFill>
-                <a:latin typeface="Helvetica Neue"/>
-                <a:ea typeface="Helvetica Neue"/>
-                <a:cs typeface="Helvetica Neue"/>
-              </a:defRPr>
-            </a:pPr>
-            <a:r>
-              <a:rPr sz="900" b="1">
-                <a:solidFill>
-                  <a:srgbClr val="245FCB"/>
-                </a:solidFill>
-                <a:latin typeface="Helvetica Neue"/>
-                <a:ea typeface="Helvetica Neue"/>
-                <a:cs typeface="Helvetica Neue"/>
-              </a:rPr>
-              <a:t>EXPLORE · 9 × 6 × 50 = 2,700</a:t>
+              <a:defRPr sz="788" b="1">
+                <a:solidFill>
+                  <a:srgbClr val="0A9F43"/>
+                </a:solidFill>
+                <a:latin typeface="Helvetica Neue"/>
+                <a:ea typeface="Helvetica Neue"/>
+                <a:cs typeface="Helvetica Neue"/>
+              </a:defRPr>
+            </a:pPr>
+            <a:r>
+              <a:rPr sz="788" b="1">
+                <a:solidFill>
+                  <a:srgbClr val="0A9F43"/>
+                </a:solidFill>
+                <a:latin typeface="Helvetica Neue"/>
+                <a:ea typeface="Helvetica Neue"/>
+                <a:cs typeface="Helvetica Neue"/>
+              </a:rPr>
+              <a:t>QUEUE REPLAY · 2 × 50 paired · exact gate PASS</a:t>
+            </a:r>
+          </a:p>
+        </p:txBody>
+      </p:sp>
+      <p:sp>
+        <p:nvSpPr>
+          <p:cNvPr id="100" name="measure-r2l-value">
+            <a:extLst xmlns:a="http://schemas.openxmlformats.org/drawingml/2006/main">
+              <a:ext uri="{FF2B5EF4-FFF2-40B4-BE49-F238E27FC236}">
+                <a16:creationId xmlns:a16="http://schemas.microsoft.com/office/drawing/2014/main" id="{1AD6F9AB-3B95-4EBE-8870-44ADB9DC0A7C}"/>
+              </a:ext>
+            </a:extLst>
+          </p:cNvPr>
+          <p:cNvSpPr>
+            <a:spLocks xmlns:a="http://schemas.openxmlformats.org/drawingml/2006/main" noGrp="1"/>
+          </p:cNvSpPr>
+          <p:nvPr/>
+        </p:nvSpPr>
+        <p:spPr>
+          <a:xfrm xmlns:a="http://schemas.openxmlformats.org/drawingml/2006/main">
+            <a:off x="552450" y="3171825"/>
+            <a:ext cx="1381125" cy="685800"/>
+          </a:xfrm>
+          <a:prstGeom xmlns:a="http://schemas.openxmlformats.org/drawingml/2006/main" prst="rect">
+            <a:avLst/>
+          </a:prstGeom>
+          <a:noFill xmlns:a="http://schemas.openxmlformats.org/drawingml/2006/main"/>
+          <a:ln xmlns:a="http://schemas.openxmlformats.org/drawingml/2006/main" w="0">
+            <a:noFill/>
+            <a:prstDash val="solid"/>
+          </a:ln>
+        </p:spPr>
+        <p:txBody>
+          <a:bodyPr xmlns:a="http://schemas.openxmlformats.org/drawingml/2006/main" wrap="square" lIns="0" tIns="0" rIns="0" bIns="0" anchor="ctr">
+            <a:normAutofit fontScale="100000"/>
+          </a:bodyPr>
+          <a:lstStyle xmlns:a="http://schemas.openxmlformats.org/drawingml/2006/main"/>
+          <a:p xmlns:a="http://schemas.openxmlformats.org/drawingml/2006/main">
+            <a:pPr algn="l">
+              <a:defRPr sz="3900" b="1">
+                <a:solidFill>
+                  <a:srgbClr val="2854E8"/>
+                </a:solidFill>
+                <a:latin typeface="Helvetica Neue"/>
+                <a:ea typeface="Helvetica Neue"/>
+                <a:cs typeface="Helvetica Neue"/>
+              </a:defRPr>
+            </a:pPr>
+            <a:r>
+              <a:rPr sz="3900" b="1">
+                <a:solidFill>
+                  <a:srgbClr val="2854E8"/>
+                </a:solidFill>
+                <a:latin typeface="Helvetica Neue"/>
+                <a:ea typeface="Helvetica Neue"/>
+                <a:cs typeface="Helvetica Neue"/>
+              </a:rPr>
+              <a:t>34</a:t>
+            </a:r>
+          </a:p>
+        </p:txBody>
+      </p:sp>
+      <p:sp>
+        <p:nvSpPr>
+          <p:cNvPr id="101" name="measure-r2l-label">
+            <a:extLst xmlns:a="http://schemas.openxmlformats.org/drawingml/2006/main">
+              <a:ext uri="{FF2B5EF4-FFF2-40B4-BE49-F238E27FC236}">
+                <a16:creationId xmlns:a16="http://schemas.microsoft.com/office/drawing/2014/main" id="{072C557A-5B2F-490D-B12B-BA4291371A58}"/>
+              </a:ext>
+            </a:extLst>
+          </p:cNvPr>
+          <p:cNvSpPr>
+            <a:spLocks xmlns:a="http://schemas.openxmlformats.org/drawingml/2006/main" noGrp="1"/>
+          </p:cNvSpPr>
+          <p:nvPr/>
+        </p:nvSpPr>
+        <p:spPr>
+          <a:xfrm xmlns:a="http://schemas.openxmlformats.org/drawingml/2006/main">
+            <a:off x="552450" y="3857625"/>
+            <a:ext cx="1428750" cy="323850"/>
+          </a:xfrm>
+          <a:prstGeom xmlns:a="http://schemas.openxmlformats.org/drawingml/2006/main" prst="rect">
+            <a:avLst/>
+          </a:prstGeom>
+          <a:noFill xmlns:a="http://schemas.openxmlformats.org/drawingml/2006/main"/>
+          <a:ln xmlns:a="http://schemas.openxmlformats.org/drawingml/2006/main" w="0">
+            <a:noFill/>
+            <a:prstDash val="solid"/>
+          </a:ln>
+        </p:spPr>
+        <p:txBody>
+          <a:bodyPr xmlns:a="http://schemas.openxmlformats.org/drawingml/2006/main" wrap="square" anchor="t">
+            <a:normAutofit fontScale="100000"/>
+          </a:bodyPr>
+          <a:lstStyle xmlns:a="http://schemas.openxmlformats.org/drawingml/2006/main"/>
+          <a:p xmlns:a="http://schemas.openxmlformats.org/drawingml/2006/main">
+            <a:pPr algn="l">
+              <a:defRPr sz="1125" b="1">
+                <a:solidFill>
+                  <a:srgbClr val="071B3A"/>
+                </a:solidFill>
+                <a:latin typeface="Helvetica Neue"/>
+                <a:ea typeface="Helvetica Neue"/>
+                <a:cs typeface="Helvetica Neue"/>
+              </a:defRPr>
+            </a:pPr>
+            <a:r>
+              <a:rPr sz="1125" b="1">
+                <a:solidFill>
+                  <a:srgbClr val="071B3A"/>
+                </a:solidFill>
+                <a:latin typeface="Helvetica Neue"/>
+                <a:ea typeface="Helvetica Neue"/>
+                <a:cs typeface="Helvetica Neue"/>
+              </a:rPr>
+              <a:t>accepted R→L</a:t>
+            </a:r>
+          </a:p>
+        </p:txBody>
+      </p:sp>
+      <p:sp>
+        <p:nvSpPr>
+          <p:cNvPr id="102" name="measure-l2r-value">
+            <a:extLst xmlns:a="http://schemas.openxmlformats.org/drawingml/2006/main">
+              <a:ext uri="{FF2B5EF4-FFF2-40B4-BE49-F238E27FC236}">
+                <a16:creationId xmlns:a16="http://schemas.microsoft.com/office/drawing/2014/main" id="{659EABDE-9269-42A2-8097-47179DD91880}"/>
+              </a:ext>
+            </a:extLst>
+          </p:cNvPr>
+          <p:cNvSpPr>
+            <a:spLocks xmlns:a="http://schemas.openxmlformats.org/drawingml/2006/main" noGrp="1"/>
+          </p:cNvSpPr>
+          <p:nvPr/>
+        </p:nvSpPr>
+        <p:spPr>
+          <a:xfrm xmlns:a="http://schemas.openxmlformats.org/drawingml/2006/main">
+            <a:off x="2247900" y="3257550"/>
+            <a:ext cx="1095375" cy="571500"/>
+          </a:xfrm>
+          <a:prstGeom xmlns:a="http://schemas.openxmlformats.org/drawingml/2006/main" prst="rect">
+            <a:avLst/>
+          </a:prstGeom>
+          <a:noFill xmlns:a="http://schemas.openxmlformats.org/drawingml/2006/main"/>
+          <a:ln xmlns:a="http://schemas.openxmlformats.org/drawingml/2006/main" w="0">
+            <a:noFill/>
+            <a:prstDash val="solid"/>
+          </a:ln>
+        </p:spPr>
+        <p:txBody>
+          <a:bodyPr xmlns:a="http://schemas.openxmlformats.org/drawingml/2006/main" wrap="square" lIns="0" tIns="0" rIns="0" bIns="0" anchor="ctr">
+            <a:normAutofit fontScale="100000"/>
+          </a:bodyPr>
+          <a:lstStyle xmlns:a="http://schemas.openxmlformats.org/drawingml/2006/main"/>
+          <a:p xmlns:a="http://schemas.openxmlformats.org/drawingml/2006/main">
+            <a:pPr algn="l">
+              <a:defRPr sz="3150" b="1">
+                <a:solidFill>
+                  <a:srgbClr val="596579"/>
+                </a:solidFill>
+                <a:latin typeface="Helvetica Neue"/>
+                <a:ea typeface="Helvetica Neue"/>
+                <a:cs typeface="Helvetica Neue"/>
+              </a:defRPr>
+            </a:pPr>
+            <a:r>
+              <a:rPr sz="3150" b="1">
+                <a:solidFill>
+                  <a:srgbClr val="596579"/>
+                </a:solidFill>
+                <a:latin typeface="Helvetica Neue"/>
+                <a:ea typeface="Helvetica Neue"/>
+                <a:cs typeface="Helvetica Neue"/>
+              </a:rPr>
+              <a:t>12</a:t>
+            </a:r>
+          </a:p>
+        </p:txBody>
+      </p:sp>
+      <p:sp>
+        <p:nvSpPr>
+          <p:cNvPr id="103" name="measure-l2r-label">
+            <a:extLst xmlns:a="http://schemas.openxmlformats.org/drawingml/2006/main">
+              <a:ext uri="{FF2B5EF4-FFF2-40B4-BE49-F238E27FC236}">
+                <a16:creationId xmlns:a16="http://schemas.microsoft.com/office/drawing/2014/main" id="{DFA3461E-90F0-4773-9450-B9A0D1C52B9C}"/>
+              </a:ext>
+            </a:extLst>
+          </p:cNvPr>
+          <p:cNvSpPr>
+            <a:spLocks xmlns:a="http://schemas.openxmlformats.org/drawingml/2006/main" noGrp="1"/>
+          </p:cNvSpPr>
+          <p:nvPr/>
+        </p:nvSpPr>
+        <p:spPr>
+          <a:xfrm xmlns:a="http://schemas.openxmlformats.org/drawingml/2006/main">
+            <a:off x="2247900" y="3857625"/>
+            <a:ext cx="1285875" cy="323850"/>
+          </a:xfrm>
+          <a:prstGeom xmlns:a="http://schemas.openxmlformats.org/drawingml/2006/main" prst="rect">
+            <a:avLst/>
+          </a:prstGeom>
+          <a:noFill xmlns:a="http://schemas.openxmlformats.org/drawingml/2006/main"/>
+          <a:ln xmlns:a="http://schemas.openxmlformats.org/drawingml/2006/main" w="0">
+            <a:noFill/>
+            <a:prstDash val="solid"/>
+          </a:ln>
+        </p:spPr>
+        <p:txBody>
+          <a:bodyPr xmlns:a="http://schemas.openxmlformats.org/drawingml/2006/main" wrap="square" anchor="t">
+            <a:normAutofit fontScale="100000"/>
+          </a:bodyPr>
+          <a:lstStyle xmlns:a="http://schemas.openxmlformats.org/drawingml/2006/main"/>
+          <a:p xmlns:a="http://schemas.openxmlformats.org/drawingml/2006/main">
+            <a:pPr algn="l">
+              <a:defRPr sz="1050" b="1">
+                <a:solidFill>
+                  <a:srgbClr val="596579"/>
+                </a:solidFill>
+                <a:latin typeface="Helvetica Neue"/>
+                <a:ea typeface="Helvetica Neue"/>
+                <a:cs typeface="Helvetica Neue"/>
+              </a:defRPr>
+            </a:pPr>
+            <a:r>
+              <a:rPr sz="1050" b="1">
+                <a:solidFill>
+                  <a:srgbClr val="596579"/>
+                </a:solidFill>
+                <a:latin typeface="Helvetica Neue"/>
+                <a:ea typeface="Helvetica Neue"/>
+                <a:cs typeface="Helvetica Neue"/>
+              </a:rPr>
+              <a:t>opposite direction</a:t>
+            </a:r>
+          </a:p>
+        </p:txBody>
+      </p:sp>
+      <p:sp>
+        <p:nvSpPr>
+          <p:cNvPr id="104" name="measure-adjudication-flow">
+            <a:extLst xmlns:a="http://schemas.openxmlformats.org/drawingml/2006/main">
+              <a:ext uri="{FF2B5EF4-FFF2-40B4-BE49-F238E27FC236}">
+                <a16:creationId xmlns:a16="http://schemas.microsoft.com/office/drawing/2014/main" id="{9412E7DE-6D34-4598-A24F-AF54075FD4EB}"/>
+              </a:ext>
+            </a:extLst>
+          </p:cNvPr>
+          <p:cNvSpPr>
+            <a:spLocks xmlns:a="http://schemas.openxmlformats.org/drawingml/2006/main" noGrp="1"/>
+          </p:cNvSpPr>
+          <p:nvPr/>
+        </p:nvSpPr>
+        <p:spPr>
+          <a:xfrm xmlns:a="http://schemas.openxmlformats.org/drawingml/2006/main">
+            <a:off x="552450" y="4371975"/>
+            <a:ext cx="3048000" cy="361950"/>
+          </a:xfrm>
+          <a:prstGeom xmlns:a="http://schemas.openxmlformats.org/drawingml/2006/main" prst="rect">
+            <a:avLst/>
+          </a:prstGeom>
+          <a:noFill xmlns:a="http://schemas.openxmlformats.org/drawingml/2006/main"/>
+          <a:ln xmlns:a="http://schemas.openxmlformats.org/drawingml/2006/main" w="0">
+            <a:noFill/>
+            <a:prstDash val="solid"/>
+          </a:ln>
+        </p:spPr>
+        <p:txBody>
+          <a:bodyPr xmlns:a="http://schemas.openxmlformats.org/drawingml/2006/main" wrap="square" anchor="ctr">
+            <a:normAutofit fontScale="100000"/>
+          </a:bodyPr>
+          <a:lstStyle xmlns:a="http://schemas.openxmlformats.org/drawingml/2006/main"/>
+          <a:p xmlns:a="http://schemas.openxmlformats.org/drawingml/2006/main">
+            <a:pPr algn="ctr">
+              <a:defRPr sz="1125" b="1">
+                <a:solidFill>
+                  <a:srgbClr val="0A9F43"/>
+                </a:solidFill>
+                <a:latin typeface="Helvetica Neue"/>
+                <a:ea typeface="Helvetica Neue"/>
+                <a:cs typeface="Helvetica Neue"/>
+              </a:defRPr>
+            </a:pPr>
+            <a:r>
+              <a:rPr sz="1125" b="1">
+                <a:solidFill>
+                  <a:srgbClr val="0A9F43"/>
+                </a:solidFill>
+                <a:latin typeface="Helvetica Neue"/>
+                <a:ea typeface="Helvetica Neue"/>
+                <a:cs typeface="Helvetica Neue"/>
+              </a:rPr>
+              <a:t>CV-assisted  →  human accepted</a:t>
             </a:r>
           </a:p>
         </p:txBody>
@@ -4452,7 +4777,7 @@
                 <a:ea typeface="Helvetica Neue"/>
                 <a:cs typeface="Helvetica Neue"/>
               </a:rPr>
-              <a:t>Variability creates delay before deterministic saturation</a:t>
+              <a:t>Queueing starts early—and the active bottleneck shifts</a:t>
             </a:r>
           </a:p>
         </p:txBody>
@@ -4506,7 +4831,7 @@
                 <a:ea typeface="Helvetica Neue"/>
                 <a:cs typeface="Helvetica Neue"/>
               </a:rPr>
-              <a:t>AnyLogic HPP vs deterministic ideal · mean P95 total wait · n=50/cell</a:t>
+              <a:t>54-cell capacity surface · mean P95 total wait · n=50/cell</a:t>
             </a:r>
           </a:p>
         </p:txBody>
@@ -4535,59 +4860,57 @@
           </a:prstGeom>
         </p:spPr>
         <p:txBody>
-          <a:bodyPr xmlns:a="http://schemas.openxmlformats.org/drawingml/2006/main" lIns="0" tIns="0" rIns="0" bIns="0" anchor="t">
+          <a:bodyPr xmlns:a="http://schemas.openxmlformats.org/drawingml/2006/main" wrap="square" lIns="19050" tIns="19050" rIns="19050" bIns="19050" anchor="ctr">
             <a:normAutofit fontScale="100000"/>
           </a:bodyPr>
           <a:lstStyle xmlns:a="http://schemas.openxmlformats.org/drawingml/2006/main"/>
           <a:p xmlns:a="http://schemas.openxmlformats.org/drawingml/2006/main">
-            <a:pPr>
+            <a:pPr algn="l">
               <a:spcAft>
                 <a:spcPts val="4"/>
               </a:spcAft>
-              <a:buNone/>
-              <a:defRPr sz="1600">
-                <a:solidFill>
-                  <a:srgbClr val="000000"/>
-                </a:solidFill>
-                <a:latin typeface="Helvetica Neue"/>
-                <a:ea typeface="Helvetica Neue"/>
-                <a:cs typeface="Helvetica Neue"/>
-              </a:defRPr>
-            </a:pPr>
-            <a:r>
-              <a:rPr sz="1600" b="1">
-                <a:solidFill>
-                  <a:srgbClr val="000000"/>
-                </a:solidFill>
-                <a:latin typeface="Helvetica Neue"/>
-                <a:ea typeface="Helvetica Neue"/>
-                <a:cs typeface="Helvetica Neue"/>
-              </a:rPr>
-              <a:t>Variability arrives early</a:t>
-            </a:r>
-          </a:p>
-          <a:p xmlns:a="http://schemas.openxmlformats.org/drawingml/2006/main">
-            <a:pPr>
-              <a:buNone/>
-              <a:defRPr sz="1600">
-                <a:solidFill>
-                  <a:srgbClr val="000000"/>
-                </a:solidFill>
-                <a:latin typeface="Helvetica Neue"/>
-                <a:ea typeface="Helvetica Neue"/>
-                <a:cs typeface="Helvetica Neue"/>
-              </a:defRPr>
-            </a:pPr>
-            <a:r>
-              <a:rPr sz="1600">
-                <a:solidFill>
-                  <a:srgbClr val="000000"/>
-                </a:solidFill>
-                <a:latin typeface="Helvetica Neue"/>
-                <a:ea typeface="Helvetica Neue"/>
-                <a:cs typeface="Helvetica Neue"/>
-              </a:rPr>
-              <a:t>At 36/21, ideal P95 is 0 s while HPP is 3.93 s.</a:t>
+              <a:defRPr sz="1200">
+                <a:solidFill>
+                  <a:srgbClr val="000000"/>
+                </a:solidFill>
+                <a:latin typeface="Helvetica Neue"/>
+                <a:ea typeface="Helvetica Neue"/>
+                <a:cs typeface="Helvetica Neue"/>
+              </a:defRPr>
+            </a:pPr>
+            <a:r>
+              <a:rPr sz="1200" b="1">
+                <a:solidFill>
+                  <a:srgbClr val="000000"/>
+                </a:solidFill>
+                <a:latin typeface="Helvetica Neue"/>
+                <a:ea typeface="Helvetica Neue"/>
+                <a:cs typeface="Helvetica Neue"/>
+              </a:rPr>
+              <a:t>Queueing starts early</a:t>
+            </a:r>
+          </a:p>
+          <a:p xmlns:a="http://schemas.openxmlformats.org/drawingml/2006/main">
+            <a:pPr algn="l">
+              <a:defRPr sz="1200">
+                <a:solidFill>
+                  <a:srgbClr val="000000"/>
+                </a:solidFill>
+                <a:latin typeface="Helvetica Neue"/>
+                <a:ea typeface="Helvetica Neue"/>
+                <a:cs typeface="Helvetica Neue"/>
+              </a:defRPr>
+            </a:pPr>
+            <a:r>
+              <a:rPr sz="1200">
+                <a:solidFill>
+                  <a:srgbClr val="000000"/>
+                </a:solidFill>
+                <a:latin typeface="Helvetica Neue"/>
+                <a:ea typeface="Helvetica Neue"/>
+                <a:cs typeface="Helvetica Neue"/>
+              </a:rPr>
+              <a:t>At 36/21, ideal P95 is 0 s; HPP arrivals produce 3.93 s.</a:t>
             </a:r>
           </a:p>
         </p:txBody>
@@ -4616,59 +4939,57 @@
           </a:prstGeom>
         </p:spPr>
         <p:txBody>
-          <a:bodyPr xmlns:a="http://schemas.openxmlformats.org/drawingml/2006/main" lIns="0" tIns="0" rIns="0" bIns="0" anchor="t">
+          <a:bodyPr xmlns:a="http://schemas.openxmlformats.org/drawingml/2006/main" wrap="square" lIns="19050" tIns="19050" rIns="19050" bIns="19050" anchor="ctr">
             <a:normAutofit fontScale="100000"/>
           </a:bodyPr>
           <a:lstStyle xmlns:a="http://schemas.openxmlformats.org/drawingml/2006/main"/>
           <a:p xmlns:a="http://schemas.openxmlformats.org/drawingml/2006/main">
-            <a:pPr>
+            <a:pPr algn="l">
               <a:spcAft>
                 <a:spcPts val="4"/>
               </a:spcAft>
-              <a:buNone/>
-              <a:defRPr sz="1600">
-                <a:solidFill>
-                  <a:srgbClr val="000000"/>
-                </a:solidFill>
-                <a:latin typeface="Helvetica Neue"/>
-                <a:ea typeface="Helvetica Neue"/>
-                <a:cs typeface="Helvetica Neue"/>
-              </a:defRPr>
-            </a:pPr>
-            <a:r>
-              <a:rPr sz="1600" b="1">
-                <a:solidFill>
-                  <a:srgbClr val="000000"/>
-                </a:solidFill>
-                <a:latin typeface="Helvetica Neue"/>
-                <a:ea typeface="Helvetica Neue"/>
-                <a:cs typeface="Helvetica Neue"/>
-              </a:rPr>
-              <a:t>Penalty accelerates near ρ ≈ 1</a:t>
-            </a:r>
-          </a:p>
-          <a:p xmlns:a="http://schemas.openxmlformats.org/drawingml/2006/main">
-            <a:pPr>
-              <a:buNone/>
-              <a:defRPr sz="1600">
-                <a:solidFill>
-                  <a:srgbClr val="000000"/>
-                </a:solidFill>
-                <a:latin typeface="Helvetica Neue"/>
-                <a:ea typeface="Helvetica Neue"/>
-                <a:cs typeface="Helvetica Neue"/>
-              </a:defRPr>
-            </a:pPr>
-            <a:r>
-              <a:rPr sz="1600">
-                <a:solidFill>
-                  <a:srgbClr val="000000"/>
-                </a:solidFill>
-                <a:latin typeface="Helvetica Neue"/>
-                <a:ea typeface="Helvetica Neue"/>
-                <a:cs typeface="Helvetica Neue"/>
-              </a:rPr>
-              <a:t>Security step: 0.29→6.98 s. Immigration: 1.31→14.68 s.</a:t>
+              <a:defRPr sz="1200">
+                <a:solidFill>
+                  <a:srgbClr val="000000"/>
+                </a:solidFill>
+                <a:latin typeface="Helvetica Neue"/>
+                <a:ea typeface="Helvetica Neue"/>
+                <a:cs typeface="Helvetica Neue"/>
+              </a:defRPr>
+            </a:pPr>
+            <a:r>
+              <a:rPr sz="1200" b="1">
+                <a:solidFill>
+                  <a:srgbClr val="000000"/>
+                </a:solidFill>
+                <a:latin typeface="Helvetica Neue"/>
+                <a:ea typeface="Helvetica Neue"/>
+                <a:cs typeface="Helvetica Neue"/>
+              </a:rPr>
+              <a:t>The bottleneck shifts</a:t>
+            </a:r>
+          </a:p>
+          <a:p xmlns:a="http://schemas.openxmlformats.org/drawingml/2006/main">
+            <a:pPr algn="l">
+              <a:defRPr sz="1200">
+                <a:solidFill>
+                  <a:srgbClr val="000000"/>
+                </a:solidFill>
+                <a:latin typeface="Helvetica Neue"/>
+                <a:ea typeface="Helvetica Neue"/>
+                <a:cs typeface="Helvetica Neue"/>
+              </a:defRPr>
+            </a:pPr>
+            <a:r>
+              <a:rPr sz="1200">
+                <a:solidFill>
+                  <a:srgbClr val="000000"/>
+                </a:solidFill>
+                <a:latin typeface="Helvetica Neue"/>
+                <a:ea typeface="Helvetica Neue"/>
+                <a:cs typeface="Helvetica Neue"/>
+              </a:rPr>
+              <a:t>At I16, Security is masked; at S28, Immigration is masked.</a:t>
             </a:r>
           </a:p>
         </p:txBody>
@@ -4697,59 +5018,57 @@
           </a:prstGeom>
         </p:spPr>
         <p:txBody>
-          <a:bodyPr xmlns:a="http://schemas.openxmlformats.org/drawingml/2006/main" lIns="0" tIns="0" rIns="0" bIns="0" anchor="t">
+          <a:bodyPr xmlns:a="http://schemas.openxmlformats.org/drawingml/2006/main" wrap="square" lIns="19050" tIns="19050" rIns="19050" bIns="19050" anchor="ctr">
             <a:normAutofit fontScale="100000"/>
           </a:bodyPr>
           <a:lstStyle xmlns:a="http://schemas.openxmlformats.org/drawingml/2006/main"/>
           <a:p xmlns:a="http://schemas.openxmlformats.org/drawingml/2006/main">
-            <a:pPr>
+            <a:pPr algn="l">
               <a:spcAft>
                 <a:spcPts val="4"/>
               </a:spcAft>
-              <a:buNone/>
-              <a:defRPr sz="1600">
-                <a:solidFill>
-                  <a:srgbClr val="000000"/>
-                </a:solidFill>
-                <a:latin typeface="Helvetica Neue"/>
-                <a:ea typeface="Helvetica Neue"/>
-                <a:cs typeface="Helvetica Neue"/>
-              </a:defRPr>
-            </a:pPr>
-            <a:r>
-              <a:rPr sz="1600" b="1">
-                <a:solidFill>
-                  <a:srgbClr val="000000"/>
-                </a:solidFill>
-                <a:latin typeface="Helvetica Neue"/>
-                <a:ea typeface="Helvetica Neue"/>
-                <a:cs typeface="Helvetica Neue"/>
-              </a:rPr>
-              <a:t>Audited, not smoothed</a:t>
-            </a:r>
-          </a:p>
-          <a:p xmlns:a="http://schemas.openxmlformats.org/drawingml/2006/main">
-            <a:pPr>
-              <a:buNone/>
-              <a:defRPr sz="1600">
-                <a:solidFill>
-                  <a:srgbClr val="000000"/>
-                </a:solidFill>
-                <a:latin typeface="Helvetica Neue"/>
-                <a:ea typeface="Helvetica Neue"/>
-                <a:cs typeface="Helvetica Neue"/>
-              </a:defRPr>
-            </a:pPr>
-            <a:r>
-              <a:rPr sz="1600">
-                <a:solidFill>
-                  <a:srgbClr val="000000"/>
-                </a:solidFill>
-                <a:latin typeface="Helvetica Neue"/>
-                <a:ea typeface="Helvetica Neue"/>
-                <a:cs typeface="Helvetica Neue"/>
-              </a:rPr>
-              <a:t>54 cells × 50. 2,700 COMPLETE; 1,113,588 traveller rows; CRN PASS.</a:t>
+              <a:defRPr sz="1200">
+                <a:solidFill>
+                  <a:srgbClr val="000000"/>
+                </a:solidFill>
+                <a:latin typeface="Helvetica Neue"/>
+                <a:ea typeface="Helvetica Neue"/>
+                <a:cs typeface="Helvetica Neue"/>
+              </a:defRPr>
+            </a:pPr>
+            <a:r>
+              <a:rPr sz="1200" b="1">
+                <a:solidFill>
+                  <a:srgbClr val="000000"/>
+                </a:solidFill>
+                <a:latin typeface="Helvetica Neue"/>
+                <a:ea typeface="Helvetica Neue"/>
+                <a:cs typeface="Helvetica Neue"/>
+              </a:rPr>
+              <a:t>Interpret the regime</a:t>
+            </a:r>
+          </a:p>
+          <a:p xmlns:a="http://schemas.openxmlformats.org/drawingml/2006/main">
+            <a:pPr algn="l">
+              <a:defRPr sz="1200">
+                <a:solidFill>
+                  <a:srgbClr val="000000"/>
+                </a:solidFill>
+                <a:latin typeface="Helvetica Neue"/>
+                <a:ea typeface="Helvetica Neue"/>
+                <a:cs typeface="Helvetica Neue"/>
+              </a:defRPr>
+            </a:pPr>
+            <a:r>
+              <a:rPr sz="1200">
+                <a:solidFill>
+                  <a:srgbClr val="000000"/>
+                </a:solidFill>
+                <a:latin typeface="Helvetica Neue"/>
+                <a:ea typeface="Helvetica Neue"/>
+                <a:cs typeface="Helvetica Neue"/>
+              </a:rPr>
+              <a:t>Near ρ ≈ 1, one lost position creates a much larger delay penalty.</a:t>
             </a:r>
           </a:p>
         </p:txBody>
@@ -4778,56 +5097,56 @@
           </a:prstGeom>
         </p:spPr>
         <p:txBody>
-          <a:bodyPr xmlns:a="http://schemas.openxmlformats.org/drawingml/2006/main" lIns="0" tIns="0" rIns="0" bIns="0" anchor="t">
-            <a:noAutofit/>
+          <a:bodyPr xmlns:a="http://schemas.openxmlformats.org/drawingml/2006/main" wrap="square" lIns="0" tIns="0" rIns="0" bIns="0" anchor="t">
+            <a:normAutofit fontScale="100000"/>
           </a:bodyPr>
           <a:lstStyle xmlns:a="http://schemas.openxmlformats.org/drawingml/2006/main"/>
           <a:p xmlns:a="http://schemas.openxmlformats.org/drawingml/2006/main">
             <a:pPr algn="l">
               <a:buNone/>
-              <a:defRPr sz="1600" b="0">
-                <a:solidFill>
-                  <a:srgbClr val="5E6570"/>
-                </a:solidFill>
-                <a:latin typeface="Helvetica Neue"/>
-                <a:ea typeface="Helvetica Neue"/>
-                <a:cs typeface="Helvetica Neue"/>
-              </a:defRPr>
-            </a:pPr>
-            <a:r>
-              <a:rPr sz="1600" b="0">
-                <a:solidFill>
-                  <a:srgbClr val="5E6570"/>
-                </a:solidFill>
-                <a:latin typeface="Helvetica Neue"/>
-                <a:ea typeface="Helvetica Neue"/>
-                <a:cs typeface="Helvetica Neue"/>
-              </a:rPr>
-              <a:t>300-s terminating cohort · empty/idle start · full drain; ideal = regular arrivals + fixed service.</a:t>
+              <a:defRPr sz="1050" b="0">
+                <a:solidFill>
+                  <a:srgbClr val="596579"/>
+                </a:solidFill>
+                <a:latin typeface="Helvetica Neue"/>
+                <a:ea typeface="Helvetica Neue"/>
+                <a:cs typeface="Helvetica Neue"/>
+              </a:defRPr>
+            </a:pPr>
+            <a:r>
+              <a:rPr sz="1050" b="0">
+                <a:solidFill>
+                  <a:srgbClr val="596579"/>
+                </a:solidFill>
+                <a:latin typeface="Helvetica Neue"/>
+                <a:ea typeface="Helvetica Neue"/>
+                <a:cs typeface="Helvetica Neue"/>
+              </a:rPr>
+              <a:t>300-s Base cohort · pooled FCFS · fixed service · empty/idle start · full drain</a:t>
             </a:r>
           </a:p>
           <a:p xmlns:a="http://schemas.openxmlformats.org/drawingml/2006/main">
             <a:pPr algn="l">
               <a:buNone/>
-              <a:defRPr sz="1600" b="0">
-                <a:solidFill>
-                  <a:srgbClr val="5E6570"/>
-                </a:solidFill>
-                <a:latin typeface="Helvetica Neue"/>
-                <a:ea typeface="Helvetica Neue"/>
-                <a:cs typeface="Helvetica Neue"/>
-              </a:defRPr>
-            </a:pPr>
-            <a:r>
-              <a:rPr sz="1600" b="0">
-                <a:solidFill>
-                  <a:srgbClr val="5E6570"/>
-                </a:solidFill>
-                <a:latin typeface="Helvetica Neue"/>
-                <a:ea typeface="Helvetica Neue"/>
-                <a:cs typeface="Helvetica Neue"/>
-              </a:rPr>
-              <a:t>Cell-mean P95 spans 3.93–35.92 s; neither series is a calibrated site forecast.</a:t>
+              <a:defRPr sz="1050" b="0">
+                <a:solidFill>
+                  <a:srgbClr val="596579"/>
+                </a:solidFill>
+                <a:latin typeface="Helvetica Neue"/>
+                <a:ea typeface="Helvetica Neue"/>
+                <a:cs typeface="Helvetica Neue"/>
+              </a:defRPr>
+            </a:pPr>
+            <a:r>
+              <a:rPr sz="1050" b="0">
+                <a:solidFill>
+                  <a:srgbClr val="596579"/>
+                </a:solidFill>
+                <a:latin typeface="Helvetica Neue"/>
+                <a:ea typeface="Helvetica Neue"/>
+                <a:cs typeface="Helvetica Neue"/>
+              </a:rPr>
+              <a:t>54 cells × 50; 2,700 COMPLETE; CRN + validation PASS—not a site forecast.</a:t>
             </a:r>
           </a:p>
         </p:txBody>
@@ -4856,21 +5175,31 @@
           </a:prstGeom>
         </p:spPr>
         <p:txBody>
-          <a:bodyPr xmlns:a="http://schemas.openxmlformats.org/drawingml/2006/main" lIns="0" tIns="0" rIns="0" bIns="0" anchor="b"/>
-          <a:lstStyle xmlns:a="http://schemas.openxmlformats.org/drawingml/2006/main"/>
-          <a:p xmlns:a="http://schemas.openxmlformats.org/drawingml/2006/main">
-            <a:pPr algn="r">
+          <a:bodyPr xmlns:a="http://schemas.openxmlformats.org/drawingml/2006/main" wrap="square" lIns="0" tIns="0" rIns="0" bIns="0" anchor="t">
+            <a:normAutofit fontScale="100000"/>
+          </a:bodyPr>
+          <a:lstStyle xmlns:a="http://schemas.openxmlformats.org/drawingml/2006/main"/>
+          <a:p xmlns:a="http://schemas.openxmlformats.org/drawingml/2006/main">
+            <a:pPr algn="ctr">
               <a:buNone/>
-              <a:defRPr sz="1000">
-                <a:solidFill>
-                  <a:srgbClr val="000000"/>
-                </a:solidFill>
-                <a:latin typeface="Helvetica Neue"/>
-                <a:ea typeface="Helvetica Neue"/>
-                <a:cs typeface="Helvetica Neue"/>
-              </a:defRPr>
-            </a:pPr>
-            <a:r>
+              <a:defRPr sz="975">
+                <a:solidFill>
+                  <a:srgbClr val="000000"/>
+                </a:solidFill>
+                <a:latin typeface="Helvetica Neue"/>
+                <a:ea typeface="Helvetica Neue"/>
+                <a:cs typeface="Helvetica Neue"/>
+              </a:defRPr>
+            </a:pPr>
+            <a:r>
+              <a:rPr sz="975">
+                <a:solidFill>
+                  <a:srgbClr val="000000"/>
+                </a:solidFill>
+                <a:latin typeface="Helvetica Neue"/>
+                <a:ea typeface="Helvetica Neue"/>
+                <a:cs typeface="Helvetica Neue"/>
+              </a:rPr>
               <a:t>3</a:t>
             </a:r>
           </a:p>
@@ -4885,13 +5214,16 @@
           <p:nvPr/>
         </p:nvPicPr>
         <p:blipFill>
-          <a:blip xmlns:r="http://schemas.openxmlformats.org/officeDocument/2006/relationships" xmlns:a="http://schemas.openxmlformats.org/drawingml/2006/main" r:embed="Rf08fa1ab821f49ec"/>
-          <a:stretch xmlns:a="http://schemas.openxmlformats.org/drawingml/2006/main"/>
+          <a:blip xmlns:r="http://schemas.openxmlformats.org/officeDocument/2006/relationships" xmlns:a="http://schemas.openxmlformats.org/drawingml/2006/main" r:embed="Raa1bd7119d684c87"/>
+          <a:srcRect xmlns:a="http://schemas.openxmlformats.org/drawingml/2006/main" l="0" t="9865" r="0" b="9865"/>
+          <a:stretch xmlns:a="http://schemas.openxmlformats.org/drawingml/2006/main">
+            <a:fillRect l="0" t="0" r="0" b="0"/>
+          </a:stretch>
         </p:blipFill>
         <p:spPr>
           <a:xfrm xmlns:a="http://schemas.openxmlformats.org/drawingml/2006/main">
-            <a:off x="400050" y="1974745"/>
-            <a:ext cx="7620000" cy="3175210"/>
+            <a:off x="400050" y="1381125"/>
+            <a:ext cx="7620000" cy="4476750"/>
           </a:xfrm>
           <a:prstGeom xmlns:a="http://schemas.openxmlformats.org/drawingml/2006/main" prst="rect">
             <a:avLst/>
@@ -4969,7 +5301,7 @@
                 <a:ea typeface="Helvetica Neue"/>
                 <a:cs typeface="Helvetica Neue"/>
               </a:rPr>
-              <a:t>The bottleneck shifts—but waits stay sub-minute at this model scale</a:t>
+              <a:t>Duration exposes the operating regime around ρ ≈ 1</a:t>
             </a:r>
           </a:p>
         </p:txBody>
@@ -5023,7 +5355,7 @@
                 <a:ea typeface="Helvetica Neue"/>
                 <a:cs typeface="Helvetica Neue"/>
               </a:rPr>
-              <a:t>54 cells · Base-demand mean P95 total wait · n=50/cell</a:t>
+              <a:t>Stationary-HPP duration sensitivity · n=50/cell</a:t>
             </a:r>
           </a:p>
         </p:txBody>
@@ -5052,59 +5384,57 @@
           </a:prstGeom>
         </p:spPr>
         <p:txBody>
-          <a:bodyPr xmlns:a="http://schemas.openxmlformats.org/drawingml/2006/main" lIns="0" tIns="0" rIns="0" bIns="0" anchor="t">
-            <a:normAutofit fontScale="95651"/>
+          <a:bodyPr xmlns:a="http://schemas.openxmlformats.org/drawingml/2006/main" wrap="square" lIns="19050" tIns="19050" rIns="19050" bIns="19050" anchor="ctr">
+            <a:normAutofit fontScale="100000"/>
           </a:bodyPr>
           <a:lstStyle xmlns:a="http://schemas.openxmlformats.org/drawingml/2006/main"/>
           <a:p xmlns:a="http://schemas.openxmlformats.org/drawingml/2006/main">
-            <a:pPr>
+            <a:pPr algn="l">
               <a:spcAft>
                 <a:spcPts val="4"/>
               </a:spcAft>
-              <a:buNone/>
-              <a:defRPr sz="1600">
-                <a:solidFill>
-                  <a:srgbClr val="000000"/>
-                </a:solidFill>
-                <a:latin typeface="Helvetica Neue"/>
-                <a:ea typeface="Helvetica Neue"/>
-                <a:cs typeface="Helvetica Neue"/>
-              </a:defRPr>
-            </a:pPr>
-            <a:r>
-              <a:rPr sz="1600" b="1">
-                <a:solidFill>
-                  <a:srgbClr val="000000"/>
-                </a:solidFill>
-                <a:latin typeface="Helvetica Neue"/>
-                <a:ea typeface="Helvetica Neue"/>
-                <a:cs typeface="Helvetica Neue"/>
-              </a:rPr>
-              <a:t>Immigration dominates</a:t>
-            </a:r>
-          </a:p>
-          <a:p xmlns:a="http://schemas.openxmlformats.org/drawingml/2006/main">
-            <a:pPr>
-              <a:buNone/>
-              <a:defRPr sz="1600">
-                <a:solidFill>
-                  <a:srgbClr val="000000"/>
-                </a:solidFill>
-                <a:latin typeface="Helvetica Neue"/>
-                <a:ea typeface="Helvetica Neue"/>
-                <a:cs typeface="Helvetica Neue"/>
-              </a:defRPr>
-            </a:pPr>
-            <a:r>
-              <a:rPr sz="1600">
-                <a:solidFill>
-                  <a:srgbClr val="000000"/>
-                </a:solidFill>
-                <a:latin typeface="Helvetica Neue"/>
-                <a:ea typeface="Helvetica Neue"/>
-                <a:cs typeface="Helvetica Neue"/>
-              </a:rPr>
-              <a:t>At I16, S36→31 remains ≈35.61 s; Security capacity changes are initially masked.</a:t>
+              <a:defRPr sz="1200">
+                <a:solidFill>
+                  <a:srgbClr val="000000"/>
+                </a:solidFill>
+                <a:latin typeface="Helvetica Neue"/>
+                <a:ea typeface="Helvetica Neue"/>
+                <a:cs typeface="Helvetica Neue"/>
+              </a:defRPr>
+            </a:pPr>
+            <a:r>
+              <a:rPr sz="1200" b="1">
+                <a:solidFill>
+                  <a:srgbClr val="000000"/>
+                </a:solidFill>
+                <a:latin typeface="Helvetica Neue"/>
+                <a:ea typeface="Helvetica Neue"/>
+                <a:cs typeface="Helvetica Neue"/>
+              </a:rPr>
+              <a:t>Stable / near-critical</a:t>
+            </a:r>
+          </a:p>
+          <a:p xmlns:a="http://schemas.openxmlformats.org/drawingml/2006/main">
+            <a:pPr algn="l">
+              <a:defRPr sz="1200">
+                <a:solidFill>
+                  <a:srgbClr val="000000"/>
+                </a:solidFill>
+                <a:latin typeface="Helvetica Neue"/>
+                <a:ea typeface="Helvetica Neue"/>
+                <a:cs typeface="Helvetica Neue"/>
+              </a:defRPr>
+            </a:pPr>
+            <a:r>
+              <a:rPr sz="1200">
+                <a:solidFill>
+                  <a:srgbClr val="000000"/>
+                </a:solidFill>
+                <a:latin typeface="Helvetica Neue"/>
+                <a:ea typeface="Helvetica Neue"/>
+                <a:cs typeface="Helvetica Neue"/>
+              </a:rPr>
+              <a:t>ρ=.845: 4.47 s at 120 min. ρ=.992: 55.91 s.</a:t>
             </a:r>
           </a:p>
         </p:txBody>
@@ -5133,59 +5463,57 @@
           </a:prstGeom>
         </p:spPr>
         <p:txBody>
-          <a:bodyPr xmlns:a="http://schemas.openxmlformats.org/drawingml/2006/main" lIns="0" tIns="0" rIns="0" bIns="0" anchor="t">
-            <a:normAutofit fontScale="95651"/>
+          <a:bodyPr xmlns:a="http://schemas.openxmlformats.org/drawingml/2006/main" wrap="square" lIns="19050" tIns="19050" rIns="19050" bIns="19050" anchor="ctr">
+            <a:normAutofit fontScale="100000"/>
           </a:bodyPr>
           <a:lstStyle xmlns:a="http://schemas.openxmlformats.org/drawingml/2006/main"/>
           <a:p xmlns:a="http://schemas.openxmlformats.org/drawingml/2006/main">
-            <a:pPr>
+            <a:pPr algn="l">
               <a:spcAft>
                 <a:spcPts val="4"/>
               </a:spcAft>
-              <a:buNone/>
-              <a:defRPr sz="1600">
-                <a:solidFill>
-                  <a:srgbClr val="000000"/>
-                </a:solidFill>
-                <a:latin typeface="Helvetica Neue"/>
-                <a:ea typeface="Helvetica Neue"/>
-                <a:cs typeface="Helvetica Neue"/>
-              </a:defRPr>
-            </a:pPr>
-            <a:r>
-              <a:rPr sz="1600" b="1">
-                <a:solidFill>
-                  <a:srgbClr val="000000"/>
-                </a:solidFill>
-                <a:latin typeface="Helvetica Neue"/>
-                <a:ea typeface="Helvetica Neue"/>
-                <a:cs typeface="Helvetica Neue"/>
-              </a:rPr>
-              <a:t>Security dominates</a:t>
-            </a:r>
-          </a:p>
-          <a:p xmlns:a="http://schemas.openxmlformats.org/drawingml/2006/main">
-            <a:pPr>
-              <a:buNone/>
-              <a:defRPr sz="1600">
-                <a:solidFill>
-                  <a:srgbClr val="000000"/>
-                </a:solidFill>
-                <a:latin typeface="Helvetica Neue"/>
-                <a:ea typeface="Helvetica Neue"/>
-                <a:cs typeface="Helvetica Neue"/>
-              </a:defRPr>
-            </a:pPr>
-            <a:r>
-              <a:rPr sz="1600">
-                <a:solidFill>
-                  <a:srgbClr val="000000"/>
-                </a:solidFill>
-                <a:latin typeface="Helvetica Neue"/>
-                <a:ea typeface="Helvetica Neue"/>
-                <a:cs typeface="Helvetica Neue"/>
-              </a:rPr>
-              <a:t>At S28, I21→17 moves only 24.43→25.38 s; Immigration capacity changes are initially masked.</a:t>
+              <a:defRPr sz="1200">
+                <a:solidFill>
+                  <a:srgbClr val="000000"/>
+                </a:solidFill>
+                <a:latin typeface="Helvetica Neue"/>
+                <a:ea typeface="Helvetica Neue"/>
+                <a:cs typeface="Helvetica Neue"/>
+              </a:defRPr>
+            </a:pPr>
+            <a:r>
+              <a:rPr sz="1200" b="1">
+                <a:solidFill>
+                  <a:srgbClr val="000000"/>
+                </a:solidFill>
+                <a:latin typeface="Helvetica Neue"/>
+                <a:ea typeface="Helvetica Neue"/>
+                <a:cs typeface="Helvetica Neue"/>
+              </a:rPr>
+              <a:t>Accumulating</a:t>
+            </a:r>
+          </a:p>
+          <a:p xmlns:a="http://schemas.openxmlformats.org/drawingml/2006/main">
+            <a:pPr algn="l">
+              <a:defRPr sz="1200">
+                <a:solidFill>
+                  <a:srgbClr val="000000"/>
+                </a:solidFill>
+                <a:latin typeface="Helvetica Neue"/>
+                <a:ea typeface="Helvetica Neue"/>
+                <a:cs typeface="Helvetica Neue"/>
+              </a:defRPr>
+            </a:pPr>
+            <a:r>
+              <a:rPr sz="1200">
+                <a:solidFill>
+                  <a:srgbClr val="000000"/>
+                </a:solidFill>
+                <a:latin typeface="Helvetica Neue"/>
+                <a:ea typeface="Helvetica Neue"/>
+                <a:cs typeface="Helvetica Neue"/>
+              </a:rPr>
+              <a:t>ρ=1.043: 307 s. ρ=1.108: 748 s.</a:t>
             </a:r>
           </a:p>
         </p:txBody>
@@ -5214,59 +5542,57 @@
           </a:prstGeom>
         </p:spPr>
         <p:txBody>
-          <a:bodyPr xmlns:a="http://schemas.openxmlformats.org/drawingml/2006/main" lIns="0" tIns="0" rIns="0" bIns="0" anchor="t">
-            <a:normAutofit fontScale="95651"/>
+          <a:bodyPr xmlns:a="http://schemas.openxmlformats.org/drawingml/2006/main" wrap="square" lIns="19050" tIns="19050" rIns="19050" bIns="19050" anchor="ctr">
+            <a:normAutofit fontScale="100000"/>
           </a:bodyPr>
           <a:lstStyle xmlns:a="http://schemas.openxmlformats.org/drawingml/2006/main"/>
           <a:p xmlns:a="http://schemas.openxmlformats.org/drawingml/2006/main">
-            <a:pPr>
+            <a:pPr algn="l">
               <a:spcAft>
                 <a:spcPts val="4"/>
               </a:spcAft>
-              <a:buNone/>
-              <a:defRPr sz="1600">
-                <a:solidFill>
-                  <a:srgbClr val="000000"/>
-                </a:solidFill>
-                <a:latin typeface="Helvetica Neue"/>
-                <a:ea typeface="Helvetica Neue"/>
-                <a:cs typeface="Helvetica Neue"/>
-              </a:defRPr>
-            </a:pPr>
-            <a:r>
-              <a:rPr sz="1600" b="1">
-                <a:solidFill>
-                  <a:srgbClr val="000000"/>
-                </a:solidFill>
-                <a:latin typeface="Helvetica Neue"/>
-                <a:ea typeface="Helvetica Neue"/>
-                <a:cs typeface="Helvetica Neue"/>
-              </a:rPr>
-              <a:t>Upstream metering</a:t>
-            </a:r>
-          </a:p>
-          <a:p xmlns:a="http://schemas.openxmlformats.org/drawingml/2006/main">
-            <a:pPr>
-              <a:buNone/>
-              <a:defRPr sz="1600">
-                <a:solidFill>
-                  <a:srgbClr val="000000"/>
-                </a:solidFill>
-                <a:latin typeface="Helvetica Neue"/>
-                <a:ea typeface="Helvetica Neue"/>
-                <a:cs typeface="Helvetica Neue"/>
-              </a:defRPr>
-            </a:pPr>
-            <a:r>
-              <a:rPr sz="1600">
-                <a:solidFill>
-                  <a:srgbClr val="000000"/>
-                </a:solidFill>
-                <a:latin typeface="Helvetica Neue"/>
-                <a:ea typeface="Helvetica Neue"/>
-                <a:cs typeface="Helvetica Neue"/>
-              </a:rPr>
-              <a:t>S30→29 with I18→17: DiD −4.02 s [−4.72, −3.32]. Negative means sub-additive—not beneficial.</a:t>
+              <a:defRPr sz="1200">
+                <a:solidFill>
+                  <a:srgbClr val="000000"/>
+                </a:solidFill>
+                <a:latin typeface="Helvetica Neue"/>
+                <a:ea typeface="Helvetica Neue"/>
+                <a:cs typeface="Helvetica Neue"/>
+              </a:defRPr>
+            </a:pPr>
+            <a:r>
+              <a:rPr sz="1200" b="1">
+                <a:solidFill>
+                  <a:srgbClr val="000000"/>
+                </a:solidFill>
+                <a:latin typeface="Helvetica Neue"/>
+                <a:ea typeface="Helvetica Neue"/>
+                <a:cs typeface="Helvetica Neue"/>
+              </a:rPr>
+              <a:t>Robustness checks</a:t>
+            </a:r>
+          </a:p>
+          <a:p xmlns:a="http://schemas.openxmlformats.org/drawingml/2006/main">
+            <a:pPr algn="l">
+              <a:defRPr sz="1200">
+                <a:solidFill>
+                  <a:srgbClr val="000000"/>
+                </a:solidFill>
+                <a:latin typeface="Helvetica Neue"/>
+                <a:ea typeface="Helvetica Neue"/>
+                <a:cs typeface="Helvetica Neue"/>
+              </a:defRPr>
+            </a:pPr>
+            <a:r>
+              <a:rPr sz="1200">
+                <a:solidFill>
+                  <a:srgbClr val="000000"/>
+                </a:solidFill>
+                <a:latin typeface="Helvetica Neue"/>
+                <a:ea typeface="Helvetica Neue"/>
+                <a:cs typeface="Helvetica Neue"/>
+              </a:rPr>
+              <a:t>Joint CV1: +96.0 s clearance. Separate queues: +7.58 s P95.</a:t>
             </a:r>
           </a:p>
         </p:txBody>
@@ -5295,56 +5621,56 @@
           </a:prstGeom>
         </p:spPr>
         <p:txBody>
-          <a:bodyPr xmlns:a="http://schemas.openxmlformats.org/drawingml/2006/main" lIns="0" tIns="0" rIns="0" bIns="0" anchor="t">
-            <a:noAutofit/>
+          <a:bodyPr xmlns:a="http://schemas.openxmlformats.org/drawingml/2006/main" wrap="square" lIns="0" tIns="0" rIns="0" bIns="0" anchor="t">
+            <a:normAutofit fontScale="100000"/>
           </a:bodyPr>
           <a:lstStyle xmlns:a="http://schemas.openxmlformats.org/drawingml/2006/main"/>
           <a:p xmlns:a="http://schemas.openxmlformats.org/drawingml/2006/main">
             <a:pPr algn="l">
               <a:buNone/>
-              <a:defRPr sz="1600" b="0">
-                <a:solidFill>
-                  <a:srgbClr val="5E6570"/>
-                </a:solidFill>
-                <a:latin typeface="Helvetica Neue"/>
-                <a:ea typeface="Helvetica Neue"/>
-                <a:cs typeface="Helvetica Neue"/>
-              </a:defRPr>
-            </a:pPr>
-            <a:r>
-              <a:rPr sz="1600" b="0">
-                <a:solidFill>
-                  <a:srgbClr val="5E6570"/>
-                </a:solidFill>
-                <a:latin typeface="Helvetica Neue"/>
-                <a:ea typeface="Helvetica Neue"/>
-                <a:cs typeface="Helvetica Neue"/>
-              </a:rPr>
-              <a:t>300-s Base cohort · empty/idle start · full drain · n=50/cell</a:t>
+              <a:defRPr sz="1050" b="0">
+                <a:solidFill>
+                  <a:srgbClr val="596579"/>
+                </a:solidFill>
+                <a:latin typeface="Helvetica Neue"/>
+                <a:ea typeface="Helvetica Neue"/>
+                <a:cs typeface="Helvetica Neue"/>
+              </a:defRPr>
+            </a:pPr>
+            <a:r>
+              <a:rPr sz="1050" b="0">
+                <a:solidFill>
+                  <a:srgbClr val="596579"/>
+                </a:solidFill>
+                <a:latin typeface="Helvetica Neue"/>
+                <a:ea typeface="Helvetica Neue"/>
+                <a:cs typeface="Helvetica Neue"/>
+              </a:rPr>
+              <a:t>Only 5/15/30/60/120 min simulated · 1,000/1,000 runs · full drain</a:t>
             </a:r>
           </a:p>
           <a:p xmlns:a="http://schemas.openxmlformats.org/drawingml/2006/main">
             <a:pPr algn="l">
               <a:buNone/>
-              <a:defRPr sz="1600" b="0">
-                <a:solidFill>
-                  <a:srgbClr val="5E6570"/>
-                </a:solidFill>
-                <a:latin typeface="Helvetica Neue"/>
-                <a:ea typeface="Helvetica Neue"/>
-                <a:cs typeface="Helvetica Neue"/>
-              </a:defRPr>
-            </a:pPr>
-            <a:r>
-              <a:rPr sz="1600" b="0">
-                <a:solidFill>
-                  <a:srgbClr val="5E6570"/>
-                </a:solidFill>
-                <a:latin typeface="Helvetica Neue"/>
-                <a:ea typeface="Helvetica Neue"/>
-                <a:cs typeface="Helvetica Neue"/>
-              </a:rPr>
-              <a:t>Cell-mean P95 3.93–35.92 s; 600/900/1200-s exceedance = 0—not an ICA SLA.</a:t>
+              <a:defRPr sz="1050" b="0">
+                <a:solidFill>
+                  <a:srgbClr val="596579"/>
+                </a:solidFill>
+                <a:latin typeface="Helvetica Neue"/>
+                <a:ea typeface="Helvetica Neue"/>
+                <a:cs typeface="Helvetica Neue"/>
+              </a:defRPr>
+            </a:pPr>
+            <a:r>
+              <a:rPr sz="1050" b="0">
+                <a:solidFill>
+                  <a:srgbClr val="596579"/>
+                </a:solidFill>
+                <a:latin typeface="Helvetica Neue"/>
+                <a:ea typeface="Helvetica Neue"/>
+                <a:cs typeface="Helvetica Neue"/>
+              </a:rPr>
+              <a:t>Stationary-HPP sensitivity—not observed time-of-day, steady-state SLA or staffing advice.</a:t>
             </a:r>
           </a:p>
         </p:txBody>
@@ -5373,21 +5699,31 @@
           </a:prstGeom>
         </p:spPr>
         <p:txBody>
-          <a:bodyPr xmlns:a="http://schemas.openxmlformats.org/drawingml/2006/main" lIns="0" tIns="0" rIns="0" bIns="0" anchor="b"/>
-          <a:lstStyle xmlns:a="http://schemas.openxmlformats.org/drawingml/2006/main"/>
-          <a:p xmlns:a="http://schemas.openxmlformats.org/drawingml/2006/main">
-            <a:pPr algn="r">
+          <a:bodyPr xmlns:a="http://schemas.openxmlformats.org/drawingml/2006/main" wrap="square" lIns="0" tIns="0" rIns="0" bIns="0" anchor="t">
+            <a:normAutofit fontScale="100000"/>
+          </a:bodyPr>
+          <a:lstStyle xmlns:a="http://schemas.openxmlformats.org/drawingml/2006/main"/>
+          <a:p xmlns:a="http://schemas.openxmlformats.org/drawingml/2006/main">
+            <a:pPr algn="ctr">
               <a:buNone/>
-              <a:defRPr sz="1000">
-                <a:solidFill>
-                  <a:srgbClr val="000000"/>
-                </a:solidFill>
-                <a:latin typeface="Helvetica Neue"/>
-                <a:ea typeface="Helvetica Neue"/>
-                <a:cs typeface="Helvetica Neue"/>
-              </a:defRPr>
-            </a:pPr>
-            <a:r>
+              <a:defRPr sz="975">
+                <a:solidFill>
+                  <a:srgbClr val="000000"/>
+                </a:solidFill>
+                <a:latin typeface="Helvetica Neue"/>
+                <a:ea typeface="Helvetica Neue"/>
+                <a:cs typeface="Helvetica Neue"/>
+              </a:defRPr>
+            </a:pPr>
+            <a:r>
+              <a:rPr sz="975">
+                <a:solidFill>
+                  <a:srgbClr val="000000"/>
+                </a:solidFill>
+                <a:latin typeface="Helvetica Neue"/>
+                <a:ea typeface="Helvetica Neue"/>
+                <a:cs typeface="Helvetica Neue"/>
+              </a:rPr>
               <a:t>4</a:t>
             </a:r>
           </a:p>
@@ -5402,16 +5738,13 @@
           <p:nvPr/>
         </p:nvPicPr>
         <p:blipFill>
-          <a:blip xmlns:r="http://schemas.openxmlformats.org/officeDocument/2006/relationships" xmlns:a="http://schemas.openxmlformats.org/drawingml/2006/main" r:embed="Rb2ed192b369b413e"/>
-          <a:srcRect xmlns:a="http://schemas.openxmlformats.org/drawingml/2006/main" l="0" t="9865" r="0" b="9865"/>
-          <a:stretch xmlns:a="http://schemas.openxmlformats.org/drawingml/2006/main">
-            <a:fillRect l="0" t="0" r="0" b="0"/>
-          </a:stretch>
+          <a:blip xmlns:r="http://schemas.openxmlformats.org/officeDocument/2006/relationships" xmlns:a="http://schemas.openxmlformats.org/drawingml/2006/main" r:embed="Rf2b644a604a940c5"/>
+          <a:stretch xmlns:a="http://schemas.openxmlformats.org/drawingml/2006/main"/>
         </p:blipFill>
         <p:spPr>
           <a:xfrm xmlns:a="http://schemas.openxmlformats.org/drawingml/2006/main">
-            <a:off x="400050" y="1381125"/>
-            <a:ext cx="7620000" cy="4476750"/>
+            <a:off x="400050" y="1992894"/>
+            <a:ext cx="7620000" cy="3396086"/>
           </a:xfrm>
           <a:prstGeom xmlns:a="http://schemas.openxmlformats.org/drawingml/2006/main" prst="rect">
             <a:avLst/>
@@ -5464,57 +5797,65 @@
           </a:prstGeom>
         </p:spPr>
         <p:txBody>
-          <a:bodyPr xmlns:a="http://schemas.openxmlformats.org/drawingml/2006/main" wrap="square" lIns="0" tIns="0" rIns="0" bIns="0" anchor="b">
-            <a:noAutofit/>
-          </a:bodyPr>
-          <a:lstStyle xmlns:a="http://schemas.openxmlformats.org/drawingml/2006/main"/>
-          <a:p xmlns:a="http://schemas.openxmlformats.org/drawingml/2006/main">
-            <a:pPr algn="r">
-              <a:buNone/>
-              <a:defRPr sz="1000">
-                <a:solidFill>
-                  <a:srgbClr val="000000"/>
-                </a:solidFill>
-                <a:latin typeface="Helvetica Neue"/>
-                <a:ea typeface="Helvetica Neue"/>
-                <a:cs typeface="Helvetica Neue"/>
-              </a:defRPr>
-            </a:pPr>
-            <a:r>
-              <a:t>5</a:t>
-            </a:r>
-          </a:p>
-        </p:txBody>
-      </p:sp>
-      <p:sp>
-        <p:nvSpPr>
-          <p:cNvPr id="2" name="Google-Shape-533-p58-3">
-            <a:extLst xmlns:a="http://schemas.openxmlformats.org/drawingml/2006/main">
-              <a:ext uri="{FF2B5EF4-FFF2-40B4-BE49-F238E27FC236}">
-                <a16:creationId xmlns:a16="http://schemas.microsoft.com/office/drawing/2014/main" id="{60D39F14-0FCC-4D48-84A9-503858E93BCD}"/>
-              </a:ext>
-            </a:extLst>
-          </p:cNvPr>
-          <p:cNvSpPr>
-            <a:spLocks xmlns:a="http://schemas.openxmlformats.org/drawingml/2006/main" noGrp="1"/>
-          </p:cNvSpPr>
-          <p:nvPr/>
-        </p:nvSpPr>
-        <p:spPr>
-          <a:xfrm xmlns:a="http://schemas.openxmlformats.org/drawingml/2006/main">
-            <a:off x="393668" y="323850"/>
-            <a:ext cx="11404568" cy="762000"/>
-          </a:xfrm>
-          <a:prstGeom xmlns:a="http://schemas.openxmlformats.org/drawingml/2006/main" prst="rect">
-            <a:avLst/>
-          </a:prstGeom>
-        </p:spPr>
-        <p:txBody>
           <a:bodyPr xmlns:a="http://schemas.openxmlformats.org/drawingml/2006/main" wrap="square" lIns="0" tIns="0" rIns="0" bIns="0" anchor="t">
             <a:normAutofit fontScale="100000"/>
           </a:bodyPr>
           <a:lstStyle xmlns:a="http://schemas.openxmlformats.org/drawingml/2006/main"/>
           <a:p xmlns:a="http://schemas.openxmlformats.org/drawingml/2006/main">
+            <a:pPr algn="ctr">
+              <a:buNone/>
+              <a:defRPr sz="975">
+                <a:solidFill>
+                  <a:srgbClr val="000000"/>
+                </a:solidFill>
+                <a:latin typeface="Helvetica Neue"/>
+                <a:ea typeface="Helvetica Neue"/>
+                <a:cs typeface="Helvetica Neue"/>
+              </a:defRPr>
+            </a:pPr>
+            <a:r>
+              <a:rPr sz="975">
+                <a:solidFill>
+                  <a:srgbClr val="000000"/>
+                </a:solidFill>
+                <a:latin typeface="Helvetica Neue"/>
+                <a:ea typeface="Helvetica Neue"/>
+                <a:cs typeface="Helvetica Neue"/>
+              </a:rPr>
+              <a:t>5</a:t>
+            </a:r>
+          </a:p>
+        </p:txBody>
+      </p:sp>
+      <p:sp>
+        <p:nvSpPr>
+          <p:cNvPr id="2" name="Google-Shape-533-p58-3">
+            <a:extLst xmlns:a="http://schemas.openxmlformats.org/drawingml/2006/main">
+              <a:ext uri="{FF2B5EF4-FFF2-40B4-BE49-F238E27FC236}">
+                <a16:creationId xmlns:a16="http://schemas.microsoft.com/office/drawing/2014/main" id="{60D39F14-0FCC-4D48-84A9-503858E93BCD}"/>
+              </a:ext>
+            </a:extLst>
+          </p:cNvPr>
+          <p:cNvSpPr>
+            <a:spLocks xmlns:a="http://schemas.openxmlformats.org/drawingml/2006/main" noGrp="1"/>
+          </p:cNvSpPr>
+          <p:nvPr/>
+        </p:nvSpPr>
+        <p:spPr>
+          <a:xfrm xmlns:a="http://schemas.openxmlformats.org/drawingml/2006/main">
+            <a:off x="393668" y="323850"/>
+            <a:ext cx="11404568" cy="762000"/>
+          </a:xfrm>
+          <a:prstGeom xmlns:a="http://schemas.openxmlformats.org/drawingml/2006/main" prst="rect">
+            <a:avLst/>
+          </a:prstGeom>
+        </p:spPr>
+        <p:txBody>
+          <a:bodyPr xmlns:a="http://schemas.openxmlformats.org/drawingml/2006/main" wrap="square" lIns="0" tIns="0" rIns="0" bIns="0" anchor="t">
+            <a:normAutofit fontScale="100000"/>
+          </a:bodyPr>
+          <a:lstStyle xmlns:a="http://schemas.openxmlformats.org/drawingml/2006/main"/>
+          <a:p xmlns:a="http://schemas.openxmlformats.org/drawingml/2006/main">
             <a:pPr algn="l">
               <a:buNone/>
               <a:defRPr sz="2850" b="0">
@@ -5535,7 +5876,7 @@
                 <a:ea typeface="Helvetica Neue"/>
                 <a:cs typeface="Helvetica Neue"/>
               </a:rPr>
-              <a:t>Calibrate the site, locate the bottleneck, then pilot relief</a:t>
+              <a:t>Calibrate the site, locate the regime, then pilot the right lever</a:t>
             </a:r>
           </a:p>
         </p:txBody>
@@ -5564,7 +5905,7 @@
           </a:prstGeom>
         </p:spPr>
         <p:txBody>
-          <a:bodyPr xmlns:a="http://schemas.openxmlformats.org/drawingml/2006/main" lIns="0" tIns="0" rIns="0" bIns="0" anchor="ctr">
+          <a:bodyPr xmlns:a="http://schemas.openxmlformats.org/drawingml/2006/main" wrap="square" lIns="0" tIns="0" rIns="0" bIns="0" anchor="ctr">
             <a:normAutofit fontScale="100000"/>
           </a:bodyPr>
           <a:lstStyle xmlns:a="http://schemas.openxmlformats.org/drawingml/2006/main"/>
@@ -5574,19 +5915,19 @@
                 <a:spcPct val="100000"/>
               </a:lnSpc>
               <a:buNone/>
-              <a:defRPr sz="1200" b="0">
-                <a:solidFill>
-                  <a:srgbClr val="111318"/>
-                </a:solidFill>
-                <a:latin typeface="Helvetica Neue"/>
-                <a:ea typeface="Helvetica Neue"/>
-                <a:cs typeface="Helvetica Neue"/>
-              </a:defRPr>
-            </a:pPr>
-            <a:r>
-              <a:rPr sz="1200" b="0">
-                <a:solidFill>
-                  <a:srgbClr val="111318"/>
+              <a:defRPr sz="1125" b="0">
+                <a:solidFill>
+                  <a:srgbClr val="000000"/>
+                </a:solidFill>
+                <a:latin typeface="Helvetica Neue"/>
+                <a:ea typeface="Helvetica Neue"/>
+                <a:cs typeface="Helvetica Neue"/>
+              </a:defRPr>
+            </a:pPr>
+            <a:r>
+              <a:rPr sz="1125" b="0">
+                <a:solidFill>
+                  <a:srgbClr val="000000"/>
                 </a:solidFill>
                 <a:latin typeface="Helvetica Neue"/>
                 <a:ea typeface="Helvetica Neue"/>
@@ -5745,26 +6086,28 @@
           </a:prstGeom>
         </p:spPr>
         <p:txBody>
-          <a:bodyPr xmlns:a="http://schemas.openxmlformats.org/drawingml/2006/main" wrap="square" lIns="0" tIns="0" rIns="0" bIns="0" anchor="t">
+          <a:bodyPr xmlns:a="http://schemas.openxmlformats.org/drawingml/2006/main" wrap="square" lIns="19050" tIns="19050" rIns="38100" bIns="19050" anchor="t">
             <a:normAutofit fontScale="100000"/>
           </a:bodyPr>
           <a:lstStyle xmlns:a="http://schemas.openxmlformats.org/drawingml/2006/main"/>
           <a:p xmlns:a="http://schemas.openxmlformats.org/drawingml/2006/main">
-            <a:pPr>
-              <a:buNone/>
-              <a:defRPr sz="1350">
-                <a:solidFill>
-                  <a:srgbClr val="111318"/>
-                </a:solidFill>
-                <a:latin typeface="Helvetica Neue"/>
-                <a:ea typeface="Helvetica Neue"/>
-                <a:cs typeface="Helvetica Neue"/>
-              </a:defRPr>
-            </a:pPr>
-            <a:r>
-              <a:rPr sz="1350" b="1">
-                <a:solidFill>
-                  <a:srgbClr val="111318"/>
+            <a:pPr algn="l">
+              <a:spcAft>
+                <a:spcPts val="4"/>
+              </a:spcAft>
+              <a:defRPr sz="1200">
+                <a:solidFill>
+                  <a:srgbClr val="000000"/>
+                </a:solidFill>
+                <a:latin typeface="Helvetica Neue"/>
+                <a:ea typeface="Helvetica Neue"/>
+                <a:cs typeface="Helvetica Neue"/>
+              </a:defRPr>
+            </a:pPr>
+            <a:r>
+              <a:rPr sz="1200" b="1">
+                <a:solidFill>
+                  <a:srgbClr val="000000"/>
                 </a:solidFill>
                 <a:latin typeface="Helvetica Neue"/>
                 <a:ea typeface="Helvetica Neue"/>
@@ -5774,24 +6117,23 @@
             </a:r>
           </a:p>
           <a:p xmlns:a="http://schemas.openxmlformats.org/drawingml/2006/main">
-            <a:pPr>
+            <a:pPr algn="l">
               <a:spcAft>
-                <a:spcPts val="12"/>
+                <a:spcPts val="10"/>
               </a:spcAft>
-              <a:buNone/>
-              <a:defRPr sz="1350">
-                <a:solidFill>
-                  <a:srgbClr val="111318"/>
-                </a:solidFill>
-                <a:latin typeface="Helvetica Neue"/>
-                <a:ea typeface="Helvetica Neue"/>
-                <a:cs typeface="Helvetica Neue"/>
-              </a:defRPr>
-            </a:pPr>
-            <a:r>
-              <a:rPr sz="1350" b="1">
-                <a:solidFill>
-                  <a:srgbClr val="111318"/>
+              <a:defRPr sz="1200">
+                <a:solidFill>
+                  <a:srgbClr val="000000"/>
+                </a:solidFill>
+                <a:latin typeface="Helvetica Neue"/>
+                <a:ea typeface="Helvetica Neue"/>
+                <a:cs typeface="Helvetica Neue"/>
+              </a:defRPr>
+            </a:pPr>
+            <a:r>
+              <a:rPr sz="1200">
+                <a:solidFill>
+                  <a:srgbClr val="000000"/>
                 </a:solidFill>
                 <a:latin typeface="Helvetica Neue"/>
                 <a:ea typeface="Helvetica Neue"/>
@@ -5801,21 +6143,23 @@
             </a:r>
           </a:p>
           <a:p xmlns:a="http://schemas.openxmlformats.org/drawingml/2006/main">
-            <a:pPr>
-              <a:buNone/>
-              <a:defRPr sz="1350">
-                <a:solidFill>
-                  <a:srgbClr val="111318"/>
-                </a:solidFill>
-                <a:latin typeface="Helvetica Neue"/>
-                <a:ea typeface="Helvetica Neue"/>
-                <a:cs typeface="Helvetica Neue"/>
-              </a:defRPr>
-            </a:pPr>
-            <a:r>
-              <a:rPr sz="1350" b="1">
-                <a:solidFill>
-                  <a:srgbClr val="111318"/>
+            <a:pPr algn="l">
+              <a:spcAft>
+                <a:spcPts val="4"/>
+              </a:spcAft>
+              <a:defRPr sz="1200">
+                <a:solidFill>
+                  <a:srgbClr val="000000"/>
+                </a:solidFill>
+                <a:latin typeface="Helvetica Neue"/>
+                <a:ea typeface="Helvetica Neue"/>
+                <a:cs typeface="Helvetica Neue"/>
+              </a:defRPr>
+            </a:pPr>
+            <a:r>
+              <a:rPr sz="1200" b="1">
+                <a:solidFill>
+                  <a:srgbClr val="000000"/>
                 </a:solidFill>
                 <a:latin typeface="Helvetica Neue"/>
                 <a:ea typeface="Helvetica Neue"/>
@@ -5825,48 +6169,49 @@
             </a:r>
           </a:p>
           <a:p xmlns:a="http://schemas.openxmlformats.org/drawingml/2006/main">
-            <a:pPr>
+            <a:pPr algn="l">
               <a:spcAft>
-                <a:spcPts val="12"/>
+                <a:spcPts val="10"/>
               </a:spcAft>
-              <a:buNone/>
-              <a:defRPr sz="1350">
-                <a:solidFill>
-                  <a:srgbClr val="111318"/>
-                </a:solidFill>
-                <a:latin typeface="Helvetica Neue"/>
-                <a:ea typeface="Helvetica Neue"/>
-                <a:cs typeface="Helvetica Neue"/>
-              </a:defRPr>
-            </a:pPr>
-            <a:r>
-              <a:rPr sz="1350">
-                <a:solidFill>
-                  <a:srgbClr val="111318"/>
-                </a:solidFill>
-                <a:latin typeface="Helvetica Neue"/>
-                <a:ea typeface="Helvetica Neue"/>
-                <a:cs typeface="Helvetica Neue"/>
-              </a:rPr>
-              <a:t>Capacity loss is nonlinear; the active bottleneck changes which intervention works.</a:t>
-            </a:r>
-          </a:p>
-          <a:p xmlns:a="http://schemas.openxmlformats.org/drawingml/2006/main">
-            <a:pPr>
-              <a:buNone/>
-              <a:defRPr sz="1350">
-                <a:solidFill>
-                  <a:srgbClr val="111318"/>
-                </a:solidFill>
-                <a:latin typeface="Helvetica Neue"/>
-                <a:ea typeface="Helvetica Neue"/>
-                <a:cs typeface="Helvetica Neue"/>
-              </a:defRPr>
-            </a:pPr>
-            <a:r>
-              <a:rPr sz="1350" b="1">
-                <a:solidFill>
-                  <a:srgbClr val="111318"/>
+              <a:defRPr sz="1200">
+                <a:solidFill>
+                  <a:srgbClr val="000000"/>
+                </a:solidFill>
+                <a:latin typeface="Helvetica Neue"/>
+                <a:ea typeface="Helvetica Neue"/>
+                <a:cs typeface="Helvetica Neue"/>
+              </a:defRPr>
+            </a:pPr>
+            <a:r>
+              <a:rPr sz="1200">
+                <a:solidFill>
+                  <a:srgbClr val="000000"/>
+                </a:solidFill>
+                <a:latin typeface="Helvetica Neue"/>
+                <a:ea typeface="Helvetica Neue"/>
+                <a:cs typeface="Helvetica Neue"/>
+              </a:rPr>
+              <a:t>The model exposes three levers: capacity margin, service variability and queue pooling.</a:t>
+            </a:r>
+          </a:p>
+          <a:p xmlns:a="http://schemas.openxmlformats.org/drawingml/2006/main">
+            <a:pPr algn="l">
+              <a:spcAft>
+                <a:spcPts val="4"/>
+              </a:spcAft>
+              <a:defRPr sz="1200">
+                <a:solidFill>
+                  <a:srgbClr val="000000"/>
+                </a:solidFill>
+                <a:latin typeface="Helvetica Neue"/>
+                <a:ea typeface="Helvetica Neue"/>
+                <a:cs typeface="Helvetica Neue"/>
+              </a:defRPr>
+            </a:pPr>
+            <a:r>
+              <a:rPr sz="1200" b="1">
+                <a:solidFill>
+                  <a:srgbClr val="000000"/>
                 </a:solidFill>
                 <a:latin typeface="Helvetica Neue"/>
                 <a:ea typeface="Helvetica Neue"/>
@@ -5876,27 +6221,26 @@
             </a:r>
           </a:p>
           <a:p xmlns:a="http://schemas.openxmlformats.org/drawingml/2006/main">
-            <a:pPr>
-              <a:buNone/>
-              <a:defRPr sz="1350">
-                <a:solidFill>
-                  <a:srgbClr val="111318"/>
-                </a:solidFill>
-                <a:latin typeface="Helvetica Neue"/>
-                <a:ea typeface="Helvetica Neue"/>
-                <a:cs typeface="Helvetica Neue"/>
-              </a:defRPr>
-            </a:pPr>
-            <a:r>
-              <a:rPr sz="1350">
-                <a:solidFill>
-                  <a:srgbClr val="111318"/>
-                </a:solidFill>
-                <a:latin typeface="Helvetica Neue"/>
-                <a:ea typeface="Helvetica Neue"/>
-                <a:cs typeface="Helvetica Neue"/>
-              </a:rPr>
-              <a:t>36/21 is a derived pooled reference—not observed staffing. Corridor-to-processing-unit allocation is unobserved.</a:t>
+            <a:pPr algn="l">
+              <a:defRPr sz="1200">
+                <a:solidFill>
+                  <a:srgbClr val="000000"/>
+                </a:solidFill>
+                <a:latin typeface="Helvetica Neue"/>
+                <a:ea typeface="Helvetica Neue"/>
+                <a:cs typeface="Helvetica Neue"/>
+              </a:defRPr>
+            </a:pPr>
+            <a:r>
+              <a:rPr sz="1200">
+                <a:solidFill>
+                  <a:srgbClr val="000000"/>
+                </a:solidFill>
+                <a:latin typeface="Helvetica Neue"/>
+                <a:ea typeface="Helvetica Neue"/>
+                <a:cs typeface="Helvetica Neue"/>
+              </a:rPr>
+              <a:t>36/21 is a derived pooled reference—not observed staffing; routing, open-resource schedules and service distributions remain unobserved.</a:t>
             </a:r>
           </a:p>
         </p:txBody>
@@ -5925,7 +6269,7 @@
           </a:prstGeom>
         </p:spPr>
         <p:txBody>
-          <a:bodyPr xmlns:a="http://schemas.openxmlformats.org/drawingml/2006/main" lIns="0" tIns="0" rIns="0" bIns="0" anchor="ctr">
+          <a:bodyPr xmlns:a="http://schemas.openxmlformats.org/drawingml/2006/main" wrap="square" lIns="0" tIns="0" rIns="0" bIns="0" anchor="ctr">
             <a:normAutofit fontScale="100000"/>
           </a:bodyPr>
           <a:lstStyle xmlns:a="http://schemas.openxmlformats.org/drawingml/2006/main"/>
@@ -5935,19 +6279,19 @@
                 <a:spcPct val="100000"/>
               </a:lnSpc>
               <a:buNone/>
-              <a:defRPr sz="1200" b="0">
-                <a:solidFill>
-                  <a:srgbClr val="111318"/>
-                </a:solidFill>
-                <a:latin typeface="Helvetica Neue"/>
-                <a:ea typeface="Helvetica Neue"/>
-                <a:cs typeface="Helvetica Neue"/>
-              </a:defRPr>
-            </a:pPr>
-            <a:r>
-              <a:rPr sz="1200" b="0">
-                <a:solidFill>
-                  <a:srgbClr val="111318"/>
+              <a:defRPr sz="1125" b="0">
+                <a:solidFill>
+                  <a:srgbClr val="000000"/>
+                </a:solidFill>
+                <a:latin typeface="Helvetica Neue"/>
+                <a:ea typeface="Helvetica Neue"/>
+                <a:cs typeface="Helvetica Neue"/>
+              </a:defRPr>
+            </a:pPr>
+            <a:r>
+              <a:rPr sz="1125" b="0">
+                <a:solidFill>
+                  <a:srgbClr val="000000"/>
                 </a:solidFill>
                 <a:latin typeface="Helvetica Neue"/>
                 <a:ea typeface="Helvetica Neue"/>
@@ -6106,7 +6450,7 @@
           </a:prstGeom>
         </p:spPr>
         <p:txBody>
-          <a:bodyPr xmlns:a="http://schemas.openxmlformats.org/drawingml/2006/main" lIns="0" tIns="0" rIns="0" bIns="0" anchor="ctr">
+          <a:bodyPr xmlns:a="http://schemas.openxmlformats.org/drawingml/2006/main" wrap="square" lIns="0" tIns="0" rIns="0" bIns="0" anchor="ctr">
             <a:normAutofit fontScale="100000"/>
           </a:bodyPr>
           <a:lstStyle xmlns:a="http://schemas.openxmlformats.org/drawingml/2006/main"/>
@@ -6116,25 +6460,25 @@
                 <a:spcPct val="100000"/>
               </a:lnSpc>
               <a:buNone/>
-              <a:defRPr sz="1200" b="0">
-                <a:solidFill>
-                  <a:srgbClr val="111318"/>
-                </a:solidFill>
-                <a:latin typeface="Helvetica Neue"/>
-                <a:ea typeface="Helvetica Neue"/>
-                <a:cs typeface="Helvetica Neue"/>
-              </a:defRPr>
-            </a:pPr>
-            <a:r>
-              <a:rPr sz="1200" b="0">
-                <a:solidFill>
-                  <a:srgbClr val="111318"/>
-                </a:solidFill>
-                <a:latin typeface="Helvetica Neue"/>
-                <a:ea typeface="Helvetica Neue"/>
-                <a:cs typeface="Helvetica Neue"/>
-              </a:rPr>
-              <a:t>Stage service, exceptions + open-resource schedules</a:t>
+              <a:defRPr sz="1125" b="0">
+                <a:solidFill>
+                  <a:srgbClr val="000000"/>
+                </a:solidFill>
+                <a:latin typeface="Helvetica Neue"/>
+                <a:ea typeface="Helvetica Neue"/>
+                <a:cs typeface="Helvetica Neue"/>
+              </a:defRPr>
+            </a:pPr>
+            <a:r>
+              <a:rPr sz="1125" b="0">
+                <a:solidFill>
+                  <a:srgbClr val="000000"/>
+                </a:solidFill>
+                <a:latin typeface="Helvetica Neue"/>
+                <a:ea typeface="Helvetica Neue"/>
+                <a:cs typeface="Helvetica Neue"/>
+              </a:rPr>
+              <a:t>Stage service distributions + exceptions</a:t>
             </a:r>
           </a:p>
         </p:txBody>
@@ -6287,7 +6631,7 @@
           </a:prstGeom>
         </p:spPr>
         <p:txBody>
-          <a:bodyPr xmlns:a="http://schemas.openxmlformats.org/drawingml/2006/main" lIns="0" tIns="0" rIns="0" bIns="0" anchor="ctr">
+          <a:bodyPr xmlns:a="http://schemas.openxmlformats.org/drawingml/2006/main" wrap="square" lIns="0" tIns="0" rIns="0" bIns="0" anchor="ctr">
             <a:normAutofit fontScale="100000"/>
           </a:bodyPr>
           <a:lstStyle xmlns:a="http://schemas.openxmlformats.org/drawingml/2006/main"/>
@@ -6297,25 +6641,25 @@
                 <a:spcPct val="100000"/>
               </a:lnSpc>
               <a:buNone/>
-              <a:defRPr sz="1200" b="0">
-                <a:solidFill>
-                  <a:srgbClr val="111318"/>
-                </a:solidFill>
-                <a:latin typeface="Helvetica Neue"/>
-                <a:ea typeface="Helvetica Neue"/>
-                <a:cs typeface="Helvetica Neue"/>
-              </a:defRPr>
-            </a:pPr>
-            <a:r>
-              <a:rPr sz="1200" b="0">
-                <a:solidFill>
-                  <a:srgbClr val="111318"/>
-                </a:solidFill>
-                <a:latin typeface="Helvetica Neue"/>
-                <a:ea typeface="Helvetica Neue"/>
-                <a:cs typeface="Helvetica Neue"/>
-              </a:rPr>
-              <a:t>Observed queues + costed pilot constraints</a:t>
+              <a:defRPr sz="1125" b="0">
+                <a:solidFill>
+                  <a:srgbClr val="000000"/>
+                </a:solidFill>
+                <a:latin typeface="Helvetica Neue"/>
+                <a:ea typeface="Helvetica Neue"/>
+                <a:cs typeface="Helvetica Neue"/>
+              </a:defRPr>
+            </a:pPr>
+            <a:r>
+              <a:rPr sz="1125" b="0">
+                <a:solidFill>
+                  <a:srgbClr val="000000"/>
+                </a:solidFill>
+                <a:latin typeface="Helvetica Neue"/>
+                <a:ea typeface="Helvetica Neue"/>
+                <a:cs typeface="Helvetica Neue"/>
+              </a:rPr>
+              <a:t>Observed queue policy + physical capacity</a:t>
             </a:r>
           </a:p>
         </p:txBody>
@@ -6468,7 +6812,7 @@
           </a:prstGeom>
         </p:spPr>
         <p:txBody>
-          <a:bodyPr xmlns:a="http://schemas.openxmlformats.org/drawingml/2006/main" lIns="0" tIns="0" rIns="0" bIns="0" anchor="ctr">
+          <a:bodyPr xmlns:a="http://schemas.openxmlformats.org/drawingml/2006/main" wrap="square" lIns="0" tIns="0" rIns="0" bIns="0" anchor="ctr">
             <a:normAutofit fontScale="100000"/>
           </a:bodyPr>
           <a:lstStyle xmlns:a="http://schemas.openxmlformats.org/drawingml/2006/main"/>
@@ -6478,19 +6822,19 @@
                 <a:spcPct val="100000"/>
               </a:lnSpc>
               <a:buNone/>
-              <a:defRPr sz="1200" b="0">
-                <a:solidFill>
-                  <a:srgbClr val="111318"/>
-                </a:solidFill>
-                <a:latin typeface="Helvetica Neue"/>
-                <a:ea typeface="Helvetica Neue"/>
-                <a:cs typeface="Helvetica Neue"/>
-              </a:defRPr>
-            </a:pPr>
-            <a:r>
-              <a:rPr sz="1200" b="0">
-                <a:solidFill>
-                  <a:srgbClr val="111318"/>
+              <a:defRPr sz="1125" b="0">
+                <a:solidFill>
+                  <a:srgbClr val="000000"/>
+                </a:solidFill>
+                <a:latin typeface="Helvetica Neue"/>
+                <a:ea typeface="Helvetica Neue"/>
+                <a:cs typeface="Helvetica Neue"/>
+              </a:defRPr>
+            </a:pPr>
+            <a:r>
+              <a:rPr sz="1125" b="0">
+                <a:solidFill>
+                  <a:srgbClr val="000000"/>
                 </a:solidFill>
                 <a:latin typeface="Helvetica Neue"/>
                 <a:ea typeface="Helvetica Neue"/>
@@ -6658,29 +7002,29 @@
           </a:ln>
         </p:spPr>
         <p:txBody>
-          <a:bodyPr xmlns:a="http://schemas.openxmlformats.org/drawingml/2006/main" lIns="171450" tIns="95250" rIns="266700" bIns="95250" anchor="ctr">
+          <a:bodyPr xmlns:a="http://schemas.openxmlformats.org/drawingml/2006/main" wrap="square" lIns="171450" tIns="95250" rIns="266700" bIns="95250" anchor="ctr">
             <a:normAutofit fontScale="100000"/>
           </a:bodyPr>
           <a:lstStyle xmlns:a="http://schemas.openxmlformats.org/drawingml/2006/main"/>
           <a:p xmlns:a="http://schemas.openxmlformats.org/drawingml/2006/main">
-            <a:pPr algn="ctr">
+            <a:pPr algn="l">
               <a:lnSpc>
                 <a:spcPct val="100000"/>
               </a:lnSpc>
               <a:buNone/>
-              <a:defRPr sz="1200" b="0">
-                <a:solidFill>
-                  <a:srgbClr val="111318"/>
-                </a:solidFill>
-                <a:latin typeface="Helvetica Neue"/>
-                <a:ea typeface="Helvetica Neue"/>
-                <a:cs typeface="Helvetica Neue"/>
-              </a:defRPr>
-            </a:pPr>
-            <a:r>
-              <a:rPr sz="1200" b="0">
-                <a:solidFill>
-                  <a:srgbClr val="111318"/>
+              <a:defRPr sz="1275" b="0">
+                <a:solidFill>
+                  <a:srgbClr val="2854E8"/>
+                </a:solidFill>
+                <a:latin typeface="Helvetica Neue"/>
+                <a:ea typeface="Helvetica Neue"/>
+                <a:cs typeface="Helvetica Neue"/>
+              </a:defRPr>
+            </a:pPr>
+            <a:r>
+              <a:rPr sz="1275" b="0">
+                <a:solidFill>
+                  <a:srgbClr val="2854E8"/>
                 </a:solidFill>
                 <a:latin typeface="Helvetica Neue"/>
                 <a:ea typeface="Helvetica Neue"/>
@@ -6690,57 +7034,57 @@
             </a:r>
           </a:p>
           <a:p xmlns:a="http://schemas.openxmlformats.org/drawingml/2006/main">
-            <a:pPr algn="ctr">
+            <a:pPr algn="l">
               <a:lnSpc>
                 <a:spcPct val="100000"/>
               </a:lnSpc>
               <a:buNone/>
-              <a:defRPr sz="1200" b="0">
-                <a:solidFill>
-                  <a:srgbClr val="111318"/>
-                </a:solidFill>
-                <a:latin typeface="Helvetica Neue"/>
-                <a:ea typeface="Helvetica Neue"/>
-                <a:cs typeface="Helvetica Neue"/>
-              </a:defRPr>
-            </a:pPr>
-            <a:r>
-              <a:rPr sz="1200" b="0">
-                <a:solidFill>
-                  <a:srgbClr val="111318"/>
-                </a:solidFill>
-                <a:latin typeface="Helvetica Neue"/>
-                <a:ea typeface="Helvetica Neue"/>
-                <a:cs typeface="Helvetica Neue"/>
-              </a:rPr>
-              <a:t>Measure time-of-day</a:t>
-            </a:r>
-          </a:p>
-          <a:p xmlns:a="http://schemas.openxmlformats.org/drawingml/2006/main">
-            <a:pPr algn="ctr">
+              <a:defRPr sz="1275" b="0">
+                <a:solidFill>
+                  <a:srgbClr val="2854E8"/>
+                </a:solidFill>
+                <a:latin typeface="Helvetica Neue"/>
+                <a:ea typeface="Helvetica Neue"/>
+                <a:cs typeface="Helvetica Neue"/>
+              </a:defRPr>
+            </a:pPr>
+            <a:r>
+              <a:rPr sz="1275" b="0">
+                <a:solidFill>
+                  <a:srgbClr val="2854E8"/>
+                </a:solidFill>
+                <a:latin typeface="Helvetica Neue"/>
+                <a:ea typeface="Helvetica Neue"/>
+                <a:cs typeface="Helvetica Neue"/>
+              </a:rPr>
+              <a:t>Time-of-day arrivals</a:t>
+            </a:r>
+          </a:p>
+          <a:p xmlns:a="http://schemas.openxmlformats.org/drawingml/2006/main">
+            <a:pPr algn="l">
               <a:lnSpc>
                 <a:spcPct val="100000"/>
               </a:lnSpc>
               <a:buNone/>
-              <a:defRPr sz="1200" b="0">
-                <a:solidFill>
-                  <a:srgbClr val="111318"/>
-                </a:solidFill>
-                <a:latin typeface="Helvetica Neue"/>
-                <a:ea typeface="Helvetica Neue"/>
-                <a:cs typeface="Helvetica Neue"/>
-              </a:defRPr>
-            </a:pPr>
-            <a:r>
-              <a:rPr sz="1200" b="0">
-                <a:solidFill>
-                  <a:srgbClr val="111318"/>
-                </a:solidFill>
-                <a:latin typeface="Helvetica Neue"/>
-                <a:ea typeface="Helvetica Neue"/>
-                <a:cs typeface="Helvetica Neue"/>
-              </a:rPr>
-              <a:t>arrivals + stage service</a:t>
+              <a:defRPr sz="1275" b="0">
+                <a:solidFill>
+                  <a:srgbClr val="2854E8"/>
+                </a:solidFill>
+                <a:latin typeface="Helvetica Neue"/>
+                <a:ea typeface="Helvetica Neue"/>
+                <a:cs typeface="Helvetica Neue"/>
+              </a:defRPr>
+            </a:pPr>
+            <a:r>
+              <a:rPr sz="1275" b="0">
+                <a:solidFill>
+                  <a:srgbClr val="2854E8"/>
+                </a:solidFill>
+                <a:latin typeface="Helvetica Neue"/>
+                <a:ea typeface="Helvetica Neue"/>
+                <a:cs typeface="Helvetica Neue"/>
+              </a:rPr>
+              <a:t>+ stage service</a:t>
             </a:r>
           </a:p>
         </p:txBody>
@@ -6778,29 +7122,29 @@
           </a:ln>
         </p:spPr>
         <p:txBody>
-          <a:bodyPr xmlns:a="http://schemas.openxmlformats.org/drawingml/2006/main" lIns="171450" tIns="95250" rIns="266700" bIns="95250" anchor="ctr">
+          <a:bodyPr xmlns:a="http://schemas.openxmlformats.org/drawingml/2006/main" wrap="square" lIns="171450" tIns="95250" rIns="266700" bIns="95250" anchor="ctr">
             <a:normAutofit fontScale="100000"/>
           </a:bodyPr>
           <a:lstStyle xmlns:a="http://schemas.openxmlformats.org/drawingml/2006/main"/>
           <a:p xmlns:a="http://schemas.openxmlformats.org/drawingml/2006/main">
-            <a:pPr algn="ctr">
+            <a:pPr algn="l">
               <a:lnSpc>
                 <a:spcPct val="100000"/>
               </a:lnSpc>
               <a:buNone/>
-              <a:defRPr sz="1200" b="0">
-                <a:solidFill>
-                  <a:srgbClr val="111318"/>
-                </a:solidFill>
-                <a:latin typeface="Helvetica Neue"/>
-                <a:ea typeface="Helvetica Neue"/>
-                <a:cs typeface="Helvetica Neue"/>
-              </a:defRPr>
-            </a:pPr>
-            <a:r>
-              <a:rPr sz="1200" b="0">
-                <a:solidFill>
-                  <a:srgbClr val="111318"/>
+              <a:defRPr sz="1275" b="0">
+                <a:solidFill>
+                  <a:srgbClr val="0A9F43"/>
+                </a:solidFill>
+                <a:latin typeface="Helvetica Neue"/>
+                <a:ea typeface="Helvetica Neue"/>
+                <a:cs typeface="Helvetica Neue"/>
+              </a:defRPr>
+            </a:pPr>
+            <a:r>
+              <a:rPr sz="1275" b="0">
+                <a:solidFill>
+                  <a:srgbClr val="0A9F43"/>
                 </a:solidFill>
                 <a:latin typeface="Helvetica Neue"/>
                 <a:ea typeface="Helvetica Neue"/>
@@ -6810,57 +7154,57 @@
             </a:r>
           </a:p>
           <a:p xmlns:a="http://schemas.openxmlformats.org/drawingml/2006/main">
-            <a:pPr algn="ctr">
+            <a:pPr algn="l">
               <a:lnSpc>
                 <a:spcPct val="100000"/>
               </a:lnSpc>
               <a:buNone/>
-              <a:defRPr sz="1200" b="0">
-                <a:solidFill>
-                  <a:srgbClr val="111318"/>
-                </a:solidFill>
-                <a:latin typeface="Helvetica Neue"/>
-                <a:ea typeface="Helvetica Neue"/>
-                <a:cs typeface="Helvetica Neue"/>
-              </a:defRPr>
-            </a:pPr>
-            <a:r>
-              <a:rPr sz="1200" b="0">
-                <a:solidFill>
-                  <a:srgbClr val="111318"/>
-                </a:solidFill>
-                <a:latin typeface="Helvetica Neue"/>
-                <a:ea typeface="Helvetica Neue"/>
-                <a:cs typeface="Helvetica Neue"/>
-              </a:rPr>
-              <a:t>Place the site on the</a:t>
-            </a:r>
-          </a:p>
-          <a:p xmlns:a="http://schemas.openxmlformats.org/drawingml/2006/main">
-            <a:pPr algn="ctr">
+              <a:defRPr sz="1275" b="0">
+                <a:solidFill>
+                  <a:srgbClr val="0A9F43"/>
+                </a:solidFill>
+                <a:latin typeface="Helvetica Neue"/>
+                <a:ea typeface="Helvetica Neue"/>
+                <a:cs typeface="Helvetica Neue"/>
+              </a:defRPr>
+            </a:pPr>
+            <a:r>
+              <a:rPr sz="1275" b="0">
+                <a:solidFill>
+                  <a:srgbClr val="0A9F43"/>
+                </a:solidFill>
+                <a:latin typeface="Helvetica Neue"/>
+                <a:ea typeface="Helvetica Neue"/>
+                <a:cs typeface="Helvetica Neue"/>
+              </a:rPr>
+              <a:t>ρ + active bottleneck</a:t>
+            </a:r>
+          </a:p>
+          <a:p xmlns:a="http://schemas.openxmlformats.org/drawingml/2006/main">
+            <a:pPr algn="l">
               <a:lnSpc>
                 <a:spcPct val="100000"/>
               </a:lnSpc>
               <a:buNone/>
-              <a:defRPr sz="1200" b="0">
-                <a:solidFill>
-                  <a:srgbClr val="111318"/>
-                </a:solidFill>
-                <a:latin typeface="Helvetica Neue"/>
-                <a:ea typeface="Helvetica Neue"/>
-                <a:cs typeface="Helvetica Neue"/>
-              </a:defRPr>
-            </a:pPr>
-            <a:r>
-              <a:rPr sz="1200" b="0">
-                <a:solidFill>
-                  <a:srgbClr val="111318"/>
-                </a:solidFill>
-                <a:latin typeface="Helvetica Neue"/>
-                <a:ea typeface="Helvetica Neue"/>
-                <a:cs typeface="Helvetica Neue"/>
-              </a:rPr>
-              <a:t>capacity surface</a:t>
+              <a:defRPr sz="1275" b="0">
+                <a:solidFill>
+                  <a:srgbClr val="0A9F43"/>
+                </a:solidFill>
+                <a:latin typeface="Helvetica Neue"/>
+                <a:ea typeface="Helvetica Neue"/>
+                <a:cs typeface="Helvetica Neue"/>
+              </a:defRPr>
+            </a:pPr>
+            <a:r>
+              <a:rPr sz="1275" b="0">
+                <a:solidFill>
+                  <a:srgbClr val="0A9F43"/>
+                </a:solidFill>
+                <a:latin typeface="Helvetica Neue"/>
+                <a:ea typeface="Helvetica Neue"/>
+                <a:cs typeface="Helvetica Neue"/>
+              </a:rPr>
+              <a:t>+ duration regime</a:t>
             </a:r>
           </a:p>
         </p:txBody>
@@ -6898,29 +7242,29 @@
           </a:ln>
         </p:spPr>
         <p:txBody>
-          <a:bodyPr xmlns:a="http://schemas.openxmlformats.org/drawingml/2006/main" lIns="171450" tIns="95250" rIns="266700" bIns="95250" anchor="ctr">
+          <a:bodyPr xmlns:a="http://schemas.openxmlformats.org/drawingml/2006/main" wrap="square" lIns="171450" tIns="95250" rIns="266700" bIns="95250" anchor="ctr">
             <a:normAutofit fontScale="100000"/>
           </a:bodyPr>
           <a:lstStyle xmlns:a="http://schemas.openxmlformats.org/drawingml/2006/main"/>
           <a:p xmlns:a="http://schemas.openxmlformats.org/drawingml/2006/main">
-            <a:pPr algn="ctr">
+            <a:pPr algn="l">
               <a:lnSpc>
                 <a:spcPct val="100000"/>
               </a:lnSpc>
               <a:buNone/>
-              <a:defRPr sz="1200" b="0">
-                <a:solidFill>
-                  <a:srgbClr val="FFFFFF"/>
-                </a:solidFill>
-                <a:latin typeface="Helvetica Neue"/>
-                <a:ea typeface="Helvetica Neue"/>
-                <a:cs typeface="Helvetica Neue"/>
-              </a:defRPr>
-            </a:pPr>
-            <a:r>
-              <a:rPr sz="1200" b="0">
-                <a:solidFill>
-                  <a:srgbClr val="FFFFFF"/>
+              <a:defRPr sz="1275" b="0">
+                <a:solidFill>
+                  <a:srgbClr val="F05B08"/>
+                </a:solidFill>
+                <a:latin typeface="Helvetica Neue"/>
+                <a:ea typeface="Helvetica Neue"/>
+                <a:cs typeface="Helvetica Neue"/>
+              </a:defRPr>
+            </a:pPr>
+            <a:r>
+              <a:rPr sz="1275" b="0">
+                <a:solidFill>
+                  <a:srgbClr val="F05B08"/>
                 </a:solidFill>
                 <a:latin typeface="Helvetica Neue"/>
                 <a:ea typeface="Helvetica Neue"/>
@@ -6930,57 +7274,57 @@
             </a:r>
           </a:p>
           <a:p xmlns:a="http://schemas.openxmlformats.org/drawingml/2006/main">
-            <a:pPr algn="ctr">
+            <a:pPr algn="l">
               <a:lnSpc>
                 <a:spcPct val="100000"/>
               </a:lnSpc>
               <a:buNone/>
-              <a:defRPr sz="1200" b="0">
-                <a:solidFill>
-                  <a:srgbClr val="FFFFFF"/>
-                </a:solidFill>
-                <a:latin typeface="Helvetica Neue"/>
-                <a:ea typeface="Helvetica Neue"/>
-                <a:cs typeface="Helvetica Neue"/>
-              </a:defRPr>
-            </a:pPr>
-            <a:r>
-              <a:rPr sz="1200" b="0">
-                <a:solidFill>
-                  <a:srgbClr val="FFFFFF"/>
-                </a:solidFill>
-                <a:latin typeface="Helvetica Neue"/>
-                <a:ea typeface="Helvetica Neue"/>
-                <a:cs typeface="Helvetica Neue"/>
-              </a:rPr>
-              <a:t>Relieve Security,</a:t>
-            </a:r>
-          </a:p>
-          <a:p xmlns:a="http://schemas.openxmlformats.org/drawingml/2006/main">
-            <a:pPr algn="ctr">
+              <a:defRPr sz="1275" b="0">
+                <a:solidFill>
+                  <a:srgbClr val="F05B08"/>
+                </a:solidFill>
+                <a:latin typeface="Helvetica Neue"/>
+                <a:ea typeface="Helvetica Neue"/>
+                <a:cs typeface="Helvetica Neue"/>
+              </a:defRPr>
+            </a:pPr>
+            <a:r>
+              <a:rPr sz="1275" b="0">
+                <a:solidFill>
+                  <a:srgbClr val="F05B08"/>
+                </a:solidFill>
+                <a:latin typeface="Helvetica Neue"/>
+                <a:ea typeface="Helvetica Neue"/>
+                <a:cs typeface="Helvetica Neue"/>
+              </a:rPr>
+              <a:t>Capacity, pooling</a:t>
+            </a:r>
+          </a:p>
+          <a:p xmlns:a="http://schemas.openxmlformats.org/drawingml/2006/main">
+            <a:pPr algn="l">
               <a:lnSpc>
                 <a:spcPct val="100000"/>
               </a:lnSpc>
               <a:buNone/>
-              <a:defRPr sz="1200" b="0">
-                <a:solidFill>
-                  <a:srgbClr val="FFFFFF"/>
-                </a:solidFill>
-                <a:latin typeface="Helvetica Neue"/>
-                <a:ea typeface="Helvetica Neue"/>
-                <a:cs typeface="Helvetica Neue"/>
-              </a:defRPr>
-            </a:pPr>
-            <a:r>
-              <a:rPr sz="1200" b="0">
-                <a:solidFill>
-                  <a:srgbClr val="FFFFFF"/>
-                </a:solidFill>
-                <a:latin typeface="Helvetica Neue"/>
-                <a:ea typeface="Helvetica Neue"/>
-                <a:cs typeface="Helvetica Neue"/>
-              </a:rPr>
-              <a:t>Immigration or both</a:t>
+              <a:defRPr sz="1275" b="0">
+                <a:solidFill>
+                  <a:srgbClr val="F05B08"/>
+                </a:solidFill>
+                <a:latin typeface="Helvetica Neue"/>
+                <a:ea typeface="Helvetica Neue"/>
+                <a:cs typeface="Helvetica Neue"/>
+              </a:defRPr>
+            </a:pPr>
+            <a:r>
+              <a:rPr sz="1275" b="0">
+                <a:solidFill>
+                  <a:srgbClr val="F05B08"/>
+                </a:solidFill>
+                <a:latin typeface="Helvetica Neue"/>
+                <a:ea typeface="Helvetica Neue"/>
+                <a:cs typeface="Helvetica Neue"/>
+              </a:rPr>
+              <a:t>or variability relief</a:t>
             </a:r>
           </a:p>
         </p:txBody>
@@ -7018,29 +7362,29 @@
           </a:ln>
         </p:spPr>
         <p:txBody>
-          <a:bodyPr xmlns:a="http://schemas.openxmlformats.org/drawingml/2006/main" lIns="171450" tIns="95250" rIns="266700" bIns="95250" anchor="ctr">
+          <a:bodyPr xmlns:a="http://schemas.openxmlformats.org/drawingml/2006/main" wrap="square" lIns="171450" tIns="95250" rIns="266700" bIns="95250" anchor="ctr">
             <a:normAutofit fontScale="100000"/>
           </a:bodyPr>
           <a:lstStyle xmlns:a="http://schemas.openxmlformats.org/drawingml/2006/main"/>
           <a:p xmlns:a="http://schemas.openxmlformats.org/drawingml/2006/main">
-            <a:pPr algn="ctr">
+            <a:pPr algn="l">
               <a:lnSpc>
                 <a:spcPct val="100000"/>
               </a:lnSpc>
               <a:buNone/>
-              <a:defRPr sz="1200" b="0">
-                <a:solidFill>
-                  <a:srgbClr val="111318"/>
-                </a:solidFill>
-                <a:latin typeface="Helvetica Neue"/>
-                <a:ea typeface="Helvetica Neue"/>
-                <a:cs typeface="Helvetica Neue"/>
-              </a:defRPr>
-            </a:pPr>
-            <a:r>
-              <a:rPr sz="1200" b="0">
-                <a:solidFill>
-                  <a:srgbClr val="111318"/>
+              <a:defRPr sz="1275" b="0">
+                <a:solidFill>
+                  <a:srgbClr val="596579"/>
+                </a:solidFill>
+                <a:latin typeface="Helvetica Neue"/>
+                <a:ea typeface="Helvetica Neue"/>
+                <a:cs typeface="Helvetica Neue"/>
+              </a:defRPr>
+            </a:pPr>
+            <a:r>
+              <a:rPr sz="1275" b="0">
+                <a:solidFill>
+                  <a:srgbClr val="596579"/>
                 </a:solidFill>
                 <a:latin typeface="Helvetica Neue"/>
                 <a:ea typeface="Helvetica Neue"/>
@@ -7050,57 +7394,57 @@
             </a:r>
           </a:p>
           <a:p xmlns:a="http://schemas.openxmlformats.org/drawingml/2006/main">
-            <a:pPr algn="ctr">
+            <a:pPr algn="l">
               <a:lnSpc>
                 <a:spcPct val="100000"/>
               </a:lnSpc>
               <a:buNone/>
-              <a:defRPr sz="1200" b="0">
-                <a:solidFill>
-                  <a:srgbClr val="111318"/>
-                </a:solidFill>
-                <a:latin typeface="Helvetica Neue"/>
-                <a:ea typeface="Helvetica Neue"/>
-                <a:cs typeface="Helvetica Neue"/>
-              </a:defRPr>
-            </a:pPr>
-            <a:r>
-              <a:rPr sz="1200" b="0">
-                <a:solidFill>
-                  <a:srgbClr val="111318"/>
-                </a:solidFill>
-                <a:latin typeface="Helvetica Neue"/>
-                <a:ea typeface="Helvetica Neue"/>
-                <a:cs typeface="Helvetica Neue"/>
-              </a:rPr>
-              <a:t>Queue impact, cost,</a:t>
-            </a:r>
-          </a:p>
-          <a:p xmlns:a="http://schemas.openxmlformats.org/drawingml/2006/main">
-            <a:pPr algn="ctr">
+              <a:defRPr sz="1275" b="0">
+                <a:solidFill>
+                  <a:srgbClr val="596579"/>
+                </a:solidFill>
+                <a:latin typeface="Helvetica Neue"/>
+                <a:ea typeface="Helvetica Neue"/>
+                <a:cs typeface="Helvetica Neue"/>
+              </a:defRPr>
+            </a:pPr>
+            <a:r>
+              <a:rPr sz="1275" b="0">
+                <a:solidFill>
+                  <a:srgbClr val="596579"/>
+                </a:solidFill>
+                <a:latin typeface="Helvetica Neue"/>
+                <a:ea typeface="Helvetica Neue"/>
+                <a:cs typeface="Helvetica Neue"/>
+              </a:rPr>
+              <a:t>Tail, recovery, cost</a:t>
+            </a:r>
+          </a:p>
+          <a:p xmlns:a="http://schemas.openxmlformats.org/drawingml/2006/main">
+            <a:pPr algn="l">
               <a:lnSpc>
                 <a:spcPct val="100000"/>
               </a:lnSpc>
               <a:buNone/>
-              <a:defRPr sz="1200" b="0">
-                <a:solidFill>
-                  <a:srgbClr val="111318"/>
-                </a:solidFill>
-                <a:latin typeface="Helvetica Neue"/>
-                <a:ea typeface="Helvetica Neue"/>
-                <a:cs typeface="Helvetica Neue"/>
-              </a:defRPr>
-            </a:pPr>
-            <a:r>
-              <a:rPr sz="1200" b="0">
-                <a:solidFill>
-                  <a:srgbClr val="111318"/>
-                </a:solidFill>
-                <a:latin typeface="Helvetica Neue"/>
-                <a:ea typeface="Helvetica Neue"/>
-                <a:cs typeface="Helvetica Neue"/>
-              </a:rPr>
-              <a:t>layout + constraints</a:t>
+              <a:defRPr sz="1275" b="0">
+                <a:solidFill>
+                  <a:srgbClr val="596579"/>
+                </a:solidFill>
+                <a:latin typeface="Helvetica Neue"/>
+                <a:ea typeface="Helvetica Neue"/>
+                <a:cs typeface="Helvetica Neue"/>
+              </a:defRPr>
+            </a:pPr>
+            <a:r>
+              <a:rPr sz="1275" b="0">
+                <a:solidFill>
+                  <a:srgbClr val="596579"/>
+                </a:solidFill>
+                <a:latin typeface="Helvetica Neue"/>
+                <a:ea typeface="Helvetica Neue"/>
+                <a:cs typeface="Helvetica Neue"/>
+              </a:rPr>
+              <a:t>+ physical constraints</a:t>
             </a:r>
           </a:p>
         </p:txBody>

</xml_diff>

<commit_message>
Clarify Task 4 problem and objective
</commit_message>
<xml_diff>
--- a/slides/HTX_Task4_Operational_Insights.pptx
+++ b/slides/HTX_Task4_Operational_Insights.pptx
@@ -2,17 +2,17 @@
 <file path=ppt/presentation.xml><?xml version="1.0" encoding="utf-8"?>
 <p:presentation xmlns:p="http://schemas.openxmlformats.org/presentationml/2006/main">
   <p:sldMasterIdLst>
-    <p:sldMasterId xmlns:r="http://schemas.openxmlformats.org/officeDocument/2006/relationships" id="2147483648" r:id="R8c425503849e416e"/>
+    <p:sldMasterId xmlns:r="http://schemas.openxmlformats.org/officeDocument/2006/relationships" id="2147483648" r:id="Ra9fc1b0f890a4bab"/>
   </p:sldMasterIdLst>
   <p:notesMasterIdLst>
-    <p:notesMasterId xmlns:r="http://schemas.openxmlformats.org/officeDocument/2006/relationships" r:id="R6b5b9dc16dac44e3"/>
+    <p:notesMasterId xmlns:r="http://schemas.openxmlformats.org/officeDocument/2006/relationships" r:id="Rd4caeb9431c249c2"/>
   </p:notesMasterIdLst>
   <p:sldIdLst>
-    <p:sldId xmlns:r="http://schemas.openxmlformats.org/officeDocument/2006/relationships" id="256" r:id="R26e0ce142c7743ee"/>
-    <p:sldId xmlns:r="http://schemas.openxmlformats.org/officeDocument/2006/relationships" id="257" r:id="Re8897910e7f34930"/>
-    <p:sldId xmlns:r="http://schemas.openxmlformats.org/officeDocument/2006/relationships" id="258" r:id="Rd582a5bf99b74fd2"/>
-    <p:sldId xmlns:r="http://schemas.openxmlformats.org/officeDocument/2006/relationships" id="259" r:id="R69666be41df948b7"/>
-    <p:sldId xmlns:r="http://schemas.openxmlformats.org/officeDocument/2006/relationships" id="260" r:id="R5f47166071a742b5"/>
+    <p:sldId xmlns:r="http://schemas.openxmlformats.org/officeDocument/2006/relationships" id="256" r:id="R1dea2565975b46dd"/>
+    <p:sldId xmlns:r="http://schemas.openxmlformats.org/officeDocument/2006/relationships" id="257" r:id="R261d75f5f1ee4213"/>
+    <p:sldId xmlns:r="http://schemas.openxmlformats.org/officeDocument/2006/relationships" id="258" r:id="R40923528efa2408c"/>
+    <p:sldId xmlns:r="http://schemas.openxmlformats.org/officeDocument/2006/relationships" id="259" r:id="R7a706d92187a4065"/>
+    <p:sldId xmlns:r="http://schemas.openxmlformats.org/officeDocument/2006/relationships" id="260" r:id="Re8fd703a06aa4c0d"/>
   </p:sldIdLst>
   <p:sldSz cx="12192000" cy="6858000"/>
   <p:notesSz cx="6858000" cy="9144000"/>
@@ -446,12 +446,17 @@
           <a:lstStyle xmlns:a="http://schemas.openxmlformats.org/drawingml/2006/main"/>
           <a:p xmlns:a="http://schemas.openxmlformats.org/drawingml/2006/main">
             <a:r>
-              <a:t>Open with the evidence boundary: the 24.9-second clip provides a human-adjudicated directional corridor anchor, not a site demand forecast.</a:t>
-            </a:r>
-          </a:p>
-          <a:p xmlns:a="http://schemas.openxmlformats.org/drawingml/2006/main">
-            <a:r>
-              <a:t>The executable model then asks conditional operating questions under explicit assumptions.</a:t>
+              <a:t>Problem statement: the 24.9-second corridor clip provides a defensible arrival snapshot, but it does not measure time-of-day demand, stage-service behaviour or observed staffing.</a:t>
+            </a:r>
+          </a:p>
+          <a:p xmlns:a="http://schemas.openxmlformats.org/drawingml/2006/main">
+            <a:r>
+              <a:t>Objective: build an auditable traveller-level DES that combines measured arrivals with editable service assumptions to stress-test queues, delays and bottleneck shifts.</a:t>
+            </a:r>
+          </a:p>
+          <a:p xmlns:a="http://schemas.openxmlformats.org/drawingml/2006/main">
+            <a:r>
+              <a:t>The resulting sandbox supports conditional operating questions; it is not a site demand forecast or staffing recommendation.</a:t>
             </a:r>
           </a:p>
           <a:p xmlns:a="http://schemas.openxmlformats.org/drawingml/2006/main">
@@ -1059,7 +1064,7 @@
   </p:cSld>
   <p:clrMap bg1="lt1" tx1="dk1" bg2="lt2" tx2="dk2" accent1="accent1" accent2="accent2" accent3="accent3" accent4="accent4" accent5="accent5" accent6="accent6" hlink="hlink" folHlink="folHlink"/>
   <p:sldLayoutIdLst>
-    <p:sldLayoutId xmlns:r="http://schemas.openxmlformats.org/officeDocument/2006/relationships" id="2147483649" r:id="R3fc44018402f4411"/>
+    <p:sldLayoutId xmlns:r="http://schemas.openxmlformats.org/officeDocument/2006/relationships" id="2147483649" r:id="Rb7f985fa2d5642b9"/>
   </p:sldLayoutIdLst>
   <p:txStyles>
     <p:titleStyle>
@@ -1671,22 +1676,22 @@
         </p:nvSpPr>
         <p:spPr>
           <a:xfrm xmlns:a="http://schemas.openxmlformats.org/drawingml/2006/main">
-            <a:off x="390525" y="4429125"/>
-            <a:ext cx="5810250" cy="1000125"/>
+            <a:off x="390525" y="3333750"/>
+            <a:ext cx="5810250" cy="1381125"/>
           </a:xfrm>
           <a:prstGeom xmlns:a="http://schemas.openxmlformats.org/drawingml/2006/main" prst="rect">
             <a:avLst/>
           </a:prstGeom>
         </p:spPr>
         <p:txBody>
-          <a:bodyPr xmlns:a="http://schemas.openxmlformats.org/drawingml/2006/main" wrap="square" lIns="0" tIns="0" rIns="0" bIns="0" anchor="ctr">
+          <a:bodyPr xmlns:a="http://schemas.openxmlformats.org/drawingml/2006/main" wrap="square" lIns="0" tIns="0" rIns="0" bIns="0" anchor="t">
             <a:normAutofit fontScale="100000"/>
           </a:bodyPr>
           <a:lstStyle xmlns:a="http://schemas.openxmlformats.org/drawingml/2006/main"/>
           <a:p xmlns:a="http://schemas.openxmlformats.org/drawingml/2006/main">
             <a:pPr algn="l">
               <a:spcAft>
-                <a:spcPts val="5"/>
+                <a:spcPts val="7"/>
               </a:spcAft>
               <a:defRPr sz="1350">
                 <a:solidFill>
@@ -1706,7 +1711,33 @@
                 <a:ea typeface="Helvetica Neue"/>
                 <a:cs typeface="Helvetica Neue"/>
               </a:rPr>
-              <a:t>34 accepted R→L crossings anchor the conditional model.</a:t>
+              <a:t>OBJECTIVE</a:t>
+            </a:r>
+          </a:p>
+          <a:p xmlns:a="http://schemas.openxmlformats.org/drawingml/2006/main">
+            <a:pPr algn="l">
+              <a:spcAft>
+                <a:spcPts val="10"/>
+              </a:spcAft>
+              <a:defRPr sz="1350">
+                <a:solidFill>
+                  <a:srgbClr val="596579"/>
+                </a:solidFill>
+                <a:latin typeface="Helvetica Neue"/>
+                <a:ea typeface="Helvetica Neue"/>
+                <a:cs typeface="Helvetica Neue"/>
+              </a:defRPr>
+            </a:pPr>
+            <a:r>
+              <a:rPr sz="1350">
+                <a:solidFill>
+                  <a:srgbClr val="596579"/>
+                </a:solidFill>
+                <a:latin typeface="Helvetica Neue"/>
+                <a:ea typeface="Helvetica Neue"/>
+                <a:cs typeface="Helvetica Neue"/>
+              </a:rPr>
+              <a:t>Build an auditable traveller-level DES that combines measured arrivals with editable service assumptions to stress-test queues, delays and bottleneck shifts.</a:t>
             </a:r>
           </a:p>
           <a:p xmlns:a="http://schemas.openxmlformats.org/drawingml/2006/main">
@@ -1721,7 +1752,7 @@
               </a:defRPr>
             </a:pPr>
             <a:r>
-              <a:rPr sz="1350">
+              <a:rPr sz="1350" b="1">
                 <a:solidFill>
                   <a:srgbClr val="596579"/>
                 </a:solidFill>
@@ -1729,7 +1760,7 @@
                 <a:ea typeface="Helvetica Neue"/>
                 <a:cs typeface="Helvetica Neue"/>
               </a:rPr>
-              <a:t>4,750 validated AnyLogic runs + exact-gated replay map its operating boundary.</a:t>
+              <a:t>EVIDENCE  |  34 accepted R→L · 4,750 validated runs · exact-gated replay</a:t>
             </a:r>
           </a:p>
         </p:txBody>
@@ -1830,7 +1861,7 @@
           <p:nvPr/>
         </p:nvPicPr>
         <p:blipFill>
-          <a:blip xmlns:r="http://schemas.openxmlformats.org/officeDocument/2006/relationships" xmlns:a="http://schemas.openxmlformats.org/drawingml/2006/main" r:embed="Rd8d3dc3955164a19"/>
+          <a:blip xmlns:r="http://schemas.openxmlformats.org/officeDocument/2006/relationships" xmlns:a="http://schemas.openxmlformats.org/drawingml/2006/main" r:embed="R37da2eaefd3a49fa"/>
           <a:srcRect xmlns:a="http://schemas.openxmlformats.org/drawingml/2006/main" l="0" t="8696" r="0" b="8696"/>
           <a:stretch xmlns:a="http://schemas.openxmlformats.org/drawingml/2006/main">
             <a:fillRect l="0" t="0" r="0" b="0"/>
@@ -2189,7 +2220,7 @@
         <p:spPr>
           <a:xfrm xmlns:a="http://schemas.openxmlformats.org/drawingml/2006/main">
             <a:off x="390525" y="2133600"/>
-            <a:ext cx="5810250" cy="838200"/>
+            <a:ext cx="5810250" cy="1000125"/>
           </a:xfrm>
           <a:prstGeom xmlns:a="http://schemas.openxmlformats.org/drawingml/2006/main" prst="rect">
             <a:avLst/>
@@ -2201,17 +2232,16 @@
           </a:ln>
         </p:spPr>
         <p:txBody>
-          <a:bodyPr xmlns:a="http://schemas.openxmlformats.org/drawingml/2006/main" wrap="square" lIns="0" tIns="0" rIns="0" bIns="0" anchor="ctr">
+          <a:bodyPr xmlns:a="http://schemas.openxmlformats.org/drawingml/2006/main" wrap="square" lIns="0" tIns="0" rIns="0" bIns="0" anchor="t">
             <a:normAutofit fontScale="100000"/>
           </a:bodyPr>
           <a:lstStyle xmlns:a="http://schemas.openxmlformats.org/drawingml/2006/main"/>
           <a:p xmlns:a="http://schemas.openxmlformats.org/drawingml/2006/main">
             <a:pPr algn="l">
-              <a:lnSpc>
-                <a:spcPct val="105000"/>
-              </a:lnSpc>
-              <a:buNone/>
-              <a:defRPr sz="2025">
+              <a:spcAft>
+                <a:spcPts val="7"/>
+              </a:spcAft>
+              <a:defRPr sz="1350">
                 <a:solidFill>
                   <a:srgbClr val="596579"/>
                 </a:solidFill>
@@ -2221,7 +2251,7 @@
               </a:defRPr>
             </a:pPr>
             <a:r>
-              <a:rPr sz="2025">
+              <a:rPr sz="1350" b="1">
                 <a:solidFill>
                   <a:srgbClr val="596579"/>
                 </a:solidFill>
@@ -2229,16 +2259,12 @@
                 <a:ea typeface="Helvetica Neue"/>
                 <a:cs typeface="Helvetica Neue"/>
               </a:rPr>
-              <a:t>From a 24.9-second observation to</a:t>
+              <a:t>PROBLEM STATEMENT</a:t>
             </a:r>
           </a:p>
           <a:p xmlns:a="http://schemas.openxmlformats.org/drawingml/2006/main">
             <a:pPr algn="l">
-              <a:lnSpc>
-                <a:spcPct val="105000"/>
-              </a:lnSpc>
-              <a:buNone/>
-              <a:defRPr sz="2025">
+              <a:defRPr sz="1350">
                 <a:solidFill>
                   <a:srgbClr val="596579"/>
                 </a:solidFill>
@@ -2248,7 +2274,7 @@
               </a:defRPr>
             </a:pPr>
             <a:r>
-              <a:rPr sz="2025">
+              <a:rPr sz="1350">
                 <a:solidFill>
                   <a:srgbClr val="596579"/>
                 </a:solidFill>
@@ -2256,7 +2282,7 @@
                 <a:ea typeface="Helvetica Neue"/>
                 <a:cs typeface="Helvetica Neue"/>
               </a:rPr>
-              <a:t>a bounded decision sandbox</a:t>
+              <a:t>A 24.9-second corridor video provides a defensible arrival snapshot—not time-of-day demand, service behaviour or observed staffing.</a:t>
             </a:r>
           </a:p>
         </p:txBody>
@@ -2383,7 +2409,7 @@
       </p:sp>
       <p:cxnSp>
         <p:nvCxnSpPr>
-          <p:cNvPr id="107" name="Google-Shape-2259-p159-4"/>
+          <p:cNvPr id="119" name="Google-Shape-2259-p159-4"/>
           <p:cNvCxnSpPr/>
           <p:nvPr/>
         </p:nvCxnSpPr>
@@ -3045,33 +3071,6 @@
           </a:ln>
         </p:spPr>
       </p:sp>
-      <p:pic>
-        <p:nvPicPr>
-          <p:cNvPr id="119" name=""/>
-          <p:cNvPicPr>
-            <a:picLocks xmlns:a="http://schemas.openxmlformats.org/drawingml/2006/main" noChangeAspect="1"/>
-          </p:cNvPicPr>
-          <p:nvPr/>
-        </p:nvPicPr>
-        <p:blipFill>
-          <a:blip xmlns:r="http://schemas.openxmlformats.org/officeDocument/2006/relationships" xmlns:a="http://schemas.openxmlformats.org/drawingml/2006/main" r:embed="Ra54d4421968a4de4"/>
-          <a:srcRect xmlns:a="http://schemas.openxmlformats.org/drawingml/2006/main" l="0" t="8139" r="0" b="8139"/>
-          <a:stretch xmlns:a="http://schemas.openxmlformats.org/drawingml/2006/main">
-            <a:fillRect l="0" t="0" r="0" b="0"/>
-          </a:stretch>
-        </p:blipFill>
-        <p:spPr>
-          <a:xfrm xmlns:a="http://schemas.openxmlformats.org/drawingml/2006/main">
-            <a:off x="4352925" y="3028950"/>
-            <a:ext cx="3448050" cy="1876425"/>
-          </a:xfrm>
-          <a:prstGeom xmlns:a="http://schemas.openxmlformats.org/drawingml/2006/main" prst="roundRect">
-            <a:avLst>
-              <a:gd name="adj" fmla="val 4569"/>
-            </a:avLst>
-          </a:prstGeom>
-        </p:spPr>
-      </p:pic>
       <p:sp>
         <p:nvSpPr>
           <p:cNvPr id="38" name="infer-grid-frame">
@@ -4451,6 +4450,7 @@
           <a:lstStyle xmlns:a="http://schemas.openxmlformats.org/drawingml/2006/main"/>
           <a:p xmlns:a="http://schemas.openxmlformats.org/drawingml/2006/main">
             <a:pPr algn="l">
+              <a:buNone/>
               <a:defRPr sz="3900" b="1">
                 <a:solidFill>
                   <a:srgbClr val="2854E8"/>
@@ -4509,6 +4509,7 @@
           <a:lstStyle xmlns:a="http://schemas.openxmlformats.org/drawingml/2006/main"/>
           <a:p xmlns:a="http://schemas.openxmlformats.org/drawingml/2006/main">
             <a:pPr algn="l">
+              <a:buNone/>
               <a:defRPr sz="1125" b="1">
                 <a:solidFill>
                   <a:srgbClr val="071B3A"/>
@@ -4567,6 +4568,7 @@
           <a:lstStyle xmlns:a="http://schemas.openxmlformats.org/drawingml/2006/main"/>
           <a:p xmlns:a="http://schemas.openxmlformats.org/drawingml/2006/main">
             <a:pPr algn="l">
+              <a:buNone/>
               <a:defRPr sz="3150" b="1">
                 <a:solidFill>
                   <a:srgbClr val="596579"/>
@@ -4625,6 +4627,7 @@
           <a:lstStyle xmlns:a="http://schemas.openxmlformats.org/drawingml/2006/main"/>
           <a:p xmlns:a="http://schemas.openxmlformats.org/drawingml/2006/main">
             <a:pPr algn="l">
+              <a:buNone/>
               <a:defRPr sz="1050" b="1">
                 <a:solidFill>
                   <a:srgbClr val="596579"/>
@@ -4654,6 +4657,297 @@
             <a:extLst xmlns:a="http://schemas.openxmlformats.org/drawingml/2006/main">
               <a:ext uri="{FF2B5EF4-FFF2-40B4-BE49-F238E27FC236}">
                 <a16:creationId xmlns:a16="http://schemas.microsoft.com/office/drawing/2014/main" id="{9412E7DE-6D34-4598-A24F-AF54075FD4EB}"/>
+              </a:ext>
+            </a:extLst>
+          </p:cNvPr>
+          <p:cNvSpPr>
+            <a:spLocks xmlns:a="http://schemas.openxmlformats.org/drawingml/2006/main" noGrp="1"/>
+          </p:cNvSpPr>
+          <p:nvPr/>
+        </p:nvSpPr>
+        <p:spPr>
+          <a:xfrm xmlns:a="http://schemas.openxmlformats.org/drawingml/2006/main">
+            <a:off x="552450" y="4371975"/>
+            <a:ext cx="3048000" cy="361950"/>
+          </a:xfrm>
+          <a:prstGeom xmlns:a="http://schemas.openxmlformats.org/drawingml/2006/main" prst="rect">
+            <a:avLst/>
+          </a:prstGeom>
+          <a:noFill xmlns:a="http://schemas.openxmlformats.org/drawingml/2006/main"/>
+          <a:ln xmlns:a="http://schemas.openxmlformats.org/drawingml/2006/main" w="0">
+            <a:noFill/>
+            <a:prstDash val="solid"/>
+          </a:ln>
+        </p:spPr>
+        <p:txBody>
+          <a:bodyPr xmlns:a="http://schemas.openxmlformats.org/drawingml/2006/main" wrap="square" anchor="ctr">
+            <a:normAutofit fontScale="100000"/>
+          </a:bodyPr>
+          <a:lstStyle xmlns:a="http://schemas.openxmlformats.org/drawingml/2006/main"/>
+          <a:p xmlns:a="http://schemas.openxmlformats.org/drawingml/2006/main">
+            <a:pPr algn="ctr">
+              <a:buNone/>
+              <a:defRPr sz="1125" b="1">
+                <a:solidFill>
+                  <a:srgbClr val="0A9F43"/>
+                </a:solidFill>
+                <a:latin typeface="Helvetica Neue"/>
+                <a:ea typeface="Helvetica Neue"/>
+                <a:cs typeface="Helvetica Neue"/>
+              </a:defRPr>
+            </a:pPr>
+            <a:r>
+              <a:rPr sz="1125" b="1">
+                <a:solidFill>
+                  <a:srgbClr val="0A9F43"/>
+                </a:solidFill>
+                <a:latin typeface="Helvetica Neue"/>
+                <a:ea typeface="Helvetica Neue"/>
+                <a:cs typeface="Helvetica Neue"/>
+              </a:rPr>
+              <a:t>CV-assisted  →  human accepted</a:t>
+            </a:r>
+          </a:p>
+        </p:txBody>
+      </p:sp>
+      <p:sp>
+        <p:nvSpPr>
+          <p:cNvPr id="112" name="measure-r2l-value">
+            <a:extLst xmlns:a="http://schemas.openxmlformats.org/drawingml/2006/main">
+              <a:ext uri="{FF2B5EF4-FFF2-40B4-BE49-F238E27FC236}">
+                <a16:creationId xmlns:a16="http://schemas.microsoft.com/office/drawing/2014/main" id="{82DB0D08-AA9C-4035-A88B-E0F1C24DF46E}"/>
+              </a:ext>
+            </a:extLst>
+          </p:cNvPr>
+          <p:cNvSpPr>
+            <a:spLocks xmlns:a="http://schemas.openxmlformats.org/drawingml/2006/main" noGrp="1"/>
+          </p:cNvSpPr>
+          <p:nvPr/>
+        </p:nvSpPr>
+        <p:spPr>
+          <a:xfrm xmlns:a="http://schemas.openxmlformats.org/drawingml/2006/main">
+            <a:off x="552450" y="3171825"/>
+            <a:ext cx="1381125" cy="685800"/>
+          </a:xfrm>
+          <a:prstGeom xmlns:a="http://schemas.openxmlformats.org/drawingml/2006/main" prst="rect">
+            <a:avLst/>
+          </a:prstGeom>
+          <a:noFill xmlns:a="http://schemas.openxmlformats.org/drawingml/2006/main"/>
+          <a:ln xmlns:a="http://schemas.openxmlformats.org/drawingml/2006/main" w="0">
+            <a:noFill/>
+            <a:prstDash val="solid"/>
+          </a:ln>
+        </p:spPr>
+        <p:txBody>
+          <a:bodyPr xmlns:a="http://schemas.openxmlformats.org/drawingml/2006/main" wrap="square" lIns="0" tIns="0" rIns="0" bIns="0" anchor="ctr">
+            <a:normAutofit fontScale="100000"/>
+          </a:bodyPr>
+          <a:lstStyle xmlns:a="http://schemas.openxmlformats.org/drawingml/2006/main"/>
+          <a:p xmlns:a="http://schemas.openxmlformats.org/drawingml/2006/main">
+            <a:pPr algn="l">
+              <a:defRPr sz="3900" b="1">
+                <a:solidFill>
+                  <a:srgbClr val="2854E8"/>
+                </a:solidFill>
+                <a:latin typeface="Helvetica Neue"/>
+                <a:ea typeface="Helvetica Neue"/>
+                <a:cs typeface="Helvetica Neue"/>
+              </a:defRPr>
+            </a:pPr>
+            <a:r>
+              <a:rPr sz="3900" b="1">
+                <a:solidFill>
+                  <a:srgbClr val="2854E8"/>
+                </a:solidFill>
+                <a:latin typeface="Helvetica Neue"/>
+                <a:ea typeface="Helvetica Neue"/>
+                <a:cs typeface="Helvetica Neue"/>
+              </a:rPr>
+              <a:t>34</a:t>
+            </a:r>
+          </a:p>
+        </p:txBody>
+      </p:sp>
+      <p:sp>
+        <p:nvSpPr>
+          <p:cNvPr id="113" name="measure-r2l-label">
+            <a:extLst xmlns:a="http://schemas.openxmlformats.org/drawingml/2006/main">
+              <a:ext uri="{FF2B5EF4-FFF2-40B4-BE49-F238E27FC236}">
+                <a16:creationId xmlns:a16="http://schemas.microsoft.com/office/drawing/2014/main" id="{86FEDFB1-8D3C-4B1B-ABF9-F697D0787FBB}"/>
+              </a:ext>
+            </a:extLst>
+          </p:cNvPr>
+          <p:cNvSpPr>
+            <a:spLocks xmlns:a="http://schemas.openxmlformats.org/drawingml/2006/main" noGrp="1"/>
+          </p:cNvSpPr>
+          <p:nvPr/>
+        </p:nvSpPr>
+        <p:spPr>
+          <a:xfrm xmlns:a="http://schemas.openxmlformats.org/drawingml/2006/main">
+            <a:off x="552450" y="3857625"/>
+            <a:ext cx="1428750" cy="323850"/>
+          </a:xfrm>
+          <a:prstGeom xmlns:a="http://schemas.openxmlformats.org/drawingml/2006/main" prst="rect">
+            <a:avLst/>
+          </a:prstGeom>
+          <a:noFill xmlns:a="http://schemas.openxmlformats.org/drawingml/2006/main"/>
+          <a:ln xmlns:a="http://schemas.openxmlformats.org/drawingml/2006/main" w="0">
+            <a:noFill/>
+            <a:prstDash val="solid"/>
+          </a:ln>
+        </p:spPr>
+        <p:txBody>
+          <a:bodyPr xmlns:a="http://schemas.openxmlformats.org/drawingml/2006/main" wrap="square" anchor="t">
+            <a:normAutofit fontScale="100000"/>
+          </a:bodyPr>
+          <a:lstStyle xmlns:a="http://schemas.openxmlformats.org/drawingml/2006/main"/>
+          <a:p xmlns:a="http://schemas.openxmlformats.org/drawingml/2006/main">
+            <a:pPr algn="l">
+              <a:defRPr sz="1125" b="1">
+                <a:solidFill>
+                  <a:srgbClr val="071B3A"/>
+                </a:solidFill>
+                <a:latin typeface="Helvetica Neue"/>
+                <a:ea typeface="Helvetica Neue"/>
+                <a:cs typeface="Helvetica Neue"/>
+              </a:defRPr>
+            </a:pPr>
+            <a:r>
+              <a:rPr sz="1125" b="1">
+                <a:solidFill>
+                  <a:srgbClr val="071B3A"/>
+                </a:solidFill>
+                <a:latin typeface="Helvetica Neue"/>
+                <a:ea typeface="Helvetica Neue"/>
+                <a:cs typeface="Helvetica Neue"/>
+              </a:rPr>
+              <a:t>accepted R→L</a:t>
+            </a:r>
+          </a:p>
+        </p:txBody>
+      </p:sp>
+      <p:sp>
+        <p:nvSpPr>
+          <p:cNvPr id="114" name="measure-l2r-value">
+            <a:extLst xmlns:a="http://schemas.openxmlformats.org/drawingml/2006/main">
+              <a:ext uri="{FF2B5EF4-FFF2-40B4-BE49-F238E27FC236}">
+                <a16:creationId xmlns:a16="http://schemas.microsoft.com/office/drawing/2014/main" id="{F83AC8B7-C023-4E2E-9E14-FB2F073F7C82}"/>
+              </a:ext>
+            </a:extLst>
+          </p:cNvPr>
+          <p:cNvSpPr>
+            <a:spLocks xmlns:a="http://schemas.openxmlformats.org/drawingml/2006/main" noGrp="1"/>
+          </p:cNvSpPr>
+          <p:nvPr/>
+        </p:nvSpPr>
+        <p:spPr>
+          <a:xfrm xmlns:a="http://schemas.openxmlformats.org/drawingml/2006/main">
+            <a:off x="2247900" y="3257550"/>
+            <a:ext cx="1095375" cy="571500"/>
+          </a:xfrm>
+          <a:prstGeom xmlns:a="http://schemas.openxmlformats.org/drawingml/2006/main" prst="rect">
+            <a:avLst/>
+          </a:prstGeom>
+          <a:noFill xmlns:a="http://schemas.openxmlformats.org/drawingml/2006/main"/>
+          <a:ln xmlns:a="http://schemas.openxmlformats.org/drawingml/2006/main" w="0">
+            <a:noFill/>
+            <a:prstDash val="solid"/>
+          </a:ln>
+        </p:spPr>
+        <p:txBody>
+          <a:bodyPr xmlns:a="http://schemas.openxmlformats.org/drawingml/2006/main" wrap="square" lIns="0" tIns="0" rIns="0" bIns="0" anchor="ctr">
+            <a:normAutofit fontScale="100000"/>
+          </a:bodyPr>
+          <a:lstStyle xmlns:a="http://schemas.openxmlformats.org/drawingml/2006/main"/>
+          <a:p xmlns:a="http://schemas.openxmlformats.org/drawingml/2006/main">
+            <a:pPr algn="l">
+              <a:defRPr sz="3150" b="1">
+                <a:solidFill>
+                  <a:srgbClr val="596579"/>
+                </a:solidFill>
+                <a:latin typeface="Helvetica Neue"/>
+                <a:ea typeface="Helvetica Neue"/>
+                <a:cs typeface="Helvetica Neue"/>
+              </a:defRPr>
+            </a:pPr>
+            <a:r>
+              <a:rPr sz="3150" b="1">
+                <a:solidFill>
+                  <a:srgbClr val="596579"/>
+                </a:solidFill>
+                <a:latin typeface="Helvetica Neue"/>
+                <a:ea typeface="Helvetica Neue"/>
+                <a:cs typeface="Helvetica Neue"/>
+              </a:rPr>
+              <a:t>12</a:t>
+            </a:r>
+          </a:p>
+        </p:txBody>
+      </p:sp>
+      <p:sp>
+        <p:nvSpPr>
+          <p:cNvPr id="115" name="measure-l2r-label">
+            <a:extLst xmlns:a="http://schemas.openxmlformats.org/drawingml/2006/main">
+              <a:ext uri="{FF2B5EF4-FFF2-40B4-BE49-F238E27FC236}">
+                <a16:creationId xmlns:a16="http://schemas.microsoft.com/office/drawing/2014/main" id="{25631FFB-BC31-490D-9C0C-2DF944B03036}"/>
+              </a:ext>
+            </a:extLst>
+          </p:cNvPr>
+          <p:cNvSpPr>
+            <a:spLocks xmlns:a="http://schemas.openxmlformats.org/drawingml/2006/main" noGrp="1"/>
+          </p:cNvSpPr>
+          <p:nvPr/>
+        </p:nvSpPr>
+        <p:spPr>
+          <a:xfrm xmlns:a="http://schemas.openxmlformats.org/drawingml/2006/main">
+            <a:off x="2247900" y="3857625"/>
+            <a:ext cx="1285875" cy="323850"/>
+          </a:xfrm>
+          <a:prstGeom xmlns:a="http://schemas.openxmlformats.org/drawingml/2006/main" prst="rect">
+            <a:avLst/>
+          </a:prstGeom>
+          <a:noFill xmlns:a="http://schemas.openxmlformats.org/drawingml/2006/main"/>
+          <a:ln xmlns:a="http://schemas.openxmlformats.org/drawingml/2006/main" w="0">
+            <a:noFill/>
+            <a:prstDash val="solid"/>
+          </a:ln>
+        </p:spPr>
+        <p:txBody>
+          <a:bodyPr xmlns:a="http://schemas.openxmlformats.org/drawingml/2006/main" wrap="square" anchor="t">
+            <a:normAutofit fontScale="100000"/>
+          </a:bodyPr>
+          <a:lstStyle xmlns:a="http://schemas.openxmlformats.org/drawingml/2006/main"/>
+          <a:p xmlns:a="http://schemas.openxmlformats.org/drawingml/2006/main">
+            <a:pPr algn="l">
+              <a:defRPr sz="1050" b="1">
+                <a:solidFill>
+                  <a:srgbClr val="596579"/>
+                </a:solidFill>
+                <a:latin typeface="Helvetica Neue"/>
+                <a:ea typeface="Helvetica Neue"/>
+                <a:cs typeface="Helvetica Neue"/>
+              </a:defRPr>
+            </a:pPr>
+            <a:r>
+              <a:rPr sz="1050" b="1">
+                <a:solidFill>
+                  <a:srgbClr val="596579"/>
+                </a:solidFill>
+                <a:latin typeface="Helvetica Neue"/>
+                <a:ea typeface="Helvetica Neue"/>
+                <a:cs typeface="Helvetica Neue"/>
+              </a:rPr>
+              <a:t>opposite direction</a:t>
+            </a:r>
+          </a:p>
+        </p:txBody>
+      </p:sp>
+      <p:sp>
+        <p:nvSpPr>
+          <p:cNvPr id="116" name="measure-adjudication-flow">
+            <a:extLst xmlns:a="http://schemas.openxmlformats.org/drawingml/2006/main">
+              <a:ext uri="{FF2B5EF4-FFF2-40B4-BE49-F238E27FC236}">
+                <a16:creationId xmlns:a16="http://schemas.microsoft.com/office/drawing/2014/main" id="{E02ED123-935F-44EC-9722-95125D7A7EF1}"/>
               </a:ext>
             </a:extLst>
           </p:cNvPr>
@@ -5214,16 +5508,16 @@
           <p:nvPr/>
         </p:nvPicPr>
         <p:blipFill>
-          <a:blip xmlns:r="http://schemas.openxmlformats.org/officeDocument/2006/relationships" xmlns:a="http://schemas.openxmlformats.org/drawingml/2006/main" r:embed="Raa1bd7119d684c87"/>
-          <a:srcRect xmlns:a="http://schemas.openxmlformats.org/drawingml/2006/main" l="0" t="9865" r="0" b="9865"/>
+          <a:blip xmlns:r="http://schemas.openxmlformats.org/officeDocument/2006/relationships" xmlns:a="http://schemas.openxmlformats.org/drawingml/2006/main" r:embed="R2fbeddb3023141c8"/>
+          <a:srcRect xmlns:a="http://schemas.openxmlformats.org/drawingml/2006/main" l="0" t="19554" r="0" b="19554"/>
           <a:stretch xmlns:a="http://schemas.openxmlformats.org/drawingml/2006/main">
             <a:fillRect l="0" t="0" r="0" b="0"/>
           </a:stretch>
         </p:blipFill>
         <p:spPr>
           <a:xfrm xmlns:a="http://schemas.openxmlformats.org/drawingml/2006/main">
-            <a:off x="400050" y="1381125"/>
-            <a:ext cx="7620000" cy="4476750"/>
+            <a:off x="400050" y="1992894"/>
+            <a:ext cx="7620000" cy="3396086"/>
           </a:xfrm>
           <a:prstGeom xmlns:a="http://schemas.openxmlformats.org/drawingml/2006/main" prst="rect">
             <a:avLst/>
@@ -5738,7 +6032,7 @@
           <p:nvPr/>
         </p:nvPicPr>
         <p:blipFill>
-          <a:blip xmlns:r="http://schemas.openxmlformats.org/officeDocument/2006/relationships" xmlns:a="http://schemas.openxmlformats.org/drawingml/2006/main" r:embed="Rf2b644a604a940c5"/>
+          <a:blip xmlns:r="http://schemas.openxmlformats.org/officeDocument/2006/relationships" xmlns:a="http://schemas.openxmlformats.org/drawingml/2006/main" r:embed="Rd7a4729e931343dc"/>
           <a:stretch xmlns:a="http://schemas.openxmlformats.org/drawingml/2006/main"/>
         </p:blipFill>
         <p:spPr>

</xml_diff>

<commit_message>
Align opening slide with operational brief
</commit_message>
<xml_diff>
--- a/slides/HTX_Task4_Operational_Insights.pptx
+++ b/slides/HTX_Task4_Operational_Insights.pptx
@@ -2,17 +2,17 @@
 <file path=ppt/presentation.xml><?xml version="1.0" encoding="utf-8"?>
 <p:presentation xmlns:p="http://schemas.openxmlformats.org/presentationml/2006/main">
   <p:sldMasterIdLst>
-    <p:sldMasterId xmlns:r="http://schemas.openxmlformats.org/officeDocument/2006/relationships" id="2147483648" r:id="Ra9fc1b0f890a4bab"/>
+    <p:sldMasterId xmlns:r="http://schemas.openxmlformats.org/officeDocument/2006/relationships" id="2147483648" r:id="Redb415779d594258"/>
   </p:sldMasterIdLst>
   <p:notesMasterIdLst>
-    <p:notesMasterId xmlns:r="http://schemas.openxmlformats.org/officeDocument/2006/relationships" r:id="Rd4caeb9431c249c2"/>
+    <p:notesMasterId xmlns:r="http://schemas.openxmlformats.org/officeDocument/2006/relationships" r:id="R5a688a4d62814bf8"/>
   </p:notesMasterIdLst>
   <p:sldIdLst>
-    <p:sldId xmlns:r="http://schemas.openxmlformats.org/officeDocument/2006/relationships" id="256" r:id="R1dea2565975b46dd"/>
-    <p:sldId xmlns:r="http://schemas.openxmlformats.org/officeDocument/2006/relationships" id="257" r:id="R261d75f5f1ee4213"/>
-    <p:sldId xmlns:r="http://schemas.openxmlformats.org/officeDocument/2006/relationships" id="258" r:id="R40923528efa2408c"/>
-    <p:sldId xmlns:r="http://schemas.openxmlformats.org/officeDocument/2006/relationships" id="259" r:id="R7a706d92187a4065"/>
-    <p:sldId xmlns:r="http://schemas.openxmlformats.org/officeDocument/2006/relationships" id="260" r:id="Re8fd703a06aa4c0d"/>
+    <p:sldId xmlns:r="http://schemas.openxmlformats.org/officeDocument/2006/relationships" id="256" r:id="R3a8e2d60673742c6"/>
+    <p:sldId xmlns:r="http://schemas.openxmlformats.org/officeDocument/2006/relationships" id="257" r:id="R09f20f9c56ca4ccb"/>
+    <p:sldId xmlns:r="http://schemas.openxmlformats.org/officeDocument/2006/relationships" id="258" r:id="R3d67231bc1ca4386"/>
+    <p:sldId xmlns:r="http://schemas.openxmlformats.org/officeDocument/2006/relationships" id="259" r:id="Raa65704fb2184268"/>
+    <p:sldId xmlns:r="http://schemas.openxmlformats.org/officeDocument/2006/relationships" id="260" r:id="R5980c98e1b504d91"/>
   </p:sldIdLst>
   <p:sldSz cx="12192000" cy="6858000"/>
   <p:notesSz cx="6858000" cy="9144000"/>
@@ -446,12 +446,17 @@
           <a:lstStyle xmlns:a="http://schemas.openxmlformats.org/drawingml/2006/main"/>
           <a:p xmlns:a="http://schemas.openxmlformats.org/drawingml/2006/main">
             <a:r>
-              <a:t>Problem statement: the 24.9-second corridor clip provides a defensible arrival snapshot, but it does not measure time-of-day demand, stage-service behaviour or observed staffing.</a:t>
-            </a:r>
-          </a:p>
-          <a:p xmlns:a="http://schemas.openxmlformats.org/drawingml/2006/main">
-            <a:r>
-              <a:t>Objective: build an auditable traveller-level DES that combines measured arrivals with editable service assumptions to stress-test queues, delays and bottleneck shifts.</a:t>
+              <a:t>Problem statement from the brief: for peak and holiday periods, checkpoint leaders need to understand how traveller demand, staffing and queue/SOP choices interact to create bottlenecks and delays.</a:t>
+            </a:r>
+          </a:p>
+          <a:p xmlns:a="http://schemas.openxmlformats.org/drawingml/2006/main">
+            <a:r>
+              <a:t>Objective: build an auditable traveller-level DES decision sandbox to compare operational scenarios and SOPs before implementation.</a:t>
+            </a:r>
+          </a:p>
+          <a:p xmlns:a="http://schemas.openxmlformats.org/drawingml/2006/main">
+            <a:r>
+              <a:t>Evidence boundary: the 24.9-second corridor clip provides a human-adjudicated short-window arrival anchor—not a time-of-day demand profile, service dataset or staffing estimate.</a:t>
             </a:r>
           </a:p>
           <a:p xmlns:a="http://schemas.openxmlformats.org/drawingml/2006/main">
@@ -1064,7 +1069,7 @@
   </p:cSld>
   <p:clrMap bg1="lt1" tx1="dk1" bg2="lt2" tx2="dk2" accent1="accent1" accent2="accent2" accent3="accent3" accent4="accent4" accent5="accent5" accent6="accent6" hlink="hlink" folHlink="folHlink"/>
   <p:sldLayoutIdLst>
-    <p:sldLayoutId xmlns:r="http://schemas.openxmlformats.org/officeDocument/2006/relationships" id="2147483649" r:id="Rb7f985fa2d5642b9"/>
+    <p:sldLayoutId xmlns:r="http://schemas.openxmlformats.org/officeDocument/2006/relationships" id="2147483649" r:id="R4a7e107019b849b0"/>
   </p:sldLayoutIdLst>
   <p:txStyles>
     <p:titleStyle>
@@ -1737,7 +1742,7 @@
                 <a:ea typeface="Helvetica Neue"/>
                 <a:cs typeface="Helvetica Neue"/>
               </a:rPr>
-              <a:t>Build an auditable traveller-level DES that combines measured arrivals with editable service assumptions to stress-test queues, delays and bottleneck shifts.</a:t>
+              <a:t>Build an auditable traveller-level DES decision sandbox to compare operational scenarios and SOPs, quantifying queues, delays, clearance time and bottleneck shifts before implementation.</a:t>
             </a:r>
           </a:p>
           <a:p xmlns:a="http://schemas.openxmlformats.org/drawingml/2006/main">
@@ -1861,7 +1866,7 @@
           <p:nvPr/>
         </p:nvPicPr>
         <p:blipFill>
-          <a:blip xmlns:r="http://schemas.openxmlformats.org/officeDocument/2006/relationships" xmlns:a="http://schemas.openxmlformats.org/drawingml/2006/main" r:embed="R37da2eaefd3a49fa"/>
+          <a:blip xmlns:r="http://schemas.openxmlformats.org/officeDocument/2006/relationships" xmlns:a="http://schemas.openxmlformats.org/drawingml/2006/main" r:embed="Rfe52ac687b2343ed"/>
           <a:srcRect xmlns:a="http://schemas.openxmlformats.org/drawingml/2006/main" l="0" t="8696" r="0" b="8696"/>
           <a:stretch xmlns:a="http://schemas.openxmlformats.org/drawingml/2006/main">
             <a:fillRect l="0" t="0" r="0" b="0"/>
@@ -2198,7 +2203,7 @@
                 <a:ea typeface="Helvetica Neue"/>
                 <a:cs typeface="Helvetica Neue"/>
               </a:rPr>
-              <a:t>Human-adjudicated short-window aggregate · not a long-run demand estimate</a:t>
+              <a:t>24.9-second corridor-flow anchor · not a time-of-day demand profile or staffing estimate</a:t>
             </a:r>
           </a:p>
         </p:txBody>
@@ -2282,7 +2287,7 @@
                 <a:ea typeface="Helvetica Neue"/>
                 <a:cs typeface="Helvetica Neue"/>
               </a:rPr>
-              <a:t>A 24.9-second corridor video provides a defensible arrival snapshot—not time-of-day demand, service behaviour or observed staffing.</a:t>
+              <a:t>For peak and holiday periods, checkpoint leaders need to understand how traveller demand, staffing and queue/SOP choices interact to create bottlenecks and delays.</a:t>
             </a:r>
           </a:p>
         </p:txBody>
@@ -2409,7 +2414,7 @@
       </p:sp>
       <p:cxnSp>
         <p:nvCxnSpPr>
-          <p:cNvPr id="119" name="Google-Shape-2259-p159-4"/>
+          <p:cNvPr id="122" name="Google-Shape-2259-p159-4"/>
           <p:cNvCxnSpPr/>
           <p:nvPr/>
         </p:nvCxnSpPr>
@@ -4745,6 +4750,7 @@
           <a:lstStyle xmlns:a="http://schemas.openxmlformats.org/drawingml/2006/main"/>
           <a:p xmlns:a="http://schemas.openxmlformats.org/drawingml/2006/main">
             <a:pPr algn="l">
+              <a:buNone/>
               <a:defRPr sz="3900" b="1">
                 <a:solidFill>
                   <a:srgbClr val="2854E8"/>
@@ -4803,6 +4809,7 @@
           <a:lstStyle xmlns:a="http://schemas.openxmlformats.org/drawingml/2006/main"/>
           <a:p xmlns:a="http://schemas.openxmlformats.org/drawingml/2006/main">
             <a:pPr algn="l">
+              <a:buNone/>
               <a:defRPr sz="1125" b="1">
                 <a:solidFill>
                   <a:srgbClr val="071B3A"/>
@@ -4861,6 +4868,7 @@
           <a:lstStyle xmlns:a="http://schemas.openxmlformats.org/drawingml/2006/main"/>
           <a:p xmlns:a="http://schemas.openxmlformats.org/drawingml/2006/main">
             <a:pPr algn="l">
+              <a:buNone/>
               <a:defRPr sz="3150" b="1">
                 <a:solidFill>
                   <a:srgbClr val="596579"/>
@@ -4919,6 +4927,7 @@
           <a:lstStyle xmlns:a="http://schemas.openxmlformats.org/drawingml/2006/main"/>
           <a:p xmlns:a="http://schemas.openxmlformats.org/drawingml/2006/main">
             <a:pPr algn="l">
+              <a:buNone/>
               <a:defRPr sz="1050" b="1">
                 <a:solidFill>
                   <a:srgbClr val="596579"/>
@@ -4977,6 +4986,7 @@
           <a:lstStyle xmlns:a="http://schemas.openxmlformats.org/drawingml/2006/main"/>
           <a:p xmlns:a="http://schemas.openxmlformats.org/drawingml/2006/main">
             <a:pPr algn="ctr">
+              <a:buNone/>
               <a:defRPr sz="1125" b="1">
                 <a:solidFill>
                   <a:srgbClr val="0A9F43"/>
@@ -5163,6 +5173,7 @@
               <a:spcAft>
                 <a:spcPts val="4"/>
               </a:spcAft>
+              <a:buNone/>
               <a:defRPr sz="1200">
                 <a:solidFill>
                   <a:srgbClr val="000000"/>
@@ -5186,6 +5197,7 @@
           </a:p>
           <a:p xmlns:a="http://schemas.openxmlformats.org/drawingml/2006/main">
             <a:pPr algn="l">
+              <a:buNone/>
               <a:defRPr sz="1200">
                 <a:solidFill>
                   <a:srgbClr val="000000"/>
@@ -5242,6 +5254,7 @@
               <a:spcAft>
                 <a:spcPts val="4"/>
               </a:spcAft>
+              <a:buNone/>
               <a:defRPr sz="1200">
                 <a:solidFill>
                   <a:srgbClr val="000000"/>
@@ -5265,6 +5278,7 @@
           </a:p>
           <a:p xmlns:a="http://schemas.openxmlformats.org/drawingml/2006/main">
             <a:pPr algn="l">
+              <a:buNone/>
               <a:defRPr sz="1200">
                 <a:solidFill>
                   <a:srgbClr val="000000"/>
@@ -5321,6 +5335,7 @@
               <a:spcAft>
                 <a:spcPts val="4"/>
               </a:spcAft>
+              <a:buNone/>
               <a:defRPr sz="1200">
                 <a:solidFill>
                   <a:srgbClr val="000000"/>
@@ -5344,6 +5359,7 @@
           </a:p>
           <a:p xmlns:a="http://schemas.openxmlformats.org/drawingml/2006/main">
             <a:pPr algn="l">
+              <a:buNone/>
               <a:defRPr sz="1200">
                 <a:solidFill>
                   <a:srgbClr val="000000"/>
@@ -5508,7 +5524,7 @@
           <p:nvPr/>
         </p:nvPicPr>
         <p:blipFill>
-          <a:blip xmlns:r="http://schemas.openxmlformats.org/officeDocument/2006/relationships" xmlns:a="http://schemas.openxmlformats.org/drawingml/2006/main" r:embed="R2fbeddb3023141c8"/>
+          <a:blip xmlns:r="http://schemas.openxmlformats.org/officeDocument/2006/relationships" xmlns:a="http://schemas.openxmlformats.org/drawingml/2006/main" r:embed="R650560ae62024632"/>
           <a:srcRect xmlns:a="http://schemas.openxmlformats.org/drawingml/2006/main" l="0" t="19554" r="0" b="19554"/>
           <a:stretch xmlns:a="http://schemas.openxmlformats.org/drawingml/2006/main">
             <a:fillRect l="0" t="0" r="0" b="0"/>
@@ -5687,6 +5703,7 @@
               <a:spcAft>
                 <a:spcPts val="4"/>
               </a:spcAft>
+              <a:buNone/>
               <a:defRPr sz="1200">
                 <a:solidFill>
                   <a:srgbClr val="000000"/>
@@ -5710,6 +5727,7 @@
           </a:p>
           <a:p xmlns:a="http://schemas.openxmlformats.org/drawingml/2006/main">
             <a:pPr algn="l">
+              <a:buNone/>
               <a:defRPr sz="1200">
                 <a:solidFill>
                   <a:srgbClr val="000000"/>
@@ -5766,6 +5784,7 @@
               <a:spcAft>
                 <a:spcPts val="4"/>
               </a:spcAft>
+              <a:buNone/>
               <a:defRPr sz="1200">
                 <a:solidFill>
                   <a:srgbClr val="000000"/>
@@ -5789,6 +5808,7 @@
           </a:p>
           <a:p xmlns:a="http://schemas.openxmlformats.org/drawingml/2006/main">
             <a:pPr algn="l">
+              <a:buNone/>
               <a:defRPr sz="1200">
                 <a:solidFill>
                   <a:srgbClr val="000000"/>
@@ -5845,6 +5865,7 @@
               <a:spcAft>
                 <a:spcPts val="4"/>
               </a:spcAft>
+              <a:buNone/>
               <a:defRPr sz="1200">
                 <a:solidFill>
                   <a:srgbClr val="000000"/>
@@ -5868,6 +5889,7 @@
           </a:p>
           <a:p xmlns:a="http://schemas.openxmlformats.org/drawingml/2006/main">
             <a:pPr algn="l">
+              <a:buNone/>
               <a:defRPr sz="1200">
                 <a:solidFill>
                   <a:srgbClr val="000000"/>
@@ -6032,7 +6054,7 @@
           <p:nvPr/>
         </p:nvPicPr>
         <p:blipFill>
-          <a:blip xmlns:r="http://schemas.openxmlformats.org/officeDocument/2006/relationships" xmlns:a="http://schemas.openxmlformats.org/drawingml/2006/main" r:embed="Rd7a4729e931343dc"/>
+          <a:blip xmlns:r="http://schemas.openxmlformats.org/officeDocument/2006/relationships" xmlns:a="http://schemas.openxmlformats.org/drawingml/2006/main" r:embed="R4db465cfe1344ba2"/>
           <a:stretch xmlns:a="http://schemas.openxmlformats.org/drawingml/2006/main"/>
         </p:blipFill>
         <p:spPr>
@@ -6389,6 +6411,7 @@
               <a:spcAft>
                 <a:spcPts val="4"/>
               </a:spcAft>
+              <a:buNone/>
               <a:defRPr sz="1200">
                 <a:solidFill>
                   <a:srgbClr val="000000"/>
@@ -6415,6 +6438,7 @@
               <a:spcAft>
                 <a:spcPts val="10"/>
               </a:spcAft>
+              <a:buNone/>
               <a:defRPr sz="1200">
                 <a:solidFill>
                   <a:srgbClr val="000000"/>
@@ -6441,6 +6465,7 @@
               <a:spcAft>
                 <a:spcPts val="4"/>
               </a:spcAft>
+              <a:buNone/>
               <a:defRPr sz="1200">
                 <a:solidFill>
                   <a:srgbClr val="000000"/>
@@ -6467,6 +6492,7 @@
               <a:spcAft>
                 <a:spcPts val="10"/>
               </a:spcAft>
+              <a:buNone/>
               <a:defRPr sz="1200">
                 <a:solidFill>
                   <a:srgbClr val="000000"/>
@@ -6493,6 +6519,7 @@
               <a:spcAft>
                 <a:spcPts val="4"/>
               </a:spcAft>
+              <a:buNone/>
               <a:defRPr sz="1200">
                 <a:solidFill>
                   <a:srgbClr val="000000"/>
@@ -6516,6 +6543,7 @@
           </a:p>
           <a:p xmlns:a="http://schemas.openxmlformats.org/drawingml/2006/main">
             <a:pPr algn="l">
+              <a:buNone/>
               <a:defRPr sz="1200">
                 <a:solidFill>
                   <a:srgbClr val="000000"/>

</xml_diff>